<commit_message>
hoan thien phuong phap de xuat end-to-end
</commit_message>
<xml_diff>
--- a/documents/hinh_ve_trong_cao_cao_do_an.pptx
+++ b/documents/hinh_ve_trong_cao_cao_do_an.pptx
@@ -6020,7 +6020,7 @@
         </p:nvSpPr>
         <p:spPr>
           <a:xfrm>
-            <a:off x="6347699" y="96012"/>
+            <a:off x="6347699" y="132588"/>
             <a:ext cx="1456944" cy="644652"/>
           </a:xfrm>
           <a:prstGeom prst="can">
@@ -6140,8 +6140,8 @@
         </p:nvSpPr>
         <p:spPr>
           <a:xfrm>
-            <a:off x="10553140" y="187452"/>
-            <a:ext cx="1523044" cy="530352"/>
+            <a:off x="10553140" y="105156"/>
+            <a:ext cx="1523044" cy="585216"/>
           </a:xfrm>
           <a:prstGeom prst="cube">
             <a:avLst>
@@ -6239,7 +6239,7 @@
         </p:nvSpPr>
         <p:spPr>
           <a:xfrm>
-            <a:off x="8388053" y="1281684"/>
+            <a:off x="8450421" y="1226820"/>
             <a:ext cx="1511804" cy="530352"/>
           </a:xfrm>
           <a:prstGeom prst="cube">
@@ -6468,7 +6468,7 @@
         </p:blipFill>
         <p:spPr>
           <a:xfrm>
-            <a:off x="2472939" y="2090743"/>
+            <a:off x="2512522" y="3226500"/>
             <a:ext cx="1003931" cy="1003931"/>
           </a:xfrm>
           <a:prstGeom prst="rect">
@@ -6560,7 +6560,7 @@
         </p:nvSpPr>
         <p:spPr>
           <a:xfrm>
-            <a:off x="8388052" y="210312"/>
+            <a:off x="8388052" y="192024"/>
             <a:ext cx="1523043" cy="530352"/>
           </a:xfrm>
           <a:prstGeom prst="roundRect">
@@ -6734,7 +6734,7 @@
         </p:nvSpPr>
         <p:spPr>
           <a:xfrm>
-            <a:off x="2223277" y="1281684"/>
+            <a:off x="2223277" y="1235964"/>
             <a:ext cx="1676400" cy="530352"/>
           </a:xfrm>
           <a:prstGeom prst="cube">
@@ -6806,8 +6806,8 @@
         </p:nvSpPr>
         <p:spPr>
           <a:xfrm>
-            <a:off x="146304" y="1281684"/>
-            <a:ext cx="1591056" cy="573024"/>
+            <a:off x="146303" y="1263396"/>
+            <a:ext cx="1597981" cy="573024"/>
           </a:xfrm>
           <a:prstGeom prst="roundRect">
             <a:avLst/>
@@ -6971,7 +6971,7 @@
         </p:nvSpPr>
         <p:spPr>
           <a:xfrm>
-            <a:off x="8388052" y="2250948"/>
+            <a:off x="8392925" y="2250948"/>
             <a:ext cx="1524983" cy="722376"/>
           </a:xfrm>
           <a:prstGeom prst="roundRect">
@@ -7211,7 +7211,7 @@
         </p:nvSpPr>
         <p:spPr>
           <a:xfrm>
-            <a:off x="8386111" y="4418076"/>
+            <a:off x="8450119" y="4418076"/>
             <a:ext cx="1524983" cy="632460"/>
           </a:xfrm>
           <a:prstGeom prst="cube">
@@ -7283,8 +7283,8 @@
         </p:nvSpPr>
         <p:spPr>
           <a:xfrm>
-            <a:off x="4395216" y="3412236"/>
-            <a:ext cx="1952484" cy="632460"/>
+            <a:off x="4395214" y="3412236"/>
+            <a:ext cx="1467079" cy="632460"/>
           </a:xfrm>
           <a:prstGeom prst="roundRect">
             <a:avLst/>
@@ -7420,8 +7420,8 @@
         </p:nvSpPr>
         <p:spPr>
           <a:xfrm>
-            <a:off x="4395215" y="4482084"/>
-            <a:ext cx="1952484" cy="632460"/>
+            <a:off x="4395214" y="4472940"/>
+            <a:ext cx="2220657" cy="632460"/>
           </a:xfrm>
           <a:prstGeom prst="roundRect">
             <a:avLst/>
@@ -7435,7 +7435,7 @@
             <a:solidFill>
               <a:schemeClr val="tx1"/>
             </a:solidFill>
-            <a:prstDash val="dash"/>
+            <a:prstDash val="solid"/>
           </a:ln>
         </p:spPr>
         <p:style>
@@ -7466,7 +7466,19 @@
                 </a:solidFill>
                 <a:latin typeface="+mj-lt"/>
               </a:rPr>
-              <a:t>Bộ phân tích cú pháp và dữ liệu phản hồi</a:t>
+              <a:t>Bộ phân tích cú pháp và</a:t>
+            </a:r>
+          </a:p>
+          <a:p>
+            <a:pPr algn="ctr"/>
+            <a:r>
+              <a:rPr lang="vi-VN" sz="1300" dirty="0">
+                <a:solidFill>
+                  <a:schemeClr val="tx1"/>
+                </a:solidFill>
+                <a:latin typeface="+mj-lt"/>
+              </a:rPr>
+              <a:t>dữ liệu phản hồi</a:t>
             </a:r>
           </a:p>
         </p:txBody>
@@ -7623,7 +7635,7 @@
         </p:nvSpPr>
         <p:spPr>
           <a:xfrm>
-            <a:off x="8388051" y="3412236"/>
+            <a:off x="8397195" y="3412236"/>
             <a:ext cx="1511805" cy="632460"/>
           </a:xfrm>
           <a:prstGeom prst="roundRect">
@@ -7693,8 +7705,8 @@
         </p:nvSpPr>
         <p:spPr>
           <a:xfrm>
-            <a:off x="4395216" y="5484876"/>
-            <a:ext cx="3409427" cy="632460"/>
+            <a:off x="8450119" y="5448300"/>
+            <a:ext cx="1919177" cy="632460"/>
           </a:xfrm>
           <a:prstGeom prst="roundRect">
             <a:avLst/>
@@ -7770,8 +7782,8 @@
         </p:nvSpPr>
         <p:spPr>
           <a:xfrm>
-            <a:off x="2298985" y="5484876"/>
-            <a:ext cx="1524983" cy="632460"/>
+            <a:off x="6425763" y="5393436"/>
+            <a:ext cx="1197834" cy="632460"/>
           </a:xfrm>
           <a:prstGeom prst="cube">
             <a:avLst>
@@ -7823,6 +7835,3175 @@
               <a:solidFill>
                 <a:schemeClr val="tx1"/>
               </a:solidFill>
+              <a:latin typeface="+mj-lt"/>
+            </a:endParaRPr>
+          </a:p>
+        </p:txBody>
+      </p:sp>
+      <p:cxnSp>
+        <p:nvCxnSpPr>
+          <p:cNvPr id="7" name="Straight Arrow Connector 6">
+            <a:extLst>
+              <a:ext uri="{FF2B5EF4-FFF2-40B4-BE49-F238E27FC236}">
+                <a16:creationId xmlns:a16="http://schemas.microsoft.com/office/drawing/2014/main" id="{E5244915-63A2-76F6-EE6C-AC60D11423EA}"/>
+              </a:ext>
+            </a:extLst>
+          </p:cNvPr>
+          <p:cNvCxnSpPr>
+            <a:stCxn id="3" idx="3"/>
+            <a:endCxn id="4" idx="1"/>
+          </p:cNvCxnSpPr>
+          <p:nvPr/>
+        </p:nvCxnSpPr>
+        <p:spPr>
+          <a:xfrm>
+            <a:off x="1737360" y="452628"/>
+            <a:ext cx="490728" cy="0"/>
+          </a:xfrm>
+          <a:prstGeom prst="straightConnector1">
+            <a:avLst/>
+          </a:prstGeom>
+          <a:ln>
+            <a:tailEnd type="triangle"/>
+          </a:ln>
+        </p:spPr>
+        <p:style>
+          <a:lnRef idx="2">
+            <a:schemeClr val="dk1"/>
+          </a:lnRef>
+          <a:fillRef idx="0">
+            <a:schemeClr val="dk1"/>
+          </a:fillRef>
+          <a:effectRef idx="1">
+            <a:schemeClr val="dk1"/>
+          </a:effectRef>
+          <a:fontRef idx="minor">
+            <a:schemeClr val="tx1"/>
+          </a:fontRef>
+        </p:style>
+      </p:cxnSp>
+      <p:cxnSp>
+        <p:nvCxnSpPr>
+          <p:cNvPr id="10" name="Straight Arrow Connector 9">
+            <a:extLst>
+              <a:ext uri="{FF2B5EF4-FFF2-40B4-BE49-F238E27FC236}">
+                <a16:creationId xmlns:a16="http://schemas.microsoft.com/office/drawing/2014/main" id="{ECB564DD-A9C2-4D81-C32E-ABF1A1F82414}"/>
+              </a:ext>
+            </a:extLst>
+          </p:cNvPr>
+          <p:cNvCxnSpPr>
+            <a:stCxn id="4" idx="3"/>
+            <a:endCxn id="5" idx="1"/>
+          </p:cNvCxnSpPr>
+          <p:nvPr/>
+        </p:nvCxnSpPr>
+        <p:spPr>
+          <a:xfrm>
+            <a:off x="3904488" y="452628"/>
+            <a:ext cx="490728" cy="0"/>
+          </a:xfrm>
+          <a:prstGeom prst="straightConnector1">
+            <a:avLst/>
+          </a:prstGeom>
+          <a:ln>
+            <a:tailEnd type="triangle"/>
+          </a:ln>
+        </p:spPr>
+        <p:style>
+          <a:lnRef idx="2">
+            <a:schemeClr val="dk1"/>
+          </a:lnRef>
+          <a:fillRef idx="0">
+            <a:schemeClr val="dk1"/>
+          </a:fillRef>
+          <a:effectRef idx="1">
+            <a:schemeClr val="dk1"/>
+          </a:effectRef>
+          <a:fontRef idx="minor">
+            <a:schemeClr val="tx1"/>
+          </a:fontRef>
+        </p:style>
+      </p:cxnSp>
+      <p:cxnSp>
+        <p:nvCxnSpPr>
+          <p:cNvPr id="12" name="Straight Arrow Connector 11">
+            <a:extLst>
+              <a:ext uri="{FF2B5EF4-FFF2-40B4-BE49-F238E27FC236}">
+                <a16:creationId xmlns:a16="http://schemas.microsoft.com/office/drawing/2014/main" id="{1DDC645D-7760-D5AD-0735-A1A545F54CB6}"/>
+              </a:ext>
+            </a:extLst>
+          </p:cNvPr>
+          <p:cNvCxnSpPr>
+            <a:stCxn id="5" idx="3"/>
+            <a:endCxn id="6" idx="2"/>
+          </p:cNvCxnSpPr>
+          <p:nvPr/>
+        </p:nvCxnSpPr>
+        <p:spPr>
+          <a:xfrm>
+            <a:off x="5852160" y="452628"/>
+            <a:ext cx="495539" cy="2286"/>
+          </a:xfrm>
+          <a:prstGeom prst="straightConnector1">
+            <a:avLst/>
+          </a:prstGeom>
+          <a:ln>
+            <a:tailEnd type="triangle"/>
+          </a:ln>
+        </p:spPr>
+        <p:style>
+          <a:lnRef idx="2">
+            <a:schemeClr val="dk1"/>
+          </a:lnRef>
+          <a:fillRef idx="0">
+            <a:schemeClr val="dk1"/>
+          </a:fillRef>
+          <a:effectRef idx="1">
+            <a:schemeClr val="dk1"/>
+          </a:effectRef>
+          <a:fontRef idx="minor">
+            <a:schemeClr val="tx1"/>
+          </a:fontRef>
+        </p:style>
+      </p:cxnSp>
+      <p:cxnSp>
+        <p:nvCxnSpPr>
+          <p:cNvPr id="16" name="Straight Arrow Connector 15">
+            <a:extLst>
+              <a:ext uri="{FF2B5EF4-FFF2-40B4-BE49-F238E27FC236}">
+                <a16:creationId xmlns:a16="http://schemas.microsoft.com/office/drawing/2014/main" id="{30E47978-4563-1DAC-40A3-E275FFD7AB75}"/>
+              </a:ext>
+            </a:extLst>
+          </p:cNvPr>
+          <p:cNvCxnSpPr>
+            <a:stCxn id="6" idx="4"/>
+            <a:endCxn id="23" idx="1"/>
+          </p:cNvCxnSpPr>
+          <p:nvPr/>
+        </p:nvCxnSpPr>
+        <p:spPr>
+          <a:xfrm>
+            <a:off x="7804643" y="454914"/>
+            <a:ext cx="583409" cy="2286"/>
+          </a:xfrm>
+          <a:prstGeom prst="straightConnector1">
+            <a:avLst/>
+          </a:prstGeom>
+          <a:ln>
+            <a:prstDash val="dash"/>
+            <a:tailEnd type="triangle"/>
+          </a:ln>
+        </p:spPr>
+        <p:style>
+          <a:lnRef idx="2">
+            <a:schemeClr val="dk1"/>
+          </a:lnRef>
+          <a:fillRef idx="0">
+            <a:schemeClr val="dk1"/>
+          </a:fillRef>
+          <a:effectRef idx="1">
+            <a:schemeClr val="dk1"/>
+          </a:effectRef>
+          <a:fontRef idx="minor">
+            <a:schemeClr val="tx1"/>
+          </a:fontRef>
+        </p:style>
+      </p:cxnSp>
+      <p:cxnSp>
+        <p:nvCxnSpPr>
+          <p:cNvPr id="19" name="Straight Arrow Connector 18">
+            <a:extLst>
+              <a:ext uri="{FF2B5EF4-FFF2-40B4-BE49-F238E27FC236}">
+                <a16:creationId xmlns:a16="http://schemas.microsoft.com/office/drawing/2014/main" id="{73369A63-B9FA-176B-E93A-AE83A9654719}"/>
+              </a:ext>
+            </a:extLst>
+          </p:cNvPr>
+          <p:cNvCxnSpPr>
+            <a:cxnSpLocks/>
+            <a:stCxn id="9" idx="2"/>
+            <a:endCxn id="23" idx="3"/>
+          </p:cNvCxnSpPr>
+          <p:nvPr/>
+        </p:nvCxnSpPr>
+        <p:spPr>
+          <a:xfrm flipH="1">
+            <a:off x="9911095" y="454659"/>
+            <a:ext cx="642045" cy="2541"/>
+          </a:xfrm>
+          <a:prstGeom prst="straightConnector1">
+            <a:avLst/>
+          </a:prstGeom>
+          <a:ln>
+            <a:prstDash val="dash"/>
+            <a:tailEnd type="triangle"/>
+          </a:ln>
+        </p:spPr>
+        <p:style>
+          <a:lnRef idx="2">
+            <a:schemeClr val="dk1"/>
+          </a:lnRef>
+          <a:fillRef idx="0">
+            <a:schemeClr val="dk1"/>
+          </a:fillRef>
+          <a:effectRef idx="1">
+            <a:schemeClr val="dk1"/>
+          </a:effectRef>
+          <a:fontRef idx="minor">
+            <a:schemeClr val="tx1"/>
+          </a:fontRef>
+        </p:style>
+      </p:cxnSp>
+      <p:cxnSp>
+        <p:nvCxnSpPr>
+          <p:cNvPr id="25" name="Straight Arrow Connector 24">
+            <a:extLst>
+              <a:ext uri="{FF2B5EF4-FFF2-40B4-BE49-F238E27FC236}">
+                <a16:creationId xmlns:a16="http://schemas.microsoft.com/office/drawing/2014/main" id="{EE8773F0-1B13-2B0F-3341-31339A3DABF0}"/>
+              </a:ext>
+            </a:extLst>
+          </p:cNvPr>
+          <p:cNvCxnSpPr>
+            <a:cxnSpLocks/>
+          </p:cNvCxnSpPr>
+          <p:nvPr/>
+        </p:nvCxnSpPr>
+        <p:spPr>
+          <a:xfrm>
+            <a:off x="9387318" y="722376"/>
+            <a:ext cx="5188" cy="607566"/>
+          </a:xfrm>
+          <a:prstGeom prst="straightConnector1">
+            <a:avLst/>
+          </a:prstGeom>
+          <a:ln>
+            <a:prstDash val="dash"/>
+            <a:tailEnd type="triangle"/>
+          </a:ln>
+        </p:spPr>
+        <p:style>
+          <a:lnRef idx="2">
+            <a:schemeClr val="dk1"/>
+          </a:lnRef>
+          <a:fillRef idx="0">
+            <a:schemeClr val="dk1"/>
+          </a:fillRef>
+          <a:effectRef idx="1">
+            <a:schemeClr val="dk1"/>
+          </a:effectRef>
+          <a:fontRef idx="minor">
+            <a:schemeClr val="tx1"/>
+          </a:fontRef>
+        </p:style>
+      </p:cxnSp>
+      <p:cxnSp>
+        <p:nvCxnSpPr>
+          <p:cNvPr id="27" name="Connector: Elbow 26">
+            <a:extLst>
+              <a:ext uri="{FF2B5EF4-FFF2-40B4-BE49-F238E27FC236}">
+                <a16:creationId xmlns:a16="http://schemas.microsoft.com/office/drawing/2014/main" id="{72047F34-37A9-DBEA-8593-094A562B174A}"/>
+              </a:ext>
+            </a:extLst>
+          </p:cNvPr>
+          <p:cNvCxnSpPr>
+            <a:stCxn id="13" idx="5"/>
+            <a:endCxn id="14" idx="2"/>
+          </p:cNvCxnSpPr>
+          <p:nvPr/>
+        </p:nvCxnSpPr>
+        <p:spPr>
+          <a:xfrm>
+            <a:off x="9962225" y="1440435"/>
+            <a:ext cx="590915" cy="687069"/>
+          </a:xfrm>
+          <a:prstGeom prst="bentConnector3">
+            <a:avLst>
+              <a:gd name="adj1" fmla="val 46906"/>
+            </a:avLst>
+          </a:prstGeom>
+          <a:ln>
+            <a:tailEnd type="triangle"/>
+          </a:ln>
+        </p:spPr>
+        <p:style>
+          <a:lnRef idx="2">
+            <a:schemeClr val="dk1"/>
+          </a:lnRef>
+          <a:fillRef idx="0">
+            <a:schemeClr val="dk1"/>
+          </a:fillRef>
+          <a:effectRef idx="1">
+            <a:schemeClr val="dk1"/>
+          </a:effectRef>
+          <a:fontRef idx="minor">
+            <a:schemeClr val="tx1"/>
+          </a:fontRef>
+        </p:style>
+      </p:cxnSp>
+      <p:cxnSp>
+        <p:nvCxnSpPr>
+          <p:cNvPr id="29" name="Straight Arrow Connector 28">
+            <a:extLst>
+              <a:ext uri="{FF2B5EF4-FFF2-40B4-BE49-F238E27FC236}">
+                <a16:creationId xmlns:a16="http://schemas.microsoft.com/office/drawing/2014/main" id="{7D113A5D-A04C-85D6-EEF1-7AF4A5A7B529}"/>
+              </a:ext>
+            </a:extLst>
+          </p:cNvPr>
+          <p:cNvCxnSpPr>
+            <a:cxnSpLocks/>
+            <a:stCxn id="17" idx="0"/>
+            <a:endCxn id="54" idx="3"/>
+          </p:cNvCxnSpPr>
+          <p:nvPr/>
+        </p:nvCxnSpPr>
+        <p:spPr>
+          <a:xfrm flipV="1">
+            <a:off x="3014488" y="1766316"/>
+            <a:ext cx="0" cy="1460184"/>
+          </a:xfrm>
+          <a:prstGeom prst="straightConnector1">
+            <a:avLst/>
+          </a:prstGeom>
+          <a:ln>
+            <a:tailEnd type="triangle"/>
+          </a:ln>
+        </p:spPr>
+        <p:style>
+          <a:lnRef idx="2">
+            <a:schemeClr val="dk1"/>
+          </a:lnRef>
+          <a:fillRef idx="0">
+            <a:schemeClr val="dk1"/>
+          </a:fillRef>
+          <a:effectRef idx="1">
+            <a:schemeClr val="dk1"/>
+          </a:effectRef>
+          <a:fontRef idx="minor">
+            <a:schemeClr val="tx1"/>
+          </a:fontRef>
+        </p:style>
+      </p:cxnSp>
+      <p:cxnSp>
+        <p:nvCxnSpPr>
+          <p:cNvPr id="34" name="Straight Arrow Connector 33">
+            <a:extLst>
+              <a:ext uri="{FF2B5EF4-FFF2-40B4-BE49-F238E27FC236}">
+                <a16:creationId xmlns:a16="http://schemas.microsoft.com/office/drawing/2014/main" id="{54C950E8-EE34-B49E-0895-F6A548ADDA64}"/>
+              </a:ext>
+            </a:extLst>
+          </p:cNvPr>
+          <p:cNvCxnSpPr>
+            <a:cxnSpLocks/>
+            <a:stCxn id="54" idx="4"/>
+            <a:endCxn id="24" idx="1"/>
+          </p:cNvCxnSpPr>
+          <p:nvPr/>
+        </p:nvCxnSpPr>
+        <p:spPr>
+          <a:xfrm flipV="1">
+            <a:off x="3805699" y="1546860"/>
+            <a:ext cx="589517" cy="1269"/>
+          </a:xfrm>
+          <a:prstGeom prst="straightConnector1">
+            <a:avLst/>
+          </a:prstGeom>
+          <a:ln>
+            <a:tailEnd type="triangle"/>
+          </a:ln>
+        </p:spPr>
+        <p:style>
+          <a:lnRef idx="2">
+            <a:schemeClr val="dk1"/>
+          </a:lnRef>
+          <a:fillRef idx="0">
+            <a:schemeClr val="dk1"/>
+          </a:fillRef>
+          <a:effectRef idx="1">
+            <a:schemeClr val="dk1"/>
+          </a:effectRef>
+          <a:fontRef idx="minor">
+            <a:schemeClr val="tx1"/>
+          </a:fontRef>
+        </p:style>
+      </p:cxnSp>
+      <p:cxnSp>
+        <p:nvCxnSpPr>
+          <p:cNvPr id="36" name="Straight Arrow Connector 35">
+            <a:extLst>
+              <a:ext uri="{FF2B5EF4-FFF2-40B4-BE49-F238E27FC236}">
+                <a16:creationId xmlns:a16="http://schemas.microsoft.com/office/drawing/2014/main" id="{F3C549D6-FF4C-1B45-A3ED-0E21615A9748}"/>
+              </a:ext>
+            </a:extLst>
+          </p:cNvPr>
+          <p:cNvCxnSpPr>
+            <a:stCxn id="24" idx="3"/>
+            <a:endCxn id="20" idx="1"/>
+          </p:cNvCxnSpPr>
+          <p:nvPr/>
+        </p:nvCxnSpPr>
+        <p:spPr>
+          <a:xfrm>
+            <a:off x="5852160" y="1546860"/>
+            <a:ext cx="495540" cy="0"/>
+          </a:xfrm>
+          <a:prstGeom prst="straightConnector1">
+            <a:avLst/>
+          </a:prstGeom>
+          <a:ln>
+            <a:tailEnd type="triangle"/>
+          </a:ln>
+        </p:spPr>
+        <p:style>
+          <a:lnRef idx="2">
+            <a:schemeClr val="dk1"/>
+          </a:lnRef>
+          <a:fillRef idx="0">
+            <a:schemeClr val="dk1"/>
+          </a:fillRef>
+          <a:effectRef idx="1">
+            <a:schemeClr val="dk1"/>
+          </a:effectRef>
+          <a:fontRef idx="minor">
+            <a:schemeClr val="tx1"/>
+          </a:fontRef>
+        </p:style>
+      </p:cxnSp>
+      <p:cxnSp>
+        <p:nvCxnSpPr>
+          <p:cNvPr id="38" name="Straight Arrow Connector 37">
+            <a:extLst>
+              <a:ext uri="{FF2B5EF4-FFF2-40B4-BE49-F238E27FC236}">
+                <a16:creationId xmlns:a16="http://schemas.microsoft.com/office/drawing/2014/main" id="{61B7315D-9A18-0B39-00A8-C588E9030025}"/>
+              </a:ext>
+            </a:extLst>
+          </p:cNvPr>
+          <p:cNvCxnSpPr>
+            <a:stCxn id="20" idx="3"/>
+            <a:endCxn id="13" idx="2"/>
+          </p:cNvCxnSpPr>
+          <p:nvPr/>
+        </p:nvCxnSpPr>
+        <p:spPr>
+          <a:xfrm flipV="1">
+            <a:off x="7804643" y="1543557"/>
+            <a:ext cx="645778" cy="3303"/>
+          </a:xfrm>
+          <a:prstGeom prst="straightConnector1">
+            <a:avLst/>
+          </a:prstGeom>
+          <a:ln>
+            <a:tailEnd type="triangle"/>
+          </a:ln>
+        </p:spPr>
+        <p:style>
+          <a:lnRef idx="2">
+            <a:schemeClr val="dk1"/>
+          </a:lnRef>
+          <a:fillRef idx="0">
+            <a:schemeClr val="dk1"/>
+          </a:fillRef>
+          <a:effectRef idx="1">
+            <a:schemeClr val="dk1"/>
+          </a:effectRef>
+          <a:fontRef idx="minor">
+            <a:schemeClr val="tx1"/>
+          </a:fontRef>
+        </p:style>
+      </p:cxnSp>
+      <p:cxnSp>
+        <p:nvCxnSpPr>
+          <p:cNvPr id="40" name="Straight Arrow Connector 39">
+            <a:extLst>
+              <a:ext uri="{FF2B5EF4-FFF2-40B4-BE49-F238E27FC236}">
+                <a16:creationId xmlns:a16="http://schemas.microsoft.com/office/drawing/2014/main" id="{F2D58ECA-A51C-44FD-6730-EF8763337F5D}"/>
+              </a:ext>
+            </a:extLst>
+          </p:cNvPr>
+          <p:cNvCxnSpPr>
+            <a:stCxn id="20" idx="2"/>
+            <a:endCxn id="58" idx="0"/>
+          </p:cNvCxnSpPr>
+          <p:nvPr/>
+        </p:nvCxnSpPr>
+        <p:spPr>
+          <a:xfrm>
+            <a:off x="7076172" y="1812036"/>
+            <a:ext cx="0" cy="538787"/>
+          </a:xfrm>
+          <a:prstGeom prst="straightConnector1">
+            <a:avLst/>
+          </a:prstGeom>
+          <a:ln>
+            <a:tailEnd type="triangle"/>
+          </a:ln>
+        </p:spPr>
+        <p:style>
+          <a:lnRef idx="2">
+            <a:schemeClr val="dk1"/>
+          </a:lnRef>
+          <a:fillRef idx="0">
+            <a:schemeClr val="dk1"/>
+          </a:fillRef>
+          <a:effectRef idx="1">
+            <a:schemeClr val="dk1"/>
+          </a:effectRef>
+          <a:fontRef idx="minor">
+            <a:schemeClr val="tx1"/>
+          </a:fontRef>
+        </p:style>
+      </p:cxnSp>
+      <p:cxnSp>
+        <p:nvCxnSpPr>
+          <p:cNvPr id="42" name="Straight Arrow Connector 41">
+            <a:extLst>
+              <a:ext uri="{FF2B5EF4-FFF2-40B4-BE49-F238E27FC236}">
+                <a16:creationId xmlns:a16="http://schemas.microsoft.com/office/drawing/2014/main" id="{645D5B8B-7D4E-1036-130C-40C221BDBEBF}"/>
+              </a:ext>
+            </a:extLst>
+          </p:cNvPr>
+          <p:cNvCxnSpPr>
+            <a:stCxn id="13" idx="3"/>
+            <a:endCxn id="57" idx="0"/>
+          </p:cNvCxnSpPr>
+          <p:nvPr/>
+        </p:nvCxnSpPr>
+        <p:spPr>
+          <a:xfrm>
+            <a:off x="9154762" y="1757172"/>
+            <a:ext cx="655" cy="493776"/>
+          </a:xfrm>
+          <a:prstGeom prst="straightConnector1">
+            <a:avLst/>
+          </a:prstGeom>
+          <a:ln>
+            <a:tailEnd type="triangle"/>
+          </a:ln>
+        </p:spPr>
+        <p:style>
+          <a:lnRef idx="2">
+            <a:schemeClr val="dk1"/>
+          </a:lnRef>
+          <a:fillRef idx="0">
+            <a:schemeClr val="dk1"/>
+          </a:fillRef>
+          <a:effectRef idx="1">
+            <a:schemeClr val="dk1"/>
+          </a:effectRef>
+          <a:fontRef idx="minor">
+            <a:schemeClr val="tx1"/>
+          </a:fontRef>
+        </p:style>
+      </p:cxnSp>
+      <p:cxnSp>
+        <p:nvCxnSpPr>
+          <p:cNvPr id="78" name="Straight Arrow Connector 77">
+            <a:extLst>
+              <a:ext uri="{FF2B5EF4-FFF2-40B4-BE49-F238E27FC236}">
+                <a16:creationId xmlns:a16="http://schemas.microsoft.com/office/drawing/2014/main" id="{3E0B055F-0174-51C2-9763-EADAF4604B8C}"/>
+              </a:ext>
+            </a:extLst>
+          </p:cNvPr>
+          <p:cNvCxnSpPr/>
+          <p:nvPr/>
+        </p:nvCxnSpPr>
+        <p:spPr>
+          <a:xfrm>
+            <a:off x="9917908" y="2496408"/>
+            <a:ext cx="635232" cy="0"/>
+          </a:xfrm>
+          <a:prstGeom prst="straightConnector1">
+            <a:avLst/>
+          </a:prstGeom>
+          <a:ln>
+            <a:tailEnd type="triangle"/>
+          </a:ln>
+        </p:spPr>
+        <p:style>
+          <a:lnRef idx="2">
+            <a:schemeClr val="dk1"/>
+          </a:lnRef>
+          <a:fillRef idx="0">
+            <a:schemeClr val="dk1"/>
+          </a:fillRef>
+          <a:effectRef idx="1">
+            <a:schemeClr val="dk1"/>
+          </a:effectRef>
+          <a:fontRef idx="minor">
+            <a:schemeClr val="tx1"/>
+          </a:fontRef>
+        </p:style>
+      </p:cxnSp>
+      <p:cxnSp>
+        <p:nvCxnSpPr>
+          <p:cNvPr id="80" name="Straight Arrow Connector 79">
+            <a:extLst>
+              <a:ext uri="{FF2B5EF4-FFF2-40B4-BE49-F238E27FC236}">
+                <a16:creationId xmlns:a16="http://schemas.microsoft.com/office/drawing/2014/main" id="{7E561A5F-68EC-D7F0-3EDD-EA2C39CA007E}"/>
+              </a:ext>
+            </a:extLst>
+          </p:cNvPr>
+          <p:cNvCxnSpPr/>
+          <p:nvPr/>
+        </p:nvCxnSpPr>
+        <p:spPr>
+          <a:xfrm flipH="1">
+            <a:off x="9917908" y="2679192"/>
+            <a:ext cx="635232" cy="0"/>
+          </a:xfrm>
+          <a:prstGeom prst="straightConnector1">
+            <a:avLst/>
+          </a:prstGeom>
+          <a:ln>
+            <a:tailEnd type="triangle"/>
+          </a:ln>
+        </p:spPr>
+        <p:style>
+          <a:lnRef idx="2">
+            <a:schemeClr val="dk1"/>
+          </a:lnRef>
+          <a:fillRef idx="0">
+            <a:schemeClr val="dk1"/>
+          </a:fillRef>
+          <a:effectRef idx="1">
+            <a:schemeClr val="dk1"/>
+          </a:effectRef>
+          <a:fontRef idx="minor">
+            <a:schemeClr val="tx1"/>
+          </a:fontRef>
+        </p:style>
+      </p:cxnSp>
+      <p:cxnSp>
+        <p:nvCxnSpPr>
+          <p:cNvPr id="82" name="Straight Arrow Connector 81">
+            <a:extLst>
+              <a:ext uri="{FF2B5EF4-FFF2-40B4-BE49-F238E27FC236}">
+                <a16:creationId xmlns:a16="http://schemas.microsoft.com/office/drawing/2014/main" id="{3C20B47F-2C45-9A57-01AE-77327090404B}"/>
+              </a:ext>
+            </a:extLst>
+          </p:cNvPr>
+          <p:cNvCxnSpPr/>
+          <p:nvPr/>
+        </p:nvCxnSpPr>
+        <p:spPr>
+          <a:xfrm>
+            <a:off x="7804643" y="2688432"/>
+            <a:ext cx="583408" cy="0"/>
+          </a:xfrm>
+          <a:prstGeom prst="straightConnector1">
+            <a:avLst/>
+          </a:prstGeom>
+          <a:ln>
+            <a:tailEnd type="triangle"/>
+          </a:ln>
+        </p:spPr>
+        <p:style>
+          <a:lnRef idx="2">
+            <a:schemeClr val="dk1"/>
+          </a:lnRef>
+          <a:fillRef idx="0">
+            <a:schemeClr val="dk1"/>
+          </a:fillRef>
+          <a:effectRef idx="1">
+            <a:schemeClr val="dk1"/>
+          </a:effectRef>
+          <a:fontRef idx="minor">
+            <a:schemeClr val="tx1"/>
+          </a:fontRef>
+        </p:style>
+      </p:cxnSp>
+      <p:cxnSp>
+        <p:nvCxnSpPr>
+          <p:cNvPr id="83" name="Straight Arrow Connector 82">
+            <a:extLst>
+              <a:ext uri="{FF2B5EF4-FFF2-40B4-BE49-F238E27FC236}">
+                <a16:creationId xmlns:a16="http://schemas.microsoft.com/office/drawing/2014/main" id="{20A3D7F3-CCCD-DBE5-9A80-EB9BDF0943D8}"/>
+              </a:ext>
+            </a:extLst>
+          </p:cNvPr>
+          <p:cNvCxnSpPr>
+            <a:cxnSpLocks/>
+          </p:cNvCxnSpPr>
+          <p:nvPr/>
+        </p:nvCxnSpPr>
+        <p:spPr>
+          <a:xfrm flipH="1">
+            <a:off x="7804643" y="2487264"/>
+            <a:ext cx="588282" cy="0"/>
+          </a:xfrm>
+          <a:prstGeom prst="straightConnector1">
+            <a:avLst/>
+          </a:prstGeom>
+          <a:ln>
+            <a:tailEnd type="triangle"/>
+          </a:ln>
+        </p:spPr>
+        <p:style>
+          <a:lnRef idx="2">
+            <a:schemeClr val="dk1"/>
+          </a:lnRef>
+          <a:fillRef idx="0">
+            <a:schemeClr val="dk1"/>
+          </a:fillRef>
+          <a:effectRef idx="1">
+            <a:schemeClr val="dk1"/>
+          </a:effectRef>
+          <a:fontRef idx="minor">
+            <a:schemeClr val="tx1"/>
+          </a:fontRef>
+        </p:style>
+      </p:cxnSp>
+      <p:cxnSp>
+        <p:nvCxnSpPr>
+          <p:cNvPr id="86" name="Straight Arrow Connector 85">
+            <a:extLst>
+              <a:ext uri="{FF2B5EF4-FFF2-40B4-BE49-F238E27FC236}">
+                <a16:creationId xmlns:a16="http://schemas.microsoft.com/office/drawing/2014/main" id="{893CE6EB-5F08-2544-FBEF-9F402634C635}"/>
+              </a:ext>
+            </a:extLst>
+          </p:cNvPr>
+          <p:cNvCxnSpPr>
+            <a:stCxn id="57" idx="2"/>
+            <a:endCxn id="65" idx="0"/>
+          </p:cNvCxnSpPr>
+          <p:nvPr/>
+        </p:nvCxnSpPr>
+        <p:spPr>
+          <a:xfrm flipH="1">
+            <a:off x="9153098" y="2973324"/>
+            <a:ext cx="2319" cy="438912"/>
+          </a:xfrm>
+          <a:prstGeom prst="straightConnector1">
+            <a:avLst/>
+          </a:prstGeom>
+          <a:ln>
+            <a:tailEnd type="triangle"/>
+          </a:ln>
+        </p:spPr>
+        <p:style>
+          <a:lnRef idx="2">
+            <a:schemeClr val="dk1"/>
+          </a:lnRef>
+          <a:fillRef idx="0">
+            <a:schemeClr val="dk1"/>
+          </a:fillRef>
+          <a:effectRef idx="1">
+            <a:schemeClr val="dk1"/>
+          </a:effectRef>
+          <a:fontRef idx="minor">
+            <a:schemeClr val="tx1"/>
+          </a:fontRef>
+        </p:style>
+      </p:cxnSp>
+      <p:cxnSp>
+        <p:nvCxnSpPr>
+          <p:cNvPr id="88" name="Straight Arrow Connector 87">
+            <a:extLst>
+              <a:ext uri="{FF2B5EF4-FFF2-40B4-BE49-F238E27FC236}">
+                <a16:creationId xmlns:a16="http://schemas.microsoft.com/office/drawing/2014/main" id="{22BF4B43-010E-23AE-6AD0-F5E5F96FEA61}"/>
+              </a:ext>
+            </a:extLst>
+          </p:cNvPr>
+          <p:cNvCxnSpPr>
+            <a:stCxn id="65" idx="3"/>
+            <a:endCxn id="59" idx="1"/>
+          </p:cNvCxnSpPr>
+          <p:nvPr/>
+        </p:nvCxnSpPr>
+        <p:spPr>
+          <a:xfrm>
+            <a:off x="9909000" y="3728466"/>
+            <a:ext cx="644140" cy="0"/>
+          </a:xfrm>
+          <a:prstGeom prst="straightConnector1">
+            <a:avLst/>
+          </a:prstGeom>
+          <a:ln>
+            <a:tailEnd type="triangle"/>
+          </a:ln>
+        </p:spPr>
+        <p:style>
+          <a:lnRef idx="2">
+            <a:schemeClr val="dk1"/>
+          </a:lnRef>
+          <a:fillRef idx="0">
+            <a:schemeClr val="dk1"/>
+          </a:fillRef>
+          <a:effectRef idx="1">
+            <a:schemeClr val="dk1"/>
+          </a:effectRef>
+          <a:fontRef idx="minor">
+            <a:schemeClr val="tx1"/>
+          </a:fontRef>
+        </p:style>
+      </p:cxnSp>
+      <p:cxnSp>
+        <p:nvCxnSpPr>
+          <p:cNvPr id="90" name="Straight Arrow Connector 89">
+            <a:extLst>
+              <a:ext uri="{FF2B5EF4-FFF2-40B4-BE49-F238E27FC236}">
+                <a16:creationId xmlns:a16="http://schemas.microsoft.com/office/drawing/2014/main" id="{5499AD5B-5E5D-6CD8-7D9B-11CB9F71C4DE}"/>
+              </a:ext>
+            </a:extLst>
+          </p:cNvPr>
+          <p:cNvCxnSpPr>
+            <a:stCxn id="65" idx="2"/>
+            <a:endCxn id="60" idx="1"/>
+          </p:cNvCxnSpPr>
+          <p:nvPr/>
+        </p:nvCxnSpPr>
+        <p:spPr>
+          <a:xfrm>
+            <a:off x="9153098" y="4044696"/>
+            <a:ext cx="3477" cy="485452"/>
+          </a:xfrm>
+          <a:prstGeom prst="straightConnector1">
+            <a:avLst/>
+          </a:prstGeom>
+          <a:ln>
+            <a:tailEnd type="triangle"/>
+          </a:ln>
+        </p:spPr>
+        <p:style>
+          <a:lnRef idx="2">
+            <a:schemeClr val="dk1"/>
+          </a:lnRef>
+          <a:fillRef idx="0">
+            <a:schemeClr val="dk1"/>
+          </a:fillRef>
+          <a:effectRef idx="1">
+            <a:schemeClr val="dk1"/>
+          </a:effectRef>
+          <a:fontRef idx="minor">
+            <a:schemeClr val="tx1"/>
+          </a:fontRef>
+        </p:style>
+      </p:cxnSp>
+      <p:cxnSp>
+        <p:nvCxnSpPr>
+          <p:cNvPr id="92" name="Connector: Elbow 91">
+            <a:extLst>
+              <a:ext uri="{FF2B5EF4-FFF2-40B4-BE49-F238E27FC236}">
+                <a16:creationId xmlns:a16="http://schemas.microsoft.com/office/drawing/2014/main" id="{674953EC-953A-2AA2-509D-D07E52184CE1}"/>
+              </a:ext>
+            </a:extLst>
+          </p:cNvPr>
+          <p:cNvCxnSpPr>
+            <a:stCxn id="59" idx="2"/>
+            <a:endCxn id="60" idx="4"/>
+          </p:cNvCxnSpPr>
+          <p:nvPr/>
+        </p:nvCxnSpPr>
+        <p:spPr>
+          <a:xfrm rot="5400000">
+            <a:off x="10216023" y="3691703"/>
+            <a:ext cx="745646" cy="1451632"/>
+          </a:xfrm>
+          <a:prstGeom prst="bentConnector2">
+            <a:avLst/>
+          </a:prstGeom>
+          <a:ln>
+            <a:tailEnd type="triangle"/>
+          </a:ln>
+        </p:spPr>
+        <p:style>
+          <a:lnRef idx="2">
+            <a:schemeClr val="dk1"/>
+          </a:lnRef>
+          <a:fillRef idx="0">
+            <a:schemeClr val="dk1"/>
+          </a:fillRef>
+          <a:effectRef idx="1">
+            <a:schemeClr val="dk1"/>
+          </a:effectRef>
+          <a:fontRef idx="minor">
+            <a:schemeClr val="tx1"/>
+          </a:fontRef>
+        </p:style>
+      </p:cxnSp>
+      <p:cxnSp>
+        <p:nvCxnSpPr>
+          <p:cNvPr id="94" name="Straight Arrow Connector 93">
+            <a:extLst>
+              <a:ext uri="{FF2B5EF4-FFF2-40B4-BE49-F238E27FC236}">
+                <a16:creationId xmlns:a16="http://schemas.microsoft.com/office/drawing/2014/main" id="{B818D712-06F0-C025-7D3D-D319D7101436}"/>
+              </a:ext>
+            </a:extLst>
+          </p:cNvPr>
+          <p:cNvCxnSpPr>
+            <a:cxnSpLocks/>
+            <a:stCxn id="60" idx="2"/>
+            <a:endCxn id="63" idx="3"/>
+          </p:cNvCxnSpPr>
+          <p:nvPr/>
+        </p:nvCxnSpPr>
+        <p:spPr>
+          <a:xfrm flipH="1" flipV="1">
+            <a:off x="6615871" y="4789170"/>
+            <a:ext cx="1834248" cy="1172"/>
+          </a:xfrm>
+          <a:prstGeom prst="straightConnector1">
+            <a:avLst/>
+          </a:prstGeom>
+          <a:ln>
+            <a:tailEnd type="triangle"/>
+          </a:ln>
+        </p:spPr>
+        <p:style>
+          <a:lnRef idx="2">
+            <a:schemeClr val="dk1"/>
+          </a:lnRef>
+          <a:fillRef idx="0">
+            <a:schemeClr val="dk1"/>
+          </a:fillRef>
+          <a:effectRef idx="1">
+            <a:schemeClr val="dk1"/>
+          </a:effectRef>
+          <a:fontRef idx="minor">
+            <a:schemeClr val="tx1"/>
+          </a:fontRef>
+        </p:style>
+      </p:cxnSp>
+      <p:cxnSp>
+        <p:nvCxnSpPr>
+          <p:cNvPr id="98" name="Connector: Elbow 97">
+            <a:extLst>
+              <a:ext uri="{FF2B5EF4-FFF2-40B4-BE49-F238E27FC236}">
+                <a16:creationId xmlns:a16="http://schemas.microsoft.com/office/drawing/2014/main" id="{CF2047C0-B234-454C-A941-7704BDE22454}"/>
+              </a:ext>
+            </a:extLst>
+          </p:cNvPr>
+          <p:cNvCxnSpPr>
+            <a:cxnSpLocks/>
+            <a:stCxn id="63" idx="1"/>
+            <a:endCxn id="17" idx="2"/>
+          </p:cNvCxnSpPr>
+          <p:nvPr/>
+        </p:nvCxnSpPr>
+        <p:spPr>
+          <a:xfrm rot="10800000">
+            <a:off x="3014488" y="4230432"/>
+            <a:ext cx="1380726" cy="558739"/>
+          </a:xfrm>
+          <a:prstGeom prst="bentConnector2">
+            <a:avLst/>
+          </a:prstGeom>
+          <a:ln>
+            <a:tailEnd type="triangle"/>
+          </a:ln>
+        </p:spPr>
+        <p:style>
+          <a:lnRef idx="2">
+            <a:schemeClr val="dk1"/>
+          </a:lnRef>
+          <a:fillRef idx="0">
+            <a:schemeClr val="dk1"/>
+          </a:fillRef>
+          <a:effectRef idx="1">
+            <a:schemeClr val="dk1"/>
+          </a:effectRef>
+          <a:fontRef idx="minor">
+            <a:schemeClr val="tx1"/>
+          </a:fontRef>
+        </p:style>
+      </p:cxnSp>
+      <p:cxnSp>
+        <p:nvCxnSpPr>
+          <p:cNvPr id="100" name="Connector: Elbow 99">
+            <a:extLst>
+              <a:ext uri="{FF2B5EF4-FFF2-40B4-BE49-F238E27FC236}">
+                <a16:creationId xmlns:a16="http://schemas.microsoft.com/office/drawing/2014/main" id="{F0C8EDDE-1843-CBCA-C82D-2EE433AEB7B4}"/>
+              </a:ext>
+            </a:extLst>
+          </p:cNvPr>
+          <p:cNvCxnSpPr>
+            <a:cxnSpLocks/>
+            <a:stCxn id="63" idx="2"/>
+            <a:endCxn id="67" idx="2"/>
+          </p:cNvCxnSpPr>
+          <p:nvPr/>
+        </p:nvCxnSpPr>
+        <p:spPr>
+          <a:xfrm rot="16200000" flipH="1">
+            <a:off x="5635502" y="4975441"/>
+            <a:ext cx="660302" cy="920220"/>
+          </a:xfrm>
+          <a:prstGeom prst="bentConnector2">
+            <a:avLst/>
+          </a:prstGeom>
+          <a:ln>
+            <a:prstDash val="dash"/>
+            <a:tailEnd type="triangle"/>
+          </a:ln>
+        </p:spPr>
+        <p:style>
+          <a:lnRef idx="2">
+            <a:schemeClr val="dk1"/>
+          </a:lnRef>
+          <a:fillRef idx="0">
+            <a:schemeClr val="dk1"/>
+          </a:fillRef>
+          <a:effectRef idx="1">
+            <a:schemeClr val="dk1"/>
+          </a:effectRef>
+          <a:fontRef idx="minor">
+            <a:schemeClr val="tx1"/>
+          </a:fontRef>
+        </p:style>
+      </p:cxnSp>
+      <p:cxnSp>
+        <p:nvCxnSpPr>
+          <p:cNvPr id="103" name="Straight Arrow Connector 102">
+            <a:extLst>
+              <a:ext uri="{FF2B5EF4-FFF2-40B4-BE49-F238E27FC236}">
+                <a16:creationId xmlns:a16="http://schemas.microsoft.com/office/drawing/2014/main" id="{6DF0944B-DF3B-FBF9-B2FA-2ACBDE23B968}"/>
+              </a:ext>
+            </a:extLst>
+          </p:cNvPr>
+          <p:cNvCxnSpPr>
+            <a:cxnSpLocks/>
+            <a:endCxn id="61" idx="1"/>
+          </p:cNvCxnSpPr>
+          <p:nvPr/>
+        </p:nvCxnSpPr>
+        <p:spPr>
+          <a:xfrm>
+            <a:off x="3516453" y="3728465"/>
+            <a:ext cx="878761" cy="1"/>
+          </a:xfrm>
+          <a:prstGeom prst="straightConnector1">
+            <a:avLst/>
+          </a:prstGeom>
+          <a:ln>
+            <a:prstDash val="dash"/>
+            <a:tailEnd type="triangle"/>
+          </a:ln>
+        </p:spPr>
+        <p:style>
+          <a:lnRef idx="2">
+            <a:schemeClr val="dk1"/>
+          </a:lnRef>
+          <a:fillRef idx="0">
+            <a:schemeClr val="dk1"/>
+          </a:fillRef>
+          <a:effectRef idx="1">
+            <a:schemeClr val="dk1"/>
+          </a:effectRef>
+          <a:fontRef idx="minor">
+            <a:schemeClr val="tx1"/>
+          </a:fontRef>
+        </p:style>
+      </p:cxnSp>
+      <p:cxnSp>
+        <p:nvCxnSpPr>
+          <p:cNvPr id="105" name="Straight Arrow Connector 104">
+            <a:extLst>
+              <a:ext uri="{FF2B5EF4-FFF2-40B4-BE49-F238E27FC236}">
+                <a16:creationId xmlns:a16="http://schemas.microsoft.com/office/drawing/2014/main" id="{3DEFA6A6-54D3-A975-2E74-ACF839F82619}"/>
+              </a:ext>
+            </a:extLst>
+          </p:cNvPr>
+          <p:cNvCxnSpPr>
+            <a:cxnSpLocks/>
+            <a:endCxn id="62" idx="3"/>
+          </p:cNvCxnSpPr>
+          <p:nvPr/>
+        </p:nvCxnSpPr>
+        <p:spPr>
+          <a:xfrm flipH="1" flipV="1">
+            <a:off x="5123687" y="2974848"/>
+            <a:ext cx="10134" cy="405384"/>
+          </a:xfrm>
+          <a:prstGeom prst="straightConnector1">
+            <a:avLst/>
+          </a:prstGeom>
+          <a:ln>
+            <a:solidFill>
+              <a:schemeClr val="tx1"/>
+            </a:solidFill>
+            <a:prstDash val="dash"/>
+            <a:tailEnd type="triangle"/>
+          </a:ln>
+        </p:spPr>
+        <p:style>
+          <a:lnRef idx="2">
+            <a:schemeClr val="dk1"/>
+          </a:lnRef>
+          <a:fillRef idx="0">
+            <a:schemeClr val="dk1"/>
+          </a:fillRef>
+          <a:effectRef idx="1">
+            <a:schemeClr val="dk1"/>
+          </a:effectRef>
+          <a:fontRef idx="minor">
+            <a:schemeClr val="tx1"/>
+          </a:fontRef>
+        </p:style>
+      </p:cxnSp>
+      <p:cxnSp>
+        <p:nvCxnSpPr>
+          <p:cNvPr id="109" name="Straight Arrow Connector 108">
+            <a:extLst>
+              <a:ext uri="{FF2B5EF4-FFF2-40B4-BE49-F238E27FC236}">
+                <a16:creationId xmlns:a16="http://schemas.microsoft.com/office/drawing/2014/main" id="{452208B9-71BD-B2E0-3CE2-EE501E854A49}"/>
+              </a:ext>
+            </a:extLst>
+          </p:cNvPr>
+          <p:cNvCxnSpPr>
+            <a:cxnSpLocks/>
+            <a:stCxn id="67" idx="4"/>
+            <a:endCxn id="66" idx="1"/>
+          </p:cNvCxnSpPr>
+          <p:nvPr/>
+        </p:nvCxnSpPr>
+        <p:spPr>
+          <a:xfrm flipV="1">
+            <a:off x="7511525" y="5764530"/>
+            <a:ext cx="938594" cy="1172"/>
+          </a:xfrm>
+          <a:prstGeom prst="straightConnector1">
+            <a:avLst/>
+          </a:prstGeom>
+          <a:ln>
+            <a:prstDash val="dash"/>
+            <a:tailEnd type="triangle"/>
+          </a:ln>
+        </p:spPr>
+        <p:style>
+          <a:lnRef idx="2">
+            <a:schemeClr val="dk1"/>
+          </a:lnRef>
+          <a:fillRef idx="0">
+            <a:schemeClr val="dk1"/>
+          </a:fillRef>
+          <a:effectRef idx="1">
+            <a:schemeClr val="dk1"/>
+          </a:effectRef>
+          <a:fontRef idx="minor">
+            <a:schemeClr val="tx1"/>
+          </a:fontRef>
+        </p:style>
+      </p:cxnSp>
+      <p:cxnSp>
+        <p:nvCxnSpPr>
+          <p:cNvPr id="113" name="Connector: Elbow 112">
+            <a:extLst>
+              <a:ext uri="{FF2B5EF4-FFF2-40B4-BE49-F238E27FC236}">
+                <a16:creationId xmlns:a16="http://schemas.microsoft.com/office/drawing/2014/main" id="{E9FC4317-5ABC-E301-8B89-0205BE05C6C3}"/>
+              </a:ext>
+            </a:extLst>
+          </p:cNvPr>
+          <p:cNvCxnSpPr>
+            <a:cxnSpLocks/>
+            <a:stCxn id="66" idx="0"/>
+            <a:endCxn id="58" idx="3"/>
+          </p:cNvCxnSpPr>
+          <p:nvPr/>
+        </p:nvCxnSpPr>
+        <p:spPr>
+          <a:xfrm rot="16200000" flipV="1">
+            <a:off x="7006214" y="3044806"/>
+            <a:ext cx="2473452" cy="2333536"/>
+          </a:xfrm>
+          <a:prstGeom prst="bentConnector3">
+            <a:avLst>
+              <a:gd name="adj1" fmla="val 10444"/>
+            </a:avLst>
+          </a:prstGeom>
+          <a:ln>
+            <a:prstDash val="dash"/>
+            <a:tailEnd type="triangle"/>
+          </a:ln>
+        </p:spPr>
+        <p:style>
+          <a:lnRef idx="2">
+            <a:schemeClr val="dk1"/>
+          </a:lnRef>
+          <a:fillRef idx="0">
+            <a:schemeClr val="dk1"/>
+          </a:fillRef>
+          <a:effectRef idx="1">
+            <a:schemeClr val="dk1"/>
+          </a:effectRef>
+          <a:fontRef idx="minor">
+            <a:schemeClr val="tx1"/>
+          </a:fontRef>
+        </p:style>
+      </p:cxnSp>
+      <p:cxnSp>
+        <p:nvCxnSpPr>
+          <p:cNvPr id="151" name="Straight Connector 150">
+            <a:extLst>
+              <a:ext uri="{FF2B5EF4-FFF2-40B4-BE49-F238E27FC236}">
+                <a16:creationId xmlns:a16="http://schemas.microsoft.com/office/drawing/2014/main" id="{2888B481-7A39-096A-3CD3-DE70ED41D2BB}"/>
+              </a:ext>
+            </a:extLst>
+          </p:cNvPr>
+          <p:cNvCxnSpPr>
+            <a:cxnSpLocks/>
+            <a:stCxn id="64" idx="3"/>
+          </p:cNvCxnSpPr>
+          <p:nvPr/>
+        </p:nvCxnSpPr>
+        <p:spPr>
+          <a:xfrm>
+            <a:off x="1737360" y="4748784"/>
+            <a:ext cx="393192" cy="0"/>
+          </a:xfrm>
+          <a:prstGeom prst="line">
+            <a:avLst/>
+          </a:prstGeom>
+          <a:ln>
+            <a:headEnd type="triangle" w="med" len="med"/>
+            <a:tailEnd type="none" w="med" len="med"/>
+          </a:ln>
+        </p:spPr>
+        <p:style>
+          <a:lnRef idx="2">
+            <a:schemeClr val="dk1"/>
+          </a:lnRef>
+          <a:fillRef idx="0">
+            <a:schemeClr val="dk1"/>
+          </a:fillRef>
+          <a:effectRef idx="1">
+            <a:schemeClr val="dk1"/>
+          </a:effectRef>
+          <a:fontRef idx="minor">
+            <a:schemeClr val="tx1"/>
+          </a:fontRef>
+        </p:style>
+      </p:cxnSp>
+      <p:cxnSp>
+        <p:nvCxnSpPr>
+          <p:cNvPr id="153" name="Straight Connector 152">
+            <a:extLst>
+              <a:ext uri="{FF2B5EF4-FFF2-40B4-BE49-F238E27FC236}">
+                <a16:creationId xmlns:a16="http://schemas.microsoft.com/office/drawing/2014/main" id="{997A810C-FDE1-B67A-673F-F3A557A0CB42}"/>
+              </a:ext>
+            </a:extLst>
+          </p:cNvPr>
+          <p:cNvCxnSpPr>
+            <a:cxnSpLocks/>
+          </p:cNvCxnSpPr>
+          <p:nvPr/>
+        </p:nvCxnSpPr>
+        <p:spPr>
+          <a:xfrm flipV="1">
+            <a:off x="2122932" y="3728465"/>
+            <a:ext cx="0" cy="1020319"/>
+          </a:xfrm>
+          <a:prstGeom prst="line">
+            <a:avLst/>
+          </a:prstGeom>
+        </p:spPr>
+        <p:style>
+          <a:lnRef idx="2">
+            <a:schemeClr val="dk1"/>
+          </a:lnRef>
+          <a:fillRef idx="0">
+            <a:schemeClr val="dk1"/>
+          </a:fillRef>
+          <a:effectRef idx="1">
+            <a:schemeClr val="dk1"/>
+          </a:effectRef>
+          <a:fontRef idx="minor">
+            <a:schemeClr val="tx1"/>
+          </a:fontRef>
+        </p:style>
+      </p:cxnSp>
+      <p:cxnSp>
+        <p:nvCxnSpPr>
+          <p:cNvPr id="155" name="Straight Connector 154">
+            <a:extLst>
+              <a:ext uri="{FF2B5EF4-FFF2-40B4-BE49-F238E27FC236}">
+                <a16:creationId xmlns:a16="http://schemas.microsoft.com/office/drawing/2014/main" id="{48767D13-55AF-5E73-A0F8-293F3EB6BE56}"/>
+              </a:ext>
+            </a:extLst>
+          </p:cNvPr>
+          <p:cNvCxnSpPr>
+            <a:cxnSpLocks/>
+          </p:cNvCxnSpPr>
+          <p:nvPr/>
+        </p:nvCxnSpPr>
+        <p:spPr>
+          <a:xfrm>
+            <a:off x="2121408" y="3728465"/>
+            <a:ext cx="466344" cy="0"/>
+          </a:xfrm>
+          <a:prstGeom prst="line">
+            <a:avLst/>
+          </a:prstGeom>
+          <a:ln>
+            <a:headEnd type="none" w="med" len="med"/>
+            <a:tailEnd type="triangle" w="med" len="med"/>
+          </a:ln>
+        </p:spPr>
+        <p:style>
+          <a:lnRef idx="2">
+            <a:schemeClr val="dk1"/>
+          </a:lnRef>
+          <a:fillRef idx="0">
+            <a:schemeClr val="dk1"/>
+          </a:fillRef>
+          <a:effectRef idx="1">
+            <a:schemeClr val="dk1"/>
+          </a:effectRef>
+          <a:fontRef idx="minor">
+            <a:schemeClr val="tx1"/>
+          </a:fontRef>
+        </p:style>
+      </p:cxnSp>
+      <p:cxnSp>
+        <p:nvCxnSpPr>
+          <p:cNvPr id="166" name="Connector: Elbow 165">
+            <a:extLst>
+              <a:ext uri="{FF2B5EF4-FFF2-40B4-BE49-F238E27FC236}">
+                <a16:creationId xmlns:a16="http://schemas.microsoft.com/office/drawing/2014/main" id="{81C65EEC-4071-5E36-0065-18102D4C3BE8}"/>
+              </a:ext>
+            </a:extLst>
+          </p:cNvPr>
+          <p:cNvCxnSpPr>
+            <a:cxnSpLocks/>
+            <a:endCxn id="56" idx="3"/>
+          </p:cNvCxnSpPr>
+          <p:nvPr/>
+        </p:nvCxnSpPr>
+        <p:spPr>
+          <a:xfrm rot="10800000">
+            <a:off x="1737361" y="2612136"/>
+            <a:ext cx="1152317" cy="611124"/>
+          </a:xfrm>
+          <a:prstGeom prst="bentConnector3">
+            <a:avLst>
+              <a:gd name="adj1" fmla="val 735"/>
+            </a:avLst>
+          </a:prstGeom>
+          <a:ln>
+            <a:tailEnd type="triangle"/>
+          </a:ln>
+        </p:spPr>
+        <p:style>
+          <a:lnRef idx="2">
+            <a:schemeClr val="dk1"/>
+          </a:lnRef>
+          <a:fillRef idx="0">
+            <a:schemeClr val="dk1"/>
+          </a:fillRef>
+          <a:effectRef idx="1">
+            <a:schemeClr val="dk1"/>
+          </a:effectRef>
+          <a:fontRef idx="minor">
+            <a:schemeClr val="tx1"/>
+          </a:fontRef>
+        </p:style>
+      </p:cxnSp>
+      <p:cxnSp>
+        <p:nvCxnSpPr>
+          <p:cNvPr id="173" name="Straight Arrow Connector 172">
+            <a:extLst>
+              <a:ext uri="{FF2B5EF4-FFF2-40B4-BE49-F238E27FC236}">
+                <a16:creationId xmlns:a16="http://schemas.microsoft.com/office/drawing/2014/main" id="{43D634BE-31AE-A930-E307-79675B0A6951}"/>
+              </a:ext>
+            </a:extLst>
+          </p:cNvPr>
+          <p:cNvCxnSpPr>
+            <a:cxnSpLocks/>
+            <a:stCxn id="56" idx="0"/>
+            <a:endCxn id="55" idx="2"/>
+          </p:cNvCxnSpPr>
+          <p:nvPr/>
+        </p:nvCxnSpPr>
+        <p:spPr>
+          <a:xfrm flipV="1">
+            <a:off x="941832" y="1836420"/>
+            <a:ext cx="3462" cy="414528"/>
+          </a:xfrm>
+          <a:prstGeom prst="straightConnector1">
+            <a:avLst/>
+          </a:prstGeom>
+          <a:ln>
+            <a:tailEnd type="triangle"/>
+          </a:ln>
+        </p:spPr>
+        <p:style>
+          <a:lnRef idx="2">
+            <a:schemeClr val="dk1"/>
+          </a:lnRef>
+          <a:fillRef idx="0">
+            <a:schemeClr val="dk1"/>
+          </a:fillRef>
+          <a:effectRef idx="1">
+            <a:schemeClr val="dk1"/>
+          </a:effectRef>
+          <a:fontRef idx="minor">
+            <a:schemeClr val="tx1"/>
+          </a:fontRef>
+        </p:style>
+      </p:cxnSp>
+      <p:cxnSp>
+        <p:nvCxnSpPr>
+          <p:cNvPr id="175" name="Straight Arrow Connector 174">
+            <a:extLst>
+              <a:ext uri="{FF2B5EF4-FFF2-40B4-BE49-F238E27FC236}">
+                <a16:creationId xmlns:a16="http://schemas.microsoft.com/office/drawing/2014/main" id="{E8C2BC04-FB25-AFA6-0C83-90D85821B5FD}"/>
+              </a:ext>
+            </a:extLst>
+          </p:cNvPr>
+          <p:cNvCxnSpPr>
+            <a:cxnSpLocks/>
+            <a:stCxn id="55" idx="3"/>
+            <a:endCxn id="54" idx="2"/>
+          </p:cNvCxnSpPr>
+          <p:nvPr/>
+        </p:nvCxnSpPr>
+        <p:spPr>
+          <a:xfrm flipV="1">
+            <a:off x="1744284" y="1548129"/>
+            <a:ext cx="478993" cy="1779"/>
+          </a:xfrm>
+          <a:prstGeom prst="straightConnector1">
+            <a:avLst/>
+          </a:prstGeom>
+          <a:ln>
+            <a:tailEnd type="triangle"/>
+          </a:ln>
+        </p:spPr>
+        <p:style>
+          <a:lnRef idx="2">
+            <a:schemeClr val="dk1"/>
+          </a:lnRef>
+          <a:fillRef idx="0">
+            <a:schemeClr val="dk1"/>
+          </a:fillRef>
+          <a:effectRef idx="1">
+            <a:schemeClr val="dk1"/>
+          </a:effectRef>
+          <a:fontRef idx="minor">
+            <a:schemeClr val="tx1"/>
+          </a:fontRef>
+        </p:style>
+      </p:cxnSp>
+      <p:cxnSp>
+        <p:nvCxnSpPr>
+          <p:cNvPr id="177" name="Connector: Elbow 176">
+            <a:extLst>
+              <a:ext uri="{FF2B5EF4-FFF2-40B4-BE49-F238E27FC236}">
+                <a16:creationId xmlns:a16="http://schemas.microsoft.com/office/drawing/2014/main" id="{937361AC-5BC3-026B-3653-708B57FC5409}"/>
+              </a:ext>
+            </a:extLst>
+          </p:cNvPr>
+          <p:cNvCxnSpPr>
+            <a:cxnSpLocks/>
+          </p:cNvCxnSpPr>
+          <p:nvPr/>
+        </p:nvCxnSpPr>
+        <p:spPr>
+          <a:xfrm rot="10800000" flipV="1">
+            <a:off x="3159761" y="2487262"/>
+            <a:ext cx="1249775" cy="734730"/>
+          </a:xfrm>
+          <a:prstGeom prst="bentConnector3">
+            <a:avLst>
+              <a:gd name="adj1" fmla="val 99793"/>
+            </a:avLst>
+          </a:prstGeom>
+          <a:ln>
+            <a:prstDash val="dash"/>
+            <a:headEnd type="triangle" w="med" len="med"/>
+            <a:tailEnd type="triangle" w="med" len="med"/>
+          </a:ln>
+        </p:spPr>
+        <p:style>
+          <a:lnRef idx="2">
+            <a:schemeClr val="dk1"/>
+          </a:lnRef>
+          <a:fillRef idx="0">
+            <a:schemeClr val="dk1"/>
+          </a:fillRef>
+          <a:effectRef idx="1">
+            <a:schemeClr val="dk1"/>
+          </a:effectRef>
+          <a:fontRef idx="minor">
+            <a:schemeClr val="tx1"/>
+          </a:fontRef>
+        </p:style>
+      </p:cxnSp>
+      <p:cxnSp>
+        <p:nvCxnSpPr>
+          <p:cNvPr id="198" name="Connector: Elbow 197">
+            <a:extLst>
+              <a:ext uri="{FF2B5EF4-FFF2-40B4-BE49-F238E27FC236}">
+                <a16:creationId xmlns:a16="http://schemas.microsoft.com/office/drawing/2014/main" id="{BA8F1A4B-01A4-11E8-378F-60F0E6E6EBF6}"/>
+              </a:ext>
+            </a:extLst>
+          </p:cNvPr>
+          <p:cNvCxnSpPr>
+            <a:cxnSpLocks/>
+            <a:endCxn id="62" idx="2"/>
+          </p:cNvCxnSpPr>
+          <p:nvPr/>
+        </p:nvCxnSpPr>
+        <p:spPr>
+          <a:xfrm rot="5400000" flipH="1" flipV="1">
+            <a:off x="3196786" y="3468879"/>
+            <a:ext cx="2053648" cy="343210"/>
+          </a:xfrm>
+          <a:prstGeom prst="bentConnector2">
+            <a:avLst/>
+          </a:prstGeom>
+          <a:ln>
+            <a:prstDash val="dash"/>
+            <a:tailEnd type="triangle"/>
+          </a:ln>
+        </p:spPr>
+        <p:style>
+          <a:lnRef idx="2">
+            <a:schemeClr val="dk1"/>
+          </a:lnRef>
+          <a:fillRef idx="0">
+            <a:schemeClr val="dk1"/>
+          </a:fillRef>
+          <a:effectRef idx="1">
+            <a:schemeClr val="dk1"/>
+          </a:effectRef>
+          <a:fontRef idx="minor">
+            <a:schemeClr val="tx1"/>
+          </a:fontRef>
+        </p:style>
+      </p:cxnSp>
+      <p:cxnSp>
+        <p:nvCxnSpPr>
+          <p:cNvPr id="210" name="Straight Arrow Connector 209">
+            <a:extLst>
+              <a:ext uri="{FF2B5EF4-FFF2-40B4-BE49-F238E27FC236}">
+                <a16:creationId xmlns:a16="http://schemas.microsoft.com/office/drawing/2014/main" id="{529515B2-14A0-5DB1-33A5-B80483A9852C}"/>
+              </a:ext>
+            </a:extLst>
+          </p:cNvPr>
+          <p:cNvCxnSpPr>
+            <a:cxnSpLocks/>
+          </p:cNvCxnSpPr>
+          <p:nvPr/>
+        </p:nvCxnSpPr>
+        <p:spPr>
+          <a:xfrm flipH="1">
+            <a:off x="4052005" y="4667308"/>
+            <a:ext cx="343209" cy="0"/>
+          </a:xfrm>
+          <a:prstGeom prst="straightConnector1">
+            <a:avLst/>
+          </a:prstGeom>
+          <a:ln>
+            <a:prstDash val="dash"/>
+            <a:headEnd type="none" w="med" len="med"/>
+            <a:tailEnd type="none" w="med" len="med"/>
+          </a:ln>
+        </p:spPr>
+        <p:style>
+          <a:lnRef idx="2">
+            <a:schemeClr val="dk1"/>
+          </a:lnRef>
+          <a:fillRef idx="0">
+            <a:schemeClr val="dk1"/>
+          </a:fillRef>
+          <a:effectRef idx="1">
+            <a:schemeClr val="dk1"/>
+          </a:effectRef>
+          <a:fontRef idx="minor">
+            <a:schemeClr val="tx1"/>
+          </a:fontRef>
+        </p:style>
+      </p:cxnSp>
+      <p:sp>
+        <p:nvSpPr>
+          <p:cNvPr id="224" name="Rectangle: Rounded Corners 223">
+            <a:extLst>
+              <a:ext uri="{FF2B5EF4-FFF2-40B4-BE49-F238E27FC236}">
+                <a16:creationId xmlns:a16="http://schemas.microsoft.com/office/drawing/2014/main" id="{D03AB27B-21F2-EE19-54E3-030F281BCE77}"/>
+              </a:ext>
+            </a:extLst>
+          </p:cNvPr>
+          <p:cNvSpPr/>
+          <p:nvPr/>
+        </p:nvSpPr>
+        <p:spPr>
+          <a:xfrm>
+            <a:off x="2334800" y="5412736"/>
+            <a:ext cx="1591056" cy="722376"/>
+          </a:xfrm>
+          <a:prstGeom prst="roundRect">
+            <a:avLst/>
+          </a:prstGeom>
+          <a:solidFill>
+            <a:schemeClr val="bg1">
+              <a:lumMod val="95000"/>
+            </a:schemeClr>
+          </a:solidFill>
+          <a:ln>
+            <a:solidFill>
+              <a:schemeClr val="tx1"/>
+            </a:solidFill>
+            <a:prstDash val="dash"/>
+          </a:ln>
+        </p:spPr>
+        <p:style>
+          <a:lnRef idx="2">
+            <a:schemeClr val="accent1">
+              <a:shade val="15000"/>
+            </a:schemeClr>
+          </a:lnRef>
+          <a:fillRef idx="1">
+            <a:schemeClr val="accent1"/>
+          </a:fillRef>
+          <a:effectRef idx="0">
+            <a:schemeClr val="accent1"/>
+          </a:effectRef>
+          <a:fontRef idx="minor">
+            <a:schemeClr val="lt1"/>
+          </a:fontRef>
+        </p:style>
+        <p:txBody>
+          <a:bodyPr rtlCol="0" anchor="ctr"/>
+          <a:lstStyle/>
+          <a:p>
+            <a:pPr algn="ctr"/>
+            <a:r>
+              <a:rPr lang="vi-VN" sz="1300" dirty="0">
+                <a:solidFill>
+                  <a:schemeClr val="tx1"/>
+                </a:solidFill>
+                <a:latin typeface="+mj-lt"/>
+              </a:rPr>
+              <a:t>Chuyển văn bản thành âm thanh</a:t>
+            </a:r>
+            <a:endParaRPr lang="en-US" sz="1300" dirty="0">
+              <a:solidFill>
+                <a:schemeClr val="tx1"/>
+              </a:solidFill>
+              <a:latin typeface="+mj-lt"/>
+            </a:endParaRPr>
+          </a:p>
+        </p:txBody>
+      </p:sp>
+      <p:cxnSp>
+        <p:nvCxnSpPr>
+          <p:cNvPr id="228" name="Connector: Elbow 227">
+            <a:extLst>
+              <a:ext uri="{FF2B5EF4-FFF2-40B4-BE49-F238E27FC236}">
+                <a16:creationId xmlns:a16="http://schemas.microsoft.com/office/drawing/2014/main" id="{7D7E927B-54AD-7885-BFAA-9003CE363D33}"/>
+              </a:ext>
+            </a:extLst>
+          </p:cNvPr>
+          <p:cNvCxnSpPr>
+            <a:cxnSpLocks/>
+            <a:endCxn id="224" idx="3"/>
+          </p:cNvCxnSpPr>
+          <p:nvPr/>
+        </p:nvCxnSpPr>
+        <p:spPr>
+          <a:xfrm rot="10800000" flipV="1">
+            <a:off x="3925856" y="5113014"/>
+            <a:ext cx="1197832" cy="660909"/>
+          </a:xfrm>
+          <a:prstGeom prst="bentConnector3">
+            <a:avLst>
+              <a:gd name="adj1" fmla="val -256"/>
+            </a:avLst>
+          </a:prstGeom>
+          <a:ln>
+            <a:tailEnd type="triangle"/>
+          </a:ln>
+        </p:spPr>
+        <p:style>
+          <a:lnRef idx="2">
+            <a:schemeClr val="dk1"/>
+          </a:lnRef>
+          <a:fillRef idx="0">
+            <a:schemeClr val="dk1"/>
+          </a:fillRef>
+          <a:effectRef idx="1">
+            <a:schemeClr val="dk1"/>
+          </a:effectRef>
+          <a:fontRef idx="minor">
+            <a:schemeClr val="tx1"/>
+          </a:fontRef>
+        </p:style>
+      </p:cxnSp>
+      <p:cxnSp>
+        <p:nvCxnSpPr>
+          <p:cNvPr id="230" name="Straight Arrow Connector 229">
+            <a:extLst>
+              <a:ext uri="{FF2B5EF4-FFF2-40B4-BE49-F238E27FC236}">
+                <a16:creationId xmlns:a16="http://schemas.microsoft.com/office/drawing/2014/main" id="{A46722BE-4CA8-7DD3-2630-4333F32F733F}"/>
+              </a:ext>
+            </a:extLst>
+          </p:cNvPr>
+          <p:cNvCxnSpPr/>
+          <p:nvPr/>
+        </p:nvCxnSpPr>
+        <p:spPr>
+          <a:xfrm flipV="1">
+            <a:off x="2874264" y="4230431"/>
+            <a:ext cx="0" cy="1174685"/>
+          </a:xfrm>
+          <a:prstGeom prst="straightConnector1">
+            <a:avLst/>
+          </a:prstGeom>
+          <a:ln>
+            <a:tailEnd type="triangle"/>
+          </a:ln>
+        </p:spPr>
+        <p:style>
+          <a:lnRef idx="2">
+            <a:schemeClr val="dk1"/>
+          </a:lnRef>
+          <a:fillRef idx="0">
+            <a:schemeClr val="dk1"/>
+          </a:fillRef>
+          <a:effectRef idx="1">
+            <a:schemeClr val="dk1"/>
+          </a:effectRef>
+          <a:fontRef idx="minor">
+            <a:schemeClr val="tx1"/>
+          </a:fontRef>
+        </p:style>
+      </p:cxnSp>
+      <p:cxnSp>
+        <p:nvCxnSpPr>
+          <p:cNvPr id="254" name="Connector: Elbow 253">
+            <a:extLst>
+              <a:ext uri="{FF2B5EF4-FFF2-40B4-BE49-F238E27FC236}">
+                <a16:creationId xmlns:a16="http://schemas.microsoft.com/office/drawing/2014/main" id="{852310E1-ECBE-0632-B85C-693B6D5BBD09}"/>
+              </a:ext>
+            </a:extLst>
+          </p:cNvPr>
+          <p:cNvCxnSpPr>
+            <a:cxnSpLocks/>
+            <a:stCxn id="6" idx="3"/>
+            <a:endCxn id="13" idx="1"/>
+          </p:cNvCxnSpPr>
+          <p:nvPr/>
+        </p:nvCxnSpPr>
+        <p:spPr>
+          <a:xfrm rot="16200000" flipH="1">
+            <a:off x="7839115" y="14295"/>
+            <a:ext cx="552702" cy="2078591"/>
+          </a:xfrm>
+          <a:prstGeom prst="bentConnector3">
+            <a:avLst/>
+          </a:prstGeom>
+          <a:ln>
+            <a:tailEnd type="triangle"/>
+          </a:ln>
+        </p:spPr>
+        <p:style>
+          <a:lnRef idx="2">
+            <a:schemeClr val="dk1"/>
+          </a:lnRef>
+          <a:fillRef idx="0">
+            <a:schemeClr val="dk1"/>
+          </a:fillRef>
+          <a:effectRef idx="1">
+            <a:schemeClr val="dk1"/>
+          </a:effectRef>
+          <a:fontRef idx="minor">
+            <a:schemeClr val="tx1"/>
+          </a:fontRef>
+        </p:style>
+      </p:cxnSp>
+      <p:sp>
+        <p:nvSpPr>
+          <p:cNvPr id="256" name="TextBox 255">
+            <a:extLst>
+              <a:ext uri="{FF2B5EF4-FFF2-40B4-BE49-F238E27FC236}">
+                <a16:creationId xmlns:a16="http://schemas.microsoft.com/office/drawing/2014/main" id="{22B93CA2-65CF-9AD2-0E86-AC44B7FD0C5C}"/>
+              </a:ext>
+            </a:extLst>
+          </p:cNvPr>
+          <p:cNvSpPr txBox="1"/>
+          <p:nvPr/>
+        </p:nvSpPr>
+        <p:spPr>
+          <a:xfrm>
+            <a:off x="1772212" y="134112"/>
+            <a:ext cx="409086" cy="323165"/>
+          </a:xfrm>
+          <a:prstGeom prst="rect">
+            <a:avLst/>
+          </a:prstGeom>
+          <a:noFill/>
+        </p:spPr>
+        <p:txBody>
+          <a:bodyPr wrap="none" rtlCol="0">
+            <a:spAutoFit/>
+          </a:bodyPr>
+          <a:lstStyle/>
+          <a:p>
+            <a:r>
+              <a:rPr lang="vi-VN" sz="1500" dirty="0">
+                <a:latin typeface="+mj-lt"/>
+              </a:rPr>
+              <a:t>(1)</a:t>
+            </a:r>
+            <a:endParaRPr lang="en-US" sz="1500" dirty="0">
+              <a:latin typeface="+mj-lt"/>
+            </a:endParaRPr>
+          </a:p>
+        </p:txBody>
+      </p:sp>
+      <p:sp>
+        <p:nvSpPr>
+          <p:cNvPr id="257" name="TextBox 256">
+            <a:extLst>
+              <a:ext uri="{FF2B5EF4-FFF2-40B4-BE49-F238E27FC236}">
+                <a16:creationId xmlns:a16="http://schemas.microsoft.com/office/drawing/2014/main" id="{61D55E67-B00D-8BED-A339-F3413189BEAC}"/>
+              </a:ext>
+            </a:extLst>
+          </p:cNvPr>
+          <p:cNvSpPr txBox="1"/>
+          <p:nvPr/>
+        </p:nvSpPr>
+        <p:spPr>
+          <a:xfrm>
+            <a:off x="3929174" y="134112"/>
+            <a:ext cx="409086" cy="323165"/>
+          </a:xfrm>
+          <a:prstGeom prst="rect">
+            <a:avLst/>
+          </a:prstGeom>
+          <a:noFill/>
+        </p:spPr>
+        <p:txBody>
+          <a:bodyPr wrap="none" rtlCol="0">
+            <a:spAutoFit/>
+          </a:bodyPr>
+          <a:lstStyle/>
+          <a:p>
+            <a:r>
+              <a:rPr lang="vi-VN" sz="1500" dirty="0">
+                <a:latin typeface="+mj-lt"/>
+              </a:rPr>
+              <a:t>(2)</a:t>
+            </a:r>
+            <a:endParaRPr lang="en-US" sz="1500" dirty="0">
+              <a:latin typeface="+mj-lt"/>
+            </a:endParaRPr>
+          </a:p>
+        </p:txBody>
+      </p:sp>
+      <p:sp>
+        <p:nvSpPr>
+          <p:cNvPr id="258" name="TextBox 257">
+            <a:extLst>
+              <a:ext uri="{FF2B5EF4-FFF2-40B4-BE49-F238E27FC236}">
+                <a16:creationId xmlns:a16="http://schemas.microsoft.com/office/drawing/2014/main" id="{32C67A7E-6D70-06C9-0053-8516DF9413F7}"/>
+              </a:ext>
+            </a:extLst>
+          </p:cNvPr>
+          <p:cNvSpPr txBox="1"/>
+          <p:nvPr/>
+        </p:nvSpPr>
+        <p:spPr>
+          <a:xfrm>
+            <a:off x="5872513" y="134112"/>
+            <a:ext cx="409086" cy="323165"/>
+          </a:xfrm>
+          <a:prstGeom prst="rect">
+            <a:avLst/>
+          </a:prstGeom>
+          <a:noFill/>
+        </p:spPr>
+        <p:txBody>
+          <a:bodyPr wrap="none" rtlCol="0">
+            <a:spAutoFit/>
+          </a:bodyPr>
+          <a:lstStyle/>
+          <a:p>
+            <a:r>
+              <a:rPr lang="vi-VN" sz="1500" dirty="0">
+                <a:latin typeface="+mj-lt"/>
+              </a:rPr>
+              <a:t>(3)</a:t>
+            </a:r>
+            <a:endParaRPr lang="en-US" sz="1500" dirty="0">
+              <a:latin typeface="+mj-lt"/>
+            </a:endParaRPr>
+          </a:p>
+        </p:txBody>
+      </p:sp>
+      <p:sp>
+        <p:nvSpPr>
+          <p:cNvPr id="259" name="TextBox 258">
+            <a:extLst>
+              <a:ext uri="{FF2B5EF4-FFF2-40B4-BE49-F238E27FC236}">
+                <a16:creationId xmlns:a16="http://schemas.microsoft.com/office/drawing/2014/main" id="{506C6AEB-3584-B844-10D1-018A0F7DFCF8}"/>
+              </a:ext>
+            </a:extLst>
+          </p:cNvPr>
+          <p:cNvSpPr txBox="1"/>
+          <p:nvPr/>
+        </p:nvSpPr>
+        <p:spPr>
+          <a:xfrm>
+            <a:off x="7855913" y="134112"/>
+            <a:ext cx="553357" cy="323165"/>
+          </a:xfrm>
+          <a:prstGeom prst="rect">
+            <a:avLst/>
+          </a:prstGeom>
+          <a:noFill/>
+        </p:spPr>
+        <p:txBody>
+          <a:bodyPr wrap="none" rtlCol="0">
+            <a:spAutoFit/>
+          </a:bodyPr>
+          <a:lstStyle/>
+          <a:p>
+            <a:r>
+              <a:rPr lang="vi-VN" sz="1500" dirty="0">
+                <a:latin typeface="+mj-lt"/>
+              </a:rPr>
+              <a:t>(4.1)</a:t>
+            </a:r>
+            <a:endParaRPr lang="en-US" sz="1500" dirty="0">
+              <a:latin typeface="+mj-lt"/>
+            </a:endParaRPr>
+          </a:p>
+        </p:txBody>
+      </p:sp>
+      <p:sp>
+        <p:nvSpPr>
+          <p:cNvPr id="260" name="TextBox 259">
+            <a:extLst>
+              <a:ext uri="{FF2B5EF4-FFF2-40B4-BE49-F238E27FC236}">
+                <a16:creationId xmlns:a16="http://schemas.microsoft.com/office/drawing/2014/main" id="{B0E2ADE8-3471-6F13-21D8-7180FB0E588B}"/>
+              </a:ext>
+            </a:extLst>
+          </p:cNvPr>
+          <p:cNvSpPr txBox="1"/>
+          <p:nvPr/>
+        </p:nvSpPr>
+        <p:spPr>
+          <a:xfrm>
+            <a:off x="10024057" y="134112"/>
+            <a:ext cx="553357" cy="323165"/>
+          </a:xfrm>
+          <a:prstGeom prst="rect">
+            <a:avLst/>
+          </a:prstGeom>
+          <a:noFill/>
+        </p:spPr>
+        <p:txBody>
+          <a:bodyPr wrap="none" rtlCol="0">
+            <a:spAutoFit/>
+          </a:bodyPr>
+          <a:lstStyle/>
+          <a:p>
+            <a:r>
+              <a:rPr lang="vi-VN" sz="1500" dirty="0">
+                <a:latin typeface="+mj-lt"/>
+              </a:rPr>
+              <a:t>(4.2)</a:t>
+            </a:r>
+            <a:endParaRPr lang="en-US" sz="1500" dirty="0">
+              <a:latin typeface="+mj-lt"/>
+            </a:endParaRPr>
+          </a:p>
+        </p:txBody>
+      </p:sp>
+      <p:sp>
+        <p:nvSpPr>
+          <p:cNvPr id="261" name="TextBox 260">
+            <a:extLst>
+              <a:ext uri="{FF2B5EF4-FFF2-40B4-BE49-F238E27FC236}">
+                <a16:creationId xmlns:a16="http://schemas.microsoft.com/office/drawing/2014/main" id="{107413D4-2765-49C5-21A5-A5F246165B11}"/>
+              </a:ext>
+            </a:extLst>
+          </p:cNvPr>
+          <p:cNvSpPr txBox="1"/>
+          <p:nvPr/>
+        </p:nvSpPr>
+        <p:spPr>
+          <a:xfrm>
+            <a:off x="9387318" y="828386"/>
+            <a:ext cx="553357" cy="323165"/>
+          </a:xfrm>
+          <a:prstGeom prst="rect">
+            <a:avLst/>
+          </a:prstGeom>
+          <a:noFill/>
+        </p:spPr>
+        <p:txBody>
+          <a:bodyPr wrap="none" rtlCol="0">
+            <a:spAutoFit/>
+          </a:bodyPr>
+          <a:lstStyle/>
+          <a:p>
+            <a:r>
+              <a:rPr lang="vi-VN" sz="1500" dirty="0">
+                <a:latin typeface="+mj-lt"/>
+              </a:rPr>
+              <a:t>(4.3)</a:t>
+            </a:r>
+            <a:endParaRPr lang="en-US" sz="1500" dirty="0">
+              <a:latin typeface="+mj-lt"/>
+            </a:endParaRPr>
+          </a:p>
+        </p:txBody>
+      </p:sp>
+      <p:sp>
+        <p:nvSpPr>
+          <p:cNvPr id="262" name="TextBox 261">
+            <a:extLst>
+              <a:ext uri="{FF2B5EF4-FFF2-40B4-BE49-F238E27FC236}">
+                <a16:creationId xmlns:a16="http://schemas.microsoft.com/office/drawing/2014/main" id="{CA0B72E3-23AF-3415-3BEA-BEA97E9B800A}"/>
+              </a:ext>
+            </a:extLst>
+          </p:cNvPr>
+          <p:cNvSpPr txBox="1"/>
+          <p:nvPr/>
+        </p:nvSpPr>
+        <p:spPr>
+          <a:xfrm>
+            <a:off x="7884959" y="749514"/>
+            <a:ext cx="409086" cy="323165"/>
+          </a:xfrm>
+          <a:prstGeom prst="rect">
+            <a:avLst/>
+          </a:prstGeom>
+          <a:noFill/>
+        </p:spPr>
+        <p:txBody>
+          <a:bodyPr wrap="none" rtlCol="0">
+            <a:spAutoFit/>
+          </a:bodyPr>
+          <a:lstStyle/>
+          <a:p>
+            <a:r>
+              <a:rPr lang="vi-VN" sz="1500" dirty="0">
+                <a:latin typeface="+mj-lt"/>
+              </a:rPr>
+              <a:t>(5)</a:t>
+            </a:r>
+            <a:endParaRPr lang="en-US" sz="1500" dirty="0">
+              <a:latin typeface="+mj-lt"/>
+            </a:endParaRPr>
+          </a:p>
+        </p:txBody>
+      </p:sp>
+      <p:sp>
+        <p:nvSpPr>
+          <p:cNvPr id="266" name="TextBox 265">
+            <a:extLst>
+              <a:ext uri="{FF2B5EF4-FFF2-40B4-BE49-F238E27FC236}">
+                <a16:creationId xmlns:a16="http://schemas.microsoft.com/office/drawing/2014/main" id="{FBD1815C-B498-6ECC-F936-4F6E255851B8}"/>
+              </a:ext>
+            </a:extLst>
+          </p:cNvPr>
+          <p:cNvSpPr txBox="1"/>
+          <p:nvPr/>
+        </p:nvSpPr>
+        <p:spPr>
+          <a:xfrm>
+            <a:off x="9137586" y="1809711"/>
+            <a:ext cx="498150" cy="323165"/>
+          </a:xfrm>
+          <a:prstGeom prst="rect">
+            <a:avLst/>
+          </a:prstGeom>
+          <a:noFill/>
+        </p:spPr>
+        <p:txBody>
+          <a:bodyPr wrap="none" rtlCol="0">
+            <a:spAutoFit/>
+          </a:bodyPr>
+          <a:lstStyle/>
+          <a:p>
+            <a:r>
+              <a:rPr lang="vi-VN" sz="1500" dirty="0">
+                <a:latin typeface="+mj-lt"/>
+              </a:rPr>
+              <a:t>(11)</a:t>
+            </a:r>
+            <a:endParaRPr lang="en-US" sz="1500" dirty="0">
+              <a:latin typeface="+mj-lt"/>
+            </a:endParaRPr>
+          </a:p>
+        </p:txBody>
+      </p:sp>
+      <p:sp>
+        <p:nvSpPr>
+          <p:cNvPr id="267" name="TextBox 266">
+            <a:extLst>
+              <a:ext uri="{FF2B5EF4-FFF2-40B4-BE49-F238E27FC236}">
+                <a16:creationId xmlns:a16="http://schemas.microsoft.com/office/drawing/2014/main" id="{551C35FC-20B1-30B2-8408-717CAD357B0D}"/>
+              </a:ext>
+            </a:extLst>
+          </p:cNvPr>
+          <p:cNvSpPr txBox="1"/>
+          <p:nvPr/>
+        </p:nvSpPr>
+        <p:spPr>
+          <a:xfrm>
+            <a:off x="9876321" y="1681735"/>
+            <a:ext cx="409086" cy="323165"/>
+          </a:xfrm>
+          <a:prstGeom prst="rect">
+            <a:avLst/>
+          </a:prstGeom>
+          <a:noFill/>
+        </p:spPr>
+        <p:txBody>
+          <a:bodyPr wrap="none" rtlCol="0">
+            <a:spAutoFit/>
+          </a:bodyPr>
+          <a:lstStyle/>
+          <a:p>
+            <a:r>
+              <a:rPr lang="vi-VN" sz="1500" dirty="0">
+                <a:latin typeface="+mj-lt"/>
+              </a:rPr>
+              <a:t>(6)</a:t>
+            </a:r>
+            <a:endParaRPr lang="en-US" sz="1500" dirty="0">
+              <a:latin typeface="+mj-lt"/>
+            </a:endParaRPr>
+          </a:p>
+        </p:txBody>
+      </p:sp>
+      <p:sp>
+        <p:nvSpPr>
+          <p:cNvPr id="268" name="TextBox 267">
+            <a:extLst>
+              <a:ext uri="{FF2B5EF4-FFF2-40B4-BE49-F238E27FC236}">
+                <a16:creationId xmlns:a16="http://schemas.microsoft.com/office/drawing/2014/main" id="{6E05D608-E9BE-51D7-9560-703B4F871F31}"/>
+              </a:ext>
+            </a:extLst>
+          </p:cNvPr>
+          <p:cNvSpPr txBox="1"/>
+          <p:nvPr/>
+        </p:nvSpPr>
+        <p:spPr>
+          <a:xfrm>
+            <a:off x="9903603" y="3392552"/>
+            <a:ext cx="649537" cy="323165"/>
+          </a:xfrm>
+          <a:prstGeom prst="rect">
+            <a:avLst/>
+          </a:prstGeom>
+          <a:noFill/>
+        </p:spPr>
+        <p:txBody>
+          <a:bodyPr wrap="none" rtlCol="0">
+            <a:spAutoFit/>
+          </a:bodyPr>
+          <a:lstStyle/>
+          <a:p>
+            <a:r>
+              <a:rPr lang="vi-VN" sz="1500" dirty="0">
+                <a:latin typeface="+mj-lt"/>
+              </a:rPr>
+              <a:t>(14.1)</a:t>
+            </a:r>
+            <a:endParaRPr lang="en-US" sz="1500" dirty="0">
+              <a:latin typeface="+mj-lt"/>
+            </a:endParaRPr>
+          </a:p>
+        </p:txBody>
+      </p:sp>
+      <p:sp>
+        <p:nvSpPr>
+          <p:cNvPr id="269" name="TextBox 268">
+            <a:extLst>
+              <a:ext uri="{FF2B5EF4-FFF2-40B4-BE49-F238E27FC236}">
+                <a16:creationId xmlns:a16="http://schemas.microsoft.com/office/drawing/2014/main" id="{DE2E276B-2324-A476-F504-B8EBB4EC0CF4}"/>
+              </a:ext>
+            </a:extLst>
+          </p:cNvPr>
+          <p:cNvSpPr txBox="1"/>
+          <p:nvPr/>
+        </p:nvSpPr>
+        <p:spPr>
+          <a:xfrm>
+            <a:off x="9151650" y="3015957"/>
+            <a:ext cx="505267" cy="323165"/>
+          </a:xfrm>
+          <a:prstGeom prst="rect">
+            <a:avLst/>
+          </a:prstGeom>
+          <a:noFill/>
+        </p:spPr>
+        <p:txBody>
+          <a:bodyPr wrap="none" rtlCol="0">
+            <a:spAutoFit/>
+          </a:bodyPr>
+          <a:lstStyle/>
+          <a:p>
+            <a:r>
+              <a:rPr lang="vi-VN" sz="1500" dirty="0">
+                <a:latin typeface="+mj-lt"/>
+              </a:rPr>
+              <a:t>(13)</a:t>
+            </a:r>
+            <a:endParaRPr lang="en-US" sz="1500" dirty="0">
+              <a:latin typeface="+mj-lt"/>
+            </a:endParaRPr>
+          </a:p>
+        </p:txBody>
+      </p:sp>
+      <p:sp>
+        <p:nvSpPr>
+          <p:cNvPr id="270" name="TextBox 269">
+            <a:extLst>
+              <a:ext uri="{FF2B5EF4-FFF2-40B4-BE49-F238E27FC236}">
+                <a16:creationId xmlns:a16="http://schemas.microsoft.com/office/drawing/2014/main" id="{80D3B9EA-0FD0-EC27-68F6-A4AF329F7A29}"/>
+              </a:ext>
+            </a:extLst>
+          </p:cNvPr>
+          <p:cNvSpPr txBox="1"/>
+          <p:nvPr/>
+        </p:nvSpPr>
+        <p:spPr>
+          <a:xfrm>
+            <a:off x="7784321" y="2173243"/>
+            <a:ext cx="649537" cy="323165"/>
+          </a:xfrm>
+          <a:prstGeom prst="rect">
+            <a:avLst/>
+          </a:prstGeom>
+          <a:noFill/>
+        </p:spPr>
+        <p:txBody>
+          <a:bodyPr wrap="none" rtlCol="0">
+            <a:spAutoFit/>
+          </a:bodyPr>
+          <a:lstStyle/>
+          <a:p>
+            <a:r>
+              <a:rPr lang="vi-VN" sz="1500" dirty="0">
+                <a:latin typeface="+mj-lt"/>
+              </a:rPr>
+              <a:t>(12.2)</a:t>
+            </a:r>
+            <a:endParaRPr lang="en-US" sz="1500" dirty="0">
+              <a:latin typeface="+mj-lt"/>
+            </a:endParaRPr>
+          </a:p>
+        </p:txBody>
+      </p:sp>
+      <p:sp>
+        <p:nvSpPr>
+          <p:cNvPr id="271" name="TextBox 270">
+            <a:extLst>
+              <a:ext uri="{FF2B5EF4-FFF2-40B4-BE49-F238E27FC236}">
+                <a16:creationId xmlns:a16="http://schemas.microsoft.com/office/drawing/2014/main" id="{9D4C1670-B0D5-BA83-2A81-F339360E9FF3}"/>
+              </a:ext>
+            </a:extLst>
+          </p:cNvPr>
+          <p:cNvSpPr txBox="1"/>
+          <p:nvPr/>
+        </p:nvSpPr>
+        <p:spPr>
+          <a:xfrm>
+            <a:off x="9939309" y="2173243"/>
+            <a:ext cx="649537" cy="323165"/>
+          </a:xfrm>
+          <a:prstGeom prst="rect">
+            <a:avLst/>
+          </a:prstGeom>
+          <a:noFill/>
+        </p:spPr>
+        <p:txBody>
+          <a:bodyPr wrap="none" rtlCol="0">
+            <a:spAutoFit/>
+          </a:bodyPr>
+          <a:lstStyle/>
+          <a:p>
+            <a:r>
+              <a:rPr lang="vi-VN" sz="1500" dirty="0">
+                <a:latin typeface="+mj-lt"/>
+              </a:rPr>
+              <a:t>(12.1)</a:t>
+            </a:r>
+            <a:endParaRPr lang="en-US" sz="1500" dirty="0">
+              <a:latin typeface="+mj-lt"/>
+            </a:endParaRPr>
+          </a:p>
+        </p:txBody>
+      </p:sp>
+      <p:sp>
+        <p:nvSpPr>
+          <p:cNvPr id="272" name="TextBox 271">
+            <a:extLst>
+              <a:ext uri="{FF2B5EF4-FFF2-40B4-BE49-F238E27FC236}">
+                <a16:creationId xmlns:a16="http://schemas.microsoft.com/office/drawing/2014/main" id="{804844C1-05A6-2D92-B31B-484250A49FB1}"/>
+              </a:ext>
+            </a:extLst>
+          </p:cNvPr>
+          <p:cNvSpPr txBox="1"/>
+          <p:nvPr/>
+        </p:nvSpPr>
+        <p:spPr>
+          <a:xfrm>
+            <a:off x="11288437" y="4255936"/>
+            <a:ext cx="649537" cy="323165"/>
+          </a:xfrm>
+          <a:prstGeom prst="rect">
+            <a:avLst/>
+          </a:prstGeom>
+          <a:noFill/>
+        </p:spPr>
+        <p:txBody>
+          <a:bodyPr wrap="none" rtlCol="0">
+            <a:spAutoFit/>
+          </a:bodyPr>
+          <a:lstStyle/>
+          <a:p>
+            <a:r>
+              <a:rPr lang="vi-VN" sz="1500" dirty="0">
+                <a:latin typeface="+mj-lt"/>
+              </a:rPr>
+              <a:t>(14.2)</a:t>
+            </a:r>
+            <a:endParaRPr lang="en-US" sz="1500" dirty="0">
+              <a:latin typeface="+mj-lt"/>
+            </a:endParaRPr>
+          </a:p>
+        </p:txBody>
+      </p:sp>
+      <p:sp>
+        <p:nvSpPr>
+          <p:cNvPr id="275" name="TextBox 274">
+            <a:extLst>
+              <a:ext uri="{FF2B5EF4-FFF2-40B4-BE49-F238E27FC236}">
+                <a16:creationId xmlns:a16="http://schemas.microsoft.com/office/drawing/2014/main" id="{A5B0BE72-EE02-F790-A759-2788949AA62F}"/>
+              </a:ext>
+            </a:extLst>
+          </p:cNvPr>
+          <p:cNvSpPr txBox="1"/>
+          <p:nvPr/>
+        </p:nvSpPr>
+        <p:spPr>
+          <a:xfrm>
+            <a:off x="9448114" y="5120304"/>
+            <a:ext cx="777777" cy="323165"/>
+          </a:xfrm>
+          <a:prstGeom prst="rect">
+            <a:avLst/>
+          </a:prstGeom>
+          <a:noFill/>
+        </p:spPr>
+        <p:txBody>
+          <a:bodyPr wrap="none" rtlCol="0">
+            <a:spAutoFit/>
+          </a:bodyPr>
+          <a:lstStyle/>
+          <a:p>
+            <a:r>
+              <a:rPr lang="vi-VN" sz="1500" dirty="0">
+                <a:latin typeface="+mj-lt"/>
+              </a:rPr>
+              <a:t>(16C.2)</a:t>
+            </a:r>
+            <a:endParaRPr lang="en-US" sz="1500" dirty="0">
+              <a:latin typeface="+mj-lt"/>
+            </a:endParaRPr>
+          </a:p>
+        </p:txBody>
+      </p:sp>
+      <p:sp>
+        <p:nvSpPr>
+          <p:cNvPr id="276" name="TextBox 275">
+            <a:extLst>
+              <a:ext uri="{FF2B5EF4-FFF2-40B4-BE49-F238E27FC236}">
+                <a16:creationId xmlns:a16="http://schemas.microsoft.com/office/drawing/2014/main" id="{0D9A538E-2FBC-F2F3-7A97-4CBF0890F0AD}"/>
+              </a:ext>
+            </a:extLst>
+          </p:cNvPr>
+          <p:cNvSpPr txBox="1"/>
+          <p:nvPr/>
+        </p:nvSpPr>
+        <p:spPr>
+          <a:xfrm>
+            <a:off x="9113193" y="4091587"/>
+            <a:ext cx="649537" cy="323165"/>
+          </a:xfrm>
+          <a:prstGeom prst="rect">
+            <a:avLst/>
+          </a:prstGeom>
+          <a:noFill/>
+        </p:spPr>
+        <p:txBody>
+          <a:bodyPr wrap="none" rtlCol="0">
+            <a:spAutoFit/>
+          </a:bodyPr>
+          <a:lstStyle/>
+          <a:p>
+            <a:r>
+              <a:rPr lang="vi-VN" sz="1500" dirty="0">
+                <a:latin typeface="+mj-lt"/>
+              </a:rPr>
+              <a:t>(14.3)</a:t>
+            </a:r>
+            <a:endParaRPr lang="en-US" sz="1500" dirty="0">
+              <a:latin typeface="+mj-lt"/>
+            </a:endParaRPr>
+          </a:p>
+        </p:txBody>
+      </p:sp>
+      <p:sp>
+        <p:nvSpPr>
+          <p:cNvPr id="280" name="TextBox 279">
+            <a:extLst>
+              <a:ext uri="{FF2B5EF4-FFF2-40B4-BE49-F238E27FC236}">
+                <a16:creationId xmlns:a16="http://schemas.microsoft.com/office/drawing/2014/main" id="{A582CEAB-1E4B-E29D-E603-FEDB1440148A}"/>
+              </a:ext>
+            </a:extLst>
+          </p:cNvPr>
+          <p:cNvSpPr txBox="1"/>
+          <p:nvPr/>
+        </p:nvSpPr>
+        <p:spPr>
+          <a:xfrm>
+            <a:off x="7541659" y="4463124"/>
+            <a:ext cx="505267" cy="323165"/>
+          </a:xfrm>
+          <a:prstGeom prst="rect">
+            <a:avLst/>
+          </a:prstGeom>
+          <a:noFill/>
+        </p:spPr>
+        <p:txBody>
+          <a:bodyPr wrap="none" rtlCol="0">
+            <a:spAutoFit/>
+          </a:bodyPr>
+          <a:lstStyle/>
+          <a:p>
+            <a:r>
+              <a:rPr lang="vi-VN" sz="1500" dirty="0">
+                <a:latin typeface="+mj-lt"/>
+              </a:rPr>
+              <a:t>(15)</a:t>
+            </a:r>
+            <a:endParaRPr lang="en-US" sz="1500" dirty="0">
+              <a:latin typeface="+mj-lt"/>
+            </a:endParaRPr>
+          </a:p>
+        </p:txBody>
+      </p:sp>
+      <p:sp>
+        <p:nvSpPr>
+          <p:cNvPr id="281" name="TextBox 280">
+            <a:extLst>
+              <a:ext uri="{FF2B5EF4-FFF2-40B4-BE49-F238E27FC236}">
+                <a16:creationId xmlns:a16="http://schemas.microsoft.com/office/drawing/2014/main" id="{AFD39DFA-22B4-EA44-2E74-BBD21813E0B0}"/>
+              </a:ext>
+            </a:extLst>
+          </p:cNvPr>
+          <p:cNvSpPr txBox="1"/>
+          <p:nvPr/>
+        </p:nvSpPr>
+        <p:spPr>
+          <a:xfrm>
+            <a:off x="7662944" y="5467984"/>
+            <a:ext cx="777777" cy="323165"/>
+          </a:xfrm>
+          <a:prstGeom prst="rect">
+            <a:avLst/>
+          </a:prstGeom>
+          <a:noFill/>
+        </p:spPr>
+        <p:txBody>
+          <a:bodyPr wrap="none" rtlCol="0">
+            <a:spAutoFit/>
+          </a:bodyPr>
+          <a:lstStyle/>
+          <a:p>
+            <a:r>
+              <a:rPr lang="vi-VN" sz="1500" dirty="0">
+                <a:latin typeface="+mj-lt"/>
+              </a:rPr>
+              <a:t>(16C.1)</a:t>
+            </a:r>
+            <a:endParaRPr lang="en-US" sz="1500" dirty="0">
+              <a:latin typeface="+mj-lt"/>
+            </a:endParaRPr>
+          </a:p>
+        </p:txBody>
+      </p:sp>
+      <p:sp>
+        <p:nvSpPr>
+          <p:cNvPr id="282" name="TextBox 281">
+            <a:extLst>
+              <a:ext uri="{FF2B5EF4-FFF2-40B4-BE49-F238E27FC236}">
+                <a16:creationId xmlns:a16="http://schemas.microsoft.com/office/drawing/2014/main" id="{B26CB8C6-C514-F1CC-14F8-64C42E4A17CB}"/>
+              </a:ext>
+            </a:extLst>
+          </p:cNvPr>
+          <p:cNvSpPr txBox="1"/>
+          <p:nvPr/>
+        </p:nvSpPr>
+        <p:spPr>
+          <a:xfrm>
+            <a:off x="5495381" y="5280955"/>
+            <a:ext cx="633507" cy="323165"/>
+          </a:xfrm>
+          <a:prstGeom prst="rect">
+            <a:avLst/>
+          </a:prstGeom>
+          <a:noFill/>
+        </p:spPr>
+        <p:txBody>
+          <a:bodyPr wrap="none" rtlCol="0">
+            <a:spAutoFit/>
+          </a:bodyPr>
+          <a:lstStyle/>
+          <a:p>
+            <a:r>
+              <a:rPr lang="vi-VN" sz="1500" dirty="0">
+                <a:latin typeface="+mj-lt"/>
+              </a:rPr>
+              <a:t>(16C)</a:t>
+            </a:r>
+            <a:endParaRPr lang="en-US" sz="1500" dirty="0">
+              <a:latin typeface="+mj-lt"/>
+            </a:endParaRPr>
+          </a:p>
+        </p:txBody>
+      </p:sp>
+      <p:sp>
+        <p:nvSpPr>
+          <p:cNvPr id="283" name="TextBox 282">
+            <a:extLst>
+              <a:ext uri="{FF2B5EF4-FFF2-40B4-BE49-F238E27FC236}">
+                <a16:creationId xmlns:a16="http://schemas.microsoft.com/office/drawing/2014/main" id="{1BE24C1E-94FB-6DB9-1C44-235293F6B6B8}"/>
+              </a:ext>
+            </a:extLst>
+          </p:cNvPr>
+          <p:cNvSpPr txBox="1"/>
+          <p:nvPr/>
+        </p:nvSpPr>
+        <p:spPr>
+          <a:xfrm>
+            <a:off x="4523296" y="5273968"/>
+            <a:ext cx="633507" cy="323165"/>
+          </a:xfrm>
+          <a:prstGeom prst="rect">
+            <a:avLst/>
+          </a:prstGeom>
+          <a:noFill/>
+        </p:spPr>
+        <p:txBody>
+          <a:bodyPr wrap="none" rtlCol="0">
+            <a:spAutoFit/>
+          </a:bodyPr>
+          <a:lstStyle/>
+          <a:p>
+            <a:r>
+              <a:rPr lang="vi-VN" sz="1500" dirty="0">
+                <a:latin typeface="+mj-lt"/>
+              </a:rPr>
+              <a:t>(16B)</a:t>
+            </a:r>
+            <a:endParaRPr lang="en-US" sz="1500" dirty="0">
+              <a:latin typeface="+mj-lt"/>
+            </a:endParaRPr>
+          </a:p>
+        </p:txBody>
+      </p:sp>
+      <p:sp>
+        <p:nvSpPr>
+          <p:cNvPr id="284" name="TextBox 283">
+            <a:extLst>
+              <a:ext uri="{FF2B5EF4-FFF2-40B4-BE49-F238E27FC236}">
+                <a16:creationId xmlns:a16="http://schemas.microsoft.com/office/drawing/2014/main" id="{1778CC2D-D547-4D70-FA88-31201997BD24}"/>
+              </a:ext>
+            </a:extLst>
+          </p:cNvPr>
+          <p:cNvSpPr txBox="1"/>
+          <p:nvPr/>
+        </p:nvSpPr>
+        <p:spPr>
+          <a:xfrm>
+            <a:off x="2822873" y="4974908"/>
+            <a:ext cx="777777" cy="323165"/>
+          </a:xfrm>
+          <a:prstGeom prst="rect">
+            <a:avLst/>
+          </a:prstGeom>
+          <a:noFill/>
+        </p:spPr>
+        <p:txBody>
+          <a:bodyPr wrap="none" rtlCol="0">
+            <a:spAutoFit/>
+          </a:bodyPr>
+          <a:lstStyle/>
+          <a:p>
+            <a:r>
+              <a:rPr lang="vi-VN" sz="1500" dirty="0">
+                <a:latin typeface="+mj-lt"/>
+              </a:rPr>
+              <a:t>(16B.1)</a:t>
+            </a:r>
+            <a:endParaRPr lang="en-US" sz="1500" dirty="0">
+              <a:latin typeface="+mj-lt"/>
+            </a:endParaRPr>
+          </a:p>
+        </p:txBody>
+      </p:sp>
+      <p:sp>
+        <p:nvSpPr>
+          <p:cNvPr id="285" name="TextBox 284">
+            <a:extLst>
+              <a:ext uri="{FF2B5EF4-FFF2-40B4-BE49-F238E27FC236}">
+                <a16:creationId xmlns:a16="http://schemas.microsoft.com/office/drawing/2014/main" id="{1CCD28F8-826B-FC07-FB91-28947CEFF281}"/>
+              </a:ext>
+            </a:extLst>
+          </p:cNvPr>
+          <p:cNvSpPr txBox="1"/>
+          <p:nvPr/>
+        </p:nvSpPr>
+        <p:spPr>
+          <a:xfrm>
+            <a:off x="3778002" y="4813325"/>
+            <a:ext cx="644728" cy="323165"/>
+          </a:xfrm>
+          <a:prstGeom prst="rect">
+            <a:avLst/>
+          </a:prstGeom>
+          <a:noFill/>
+        </p:spPr>
+        <p:txBody>
+          <a:bodyPr wrap="none" rtlCol="0">
+            <a:spAutoFit/>
+          </a:bodyPr>
+          <a:lstStyle/>
+          <a:p>
+            <a:r>
+              <a:rPr lang="vi-VN" sz="1500" dirty="0">
+                <a:latin typeface="+mj-lt"/>
+              </a:rPr>
+              <a:t>(16A)</a:t>
+            </a:r>
+            <a:endParaRPr lang="en-US" sz="1500" dirty="0">
+              <a:latin typeface="+mj-lt"/>
+            </a:endParaRPr>
+          </a:p>
+        </p:txBody>
+      </p:sp>
+      <p:sp>
+        <p:nvSpPr>
+          <p:cNvPr id="286" name="TextBox 285">
+            <a:extLst>
+              <a:ext uri="{FF2B5EF4-FFF2-40B4-BE49-F238E27FC236}">
+                <a16:creationId xmlns:a16="http://schemas.microsoft.com/office/drawing/2014/main" id="{99869131-941E-87CF-3E96-63408E7E167F}"/>
+              </a:ext>
+            </a:extLst>
+          </p:cNvPr>
+          <p:cNvSpPr txBox="1"/>
+          <p:nvPr/>
+        </p:nvSpPr>
+        <p:spPr>
+          <a:xfrm>
+            <a:off x="3453648" y="4190239"/>
+            <a:ext cx="644728" cy="323165"/>
+          </a:xfrm>
+          <a:prstGeom prst="rect">
+            <a:avLst/>
+          </a:prstGeom>
+          <a:noFill/>
+        </p:spPr>
+        <p:txBody>
+          <a:bodyPr wrap="none" rtlCol="0">
+            <a:spAutoFit/>
+          </a:bodyPr>
+          <a:lstStyle/>
+          <a:p>
+            <a:r>
+              <a:rPr lang="vi-VN" sz="1500" dirty="0">
+                <a:latin typeface="+mj-lt"/>
+              </a:rPr>
+              <a:t>(16D)</a:t>
+            </a:r>
+            <a:endParaRPr lang="en-US" sz="1500" dirty="0">
+              <a:latin typeface="+mj-lt"/>
+            </a:endParaRPr>
+          </a:p>
+        </p:txBody>
+      </p:sp>
+      <p:sp>
+        <p:nvSpPr>
+          <p:cNvPr id="287" name="TextBox 286">
+            <a:extLst>
+              <a:ext uri="{FF2B5EF4-FFF2-40B4-BE49-F238E27FC236}">
+                <a16:creationId xmlns:a16="http://schemas.microsoft.com/office/drawing/2014/main" id="{ACEC940B-E761-D45B-3C71-5D34A962B899}"/>
+              </a:ext>
+            </a:extLst>
+          </p:cNvPr>
+          <p:cNvSpPr txBox="1"/>
+          <p:nvPr/>
+        </p:nvSpPr>
+        <p:spPr>
+          <a:xfrm>
+            <a:off x="2047329" y="3405299"/>
+            <a:ext cx="505267" cy="323165"/>
+          </a:xfrm>
+          <a:prstGeom prst="rect">
+            <a:avLst/>
+          </a:prstGeom>
+          <a:noFill/>
+        </p:spPr>
+        <p:txBody>
+          <a:bodyPr wrap="none" rtlCol="0">
+            <a:spAutoFit/>
+          </a:bodyPr>
+          <a:lstStyle/>
+          <a:p>
+            <a:r>
+              <a:rPr lang="vi-VN" sz="1500" dirty="0">
+                <a:latin typeface="+mj-lt"/>
+              </a:rPr>
+              <a:t>(18)</a:t>
+            </a:r>
+            <a:endParaRPr lang="en-US" sz="1500" dirty="0">
+              <a:latin typeface="+mj-lt"/>
+            </a:endParaRPr>
+          </a:p>
+        </p:txBody>
+      </p:sp>
+      <p:sp>
+        <p:nvSpPr>
+          <p:cNvPr id="288" name="TextBox 287">
+            <a:extLst>
+              <a:ext uri="{FF2B5EF4-FFF2-40B4-BE49-F238E27FC236}">
+                <a16:creationId xmlns:a16="http://schemas.microsoft.com/office/drawing/2014/main" id="{06088D57-887B-70CF-0080-9E0171F38698}"/>
+              </a:ext>
+            </a:extLst>
+          </p:cNvPr>
+          <p:cNvSpPr txBox="1"/>
+          <p:nvPr/>
+        </p:nvSpPr>
+        <p:spPr>
+          <a:xfrm>
+            <a:off x="2404446" y="2811741"/>
+            <a:ext cx="537327" cy="323165"/>
+          </a:xfrm>
+          <a:prstGeom prst="rect">
+            <a:avLst/>
+          </a:prstGeom>
+          <a:noFill/>
+        </p:spPr>
+        <p:txBody>
+          <a:bodyPr wrap="none" rtlCol="0">
+            <a:spAutoFit/>
+          </a:bodyPr>
+          <a:lstStyle/>
+          <a:p>
+            <a:r>
+              <a:rPr lang="vi-VN" sz="1500" dirty="0">
+                <a:latin typeface="+mj-lt"/>
+              </a:rPr>
+              <a:t>(7B)</a:t>
+            </a:r>
+            <a:endParaRPr lang="en-US" sz="1500" dirty="0">
+              <a:latin typeface="+mj-lt"/>
+            </a:endParaRPr>
+          </a:p>
+        </p:txBody>
+      </p:sp>
+      <p:sp>
+        <p:nvSpPr>
+          <p:cNvPr id="289" name="TextBox 288">
+            <a:extLst>
+              <a:ext uri="{FF2B5EF4-FFF2-40B4-BE49-F238E27FC236}">
+                <a16:creationId xmlns:a16="http://schemas.microsoft.com/office/drawing/2014/main" id="{BE135A3D-4206-F7E3-D6D6-EA7F5BE88389}"/>
+              </a:ext>
+            </a:extLst>
+          </p:cNvPr>
+          <p:cNvSpPr txBox="1"/>
+          <p:nvPr/>
+        </p:nvSpPr>
+        <p:spPr>
+          <a:xfrm>
+            <a:off x="2498213" y="1945116"/>
+            <a:ext cx="548548" cy="323165"/>
+          </a:xfrm>
+          <a:prstGeom prst="rect">
+            <a:avLst/>
+          </a:prstGeom>
+          <a:noFill/>
+        </p:spPr>
+        <p:txBody>
+          <a:bodyPr wrap="none" rtlCol="0">
+            <a:spAutoFit/>
+          </a:bodyPr>
+          <a:lstStyle/>
+          <a:p>
+            <a:r>
+              <a:rPr lang="vi-VN" sz="1500" dirty="0">
+                <a:latin typeface="+mj-lt"/>
+              </a:rPr>
+              <a:t>(7A)</a:t>
+            </a:r>
+            <a:endParaRPr lang="en-US" sz="1500" dirty="0">
+              <a:latin typeface="+mj-lt"/>
+            </a:endParaRPr>
+          </a:p>
+        </p:txBody>
+      </p:sp>
+      <p:sp>
+        <p:nvSpPr>
+          <p:cNvPr id="290" name="TextBox 289">
+            <a:extLst>
+              <a:ext uri="{FF2B5EF4-FFF2-40B4-BE49-F238E27FC236}">
+                <a16:creationId xmlns:a16="http://schemas.microsoft.com/office/drawing/2014/main" id="{A5F7C83A-C0D9-C3BA-39D2-230A1B0A7E84}"/>
+              </a:ext>
+            </a:extLst>
+          </p:cNvPr>
+          <p:cNvSpPr txBox="1"/>
+          <p:nvPr/>
+        </p:nvSpPr>
+        <p:spPr>
+          <a:xfrm>
+            <a:off x="3183240" y="2482755"/>
+            <a:ext cx="649537" cy="323165"/>
+          </a:xfrm>
+          <a:prstGeom prst="rect">
+            <a:avLst/>
+          </a:prstGeom>
+          <a:noFill/>
+        </p:spPr>
+        <p:txBody>
+          <a:bodyPr wrap="none" rtlCol="0">
+            <a:spAutoFit/>
+          </a:bodyPr>
+          <a:lstStyle/>
+          <a:p>
+            <a:r>
+              <a:rPr lang="vi-VN" sz="1500" dirty="0">
+                <a:latin typeface="+mj-lt"/>
+              </a:rPr>
+              <a:t>(17.3)</a:t>
+            </a:r>
+            <a:endParaRPr lang="en-US" sz="1500" dirty="0">
+              <a:latin typeface="+mj-lt"/>
+            </a:endParaRPr>
+          </a:p>
+        </p:txBody>
+      </p:sp>
+      <p:sp>
+        <p:nvSpPr>
+          <p:cNvPr id="291" name="TextBox 290">
+            <a:extLst>
+              <a:ext uri="{FF2B5EF4-FFF2-40B4-BE49-F238E27FC236}">
+                <a16:creationId xmlns:a16="http://schemas.microsoft.com/office/drawing/2014/main" id="{17D0318E-D31A-40CC-A06C-CF44698FAB89}"/>
+              </a:ext>
+            </a:extLst>
+          </p:cNvPr>
+          <p:cNvSpPr txBox="1"/>
+          <p:nvPr/>
+        </p:nvSpPr>
+        <p:spPr>
+          <a:xfrm>
+            <a:off x="3216024" y="3372192"/>
+            <a:ext cx="649537" cy="323165"/>
+          </a:xfrm>
+          <a:prstGeom prst="rect">
+            <a:avLst/>
+          </a:prstGeom>
+          <a:noFill/>
+        </p:spPr>
+        <p:txBody>
+          <a:bodyPr wrap="none" rtlCol="0">
+            <a:spAutoFit/>
+          </a:bodyPr>
+          <a:lstStyle/>
+          <a:p>
+            <a:r>
+              <a:rPr lang="vi-VN" sz="1500" dirty="0">
+                <a:latin typeface="+mj-lt"/>
+              </a:rPr>
+              <a:t>(17.1)</a:t>
+            </a:r>
+            <a:endParaRPr lang="en-US" sz="1500" dirty="0">
+              <a:latin typeface="+mj-lt"/>
+            </a:endParaRPr>
+          </a:p>
+        </p:txBody>
+      </p:sp>
+      <p:sp>
+        <p:nvSpPr>
+          <p:cNvPr id="292" name="TextBox 291">
+            <a:extLst>
+              <a:ext uri="{FF2B5EF4-FFF2-40B4-BE49-F238E27FC236}">
+                <a16:creationId xmlns:a16="http://schemas.microsoft.com/office/drawing/2014/main" id="{19FC8885-F706-6FC7-9244-4DFDBD2CC8B7}"/>
+              </a:ext>
+            </a:extLst>
+          </p:cNvPr>
+          <p:cNvSpPr txBox="1"/>
+          <p:nvPr/>
+        </p:nvSpPr>
+        <p:spPr>
+          <a:xfrm>
+            <a:off x="975341" y="1878291"/>
+            <a:ext cx="681597" cy="323165"/>
+          </a:xfrm>
+          <a:prstGeom prst="rect">
+            <a:avLst/>
+          </a:prstGeom>
+          <a:noFill/>
+        </p:spPr>
+        <p:txBody>
+          <a:bodyPr wrap="none" rtlCol="0">
+            <a:spAutoFit/>
+          </a:bodyPr>
+          <a:lstStyle/>
+          <a:p>
+            <a:r>
+              <a:rPr lang="vi-VN" sz="1500" dirty="0">
+                <a:latin typeface="+mj-lt"/>
+              </a:rPr>
+              <a:t>(7B.1)</a:t>
+            </a:r>
+            <a:endParaRPr lang="en-US" sz="1500" dirty="0">
+              <a:latin typeface="+mj-lt"/>
+            </a:endParaRPr>
+          </a:p>
+        </p:txBody>
+      </p:sp>
+      <p:sp>
+        <p:nvSpPr>
+          <p:cNvPr id="293" name="TextBox 292">
+            <a:extLst>
+              <a:ext uri="{FF2B5EF4-FFF2-40B4-BE49-F238E27FC236}">
+                <a16:creationId xmlns:a16="http://schemas.microsoft.com/office/drawing/2014/main" id="{108AA94C-3148-7A1C-B256-555FEAD43013}"/>
+              </a:ext>
+            </a:extLst>
+          </p:cNvPr>
+          <p:cNvSpPr txBox="1"/>
+          <p:nvPr/>
+        </p:nvSpPr>
+        <p:spPr>
+          <a:xfrm>
+            <a:off x="1635956" y="1017700"/>
+            <a:ext cx="681597" cy="323165"/>
+          </a:xfrm>
+          <a:prstGeom prst="rect">
+            <a:avLst/>
+          </a:prstGeom>
+          <a:noFill/>
+        </p:spPr>
+        <p:txBody>
+          <a:bodyPr wrap="none" rtlCol="0">
+            <a:spAutoFit/>
+          </a:bodyPr>
+          <a:lstStyle/>
+          <a:p>
+            <a:r>
+              <a:rPr lang="vi-VN" sz="1500" dirty="0">
+                <a:latin typeface="+mj-lt"/>
+              </a:rPr>
+              <a:t>(7B.2)</a:t>
+            </a:r>
+            <a:endParaRPr lang="en-US" sz="1500" dirty="0">
+              <a:latin typeface="+mj-lt"/>
+            </a:endParaRPr>
+          </a:p>
+        </p:txBody>
+      </p:sp>
+      <p:sp>
+        <p:nvSpPr>
+          <p:cNvPr id="294" name="TextBox 293">
+            <a:extLst>
+              <a:ext uri="{FF2B5EF4-FFF2-40B4-BE49-F238E27FC236}">
+                <a16:creationId xmlns:a16="http://schemas.microsoft.com/office/drawing/2014/main" id="{261694D5-AB9A-2B9D-606E-BB028723A396}"/>
+              </a:ext>
+            </a:extLst>
+          </p:cNvPr>
+          <p:cNvSpPr txBox="1"/>
+          <p:nvPr/>
+        </p:nvSpPr>
+        <p:spPr>
+          <a:xfrm>
+            <a:off x="3952519" y="1226916"/>
+            <a:ext cx="409086" cy="323165"/>
+          </a:xfrm>
+          <a:prstGeom prst="rect">
+            <a:avLst/>
+          </a:prstGeom>
+          <a:noFill/>
+        </p:spPr>
+        <p:txBody>
+          <a:bodyPr wrap="none" rtlCol="0">
+            <a:spAutoFit/>
+          </a:bodyPr>
+          <a:lstStyle/>
+          <a:p>
+            <a:r>
+              <a:rPr lang="vi-VN" sz="1500" dirty="0">
+                <a:latin typeface="+mj-lt"/>
+              </a:rPr>
+              <a:t>(8)</a:t>
+            </a:r>
+            <a:endParaRPr lang="en-US" sz="1500" dirty="0">
+              <a:latin typeface="+mj-lt"/>
+            </a:endParaRPr>
+          </a:p>
+        </p:txBody>
+      </p:sp>
+      <p:sp>
+        <p:nvSpPr>
+          <p:cNvPr id="295" name="TextBox 294">
+            <a:extLst>
+              <a:ext uri="{FF2B5EF4-FFF2-40B4-BE49-F238E27FC236}">
+                <a16:creationId xmlns:a16="http://schemas.microsoft.com/office/drawing/2014/main" id="{5E87B460-B410-8220-576E-E23E384857B0}"/>
+              </a:ext>
+            </a:extLst>
+          </p:cNvPr>
+          <p:cNvSpPr txBox="1"/>
+          <p:nvPr/>
+        </p:nvSpPr>
+        <p:spPr>
+          <a:xfrm>
+            <a:off x="5910601" y="1226916"/>
+            <a:ext cx="409086" cy="323165"/>
+          </a:xfrm>
+          <a:prstGeom prst="rect">
+            <a:avLst/>
+          </a:prstGeom>
+          <a:noFill/>
+        </p:spPr>
+        <p:txBody>
+          <a:bodyPr wrap="none" rtlCol="0">
+            <a:spAutoFit/>
+          </a:bodyPr>
+          <a:lstStyle/>
+          <a:p>
+            <a:r>
+              <a:rPr lang="vi-VN" sz="1500" dirty="0">
+                <a:latin typeface="+mj-lt"/>
+              </a:rPr>
+              <a:t>(9)</a:t>
+            </a:r>
+            <a:endParaRPr lang="en-US" sz="1500" dirty="0">
+              <a:latin typeface="+mj-lt"/>
+            </a:endParaRPr>
+          </a:p>
+        </p:txBody>
+      </p:sp>
+      <p:sp>
+        <p:nvSpPr>
+          <p:cNvPr id="296" name="TextBox 295">
+            <a:extLst>
+              <a:ext uri="{FF2B5EF4-FFF2-40B4-BE49-F238E27FC236}">
+                <a16:creationId xmlns:a16="http://schemas.microsoft.com/office/drawing/2014/main" id="{8C3CAB20-4800-D1ED-0A69-77E11E886F2B}"/>
+              </a:ext>
+            </a:extLst>
+          </p:cNvPr>
+          <p:cNvSpPr txBox="1"/>
+          <p:nvPr/>
+        </p:nvSpPr>
+        <p:spPr>
+          <a:xfrm>
+            <a:off x="7802764" y="1226916"/>
+            <a:ext cx="649537" cy="323165"/>
+          </a:xfrm>
+          <a:prstGeom prst="rect">
+            <a:avLst/>
+          </a:prstGeom>
+          <a:noFill/>
+        </p:spPr>
+        <p:txBody>
+          <a:bodyPr wrap="none" rtlCol="0">
+            <a:spAutoFit/>
+          </a:bodyPr>
+          <a:lstStyle/>
+          <a:p>
+            <a:r>
+              <a:rPr lang="vi-VN" sz="1500" dirty="0">
+                <a:latin typeface="+mj-lt"/>
+              </a:rPr>
+              <a:t>(10.2)</a:t>
+            </a:r>
+            <a:endParaRPr lang="en-US" sz="1500" dirty="0">
+              <a:latin typeface="+mj-lt"/>
+            </a:endParaRPr>
+          </a:p>
+        </p:txBody>
+      </p:sp>
+      <p:sp>
+        <p:nvSpPr>
+          <p:cNvPr id="297" name="TextBox 296">
+            <a:extLst>
+              <a:ext uri="{FF2B5EF4-FFF2-40B4-BE49-F238E27FC236}">
+                <a16:creationId xmlns:a16="http://schemas.microsoft.com/office/drawing/2014/main" id="{88A04E50-BAC5-0C94-6CDE-0D9CA0329A0A}"/>
+              </a:ext>
+            </a:extLst>
+          </p:cNvPr>
+          <p:cNvSpPr txBox="1"/>
+          <p:nvPr/>
+        </p:nvSpPr>
+        <p:spPr>
+          <a:xfrm>
+            <a:off x="6492996" y="1849413"/>
+            <a:ext cx="649537" cy="323165"/>
+          </a:xfrm>
+          <a:prstGeom prst="rect">
+            <a:avLst/>
+          </a:prstGeom>
+          <a:noFill/>
+        </p:spPr>
+        <p:txBody>
+          <a:bodyPr wrap="none" rtlCol="0">
+            <a:spAutoFit/>
+          </a:bodyPr>
+          <a:lstStyle/>
+          <a:p>
+            <a:r>
+              <a:rPr lang="vi-VN" sz="1500" dirty="0">
+                <a:latin typeface="+mj-lt"/>
+              </a:rPr>
+              <a:t>(10.1)</a:t>
+            </a:r>
+            <a:endParaRPr lang="en-US" sz="1500" dirty="0">
+              <a:latin typeface="+mj-lt"/>
+            </a:endParaRPr>
+          </a:p>
+        </p:txBody>
+      </p:sp>
+      <p:sp>
+        <p:nvSpPr>
+          <p:cNvPr id="298" name="TextBox 297">
+            <a:extLst>
+              <a:ext uri="{FF2B5EF4-FFF2-40B4-BE49-F238E27FC236}">
+                <a16:creationId xmlns:a16="http://schemas.microsoft.com/office/drawing/2014/main" id="{23DD19B5-7E29-83A0-1912-E3B127FD3F04}"/>
+              </a:ext>
+            </a:extLst>
+          </p:cNvPr>
+          <p:cNvSpPr txBox="1"/>
+          <p:nvPr/>
+        </p:nvSpPr>
+        <p:spPr>
+          <a:xfrm>
+            <a:off x="4507260" y="3003508"/>
+            <a:ext cx="649537" cy="323165"/>
+          </a:xfrm>
+          <a:prstGeom prst="rect">
+            <a:avLst/>
+          </a:prstGeom>
+          <a:noFill/>
+        </p:spPr>
+        <p:txBody>
+          <a:bodyPr wrap="none" rtlCol="0">
+            <a:spAutoFit/>
+          </a:bodyPr>
+          <a:lstStyle/>
+          <a:p>
+            <a:r>
+              <a:rPr lang="vi-VN" sz="1500" dirty="0">
+                <a:latin typeface="+mj-lt"/>
+              </a:rPr>
+              <a:t>(17.2)</a:t>
+            </a:r>
+            <a:endParaRPr lang="en-US" sz="1500" dirty="0">
               <a:latin typeface="+mj-lt"/>
             </a:endParaRPr>
           </a:p>

</xml_diff>

<commit_message>
Update file hinh anh: Cap nhat bieu do chuc nang va use case cua chuc nang dang nhap - dang ky, va chuc nang nguoi dung cai dat tuy chon
</commit_message>
<xml_diff>
--- a/documents/hinh_ve_trong_cao_cao_do_an.pptx
+++ b/documents/hinh_ve_trong_cao_cao_do_an.pptx
@@ -5,7 +5,7 @@
     <p:sldMasterId id="2147483648" r:id="rId1"/>
   </p:sldMasterIdLst>
   <p:notesMasterIdLst>
-    <p:notesMasterId r:id="rId13"/>
+    <p:notesMasterId r:id="rId15"/>
   </p:notesMasterIdLst>
   <p:sldIdLst>
     <p:sldId id="263" r:id="rId2"/>
@@ -15,10 +15,12 @@
     <p:sldId id="266" r:id="rId6"/>
     <p:sldId id="267" r:id="rId7"/>
     <p:sldId id="260" r:id="rId8"/>
-    <p:sldId id="269" r:id="rId9"/>
-    <p:sldId id="268" r:id="rId10"/>
-    <p:sldId id="262" r:id="rId11"/>
-    <p:sldId id="270" r:id="rId12"/>
+    <p:sldId id="262" r:id="rId9"/>
+    <p:sldId id="269" r:id="rId10"/>
+    <p:sldId id="268" r:id="rId11"/>
+    <p:sldId id="272" r:id="rId12"/>
+    <p:sldId id="271" r:id="rId13"/>
+    <p:sldId id="270" r:id="rId14"/>
   </p:sldIdLst>
   <p:sldSz cx="12192000" cy="6858000"/>
   <p:notesSz cx="6858000" cy="9144000"/>
@@ -207,7 +209,7 @@
           <a:p>
             <a:fld id="{1699B688-3183-4F5A-8B47-70F70E2DF15B}" type="datetimeFigureOut">
               <a:rPr lang="en-US" smtClean="0"/>
-              <a:t>5/27/2025</a:t>
+              <a:t>5/28/2025</a:t>
             </a:fld>
             <a:endParaRPr lang="en-US"/>
           </a:p>
@@ -562,6 +564,268 @@
 </p:notes>
 </file>
 
+<file path=ppt/notesSlides/notesSlide10.xml><?xml version="1.0" encoding="utf-8"?>
+<p:notes xmlns:a="http://schemas.openxmlformats.org/drawingml/2006/main" xmlns:r="http://schemas.openxmlformats.org/officeDocument/2006/relationships" xmlns:p="http://schemas.openxmlformats.org/presentationml/2006/main">
+  <p:cSld>
+    <p:spTree>
+      <p:nvGrpSpPr>
+        <p:cNvPr id="1" name=""/>
+        <p:cNvGrpSpPr/>
+        <p:nvPr/>
+      </p:nvGrpSpPr>
+      <p:grpSpPr>
+        <a:xfrm>
+          <a:off x="0" y="0"/>
+          <a:ext cx="0" cy="0"/>
+          <a:chOff x="0" y="0"/>
+          <a:chExt cx="0" cy="0"/>
+        </a:xfrm>
+      </p:grpSpPr>
+      <p:sp>
+        <p:nvSpPr>
+          <p:cNvPr id="2" name="Slide Image Placeholder 1"/>
+          <p:cNvSpPr>
+            <a:spLocks noGrp="1" noRot="1" noChangeAspect="1"/>
+          </p:cNvSpPr>
+          <p:nvPr>
+            <p:ph type="sldImg"/>
+          </p:nvPr>
+        </p:nvSpPr>
+        <p:spPr/>
+      </p:sp>
+      <p:sp>
+        <p:nvSpPr>
+          <p:cNvPr id="3" name="Notes Placeholder 2"/>
+          <p:cNvSpPr>
+            <a:spLocks noGrp="1"/>
+          </p:cNvSpPr>
+          <p:nvPr>
+            <p:ph type="body" idx="1"/>
+          </p:nvPr>
+        </p:nvSpPr>
+        <p:spPr/>
+        <p:txBody>
+          <a:bodyPr/>
+          <a:lstStyle/>
+          <a:p>
+            <a:r>
+              <a:rPr lang="en-US"/>
+              <a:t>Biểu đồ use case chức năng người dùng cài đặt tùy chọn</a:t>
+            </a:r>
+          </a:p>
+        </p:txBody>
+      </p:sp>
+      <p:sp>
+        <p:nvSpPr>
+          <p:cNvPr id="4" name="Slide Number Placeholder 3"/>
+          <p:cNvSpPr>
+            <a:spLocks noGrp="1"/>
+          </p:cNvSpPr>
+          <p:nvPr>
+            <p:ph type="sldNum" sz="quarter" idx="5"/>
+          </p:nvPr>
+        </p:nvSpPr>
+        <p:spPr/>
+        <p:txBody>
+          <a:bodyPr/>
+          <a:lstStyle/>
+          <a:p>
+            <a:fld id="{959F4E64-33AD-4E03-A94E-822473CE3B48}" type="slidenum">
+              <a:rPr lang="en-US" smtClean="0"/>
+              <a:t>11</a:t>
+            </a:fld>
+            <a:endParaRPr lang="en-US"/>
+          </a:p>
+        </p:txBody>
+      </p:sp>
+    </p:spTree>
+    <p:extLst>
+      <p:ext uri="{BB962C8B-B14F-4D97-AF65-F5344CB8AC3E}">
+        <p14:creationId xmlns:p14="http://schemas.microsoft.com/office/powerpoint/2010/main" val="1828968213"/>
+      </p:ext>
+    </p:extLst>
+  </p:cSld>
+  <p:clrMapOvr>
+    <a:masterClrMapping/>
+  </p:clrMapOvr>
+</p:notes>
+</file>
+
+<file path=ppt/notesSlides/notesSlide11.xml><?xml version="1.0" encoding="utf-8"?>
+<p:notes xmlns:a="http://schemas.openxmlformats.org/drawingml/2006/main" xmlns:r="http://schemas.openxmlformats.org/officeDocument/2006/relationships" xmlns:p="http://schemas.openxmlformats.org/presentationml/2006/main">
+  <p:cSld>
+    <p:spTree>
+      <p:nvGrpSpPr>
+        <p:cNvPr id="1" name=""/>
+        <p:cNvGrpSpPr/>
+        <p:nvPr/>
+      </p:nvGrpSpPr>
+      <p:grpSpPr>
+        <a:xfrm>
+          <a:off x="0" y="0"/>
+          <a:ext cx="0" cy="0"/>
+          <a:chOff x="0" y="0"/>
+          <a:chExt cx="0" cy="0"/>
+        </a:xfrm>
+      </p:grpSpPr>
+      <p:sp>
+        <p:nvSpPr>
+          <p:cNvPr id="2" name="Slide Image Placeholder 1"/>
+          <p:cNvSpPr>
+            <a:spLocks noGrp="1" noRot="1" noChangeAspect="1"/>
+          </p:cNvSpPr>
+          <p:nvPr>
+            <p:ph type="sldImg"/>
+          </p:nvPr>
+        </p:nvSpPr>
+        <p:spPr/>
+      </p:sp>
+      <p:sp>
+        <p:nvSpPr>
+          <p:cNvPr id="3" name="Notes Placeholder 2"/>
+          <p:cNvSpPr>
+            <a:spLocks noGrp="1"/>
+          </p:cNvSpPr>
+          <p:nvPr>
+            <p:ph type="body" idx="1"/>
+          </p:nvPr>
+        </p:nvSpPr>
+        <p:spPr/>
+        <p:txBody>
+          <a:bodyPr/>
+          <a:lstStyle/>
+          <a:p>
+            <a:r>
+              <a:rPr lang="en-US"/>
+              <a:t>Biểu đồ chức năng người dùng cài đặt tùy chọn</a:t>
+            </a:r>
+          </a:p>
+        </p:txBody>
+      </p:sp>
+      <p:sp>
+        <p:nvSpPr>
+          <p:cNvPr id="4" name="Slide Number Placeholder 3"/>
+          <p:cNvSpPr>
+            <a:spLocks noGrp="1"/>
+          </p:cNvSpPr>
+          <p:nvPr>
+            <p:ph type="sldNum" sz="quarter" idx="5"/>
+          </p:nvPr>
+        </p:nvSpPr>
+        <p:spPr/>
+        <p:txBody>
+          <a:bodyPr/>
+          <a:lstStyle/>
+          <a:p>
+            <a:fld id="{959F4E64-33AD-4E03-A94E-822473CE3B48}" type="slidenum">
+              <a:rPr lang="en-US" smtClean="0"/>
+              <a:t>12</a:t>
+            </a:fld>
+            <a:endParaRPr lang="en-US"/>
+          </a:p>
+        </p:txBody>
+      </p:sp>
+    </p:spTree>
+    <p:extLst>
+      <p:ext uri="{BB962C8B-B14F-4D97-AF65-F5344CB8AC3E}">
+        <p14:creationId xmlns:p14="http://schemas.microsoft.com/office/powerpoint/2010/main" val="2854509630"/>
+      </p:ext>
+    </p:extLst>
+  </p:cSld>
+  <p:clrMapOvr>
+    <a:masterClrMapping/>
+  </p:clrMapOvr>
+</p:notes>
+</file>
+
+<file path=ppt/notesSlides/notesSlide12.xml><?xml version="1.0" encoding="utf-8"?>
+<p:notes xmlns:a="http://schemas.openxmlformats.org/drawingml/2006/main" xmlns:r="http://schemas.openxmlformats.org/officeDocument/2006/relationships" xmlns:p="http://schemas.openxmlformats.org/presentationml/2006/main">
+  <p:cSld>
+    <p:spTree>
+      <p:nvGrpSpPr>
+        <p:cNvPr id="1" name=""/>
+        <p:cNvGrpSpPr/>
+        <p:nvPr/>
+      </p:nvGrpSpPr>
+      <p:grpSpPr>
+        <a:xfrm>
+          <a:off x="0" y="0"/>
+          <a:ext cx="0" cy="0"/>
+          <a:chOff x="0" y="0"/>
+          <a:chExt cx="0" cy="0"/>
+        </a:xfrm>
+      </p:grpSpPr>
+      <p:sp>
+        <p:nvSpPr>
+          <p:cNvPr id="2" name="Slide Image Placeholder 1"/>
+          <p:cNvSpPr>
+            <a:spLocks noGrp="1" noRot="1" noChangeAspect="1"/>
+          </p:cNvSpPr>
+          <p:nvPr>
+            <p:ph type="sldImg"/>
+          </p:nvPr>
+        </p:nvSpPr>
+        <p:spPr/>
+      </p:sp>
+      <p:sp>
+        <p:nvSpPr>
+          <p:cNvPr id="3" name="Notes Placeholder 2"/>
+          <p:cNvSpPr>
+            <a:spLocks noGrp="1"/>
+          </p:cNvSpPr>
+          <p:nvPr>
+            <p:ph type="body" idx="1"/>
+          </p:nvPr>
+        </p:nvSpPr>
+        <p:spPr/>
+        <p:txBody>
+          <a:bodyPr/>
+          <a:lstStyle/>
+          <a:p>
+            <a:r>
+              <a:rPr lang="vi-VN"/>
+              <a:t>Style</a:t>
+            </a:r>
+            <a:endParaRPr lang="en-US"/>
+          </a:p>
+        </p:txBody>
+      </p:sp>
+      <p:sp>
+        <p:nvSpPr>
+          <p:cNvPr id="4" name="Slide Number Placeholder 3"/>
+          <p:cNvSpPr>
+            <a:spLocks noGrp="1"/>
+          </p:cNvSpPr>
+          <p:nvPr>
+            <p:ph type="sldNum" sz="quarter" idx="5"/>
+          </p:nvPr>
+        </p:nvSpPr>
+        <p:spPr/>
+        <p:txBody>
+          <a:bodyPr/>
+          <a:lstStyle/>
+          <a:p>
+            <a:fld id="{959F4E64-33AD-4E03-A94E-822473CE3B48}" type="slidenum">
+              <a:rPr lang="en-US" smtClean="0"/>
+              <a:t>13</a:t>
+            </a:fld>
+            <a:endParaRPr lang="en-US"/>
+          </a:p>
+        </p:txBody>
+      </p:sp>
+    </p:spTree>
+    <p:extLst>
+      <p:ext uri="{BB962C8B-B14F-4D97-AF65-F5344CB8AC3E}">
+        <p14:creationId xmlns:p14="http://schemas.microsoft.com/office/powerpoint/2010/main" val="1436646404"/>
+      </p:ext>
+    </p:extLst>
+  </p:cSld>
+  <p:clrMapOvr>
+    <a:masterClrMapping/>
+  </p:clrMapOvr>
+</p:notes>
+</file>
+
 <file path=ppt/notesSlides/notesSlide2.xml><?xml version="1.0" encoding="utf-8"?>
 <p:notes xmlns:a="http://schemas.openxmlformats.org/drawingml/2006/main" xmlns:r="http://schemas.openxmlformats.org/officeDocument/2006/relationships" xmlns:p="http://schemas.openxmlformats.org/presentationml/2006/main">
   <p:cSld>
@@ -1045,7 +1309,27 @@
           <a:bodyPr/>
           <a:lstStyle/>
           <a:p>
-            <a:endParaRPr lang="en-US"/>
+            <a:pPr marL="0" marR="0" lvl="0" indent="0" algn="l" defTabSz="914400" rtl="0" eaLnBrk="1" fontAlgn="auto" latinLnBrk="0" hangingPunct="1">
+              <a:lnSpc>
+                <a:spcPct val="100000"/>
+              </a:lnSpc>
+              <a:spcBef>
+                <a:spcPts val="0"/>
+              </a:spcBef>
+              <a:spcAft>
+                <a:spcPts val="0"/>
+              </a:spcAft>
+              <a:buClrTx/>
+              <a:buSzTx/>
+              <a:buFontTx/>
+              <a:buNone/>
+              <a:tabLst/>
+              <a:defRPr/>
+            </a:pPr>
+            <a:r>
+              <a:rPr lang="en-US"/>
+              <a:t>Minh họa tại sao phải đánh giá các mô hình embedding</a:t>
+            </a:r>
           </a:p>
         </p:txBody>
       </p:sp>
@@ -1154,7 +1438,7 @@
           <a:p>
             <a:fld id="{959F4E64-33AD-4E03-A94E-822473CE3B48}" type="slidenum">
               <a:rPr lang="en-US" smtClean="0"/>
-              <a:t>8</a:t>
+              <a:t>9</a:t>
             </a:fld>
             <a:endParaRPr lang="en-US"/>
           </a:p>
@@ -1218,10 +1502,9 @@
           <a:lstStyle/>
           <a:p>
             <a:r>
-              <a:rPr lang="vi-VN"/>
-              <a:t>Style</a:t>
+              <a:rPr lang="en-US"/>
+              <a:t>Biểu đồ chức năng đăng nhập – đăng ký</a:t>
             </a:r>
-            <a:endParaRPr lang="en-US"/>
           </a:p>
         </p:txBody>
       </p:sp>
@@ -1242,7 +1525,7 @@
           <a:p>
             <a:fld id="{959F4E64-33AD-4E03-A94E-822473CE3B48}" type="slidenum">
               <a:rPr lang="en-US" smtClean="0"/>
-              <a:t>11</a:t>
+              <a:t>10</a:t>
             </a:fld>
             <a:endParaRPr lang="en-US"/>
           </a:p>
@@ -1251,7 +1534,7 @@
     </p:spTree>
     <p:extLst>
       <p:ext uri="{BB962C8B-B14F-4D97-AF65-F5344CB8AC3E}">
-        <p14:creationId xmlns:p14="http://schemas.microsoft.com/office/powerpoint/2010/main" val="1436646404"/>
+        <p14:creationId xmlns:p14="http://schemas.microsoft.com/office/powerpoint/2010/main" val="3689453927"/>
       </p:ext>
     </p:extLst>
   </p:cSld>
@@ -1408,7 +1691,7 @@
           <a:p>
             <a:fld id="{1274BF1E-CB95-4284-9B4D-720351FD5384}" type="datetimeFigureOut">
               <a:rPr lang="en-US" smtClean="0"/>
-              <a:t>5/27/2025</a:t>
+              <a:t>5/28/2025</a:t>
             </a:fld>
             <a:endParaRPr lang="en-US"/>
           </a:p>
@@ -1606,7 +1889,7 @@
           <a:p>
             <a:fld id="{1274BF1E-CB95-4284-9B4D-720351FD5384}" type="datetimeFigureOut">
               <a:rPr lang="en-US" smtClean="0"/>
-              <a:t>5/27/2025</a:t>
+              <a:t>5/28/2025</a:t>
             </a:fld>
             <a:endParaRPr lang="en-US"/>
           </a:p>
@@ -1814,7 +2097,7 @@
           <a:p>
             <a:fld id="{1274BF1E-CB95-4284-9B4D-720351FD5384}" type="datetimeFigureOut">
               <a:rPr lang="en-US" smtClean="0"/>
-              <a:t>5/27/2025</a:t>
+              <a:t>5/28/2025</a:t>
             </a:fld>
             <a:endParaRPr lang="en-US"/>
           </a:p>
@@ -2012,7 +2295,7 @@
           <a:p>
             <a:fld id="{1274BF1E-CB95-4284-9B4D-720351FD5384}" type="datetimeFigureOut">
               <a:rPr lang="en-US" smtClean="0"/>
-              <a:t>5/27/2025</a:t>
+              <a:t>5/28/2025</a:t>
             </a:fld>
             <a:endParaRPr lang="en-US"/>
           </a:p>
@@ -2287,7 +2570,7 @@
           <a:p>
             <a:fld id="{1274BF1E-CB95-4284-9B4D-720351FD5384}" type="datetimeFigureOut">
               <a:rPr lang="en-US" smtClean="0"/>
-              <a:t>5/27/2025</a:t>
+              <a:t>5/28/2025</a:t>
             </a:fld>
             <a:endParaRPr lang="en-US"/>
           </a:p>
@@ -2552,7 +2835,7 @@
           <a:p>
             <a:fld id="{1274BF1E-CB95-4284-9B4D-720351FD5384}" type="datetimeFigureOut">
               <a:rPr lang="en-US" smtClean="0"/>
-              <a:t>5/27/2025</a:t>
+              <a:t>5/28/2025</a:t>
             </a:fld>
             <a:endParaRPr lang="en-US"/>
           </a:p>
@@ -2964,7 +3247,7 @@
           <a:p>
             <a:fld id="{1274BF1E-CB95-4284-9B4D-720351FD5384}" type="datetimeFigureOut">
               <a:rPr lang="en-US" smtClean="0"/>
-              <a:t>5/27/2025</a:t>
+              <a:t>5/28/2025</a:t>
             </a:fld>
             <a:endParaRPr lang="en-US"/>
           </a:p>
@@ -3105,7 +3388,7 @@
           <a:p>
             <a:fld id="{1274BF1E-CB95-4284-9B4D-720351FD5384}" type="datetimeFigureOut">
               <a:rPr lang="en-US" smtClean="0"/>
-              <a:t>5/27/2025</a:t>
+              <a:t>5/28/2025</a:t>
             </a:fld>
             <a:endParaRPr lang="en-US"/>
           </a:p>
@@ -3218,7 +3501,7 @@
           <a:p>
             <a:fld id="{1274BF1E-CB95-4284-9B4D-720351FD5384}" type="datetimeFigureOut">
               <a:rPr lang="en-US" smtClean="0"/>
-              <a:t>5/27/2025</a:t>
+              <a:t>5/28/2025</a:t>
             </a:fld>
             <a:endParaRPr lang="en-US"/>
           </a:p>
@@ -3529,7 +3812,7 @@
           <a:p>
             <a:fld id="{1274BF1E-CB95-4284-9B4D-720351FD5384}" type="datetimeFigureOut">
               <a:rPr lang="en-US" smtClean="0"/>
-              <a:t>5/27/2025</a:t>
+              <a:t>5/28/2025</a:t>
             </a:fld>
             <a:endParaRPr lang="en-US"/>
           </a:p>
@@ -3817,7 +4100,7 @@
           <a:p>
             <a:fld id="{1274BF1E-CB95-4284-9B4D-720351FD5384}" type="datetimeFigureOut">
               <a:rPr lang="en-US" smtClean="0"/>
-              <a:t>5/27/2025</a:t>
+              <a:t>5/28/2025</a:t>
             </a:fld>
             <a:endParaRPr lang="en-US"/>
           </a:p>
@@ -4058,7 +4341,7 @@
           <a:p>
             <a:fld id="{1274BF1E-CB95-4284-9B4D-720351FD5384}" type="datetimeFigureOut">
               <a:rPr lang="en-US" smtClean="0"/>
-              <a:t>5/27/2025</a:t>
+              <a:t>5/28/2025</a:t>
             </a:fld>
             <a:endParaRPr lang="en-US"/>
           </a:p>
@@ -4507,10 +4790,841 @@
       </p:grpSpPr>
       <p:sp>
         <p:nvSpPr>
-          <p:cNvPr id="2" name="TextBox 1">
+          <p:cNvPr id="104" name="Oval 103">
             <a:extLst>
               <a:ext uri="{FF2B5EF4-FFF2-40B4-BE49-F238E27FC236}">
-                <a16:creationId xmlns:a16="http://schemas.microsoft.com/office/drawing/2014/main" id="{A76BB85E-EAB6-2089-5682-48447CE032A4}"/>
+                <a16:creationId xmlns:a16="http://schemas.microsoft.com/office/drawing/2014/main" id="{CF0DE857-44E6-6D0A-EEB3-B0FD3340E2AE}"/>
+              </a:ext>
+            </a:extLst>
+          </p:cNvPr>
+          <p:cNvSpPr/>
+          <p:nvPr/>
+        </p:nvSpPr>
+        <p:spPr>
+          <a:xfrm>
+            <a:off x="5173980" y="213360"/>
+            <a:ext cx="1844040" cy="838200"/>
+          </a:xfrm>
+          <a:prstGeom prst="ellipse">
+            <a:avLst/>
+          </a:prstGeom>
+          <a:solidFill>
+            <a:schemeClr val="bg2"/>
+          </a:solidFill>
+        </p:spPr>
+        <p:style>
+          <a:lnRef idx="2">
+            <a:schemeClr val="dk1"/>
+          </a:lnRef>
+          <a:fillRef idx="1">
+            <a:schemeClr val="lt1"/>
+          </a:fillRef>
+          <a:effectRef idx="0">
+            <a:schemeClr val="dk1"/>
+          </a:effectRef>
+          <a:fontRef idx="minor">
+            <a:schemeClr val="dk1"/>
+          </a:fontRef>
+        </p:style>
+        <p:txBody>
+          <a:bodyPr rtlCol="0" anchor="ctr"/>
+          <a:lstStyle/>
+          <a:p>
+            <a:pPr algn="ctr"/>
+            <a:r>
+              <a:rPr lang="en-US">
+                <a:latin typeface="Times New Roman" panose="02020603050405020304" pitchFamily="18" charset="0"/>
+                <a:cs typeface="Times New Roman" panose="02020603050405020304" pitchFamily="18" charset="0"/>
+              </a:rPr>
+              <a:t>Bắt đầu</a:t>
+            </a:r>
+          </a:p>
+        </p:txBody>
+      </p:sp>
+      <p:sp>
+        <p:nvSpPr>
+          <p:cNvPr id="105" name="Rectangle: Rounded Corners 104">
+            <a:extLst>
+              <a:ext uri="{FF2B5EF4-FFF2-40B4-BE49-F238E27FC236}">
+                <a16:creationId xmlns:a16="http://schemas.microsoft.com/office/drawing/2014/main" id="{2967CB8B-9291-D8E1-7D10-4BBDB50EC91D}"/>
+              </a:ext>
+            </a:extLst>
+          </p:cNvPr>
+          <p:cNvSpPr/>
+          <p:nvPr/>
+        </p:nvSpPr>
+        <p:spPr>
+          <a:xfrm>
+            <a:off x="7018020" y="1562099"/>
+            <a:ext cx="2941320" cy="1021080"/>
+          </a:xfrm>
+          <a:prstGeom prst="roundRect">
+            <a:avLst/>
+          </a:prstGeom>
+          <a:solidFill>
+            <a:schemeClr val="bg2"/>
+          </a:solidFill>
+        </p:spPr>
+        <p:style>
+          <a:lnRef idx="2">
+            <a:schemeClr val="dk1"/>
+          </a:lnRef>
+          <a:fillRef idx="1">
+            <a:schemeClr val="lt1"/>
+          </a:fillRef>
+          <a:effectRef idx="0">
+            <a:schemeClr val="dk1"/>
+          </a:effectRef>
+          <a:fontRef idx="minor">
+            <a:schemeClr val="dk1"/>
+          </a:fontRef>
+        </p:style>
+        <p:txBody>
+          <a:bodyPr rtlCol="0" anchor="ctr"/>
+          <a:lstStyle/>
+          <a:p>
+            <a:pPr algn="ctr"/>
+            <a:r>
+              <a:rPr lang="en-US">
+                <a:latin typeface="Times New Roman" panose="02020603050405020304" pitchFamily="18" charset="0"/>
+                <a:cs typeface="Times New Roman" panose="02020603050405020304" pitchFamily="18" charset="0"/>
+              </a:rPr>
+              <a:t>Người dùng thực hiện</a:t>
+            </a:r>
+          </a:p>
+          <a:p>
+            <a:pPr algn="ctr"/>
+            <a:r>
+              <a:rPr lang="en-US">
+                <a:latin typeface="Times New Roman" panose="02020603050405020304" pitchFamily="18" charset="0"/>
+                <a:cs typeface="Times New Roman" panose="02020603050405020304" pitchFamily="18" charset="0"/>
+              </a:rPr>
+              <a:t>đăng nhập</a:t>
+            </a:r>
+          </a:p>
+        </p:txBody>
+      </p:sp>
+      <p:sp>
+        <p:nvSpPr>
+          <p:cNvPr id="107" name="Diamond 106">
+            <a:extLst>
+              <a:ext uri="{FF2B5EF4-FFF2-40B4-BE49-F238E27FC236}">
+                <a16:creationId xmlns:a16="http://schemas.microsoft.com/office/drawing/2014/main" id="{65C28E9C-15F4-1130-6089-B5D1F062A39C}"/>
+              </a:ext>
+            </a:extLst>
+          </p:cNvPr>
+          <p:cNvSpPr/>
+          <p:nvPr/>
+        </p:nvSpPr>
+        <p:spPr>
+          <a:xfrm>
+            <a:off x="7018020" y="3093720"/>
+            <a:ext cx="2941320" cy="1844039"/>
+          </a:xfrm>
+          <a:prstGeom prst="diamond">
+            <a:avLst/>
+          </a:prstGeom>
+          <a:solidFill>
+            <a:schemeClr val="bg2"/>
+          </a:solidFill>
+        </p:spPr>
+        <p:style>
+          <a:lnRef idx="2">
+            <a:schemeClr val="dk1"/>
+          </a:lnRef>
+          <a:fillRef idx="1">
+            <a:schemeClr val="lt1"/>
+          </a:fillRef>
+          <a:effectRef idx="0">
+            <a:schemeClr val="dk1"/>
+          </a:effectRef>
+          <a:fontRef idx="minor">
+            <a:schemeClr val="dk1"/>
+          </a:fontRef>
+        </p:style>
+        <p:txBody>
+          <a:bodyPr rtlCol="0" anchor="ctr"/>
+          <a:lstStyle/>
+          <a:p>
+            <a:pPr algn="ctr"/>
+            <a:r>
+              <a:rPr lang="en-US">
+                <a:latin typeface="Times New Roman" panose="02020603050405020304" pitchFamily="18" charset="0"/>
+                <a:cs typeface="Times New Roman" panose="02020603050405020304" pitchFamily="18" charset="0"/>
+              </a:rPr>
+              <a:t>Hệ thống kiểm tra thông tin đăng nhập</a:t>
+            </a:r>
+          </a:p>
+        </p:txBody>
+      </p:sp>
+      <p:sp>
+        <p:nvSpPr>
+          <p:cNvPr id="108" name="Rectangle: Rounded Corners 107">
+            <a:extLst>
+              <a:ext uri="{FF2B5EF4-FFF2-40B4-BE49-F238E27FC236}">
+                <a16:creationId xmlns:a16="http://schemas.microsoft.com/office/drawing/2014/main" id="{917EAA67-5691-42CB-506A-D4AA705CF051}"/>
+              </a:ext>
+            </a:extLst>
+          </p:cNvPr>
+          <p:cNvSpPr/>
+          <p:nvPr/>
+        </p:nvSpPr>
+        <p:spPr>
+          <a:xfrm>
+            <a:off x="4480560" y="5349239"/>
+            <a:ext cx="2941320" cy="1021080"/>
+          </a:xfrm>
+          <a:prstGeom prst="roundRect">
+            <a:avLst/>
+          </a:prstGeom>
+          <a:solidFill>
+            <a:schemeClr val="bg2"/>
+          </a:solidFill>
+        </p:spPr>
+        <p:style>
+          <a:lnRef idx="2">
+            <a:schemeClr val="dk1"/>
+          </a:lnRef>
+          <a:fillRef idx="1">
+            <a:schemeClr val="lt1"/>
+          </a:fillRef>
+          <a:effectRef idx="0">
+            <a:schemeClr val="dk1"/>
+          </a:effectRef>
+          <a:fontRef idx="minor">
+            <a:schemeClr val="dk1"/>
+          </a:fontRef>
+        </p:style>
+        <p:txBody>
+          <a:bodyPr rtlCol="0" anchor="ctr"/>
+          <a:lstStyle/>
+          <a:p>
+            <a:pPr algn="ctr"/>
+            <a:r>
+              <a:rPr lang="en-US">
+                <a:latin typeface="Times New Roman" panose="02020603050405020304" pitchFamily="18" charset="0"/>
+                <a:cs typeface="Times New Roman" panose="02020603050405020304" pitchFamily="18" charset="0"/>
+              </a:rPr>
+              <a:t>Giao diện chat</a:t>
+            </a:r>
+          </a:p>
+        </p:txBody>
+      </p:sp>
+      <p:sp>
+        <p:nvSpPr>
+          <p:cNvPr id="109" name="Rectangle: Rounded Corners 108">
+            <a:extLst>
+              <a:ext uri="{FF2B5EF4-FFF2-40B4-BE49-F238E27FC236}">
+                <a16:creationId xmlns:a16="http://schemas.microsoft.com/office/drawing/2014/main" id="{CE025A2A-FF9A-D931-CD29-CBC668861B50}"/>
+              </a:ext>
+            </a:extLst>
+          </p:cNvPr>
+          <p:cNvSpPr/>
+          <p:nvPr/>
+        </p:nvSpPr>
+        <p:spPr>
+          <a:xfrm>
+            <a:off x="2232660" y="1562099"/>
+            <a:ext cx="2941320" cy="1021080"/>
+          </a:xfrm>
+          <a:prstGeom prst="roundRect">
+            <a:avLst/>
+          </a:prstGeom>
+          <a:solidFill>
+            <a:schemeClr val="bg2"/>
+          </a:solidFill>
+        </p:spPr>
+        <p:style>
+          <a:lnRef idx="2">
+            <a:schemeClr val="dk1"/>
+          </a:lnRef>
+          <a:fillRef idx="1">
+            <a:schemeClr val="lt1"/>
+          </a:fillRef>
+          <a:effectRef idx="0">
+            <a:schemeClr val="dk1"/>
+          </a:effectRef>
+          <a:fontRef idx="minor">
+            <a:schemeClr val="dk1"/>
+          </a:fontRef>
+        </p:style>
+        <p:txBody>
+          <a:bodyPr rtlCol="0" anchor="ctr"/>
+          <a:lstStyle/>
+          <a:p>
+            <a:pPr algn="ctr"/>
+            <a:r>
+              <a:rPr lang="en-US">
+                <a:latin typeface="Times New Roman" panose="02020603050405020304" pitchFamily="18" charset="0"/>
+                <a:cs typeface="Times New Roman" panose="02020603050405020304" pitchFamily="18" charset="0"/>
+              </a:rPr>
+              <a:t>Người dùng thực hiện</a:t>
+            </a:r>
+          </a:p>
+          <a:p>
+            <a:pPr algn="ctr"/>
+            <a:r>
+              <a:rPr lang="en-US">
+                <a:latin typeface="Times New Roman" panose="02020603050405020304" pitchFamily="18" charset="0"/>
+                <a:cs typeface="Times New Roman" panose="02020603050405020304" pitchFamily="18" charset="0"/>
+              </a:rPr>
+              <a:t>đăng ký</a:t>
+            </a:r>
+          </a:p>
+        </p:txBody>
+      </p:sp>
+      <p:sp>
+        <p:nvSpPr>
+          <p:cNvPr id="110" name="Diamond 109">
+            <a:extLst>
+              <a:ext uri="{FF2B5EF4-FFF2-40B4-BE49-F238E27FC236}">
+                <a16:creationId xmlns:a16="http://schemas.microsoft.com/office/drawing/2014/main" id="{0AF7C904-E5A9-2BE1-E5CF-5BBE8BD2C068}"/>
+              </a:ext>
+            </a:extLst>
+          </p:cNvPr>
+          <p:cNvSpPr/>
+          <p:nvPr/>
+        </p:nvSpPr>
+        <p:spPr>
+          <a:xfrm>
+            <a:off x="2232660" y="3093720"/>
+            <a:ext cx="2941320" cy="1844039"/>
+          </a:xfrm>
+          <a:prstGeom prst="diamond">
+            <a:avLst/>
+          </a:prstGeom>
+          <a:solidFill>
+            <a:schemeClr val="bg2"/>
+          </a:solidFill>
+        </p:spPr>
+        <p:style>
+          <a:lnRef idx="2">
+            <a:schemeClr val="dk1"/>
+          </a:lnRef>
+          <a:fillRef idx="1">
+            <a:schemeClr val="lt1"/>
+          </a:fillRef>
+          <a:effectRef idx="0">
+            <a:schemeClr val="dk1"/>
+          </a:effectRef>
+          <a:fontRef idx="minor">
+            <a:schemeClr val="dk1"/>
+          </a:fontRef>
+        </p:style>
+        <p:txBody>
+          <a:bodyPr rtlCol="0" anchor="ctr"/>
+          <a:lstStyle/>
+          <a:p>
+            <a:pPr algn="ctr"/>
+            <a:r>
+              <a:rPr lang="en-US">
+                <a:latin typeface="Times New Roman" panose="02020603050405020304" pitchFamily="18" charset="0"/>
+                <a:cs typeface="Times New Roman" panose="02020603050405020304" pitchFamily="18" charset="0"/>
+              </a:rPr>
+              <a:t>Hệ thống kiểm tra thông tin đăng ký</a:t>
+            </a:r>
+          </a:p>
+        </p:txBody>
+      </p:sp>
+      <p:cxnSp>
+        <p:nvCxnSpPr>
+          <p:cNvPr id="112" name="Connector: Elbow 111">
+            <a:extLst>
+              <a:ext uri="{FF2B5EF4-FFF2-40B4-BE49-F238E27FC236}">
+                <a16:creationId xmlns:a16="http://schemas.microsoft.com/office/drawing/2014/main" id="{8CF5B753-1868-E16A-BB06-838D7C4EC81C}"/>
+              </a:ext>
+            </a:extLst>
+          </p:cNvPr>
+          <p:cNvCxnSpPr>
+            <a:cxnSpLocks/>
+            <a:stCxn id="104" idx="2"/>
+            <a:endCxn id="109" idx="0"/>
+          </p:cNvCxnSpPr>
+          <p:nvPr/>
+        </p:nvCxnSpPr>
+        <p:spPr>
+          <a:xfrm rot="10800000" flipV="1">
+            <a:off x="3703320" y="632459"/>
+            <a:ext cx="1470660" cy="929639"/>
+          </a:xfrm>
+          <a:prstGeom prst="bentConnector2">
+            <a:avLst/>
+          </a:prstGeom>
+          <a:ln>
+            <a:tailEnd type="triangle"/>
+          </a:ln>
+        </p:spPr>
+        <p:style>
+          <a:lnRef idx="2">
+            <a:schemeClr val="dk1"/>
+          </a:lnRef>
+          <a:fillRef idx="0">
+            <a:schemeClr val="dk1"/>
+          </a:fillRef>
+          <a:effectRef idx="1">
+            <a:schemeClr val="dk1"/>
+          </a:effectRef>
+          <a:fontRef idx="minor">
+            <a:schemeClr val="tx1"/>
+          </a:fontRef>
+        </p:style>
+      </p:cxnSp>
+      <p:cxnSp>
+        <p:nvCxnSpPr>
+          <p:cNvPr id="114" name="Connector: Elbow 113">
+            <a:extLst>
+              <a:ext uri="{FF2B5EF4-FFF2-40B4-BE49-F238E27FC236}">
+                <a16:creationId xmlns:a16="http://schemas.microsoft.com/office/drawing/2014/main" id="{EE05216D-7A3A-7C1A-2BF4-0404AA31F361}"/>
+              </a:ext>
+            </a:extLst>
+          </p:cNvPr>
+          <p:cNvCxnSpPr>
+            <a:cxnSpLocks/>
+            <a:stCxn id="104" idx="6"/>
+            <a:endCxn id="105" idx="0"/>
+          </p:cNvCxnSpPr>
+          <p:nvPr/>
+        </p:nvCxnSpPr>
+        <p:spPr>
+          <a:xfrm>
+            <a:off x="7018020" y="632460"/>
+            <a:ext cx="1470660" cy="929639"/>
+          </a:xfrm>
+          <a:prstGeom prst="bentConnector2">
+            <a:avLst/>
+          </a:prstGeom>
+          <a:ln>
+            <a:tailEnd type="triangle"/>
+          </a:ln>
+        </p:spPr>
+        <p:style>
+          <a:lnRef idx="2">
+            <a:schemeClr val="dk1"/>
+          </a:lnRef>
+          <a:fillRef idx="0">
+            <a:schemeClr val="dk1"/>
+          </a:fillRef>
+          <a:effectRef idx="1">
+            <a:schemeClr val="dk1"/>
+          </a:effectRef>
+          <a:fontRef idx="minor">
+            <a:schemeClr val="tx1"/>
+          </a:fontRef>
+        </p:style>
+      </p:cxnSp>
+      <p:cxnSp>
+        <p:nvCxnSpPr>
+          <p:cNvPr id="116" name="Straight Arrow Connector 115">
+            <a:extLst>
+              <a:ext uri="{FF2B5EF4-FFF2-40B4-BE49-F238E27FC236}">
+                <a16:creationId xmlns:a16="http://schemas.microsoft.com/office/drawing/2014/main" id="{70DDAD2B-2F3D-821C-7BAE-F7D41AF5CC02}"/>
+              </a:ext>
+            </a:extLst>
+          </p:cNvPr>
+          <p:cNvCxnSpPr>
+            <a:stCxn id="109" idx="2"/>
+            <a:endCxn id="110" idx="0"/>
+          </p:cNvCxnSpPr>
+          <p:nvPr/>
+        </p:nvCxnSpPr>
+        <p:spPr>
+          <a:xfrm>
+            <a:off x="3703320" y="2583179"/>
+            <a:ext cx="0" cy="510541"/>
+          </a:xfrm>
+          <a:prstGeom prst="straightConnector1">
+            <a:avLst/>
+          </a:prstGeom>
+          <a:ln>
+            <a:solidFill>
+              <a:schemeClr val="tx1"/>
+            </a:solidFill>
+            <a:tailEnd type="triangle"/>
+          </a:ln>
+        </p:spPr>
+        <p:style>
+          <a:lnRef idx="2">
+            <a:schemeClr val="accent1"/>
+          </a:lnRef>
+          <a:fillRef idx="0">
+            <a:schemeClr val="accent1"/>
+          </a:fillRef>
+          <a:effectRef idx="1">
+            <a:schemeClr val="accent1"/>
+          </a:effectRef>
+          <a:fontRef idx="minor">
+            <a:schemeClr val="tx1"/>
+          </a:fontRef>
+        </p:style>
+      </p:cxnSp>
+      <p:cxnSp>
+        <p:nvCxnSpPr>
+          <p:cNvPr id="118" name="Straight Arrow Connector 117">
+            <a:extLst>
+              <a:ext uri="{FF2B5EF4-FFF2-40B4-BE49-F238E27FC236}">
+                <a16:creationId xmlns:a16="http://schemas.microsoft.com/office/drawing/2014/main" id="{C4184C5E-118A-D8CE-415A-C46980B8FED4}"/>
+              </a:ext>
+            </a:extLst>
+          </p:cNvPr>
+          <p:cNvCxnSpPr>
+            <a:stCxn id="105" idx="2"/>
+            <a:endCxn id="107" idx="0"/>
+          </p:cNvCxnSpPr>
+          <p:nvPr/>
+        </p:nvCxnSpPr>
+        <p:spPr>
+          <a:xfrm>
+            <a:off x="8488680" y="2583179"/>
+            <a:ext cx="0" cy="510541"/>
+          </a:xfrm>
+          <a:prstGeom prst="straightConnector1">
+            <a:avLst/>
+          </a:prstGeom>
+          <a:ln>
+            <a:solidFill>
+              <a:schemeClr val="tx1"/>
+            </a:solidFill>
+            <a:tailEnd type="triangle"/>
+          </a:ln>
+        </p:spPr>
+        <p:style>
+          <a:lnRef idx="2">
+            <a:schemeClr val="accent1"/>
+          </a:lnRef>
+          <a:fillRef idx="0">
+            <a:schemeClr val="accent1"/>
+          </a:fillRef>
+          <a:effectRef idx="1">
+            <a:schemeClr val="accent1"/>
+          </a:effectRef>
+          <a:fontRef idx="minor">
+            <a:schemeClr val="tx1"/>
+          </a:fontRef>
+        </p:style>
+      </p:cxnSp>
+      <p:cxnSp>
+        <p:nvCxnSpPr>
+          <p:cNvPr id="120" name="Connector: Elbow 119">
+            <a:extLst>
+              <a:ext uri="{FF2B5EF4-FFF2-40B4-BE49-F238E27FC236}">
+                <a16:creationId xmlns:a16="http://schemas.microsoft.com/office/drawing/2014/main" id="{7A0DA4CF-935D-591E-95A0-825E2860BC7C}"/>
+              </a:ext>
+            </a:extLst>
+          </p:cNvPr>
+          <p:cNvCxnSpPr>
+            <a:stCxn id="110" idx="1"/>
+            <a:endCxn id="109" idx="1"/>
+          </p:cNvCxnSpPr>
+          <p:nvPr/>
+        </p:nvCxnSpPr>
+        <p:spPr>
+          <a:xfrm rot="10800000">
+            <a:off x="2232660" y="2072640"/>
+            <a:ext cx="12700" cy="1943101"/>
+          </a:xfrm>
+          <a:prstGeom prst="bentConnector3">
+            <a:avLst>
+              <a:gd name="adj1" fmla="val 7440000"/>
+            </a:avLst>
+          </a:prstGeom>
+          <a:ln>
+            <a:solidFill>
+              <a:schemeClr val="tx1"/>
+            </a:solidFill>
+            <a:tailEnd type="triangle"/>
+          </a:ln>
+        </p:spPr>
+        <p:style>
+          <a:lnRef idx="2">
+            <a:schemeClr val="accent1"/>
+          </a:lnRef>
+          <a:fillRef idx="0">
+            <a:schemeClr val="accent1"/>
+          </a:fillRef>
+          <a:effectRef idx="1">
+            <a:schemeClr val="accent1"/>
+          </a:effectRef>
+          <a:fontRef idx="minor">
+            <a:schemeClr val="tx1"/>
+          </a:fontRef>
+        </p:style>
+      </p:cxnSp>
+      <p:cxnSp>
+        <p:nvCxnSpPr>
+          <p:cNvPr id="123" name="Connector: Elbow 122">
+            <a:extLst>
+              <a:ext uri="{FF2B5EF4-FFF2-40B4-BE49-F238E27FC236}">
+                <a16:creationId xmlns:a16="http://schemas.microsoft.com/office/drawing/2014/main" id="{9E4DCF95-BAC0-E560-4D39-5F26EAB02355}"/>
+              </a:ext>
+            </a:extLst>
+          </p:cNvPr>
+          <p:cNvCxnSpPr>
+            <a:stCxn id="107" idx="3"/>
+            <a:endCxn id="105" idx="3"/>
+          </p:cNvCxnSpPr>
+          <p:nvPr/>
+        </p:nvCxnSpPr>
+        <p:spPr>
+          <a:xfrm flipV="1">
+            <a:off x="9959340" y="2072639"/>
+            <a:ext cx="12700" cy="1943101"/>
+          </a:xfrm>
+          <a:prstGeom prst="bentConnector3">
+            <a:avLst>
+              <a:gd name="adj1" fmla="val 6840000"/>
+            </a:avLst>
+          </a:prstGeom>
+          <a:ln>
+            <a:solidFill>
+              <a:schemeClr val="tx1"/>
+            </a:solidFill>
+            <a:tailEnd type="triangle"/>
+          </a:ln>
+        </p:spPr>
+        <p:style>
+          <a:lnRef idx="2">
+            <a:schemeClr val="accent1"/>
+          </a:lnRef>
+          <a:fillRef idx="0">
+            <a:schemeClr val="accent1"/>
+          </a:fillRef>
+          <a:effectRef idx="1">
+            <a:schemeClr val="accent1"/>
+          </a:effectRef>
+          <a:fontRef idx="minor">
+            <a:schemeClr val="tx1"/>
+          </a:fontRef>
+        </p:style>
+      </p:cxnSp>
+      <p:cxnSp>
+        <p:nvCxnSpPr>
+          <p:cNvPr id="126" name="Connector: Elbow 125">
+            <a:extLst>
+              <a:ext uri="{FF2B5EF4-FFF2-40B4-BE49-F238E27FC236}">
+                <a16:creationId xmlns:a16="http://schemas.microsoft.com/office/drawing/2014/main" id="{2150CE8E-6185-F2D0-8799-892E184E3001}"/>
+              </a:ext>
+            </a:extLst>
+          </p:cNvPr>
+          <p:cNvCxnSpPr>
+            <a:stCxn id="110" idx="2"/>
+            <a:endCxn id="108" idx="0"/>
+          </p:cNvCxnSpPr>
+          <p:nvPr/>
+        </p:nvCxnSpPr>
+        <p:spPr>
+          <a:xfrm rot="16200000" flipH="1">
+            <a:off x="4621530" y="4019549"/>
+            <a:ext cx="411480" cy="2247900"/>
+          </a:xfrm>
+          <a:prstGeom prst="bentConnector3">
+            <a:avLst/>
+          </a:prstGeom>
+          <a:ln>
+            <a:tailEnd type="triangle"/>
+          </a:ln>
+        </p:spPr>
+        <p:style>
+          <a:lnRef idx="2">
+            <a:schemeClr val="dk1"/>
+          </a:lnRef>
+          <a:fillRef idx="0">
+            <a:schemeClr val="dk1"/>
+          </a:fillRef>
+          <a:effectRef idx="1">
+            <a:schemeClr val="dk1"/>
+          </a:effectRef>
+          <a:fontRef idx="minor">
+            <a:schemeClr val="tx1"/>
+          </a:fontRef>
+        </p:style>
+      </p:cxnSp>
+      <p:cxnSp>
+        <p:nvCxnSpPr>
+          <p:cNvPr id="128" name="Connector: Elbow 127">
+            <a:extLst>
+              <a:ext uri="{FF2B5EF4-FFF2-40B4-BE49-F238E27FC236}">
+                <a16:creationId xmlns:a16="http://schemas.microsoft.com/office/drawing/2014/main" id="{8C95E6B3-8930-91B1-4021-9CB4F561705F}"/>
+              </a:ext>
+            </a:extLst>
+          </p:cNvPr>
+          <p:cNvCxnSpPr>
+            <a:stCxn id="107" idx="2"/>
+            <a:endCxn id="108" idx="0"/>
+          </p:cNvCxnSpPr>
+          <p:nvPr/>
+        </p:nvCxnSpPr>
+        <p:spPr>
+          <a:xfrm rot="5400000">
+            <a:off x="7014210" y="3874769"/>
+            <a:ext cx="411480" cy="2537460"/>
+          </a:xfrm>
+          <a:prstGeom prst="bentConnector3">
+            <a:avLst/>
+          </a:prstGeom>
+          <a:ln>
+            <a:tailEnd type="triangle"/>
+          </a:ln>
+        </p:spPr>
+        <p:style>
+          <a:lnRef idx="2">
+            <a:schemeClr val="dk1"/>
+          </a:lnRef>
+          <a:fillRef idx="0">
+            <a:schemeClr val="dk1"/>
+          </a:fillRef>
+          <a:effectRef idx="1">
+            <a:schemeClr val="dk1"/>
+          </a:effectRef>
+          <a:fontRef idx="minor">
+            <a:schemeClr val="tx1"/>
+          </a:fontRef>
+        </p:style>
+      </p:cxnSp>
+      <p:sp>
+        <p:nvSpPr>
+          <p:cNvPr id="129" name="Rectangle: Rounded Corners 128">
+            <a:extLst>
+              <a:ext uri="{FF2B5EF4-FFF2-40B4-BE49-F238E27FC236}">
+                <a16:creationId xmlns:a16="http://schemas.microsoft.com/office/drawing/2014/main" id="{1D24CF0B-21FE-19B8-B6A2-F1275DCDDE20}"/>
+              </a:ext>
+            </a:extLst>
+          </p:cNvPr>
+          <p:cNvSpPr/>
+          <p:nvPr/>
+        </p:nvSpPr>
+        <p:spPr>
+          <a:xfrm>
+            <a:off x="8488680" y="5661659"/>
+            <a:ext cx="1844040" cy="396240"/>
+          </a:xfrm>
+          <a:prstGeom prst="roundRect">
+            <a:avLst/>
+          </a:prstGeom>
+          <a:solidFill>
+            <a:schemeClr val="bg2"/>
+          </a:solidFill>
+        </p:spPr>
+        <p:style>
+          <a:lnRef idx="2">
+            <a:schemeClr val="dk1"/>
+          </a:lnRef>
+          <a:fillRef idx="1">
+            <a:schemeClr val="lt1"/>
+          </a:fillRef>
+          <a:effectRef idx="0">
+            <a:schemeClr val="dk1"/>
+          </a:effectRef>
+          <a:fontRef idx="minor">
+            <a:schemeClr val="dk1"/>
+          </a:fontRef>
+        </p:style>
+        <p:txBody>
+          <a:bodyPr rtlCol="0" anchor="ctr"/>
+          <a:lstStyle/>
+          <a:p>
+            <a:pPr algn="ctr"/>
+            <a:r>
+              <a:rPr lang="en-US">
+                <a:latin typeface="Times New Roman" panose="02020603050405020304" pitchFamily="18" charset="0"/>
+                <a:cs typeface="Times New Roman" panose="02020603050405020304" pitchFamily="18" charset="0"/>
+              </a:rPr>
+              <a:t>Đăng xuất</a:t>
+            </a:r>
+          </a:p>
+        </p:txBody>
+      </p:sp>
+      <p:cxnSp>
+        <p:nvCxnSpPr>
+          <p:cNvPr id="131" name="Straight Arrow Connector 130">
+            <a:extLst>
+              <a:ext uri="{FF2B5EF4-FFF2-40B4-BE49-F238E27FC236}">
+                <a16:creationId xmlns:a16="http://schemas.microsoft.com/office/drawing/2014/main" id="{FEDDF2BB-202E-1627-1825-D8223BED3674}"/>
+              </a:ext>
+            </a:extLst>
+          </p:cNvPr>
+          <p:cNvCxnSpPr>
+            <a:stCxn id="108" idx="3"/>
+            <a:endCxn id="129" idx="1"/>
+          </p:cNvCxnSpPr>
+          <p:nvPr/>
+        </p:nvCxnSpPr>
+        <p:spPr>
+          <a:xfrm>
+            <a:off x="7421880" y="5859779"/>
+            <a:ext cx="1066800" cy="0"/>
+          </a:xfrm>
+          <a:prstGeom prst="straightConnector1">
+            <a:avLst/>
+          </a:prstGeom>
+          <a:ln>
+            <a:tailEnd type="triangle"/>
+          </a:ln>
+        </p:spPr>
+        <p:style>
+          <a:lnRef idx="2">
+            <a:schemeClr val="dk1"/>
+          </a:lnRef>
+          <a:fillRef idx="0">
+            <a:schemeClr val="dk1"/>
+          </a:fillRef>
+          <a:effectRef idx="1">
+            <a:schemeClr val="dk1"/>
+          </a:effectRef>
+          <a:fontRef idx="minor">
+            <a:schemeClr val="tx1"/>
+          </a:fontRef>
+        </p:style>
+      </p:cxnSp>
+      <p:cxnSp>
+        <p:nvCxnSpPr>
+          <p:cNvPr id="134" name="Connector: Elbow 133">
+            <a:extLst>
+              <a:ext uri="{FF2B5EF4-FFF2-40B4-BE49-F238E27FC236}">
+                <a16:creationId xmlns:a16="http://schemas.microsoft.com/office/drawing/2014/main" id="{E4E36DCD-EE28-38FC-394B-2D234BE1BEE8}"/>
+              </a:ext>
+            </a:extLst>
+          </p:cNvPr>
+          <p:cNvCxnSpPr>
+            <a:stCxn id="129" idx="3"/>
+            <a:endCxn id="105" idx="3"/>
+          </p:cNvCxnSpPr>
+          <p:nvPr/>
+        </p:nvCxnSpPr>
+        <p:spPr>
+          <a:xfrm flipH="1" flipV="1">
+            <a:off x="9959340" y="2072639"/>
+            <a:ext cx="373380" cy="3787140"/>
+          </a:xfrm>
+          <a:prstGeom prst="bentConnector3">
+            <a:avLst>
+              <a:gd name="adj1" fmla="val -132653"/>
+            </a:avLst>
+          </a:prstGeom>
+          <a:ln>
+            <a:tailEnd type="triangle"/>
+          </a:ln>
+        </p:spPr>
+        <p:style>
+          <a:lnRef idx="2">
+            <a:schemeClr val="dk1"/>
+          </a:lnRef>
+          <a:fillRef idx="0">
+            <a:schemeClr val="dk1"/>
+          </a:fillRef>
+          <a:effectRef idx="1">
+            <a:schemeClr val="dk1"/>
+          </a:effectRef>
+          <a:fontRef idx="minor">
+            <a:schemeClr val="tx1"/>
+          </a:fontRef>
+        </p:style>
+      </p:cxnSp>
+      <p:sp>
+        <p:nvSpPr>
+          <p:cNvPr id="139" name="TextBox 138">
+            <a:extLst>
+              <a:ext uri="{FF2B5EF4-FFF2-40B4-BE49-F238E27FC236}">
+                <a16:creationId xmlns:a16="http://schemas.microsoft.com/office/drawing/2014/main" id="{F50CF43A-BDB9-AE31-7220-74AF57532A00}"/>
               </a:ext>
             </a:extLst>
           </p:cNvPr>
@@ -4519,8 +5633,8 @@
         </p:nvSpPr>
         <p:spPr>
           <a:xfrm>
-            <a:off x="612648" y="795528"/>
-            <a:ext cx="8497839" cy="3693319"/>
+            <a:off x="1455420" y="4015739"/>
+            <a:ext cx="793807" cy="584775"/>
           </a:xfrm>
           <a:prstGeom prst="rect">
             <a:avLst/>
@@ -4533,139 +5647,532 @@
           </a:bodyPr>
           <a:lstStyle/>
           <a:p>
-            <a:pPr marL="285750" indent="-285750">
-              <a:buFontTx/>
-              <a:buChar char="-"/>
-            </a:pPr>
             <a:r>
-              <a:rPr lang="vi-VN"/>
-              <a:t>Chức năng đăng nhập/đăng xuất: biểu đồ chức năng, usecase, tuần tự</a:t>
+              <a:rPr lang="en-US" sz="1600">
+                <a:latin typeface="Times New Roman" panose="02020603050405020304" pitchFamily="18" charset="0"/>
+                <a:cs typeface="Times New Roman" panose="02020603050405020304" pitchFamily="18" charset="0"/>
+              </a:rPr>
+              <a:t>Không </a:t>
             </a:r>
           </a:p>
           <a:p>
-            <a:pPr marL="285750" indent="-285750">
-              <a:buFontTx/>
-              <a:buChar char="-"/>
-            </a:pPr>
             <a:r>
-              <a:rPr lang="vi-VN"/>
-              <a:t>Chức năng cài đặt người dùng tùy chọn: biểu đồ  chức năng, usecase, tuần tự</a:t>
+              <a:rPr lang="en-US" sz="1600">
+                <a:latin typeface="Times New Roman" panose="02020603050405020304" pitchFamily="18" charset="0"/>
+                <a:cs typeface="Times New Roman" panose="02020603050405020304" pitchFamily="18" charset="0"/>
+              </a:rPr>
+              <a:t>hợp lệ</a:t>
             </a:r>
           </a:p>
-          <a:p>
-            <a:pPr marL="285750" indent="-285750">
-              <a:buFontTx/>
-              <a:buChar char="-"/>
-            </a:pPr>
+        </p:txBody>
+      </p:sp>
+      <p:sp>
+        <p:nvSpPr>
+          <p:cNvPr id="140" name="TextBox 139">
+            <a:extLst>
+              <a:ext uri="{FF2B5EF4-FFF2-40B4-BE49-F238E27FC236}">
+                <a16:creationId xmlns:a16="http://schemas.microsoft.com/office/drawing/2014/main" id="{02E7496E-0415-ED06-196F-D7DFC7BB94E8}"/>
+              </a:ext>
+            </a:extLst>
+          </p:cNvPr>
+          <p:cNvSpPr txBox="1"/>
+          <p:nvPr/>
+        </p:nvSpPr>
+        <p:spPr>
+          <a:xfrm>
+            <a:off x="9905359" y="4015739"/>
+            <a:ext cx="793807" cy="584775"/>
+          </a:xfrm>
+          <a:prstGeom prst="rect">
+            <a:avLst/>
+          </a:prstGeom>
+          <a:noFill/>
+        </p:spPr>
+        <p:txBody>
+          <a:bodyPr wrap="none" rtlCol="0">
+            <a:spAutoFit/>
+          </a:bodyPr>
+          <a:lstStyle/>
+          <a:p>
             <a:r>
-              <a:rPr lang="vi-VN"/>
-              <a:t>Chức năng khởi tạo starter: biểu đồ tuần tự</a:t>
+              <a:rPr lang="en-US" sz="1600">
+                <a:latin typeface="Times New Roman" panose="02020603050405020304" pitchFamily="18" charset="0"/>
+                <a:cs typeface="Times New Roman" panose="02020603050405020304" pitchFamily="18" charset="0"/>
+              </a:rPr>
+              <a:t>Không </a:t>
             </a:r>
           </a:p>
           <a:p>
-            <a:pPr marL="285750" indent="-285750">
-              <a:buFontTx/>
-              <a:buChar char="-"/>
-            </a:pPr>
             <a:r>
-              <a:rPr lang="vi-VN"/>
-              <a:t>Chức năng trò chuyện văn bản: biểu đồ chức năng, usecase, tuần tự</a:t>
+              <a:rPr lang="en-US" sz="1600">
+                <a:latin typeface="Times New Roman" panose="02020603050405020304" pitchFamily="18" charset="0"/>
+                <a:cs typeface="Times New Roman" panose="02020603050405020304" pitchFamily="18" charset="0"/>
+              </a:rPr>
+              <a:t>hợp lệ</a:t>
             </a:r>
           </a:p>
-          <a:p>
-            <a:pPr marL="285750" indent="-285750">
-              <a:buFontTx/>
-              <a:buChar char="-"/>
-            </a:pPr>
+        </p:txBody>
+      </p:sp>
+      <p:sp>
+        <p:nvSpPr>
+          <p:cNvPr id="141" name="TextBox 140">
+            <a:extLst>
+              <a:ext uri="{FF2B5EF4-FFF2-40B4-BE49-F238E27FC236}">
+                <a16:creationId xmlns:a16="http://schemas.microsoft.com/office/drawing/2014/main" id="{B69CA317-E04F-AF31-18FE-AA25F6B474D7}"/>
+              </a:ext>
+            </a:extLst>
+          </p:cNvPr>
+          <p:cNvSpPr txBox="1"/>
+          <p:nvPr/>
+        </p:nvSpPr>
+        <p:spPr>
+          <a:xfrm>
+            <a:off x="3703320" y="5143498"/>
+            <a:ext cx="763351" cy="338554"/>
+          </a:xfrm>
+          <a:prstGeom prst="rect">
+            <a:avLst/>
+          </a:prstGeom>
+          <a:noFill/>
+        </p:spPr>
+        <p:txBody>
+          <a:bodyPr wrap="none" rtlCol="0">
+            <a:spAutoFit/>
+          </a:bodyPr>
+          <a:lstStyle/>
+          <a:p>
             <a:r>
-              <a:rPr lang="vi-VN"/>
-              <a:t>Chức năng trò chuyện âm thanh: chức năng, usecase, tuần tự</a:t>
+              <a:rPr lang="en-US" sz="1600">
+                <a:latin typeface="Times New Roman" panose="02020603050405020304" pitchFamily="18" charset="0"/>
+                <a:cs typeface="Times New Roman" panose="02020603050405020304" pitchFamily="18" charset="0"/>
+              </a:rPr>
+              <a:t>Hợp lệ</a:t>
             </a:r>
           </a:p>
-          <a:p>
-            <a:pPr marL="285750" indent="-285750">
-              <a:buFontTx/>
-              <a:buChar char="-"/>
-            </a:pPr>
+        </p:txBody>
+      </p:sp>
+      <p:sp>
+        <p:nvSpPr>
+          <p:cNvPr id="142" name="TextBox 141">
+            <a:extLst>
+              <a:ext uri="{FF2B5EF4-FFF2-40B4-BE49-F238E27FC236}">
+                <a16:creationId xmlns:a16="http://schemas.microsoft.com/office/drawing/2014/main" id="{94CE0EB5-C05E-0024-9F02-473C547E437C}"/>
+              </a:ext>
+            </a:extLst>
+          </p:cNvPr>
+          <p:cNvSpPr txBox="1"/>
+          <p:nvPr/>
+        </p:nvSpPr>
+        <p:spPr>
+          <a:xfrm>
+            <a:off x="7725329" y="5143498"/>
+            <a:ext cx="763351" cy="338554"/>
+          </a:xfrm>
+          <a:prstGeom prst="rect">
+            <a:avLst/>
+          </a:prstGeom>
+          <a:noFill/>
+        </p:spPr>
+        <p:txBody>
+          <a:bodyPr wrap="none" rtlCol="0">
+            <a:spAutoFit/>
+          </a:bodyPr>
+          <a:lstStyle/>
+          <a:p>
             <a:r>
-              <a:rPr lang="vi-VN"/>
-              <a:t>Chức năng tăng cường trí nhớ hội thoại: chức năng, usecase, tuần tự</a:t>
+              <a:rPr lang="en-US" sz="1600">
+                <a:latin typeface="Times New Roman" panose="02020603050405020304" pitchFamily="18" charset="0"/>
+                <a:cs typeface="Times New Roman" panose="02020603050405020304" pitchFamily="18" charset="0"/>
+              </a:rPr>
+              <a:t>Hợp lệ</a:t>
             </a:r>
           </a:p>
-          <a:p>
-            <a:pPr marL="285750" indent="-285750">
-              <a:buFontTx/>
-              <a:buChar char="-"/>
-            </a:pPr>
+        </p:txBody>
+      </p:sp>
+      <p:sp>
+        <p:nvSpPr>
+          <p:cNvPr id="143" name="TextBox 142">
+            <a:extLst>
+              <a:ext uri="{FF2B5EF4-FFF2-40B4-BE49-F238E27FC236}">
+                <a16:creationId xmlns:a16="http://schemas.microsoft.com/office/drawing/2014/main" id="{9849074F-7731-DED0-3CD6-1805CC6925B4}"/>
+              </a:ext>
+            </a:extLst>
+          </p:cNvPr>
+          <p:cNvSpPr txBox="1"/>
+          <p:nvPr/>
+        </p:nvSpPr>
+        <p:spPr>
+          <a:xfrm>
+            <a:off x="7019925" y="263127"/>
+            <a:ext cx="620683" cy="369332"/>
+          </a:xfrm>
+          <a:prstGeom prst="rect">
+            <a:avLst/>
+          </a:prstGeom>
+          <a:noFill/>
+        </p:spPr>
+        <p:txBody>
+          <a:bodyPr wrap="none" rtlCol="0">
+            <a:spAutoFit/>
+          </a:bodyPr>
+          <a:lstStyle/>
+          <a:p>
             <a:r>
-              <a:rPr lang="vi-VN"/>
-              <a:t>Chức năng quản lý hành vi người dùng: chức năng, usecase, tuần tự</a:t>
+              <a:rPr lang="en-US">
+                <a:latin typeface="Times New Roman" panose="02020603050405020304" pitchFamily="18" charset="0"/>
+                <a:cs typeface="Times New Roman" panose="02020603050405020304" pitchFamily="18" charset="0"/>
+              </a:rPr>
+              <a:t>(1A)</a:t>
             </a:r>
           </a:p>
-          <a:p>
-            <a:pPr marL="285750" indent="-285750">
-              <a:buFontTx/>
-              <a:buChar char="-"/>
-            </a:pPr>
+        </p:txBody>
+      </p:sp>
+      <p:sp>
+        <p:nvSpPr>
+          <p:cNvPr id="144" name="TextBox 143">
+            <a:extLst>
+              <a:ext uri="{FF2B5EF4-FFF2-40B4-BE49-F238E27FC236}">
+                <a16:creationId xmlns:a16="http://schemas.microsoft.com/office/drawing/2014/main" id="{E132DEFE-9AF1-CA61-30F8-2E4ADA112EE1}"/>
+              </a:ext>
+            </a:extLst>
+          </p:cNvPr>
+          <p:cNvSpPr txBox="1"/>
+          <p:nvPr/>
+        </p:nvSpPr>
+        <p:spPr>
+          <a:xfrm>
+            <a:off x="4540171" y="265123"/>
+            <a:ext cx="607859" cy="369332"/>
+          </a:xfrm>
+          <a:prstGeom prst="rect">
+            <a:avLst/>
+          </a:prstGeom>
+          <a:noFill/>
+        </p:spPr>
+        <p:txBody>
+          <a:bodyPr wrap="none" rtlCol="0">
+            <a:spAutoFit/>
+          </a:bodyPr>
+          <a:lstStyle/>
+          <a:p>
             <a:r>
-              <a:rPr lang="vi-VN"/>
-              <a:t>Chức năng quản lý hội thoại: chức năng, usecase, tuần tự</a:t>
+              <a:rPr lang="en-US">
+                <a:latin typeface="Times New Roman" panose="02020603050405020304" pitchFamily="18" charset="0"/>
+                <a:cs typeface="Times New Roman" panose="02020603050405020304" pitchFamily="18" charset="0"/>
+              </a:rPr>
+              <a:t>(1B)</a:t>
             </a:r>
           </a:p>
-          <a:p>
-            <a:pPr marL="285750" indent="-285750">
-              <a:buFontTx/>
-              <a:buChar char="-"/>
-            </a:pPr>
+        </p:txBody>
+      </p:sp>
+      <p:sp>
+        <p:nvSpPr>
+          <p:cNvPr id="145" name="TextBox 144">
+            <a:extLst>
+              <a:ext uri="{FF2B5EF4-FFF2-40B4-BE49-F238E27FC236}">
+                <a16:creationId xmlns:a16="http://schemas.microsoft.com/office/drawing/2014/main" id="{C980FEC5-67B0-24B6-6B9E-607A16950B1C}"/>
+              </a:ext>
+            </a:extLst>
+          </p:cNvPr>
+          <p:cNvSpPr txBox="1"/>
+          <p:nvPr/>
+        </p:nvSpPr>
+        <p:spPr>
+          <a:xfrm>
+            <a:off x="8488680" y="2577582"/>
+            <a:ext cx="620683" cy="369332"/>
+          </a:xfrm>
+          <a:prstGeom prst="rect">
+            <a:avLst/>
+          </a:prstGeom>
+          <a:noFill/>
+        </p:spPr>
+        <p:txBody>
+          <a:bodyPr wrap="none" rtlCol="0">
+            <a:spAutoFit/>
+          </a:bodyPr>
+          <a:lstStyle/>
+          <a:p>
             <a:r>
-              <a:rPr lang="vi-VN"/>
-              <a:t>Chức năng xử lý trích xuất thông tin trò chuyện</a:t>
+              <a:rPr lang="en-US">
+                <a:latin typeface="Times New Roman" panose="02020603050405020304" pitchFamily="18" charset="0"/>
+                <a:cs typeface="Times New Roman" panose="02020603050405020304" pitchFamily="18" charset="0"/>
+              </a:rPr>
+              <a:t>(2A)</a:t>
             </a:r>
           </a:p>
-          <a:p>
-            <a:pPr marL="285750" indent="-285750">
-              <a:buFontTx/>
-              <a:buChar char="-"/>
-            </a:pPr>
-            <a:endParaRPr lang="vi-VN"/>
-          </a:p>
-          <a:p>
-            <a:pPr marL="285750" indent="-285750">
-              <a:buFontTx/>
-              <a:buChar char="-"/>
-            </a:pPr>
+        </p:txBody>
+      </p:sp>
+      <p:sp>
+        <p:nvSpPr>
+          <p:cNvPr id="150" name="TextBox 149">
+            <a:extLst>
+              <a:ext uri="{FF2B5EF4-FFF2-40B4-BE49-F238E27FC236}">
+                <a16:creationId xmlns:a16="http://schemas.microsoft.com/office/drawing/2014/main" id="{64BBBA42-1BCF-2531-021A-6FAD597D5EF1}"/>
+              </a:ext>
+            </a:extLst>
+          </p:cNvPr>
+          <p:cNvSpPr txBox="1"/>
+          <p:nvPr/>
+        </p:nvSpPr>
+        <p:spPr>
+          <a:xfrm>
+            <a:off x="3690620" y="2577582"/>
+            <a:ext cx="607859" cy="369332"/>
+          </a:xfrm>
+          <a:prstGeom prst="rect">
+            <a:avLst/>
+          </a:prstGeom>
+          <a:noFill/>
+        </p:spPr>
+        <p:txBody>
+          <a:bodyPr wrap="none" rtlCol="0">
+            <a:spAutoFit/>
+          </a:bodyPr>
+          <a:lstStyle/>
+          <a:p>
             <a:r>
-              <a:rPr lang="vi-VN"/>
-              <a:t>Thiết kế cơ sở dữ liệu embedding: có những trường nào</a:t>
+              <a:rPr lang="en-US">
+                <a:latin typeface="Times New Roman" panose="02020603050405020304" pitchFamily="18" charset="0"/>
+                <a:cs typeface="Times New Roman" panose="02020603050405020304" pitchFamily="18" charset="0"/>
+              </a:rPr>
+              <a:t>(2B)</a:t>
             </a:r>
           </a:p>
-          <a:p>
-            <a:pPr marL="285750" indent="-285750">
-              <a:buFontTx/>
-              <a:buChar char="-"/>
-            </a:pPr>
+        </p:txBody>
+      </p:sp>
+      <p:sp>
+        <p:nvSpPr>
+          <p:cNvPr id="151" name="TextBox 150">
+            <a:extLst>
+              <a:ext uri="{FF2B5EF4-FFF2-40B4-BE49-F238E27FC236}">
+                <a16:creationId xmlns:a16="http://schemas.microsoft.com/office/drawing/2014/main" id="{5F7F5BE2-B6B7-CA49-F6DC-41220719D6F8}"/>
+              </a:ext>
+            </a:extLst>
+          </p:cNvPr>
+          <p:cNvSpPr txBox="1"/>
+          <p:nvPr/>
+        </p:nvSpPr>
+        <p:spPr>
+          <a:xfrm>
+            <a:off x="8488679" y="4932848"/>
+            <a:ext cx="793807" cy="369332"/>
+          </a:xfrm>
+          <a:prstGeom prst="rect">
+            <a:avLst/>
+          </a:prstGeom>
+          <a:noFill/>
+        </p:spPr>
+        <p:txBody>
+          <a:bodyPr wrap="none" rtlCol="0">
+            <a:spAutoFit/>
+          </a:bodyPr>
+          <a:lstStyle/>
+          <a:p>
             <a:r>
-              <a:rPr lang="vi-VN"/>
-              <a:t>Cơ sở dữ liệu lưu trữ lịch sử hội thoại</a:t>
+              <a:rPr lang="en-US">
+                <a:latin typeface="Times New Roman" panose="02020603050405020304" pitchFamily="18" charset="0"/>
+                <a:cs typeface="Times New Roman" panose="02020603050405020304" pitchFamily="18" charset="0"/>
+              </a:rPr>
+              <a:t>(3A.1)</a:t>
             </a:r>
           </a:p>
-          <a:p>
-            <a:pPr marL="285750" indent="-285750">
-              <a:buFontTx/>
-              <a:buChar char="-"/>
-            </a:pPr>
+        </p:txBody>
+      </p:sp>
+      <p:sp>
+        <p:nvSpPr>
+          <p:cNvPr id="152" name="TextBox 151">
+            <a:extLst>
+              <a:ext uri="{FF2B5EF4-FFF2-40B4-BE49-F238E27FC236}">
+                <a16:creationId xmlns:a16="http://schemas.microsoft.com/office/drawing/2014/main" id="{111FEC82-001B-C9FB-A5CC-07E8230CBD4E}"/>
+              </a:ext>
+            </a:extLst>
+          </p:cNvPr>
+          <p:cNvSpPr txBox="1"/>
+          <p:nvPr/>
+        </p:nvSpPr>
+        <p:spPr>
+          <a:xfrm>
+            <a:off x="2922336" y="4943443"/>
+            <a:ext cx="780983" cy="369332"/>
+          </a:xfrm>
+          <a:prstGeom prst="rect">
+            <a:avLst/>
+          </a:prstGeom>
+          <a:noFill/>
+        </p:spPr>
+        <p:txBody>
+          <a:bodyPr wrap="none" rtlCol="0">
+            <a:spAutoFit/>
+          </a:bodyPr>
+          <a:lstStyle/>
+          <a:p>
             <a:r>
-              <a:rPr lang="vi-VN"/>
-              <a:t>Co sơ dữ liệu lưu trữ thông tin người dùng</a:t>
+              <a:rPr lang="en-US">
+                <a:latin typeface="Times New Roman" panose="02020603050405020304" pitchFamily="18" charset="0"/>
+                <a:cs typeface="Times New Roman" panose="02020603050405020304" pitchFamily="18" charset="0"/>
+              </a:rPr>
+              <a:t>(3B.1)</a:t>
             </a:r>
-            <a:endParaRPr lang="en-US"/>
+          </a:p>
+        </p:txBody>
+      </p:sp>
+      <p:sp>
+        <p:nvSpPr>
+          <p:cNvPr id="153" name="TextBox 152">
+            <a:extLst>
+              <a:ext uri="{FF2B5EF4-FFF2-40B4-BE49-F238E27FC236}">
+                <a16:creationId xmlns:a16="http://schemas.microsoft.com/office/drawing/2014/main" id="{FF903399-78B1-94BC-F3D0-374C05BCC981}"/>
+              </a:ext>
+            </a:extLst>
+          </p:cNvPr>
+          <p:cNvSpPr txBox="1"/>
+          <p:nvPr/>
+        </p:nvSpPr>
+        <p:spPr>
+          <a:xfrm>
+            <a:off x="9959340" y="3643953"/>
+            <a:ext cx="793807" cy="369332"/>
+          </a:xfrm>
+          <a:prstGeom prst="rect">
+            <a:avLst/>
+          </a:prstGeom>
+          <a:noFill/>
+        </p:spPr>
+        <p:txBody>
+          <a:bodyPr wrap="none" rtlCol="0">
+            <a:spAutoFit/>
+          </a:bodyPr>
+          <a:lstStyle/>
+          <a:p>
+            <a:r>
+              <a:rPr lang="en-US">
+                <a:latin typeface="Times New Roman" panose="02020603050405020304" pitchFamily="18" charset="0"/>
+                <a:cs typeface="Times New Roman" panose="02020603050405020304" pitchFamily="18" charset="0"/>
+              </a:rPr>
+              <a:t>(3A.2)</a:t>
+            </a:r>
+          </a:p>
+        </p:txBody>
+      </p:sp>
+      <p:sp>
+        <p:nvSpPr>
+          <p:cNvPr id="154" name="TextBox 153">
+            <a:extLst>
+              <a:ext uri="{FF2B5EF4-FFF2-40B4-BE49-F238E27FC236}">
+                <a16:creationId xmlns:a16="http://schemas.microsoft.com/office/drawing/2014/main" id="{293FE729-B807-0B94-217D-F1FF85CF8FF9}"/>
+              </a:ext>
+            </a:extLst>
+          </p:cNvPr>
+          <p:cNvSpPr txBox="1"/>
+          <p:nvPr/>
+        </p:nvSpPr>
+        <p:spPr>
+          <a:xfrm>
+            <a:off x="1451553" y="3640723"/>
+            <a:ext cx="780983" cy="369332"/>
+          </a:xfrm>
+          <a:prstGeom prst="rect">
+            <a:avLst/>
+          </a:prstGeom>
+          <a:noFill/>
+        </p:spPr>
+        <p:txBody>
+          <a:bodyPr wrap="none" rtlCol="0">
+            <a:spAutoFit/>
+          </a:bodyPr>
+          <a:lstStyle/>
+          <a:p>
+            <a:r>
+              <a:rPr lang="en-US">
+                <a:latin typeface="Times New Roman" panose="02020603050405020304" pitchFamily="18" charset="0"/>
+                <a:cs typeface="Times New Roman" panose="02020603050405020304" pitchFamily="18" charset="0"/>
+              </a:rPr>
+              <a:t>(3B.2)</a:t>
+            </a:r>
+          </a:p>
+        </p:txBody>
+      </p:sp>
+      <p:sp>
+        <p:nvSpPr>
+          <p:cNvPr id="155" name="TextBox 154">
+            <a:extLst>
+              <a:ext uri="{FF2B5EF4-FFF2-40B4-BE49-F238E27FC236}">
+                <a16:creationId xmlns:a16="http://schemas.microsoft.com/office/drawing/2014/main" id="{09DFDA9A-1BB3-7DA5-59AD-78DC5CD94235}"/>
+              </a:ext>
+            </a:extLst>
+          </p:cNvPr>
+          <p:cNvSpPr txBox="1"/>
+          <p:nvPr/>
+        </p:nvSpPr>
+        <p:spPr>
+          <a:xfrm>
+            <a:off x="7421399" y="5852158"/>
+            <a:ext cx="453970" cy="369332"/>
+          </a:xfrm>
+          <a:prstGeom prst="rect">
+            <a:avLst/>
+          </a:prstGeom>
+          <a:noFill/>
+        </p:spPr>
+        <p:txBody>
+          <a:bodyPr wrap="none" rtlCol="0">
+            <a:spAutoFit/>
+          </a:bodyPr>
+          <a:lstStyle/>
+          <a:p>
+            <a:r>
+              <a:rPr lang="en-US">
+                <a:latin typeface="Times New Roman" panose="02020603050405020304" pitchFamily="18" charset="0"/>
+                <a:cs typeface="Times New Roman" panose="02020603050405020304" pitchFamily="18" charset="0"/>
+              </a:rPr>
+              <a:t>(4)</a:t>
+            </a:r>
+          </a:p>
+        </p:txBody>
+      </p:sp>
+      <p:sp>
+        <p:nvSpPr>
+          <p:cNvPr id="156" name="TextBox 155">
+            <a:extLst>
+              <a:ext uri="{FF2B5EF4-FFF2-40B4-BE49-F238E27FC236}">
+                <a16:creationId xmlns:a16="http://schemas.microsoft.com/office/drawing/2014/main" id="{10C1A162-B48F-EF9C-4DC3-E07AFF9084BC}"/>
+              </a:ext>
+            </a:extLst>
+          </p:cNvPr>
+          <p:cNvSpPr txBox="1"/>
+          <p:nvPr/>
+        </p:nvSpPr>
+        <p:spPr>
+          <a:xfrm>
+            <a:off x="10332720" y="5859779"/>
+            <a:ext cx="627095" cy="369332"/>
+          </a:xfrm>
+          <a:prstGeom prst="rect">
+            <a:avLst/>
+          </a:prstGeom>
+          <a:noFill/>
+        </p:spPr>
+        <p:txBody>
+          <a:bodyPr wrap="none" rtlCol="0">
+            <a:spAutoFit/>
+          </a:bodyPr>
+          <a:lstStyle/>
+          <a:p>
+            <a:r>
+              <a:rPr lang="en-US">
+                <a:latin typeface="Times New Roman" panose="02020603050405020304" pitchFamily="18" charset="0"/>
+                <a:cs typeface="Times New Roman" panose="02020603050405020304" pitchFamily="18" charset="0"/>
+              </a:rPr>
+              <a:t>(4.1)</a:t>
+            </a:r>
           </a:p>
         </p:txBody>
       </p:sp>
     </p:spTree>
     <p:extLst>
       <p:ext uri="{BB962C8B-B14F-4D97-AF65-F5344CB8AC3E}">
-        <p14:creationId xmlns:p14="http://schemas.microsoft.com/office/powerpoint/2010/main" val="629964740"/>
+        <p14:creationId xmlns:p14="http://schemas.microsoft.com/office/powerpoint/2010/main" val="3397203099"/>
       </p:ext>
     </p:extLst>
   </p:cSld>
@@ -4676,6 +6183,2052 @@
 </file>
 
 <file path=ppt/slides/slide11.xml><?xml version="1.0" encoding="utf-8"?>
+<p:sld xmlns:a="http://schemas.openxmlformats.org/drawingml/2006/main" xmlns:r="http://schemas.openxmlformats.org/officeDocument/2006/relationships" xmlns:p="http://schemas.openxmlformats.org/presentationml/2006/main">
+  <p:cSld>
+    <p:spTree>
+      <p:nvGrpSpPr>
+        <p:cNvPr id="1" name=""/>
+        <p:cNvGrpSpPr/>
+        <p:nvPr/>
+      </p:nvGrpSpPr>
+      <p:grpSpPr>
+        <a:xfrm>
+          <a:off x="0" y="0"/>
+          <a:ext cx="0" cy="0"/>
+          <a:chOff x="0" y="0"/>
+          <a:chExt cx="0" cy="0"/>
+        </a:xfrm>
+      </p:grpSpPr>
+      <p:grpSp>
+        <p:nvGrpSpPr>
+          <p:cNvPr id="2" name="Group 1">
+            <a:extLst>
+              <a:ext uri="{FF2B5EF4-FFF2-40B4-BE49-F238E27FC236}">
+                <a16:creationId xmlns:a16="http://schemas.microsoft.com/office/drawing/2014/main" id="{69B0A154-08A4-D97A-0E7A-7396FCA25FE6}"/>
+              </a:ext>
+            </a:extLst>
+          </p:cNvPr>
+          <p:cNvGrpSpPr/>
+          <p:nvPr/>
+        </p:nvGrpSpPr>
+        <p:grpSpPr>
+          <a:xfrm>
+            <a:off x="5509138" y="214652"/>
+            <a:ext cx="1173719" cy="1180574"/>
+            <a:chOff x="5509139" y="42349"/>
+            <a:chExt cx="1173719" cy="1180574"/>
+          </a:xfrm>
+        </p:grpSpPr>
+        <p:pic>
+          <p:nvPicPr>
+            <p:cNvPr id="3" name="Graphic 2" descr="User with solid fill">
+              <a:extLst>
+                <a:ext uri="{FF2B5EF4-FFF2-40B4-BE49-F238E27FC236}">
+                  <a16:creationId xmlns:a16="http://schemas.microsoft.com/office/drawing/2014/main" id="{1BED0E52-2D63-7666-1151-C989191C0733}"/>
+                </a:ext>
+              </a:extLst>
+            </p:cNvPr>
+            <p:cNvPicPr>
+              <a:picLocks noChangeAspect="1"/>
+            </p:cNvPicPr>
+            <p:nvPr/>
+          </p:nvPicPr>
+          <p:blipFill>
+            <a:blip r:embed="rId3">
+              <a:extLst>
+                <a:ext uri="{96DAC541-7B7A-43D3-8B79-37D633B846F1}">
+                  <asvg:svgBlip xmlns:asvg="http://schemas.microsoft.com/office/drawing/2016/SVG/main" r:embed="rId4"/>
+                </a:ext>
+              </a:extLst>
+            </a:blip>
+            <a:stretch>
+              <a:fillRect/>
+            </a:stretch>
+          </p:blipFill>
+          <p:spPr>
+            <a:xfrm>
+              <a:off x="5594034" y="42349"/>
+              <a:ext cx="1003931" cy="1003931"/>
+            </a:xfrm>
+            <a:prstGeom prst="rect">
+              <a:avLst/>
+            </a:prstGeom>
+          </p:spPr>
+        </p:pic>
+        <p:sp>
+          <p:nvSpPr>
+            <p:cNvPr id="4" name="TextBox 3">
+              <a:extLst>
+                <a:ext uri="{FF2B5EF4-FFF2-40B4-BE49-F238E27FC236}">
+                  <a16:creationId xmlns:a16="http://schemas.microsoft.com/office/drawing/2014/main" id="{C4BB48F4-6707-24B4-E7C4-AEE772FBD3BE}"/>
+                </a:ext>
+              </a:extLst>
+            </p:cNvPr>
+            <p:cNvSpPr txBox="1"/>
+            <p:nvPr/>
+          </p:nvSpPr>
+          <p:spPr>
+            <a:xfrm>
+              <a:off x="5509139" y="884369"/>
+              <a:ext cx="1173719" cy="338554"/>
+            </a:xfrm>
+            <a:prstGeom prst="rect">
+              <a:avLst/>
+            </a:prstGeom>
+            <a:noFill/>
+          </p:spPr>
+          <p:txBody>
+            <a:bodyPr wrap="none" rtlCol="0">
+              <a:spAutoFit/>
+            </a:bodyPr>
+            <a:lstStyle/>
+            <a:p>
+              <a:r>
+                <a:rPr lang="vi-VN" sz="1600">
+                  <a:latin typeface="+mj-lt"/>
+                </a:rPr>
+                <a:t>Người dùng</a:t>
+              </a:r>
+              <a:endParaRPr lang="en-US" sz="1600">
+                <a:latin typeface="+mj-lt"/>
+              </a:endParaRPr>
+            </a:p>
+          </p:txBody>
+        </p:sp>
+      </p:grpSp>
+      <p:sp>
+        <p:nvSpPr>
+          <p:cNvPr id="5" name="Rectangle: Rounded Corners 4">
+            <a:extLst>
+              <a:ext uri="{FF2B5EF4-FFF2-40B4-BE49-F238E27FC236}">
+                <a16:creationId xmlns:a16="http://schemas.microsoft.com/office/drawing/2014/main" id="{8E8A3DB1-B542-BF43-4249-6A673A081C01}"/>
+              </a:ext>
+            </a:extLst>
+          </p:cNvPr>
+          <p:cNvSpPr/>
+          <p:nvPr/>
+        </p:nvSpPr>
+        <p:spPr>
+          <a:xfrm>
+            <a:off x="4397828" y="1712259"/>
+            <a:ext cx="3396343" cy="442686"/>
+          </a:xfrm>
+          <a:prstGeom prst="roundRect">
+            <a:avLst/>
+          </a:prstGeom>
+          <a:solidFill>
+            <a:schemeClr val="bg2"/>
+          </a:solidFill>
+          <a:ln>
+            <a:solidFill>
+              <a:schemeClr val="tx1"/>
+            </a:solidFill>
+            <a:prstDash val="dash"/>
+          </a:ln>
+        </p:spPr>
+        <p:style>
+          <a:lnRef idx="2">
+            <a:schemeClr val="accent1">
+              <a:shade val="15000"/>
+            </a:schemeClr>
+          </a:lnRef>
+          <a:fillRef idx="1">
+            <a:schemeClr val="accent1"/>
+          </a:fillRef>
+          <a:effectRef idx="0">
+            <a:schemeClr val="accent1"/>
+          </a:effectRef>
+          <a:fontRef idx="minor">
+            <a:schemeClr val="lt1"/>
+          </a:fontRef>
+        </p:style>
+        <p:txBody>
+          <a:bodyPr rtlCol="0" anchor="ctr"/>
+          <a:lstStyle/>
+          <a:p>
+            <a:pPr algn="ctr"/>
+            <a:r>
+              <a:rPr lang="en-US">
+                <a:solidFill>
+                  <a:schemeClr val="tx1"/>
+                </a:solidFill>
+              </a:rPr>
+              <a:t>Giao diện chat</a:t>
+            </a:r>
+          </a:p>
+        </p:txBody>
+      </p:sp>
+      <p:sp>
+        <p:nvSpPr>
+          <p:cNvPr id="7" name="Rectangle: Rounded Corners 6">
+            <a:extLst>
+              <a:ext uri="{FF2B5EF4-FFF2-40B4-BE49-F238E27FC236}">
+                <a16:creationId xmlns:a16="http://schemas.microsoft.com/office/drawing/2014/main" id="{6BA552BB-F47C-5233-E510-733187E9BC67}"/>
+              </a:ext>
+            </a:extLst>
+          </p:cNvPr>
+          <p:cNvSpPr/>
+          <p:nvPr/>
+        </p:nvSpPr>
+        <p:spPr>
+          <a:xfrm>
+            <a:off x="4397824" y="2861833"/>
+            <a:ext cx="3396343" cy="442686"/>
+          </a:xfrm>
+          <a:prstGeom prst="roundRect">
+            <a:avLst/>
+          </a:prstGeom>
+          <a:solidFill>
+            <a:schemeClr val="bg2"/>
+          </a:solidFill>
+          <a:ln>
+            <a:solidFill>
+              <a:schemeClr val="tx1"/>
+            </a:solidFill>
+          </a:ln>
+        </p:spPr>
+        <p:style>
+          <a:lnRef idx="2">
+            <a:schemeClr val="accent1">
+              <a:shade val="15000"/>
+            </a:schemeClr>
+          </a:lnRef>
+          <a:fillRef idx="1">
+            <a:schemeClr val="accent1"/>
+          </a:fillRef>
+          <a:effectRef idx="0">
+            <a:schemeClr val="accent1"/>
+          </a:effectRef>
+          <a:fontRef idx="minor">
+            <a:schemeClr val="lt1"/>
+          </a:fontRef>
+        </p:style>
+        <p:txBody>
+          <a:bodyPr rtlCol="0" anchor="ctr"/>
+          <a:lstStyle/>
+          <a:p>
+            <a:pPr algn="ctr"/>
+            <a:r>
+              <a:rPr lang="en-US">
+                <a:solidFill>
+                  <a:schemeClr val="tx1"/>
+                </a:solidFill>
+              </a:rPr>
+              <a:t>Mở giao diện cài đặt tùy chọn</a:t>
+            </a:r>
+          </a:p>
+        </p:txBody>
+      </p:sp>
+      <p:sp>
+        <p:nvSpPr>
+          <p:cNvPr id="10" name="Rectangle: Rounded Corners 9">
+            <a:extLst>
+              <a:ext uri="{FF2B5EF4-FFF2-40B4-BE49-F238E27FC236}">
+                <a16:creationId xmlns:a16="http://schemas.microsoft.com/office/drawing/2014/main" id="{54FC52ED-D325-D40F-15FE-AB3D4B713DAF}"/>
+              </a:ext>
+            </a:extLst>
+          </p:cNvPr>
+          <p:cNvSpPr/>
+          <p:nvPr/>
+        </p:nvSpPr>
+        <p:spPr>
+          <a:xfrm>
+            <a:off x="7794164" y="4226782"/>
+            <a:ext cx="1944912" cy="918959"/>
+          </a:xfrm>
+          <a:prstGeom prst="roundRect">
+            <a:avLst/>
+          </a:prstGeom>
+          <a:solidFill>
+            <a:schemeClr val="bg2"/>
+          </a:solidFill>
+          <a:ln>
+            <a:solidFill>
+              <a:schemeClr val="tx1"/>
+            </a:solidFill>
+            <a:prstDash val="dash"/>
+          </a:ln>
+        </p:spPr>
+        <p:style>
+          <a:lnRef idx="2">
+            <a:schemeClr val="accent1">
+              <a:shade val="15000"/>
+            </a:schemeClr>
+          </a:lnRef>
+          <a:fillRef idx="1">
+            <a:schemeClr val="accent1"/>
+          </a:fillRef>
+          <a:effectRef idx="0">
+            <a:schemeClr val="accent1"/>
+          </a:effectRef>
+          <a:fontRef idx="minor">
+            <a:schemeClr val="lt1"/>
+          </a:fontRef>
+        </p:style>
+        <p:txBody>
+          <a:bodyPr rtlCol="0" anchor="ctr"/>
+          <a:lstStyle/>
+          <a:p>
+            <a:pPr algn="ctr"/>
+            <a:r>
+              <a:rPr lang="en-US">
+                <a:solidFill>
+                  <a:schemeClr val="tx1"/>
+                </a:solidFill>
+              </a:rPr>
+              <a:t>Điều chỉnh temperature</a:t>
+            </a:r>
+          </a:p>
+        </p:txBody>
+      </p:sp>
+      <p:sp>
+        <p:nvSpPr>
+          <p:cNvPr id="11" name="Rectangle: Rounded Corners 10">
+            <a:extLst>
+              <a:ext uri="{FF2B5EF4-FFF2-40B4-BE49-F238E27FC236}">
+                <a16:creationId xmlns:a16="http://schemas.microsoft.com/office/drawing/2014/main" id="{9182A22E-530B-15D3-3773-9A83D3C878C2}"/>
+              </a:ext>
+            </a:extLst>
+          </p:cNvPr>
+          <p:cNvSpPr/>
+          <p:nvPr/>
+        </p:nvSpPr>
+        <p:spPr>
+          <a:xfrm>
+            <a:off x="4397825" y="5666887"/>
+            <a:ext cx="3396343" cy="442686"/>
+          </a:xfrm>
+          <a:prstGeom prst="roundRect">
+            <a:avLst/>
+          </a:prstGeom>
+          <a:solidFill>
+            <a:schemeClr val="bg2"/>
+          </a:solidFill>
+          <a:ln>
+            <a:solidFill>
+              <a:schemeClr val="tx1"/>
+            </a:solidFill>
+          </a:ln>
+        </p:spPr>
+        <p:style>
+          <a:lnRef idx="2">
+            <a:schemeClr val="accent1">
+              <a:shade val="15000"/>
+            </a:schemeClr>
+          </a:lnRef>
+          <a:fillRef idx="1">
+            <a:schemeClr val="accent1"/>
+          </a:fillRef>
+          <a:effectRef idx="0">
+            <a:schemeClr val="accent1"/>
+          </a:effectRef>
+          <a:fontRef idx="minor">
+            <a:schemeClr val="lt1"/>
+          </a:fontRef>
+        </p:style>
+        <p:txBody>
+          <a:bodyPr rtlCol="0" anchor="ctr"/>
+          <a:lstStyle/>
+          <a:p>
+            <a:pPr algn="ctr"/>
+            <a:r>
+              <a:rPr lang="en-US">
+                <a:solidFill>
+                  <a:schemeClr val="tx1"/>
+                </a:solidFill>
+              </a:rPr>
+              <a:t>Lưu và áp dụng tùy chọn</a:t>
+            </a:r>
+          </a:p>
+        </p:txBody>
+      </p:sp>
+      <p:sp>
+        <p:nvSpPr>
+          <p:cNvPr id="13" name="Rectangle: Rounded Corners 12">
+            <a:extLst>
+              <a:ext uri="{FF2B5EF4-FFF2-40B4-BE49-F238E27FC236}">
+                <a16:creationId xmlns:a16="http://schemas.microsoft.com/office/drawing/2014/main" id="{CF3E6DEE-2F74-0B2C-64BA-F5B24461CD3A}"/>
+              </a:ext>
+            </a:extLst>
+          </p:cNvPr>
+          <p:cNvSpPr/>
+          <p:nvPr/>
+        </p:nvSpPr>
+        <p:spPr>
+          <a:xfrm>
+            <a:off x="5123539" y="4226783"/>
+            <a:ext cx="1944911" cy="918958"/>
+          </a:xfrm>
+          <a:prstGeom prst="roundRect">
+            <a:avLst/>
+          </a:prstGeom>
+          <a:solidFill>
+            <a:schemeClr val="bg2"/>
+          </a:solidFill>
+          <a:ln>
+            <a:solidFill>
+              <a:schemeClr val="tx1"/>
+            </a:solidFill>
+            <a:prstDash val="dash"/>
+          </a:ln>
+        </p:spPr>
+        <p:style>
+          <a:lnRef idx="2">
+            <a:schemeClr val="accent1">
+              <a:shade val="15000"/>
+            </a:schemeClr>
+          </a:lnRef>
+          <a:fillRef idx="1">
+            <a:schemeClr val="accent1"/>
+          </a:fillRef>
+          <a:effectRef idx="0">
+            <a:schemeClr val="accent1"/>
+          </a:effectRef>
+          <a:fontRef idx="minor">
+            <a:schemeClr val="lt1"/>
+          </a:fontRef>
+        </p:style>
+        <p:txBody>
+          <a:bodyPr rtlCol="0" anchor="ctr"/>
+          <a:lstStyle/>
+          <a:p>
+            <a:pPr algn="ctr"/>
+            <a:r>
+              <a:rPr lang="en-US">
+                <a:solidFill>
+                  <a:schemeClr val="tx1"/>
+                </a:solidFill>
+              </a:rPr>
+              <a:t>Lựa chọn LLM</a:t>
+            </a:r>
+          </a:p>
+        </p:txBody>
+      </p:sp>
+      <p:sp>
+        <p:nvSpPr>
+          <p:cNvPr id="14" name="Rectangle: Rounded Corners 13">
+            <a:extLst>
+              <a:ext uri="{FF2B5EF4-FFF2-40B4-BE49-F238E27FC236}">
+                <a16:creationId xmlns:a16="http://schemas.microsoft.com/office/drawing/2014/main" id="{939A4245-B633-7D02-D20B-44DFD81F966C}"/>
+              </a:ext>
+            </a:extLst>
+          </p:cNvPr>
+          <p:cNvSpPr/>
+          <p:nvPr/>
+        </p:nvSpPr>
+        <p:spPr>
+          <a:xfrm>
+            <a:off x="2452912" y="4226783"/>
+            <a:ext cx="1944911" cy="918958"/>
+          </a:xfrm>
+          <a:prstGeom prst="roundRect">
+            <a:avLst/>
+          </a:prstGeom>
+          <a:solidFill>
+            <a:schemeClr val="bg2"/>
+          </a:solidFill>
+          <a:ln>
+            <a:solidFill>
+              <a:schemeClr val="tx1"/>
+            </a:solidFill>
+            <a:prstDash val="dash"/>
+          </a:ln>
+        </p:spPr>
+        <p:style>
+          <a:lnRef idx="2">
+            <a:schemeClr val="accent1">
+              <a:shade val="15000"/>
+            </a:schemeClr>
+          </a:lnRef>
+          <a:fillRef idx="1">
+            <a:schemeClr val="accent1"/>
+          </a:fillRef>
+          <a:effectRef idx="0">
+            <a:schemeClr val="accent1"/>
+          </a:effectRef>
+          <a:fontRef idx="minor">
+            <a:schemeClr val="lt1"/>
+          </a:fontRef>
+        </p:style>
+        <p:txBody>
+          <a:bodyPr rtlCol="0" anchor="ctr"/>
+          <a:lstStyle/>
+          <a:p>
+            <a:pPr algn="ctr"/>
+            <a:r>
+              <a:rPr lang="en-US">
+                <a:solidFill>
+                  <a:schemeClr val="tx1"/>
+                </a:solidFill>
+              </a:rPr>
+              <a:t>Bật/tắt streaming</a:t>
+            </a:r>
+          </a:p>
+        </p:txBody>
+      </p:sp>
+      <p:cxnSp>
+        <p:nvCxnSpPr>
+          <p:cNvPr id="16" name="Connector: Elbow 15">
+            <a:extLst>
+              <a:ext uri="{FF2B5EF4-FFF2-40B4-BE49-F238E27FC236}">
+                <a16:creationId xmlns:a16="http://schemas.microsoft.com/office/drawing/2014/main" id="{164EA925-73AB-D4A3-72F9-B0E067CA613A}"/>
+              </a:ext>
+            </a:extLst>
+          </p:cNvPr>
+          <p:cNvCxnSpPr>
+            <a:stCxn id="7" idx="2"/>
+            <a:endCxn id="14" idx="0"/>
+          </p:cNvCxnSpPr>
+          <p:nvPr/>
+        </p:nvCxnSpPr>
+        <p:spPr>
+          <a:xfrm rot="5400000">
+            <a:off x="4299550" y="2430337"/>
+            <a:ext cx="922264" cy="2670628"/>
+          </a:xfrm>
+          <a:prstGeom prst="bentConnector3">
+            <a:avLst/>
+          </a:prstGeom>
+          <a:ln>
+            <a:tailEnd type="triangle"/>
+          </a:ln>
+        </p:spPr>
+        <p:style>
+          <a:lnRef idx="2">
+            <a:schemeClr val="dk1"/>
+          </a:lnRef>
+          <a:fillRef idx="0">
+            <a:schemeClr val="dk1"/>
+          </a:fillRef>
+          <a:effectRef idx="1">
+            <a:schemeClr val="dk1"/>
+          </a:effectRef>
+          <a:fontRef idx="minor">
+            <a:schemeClr val="tx1"/>
+          </a:fontRef>
+        </p:style>
+      </p:cxnSp>
+      <p:cxnSp>
+        <p:nvCxnSpPr>
+          <p:cNvPr id="20" name="Connector: Elbow 19">
+            <a:extLst>
+              <a:ext uri="{FF2B5EF4-FFF2-40B4-BE49-F238E27FC236}">
+                <a16:creationId xmlns:a16="http://schemas.microsoft.com/office/drawing/2014/main" id="{9AFC90FF-2B9B-28B4-B00A-E620B71E8A73}"/>
+              </a:ext>
+            </a:extLst>
+          </p:cNvPr>
+          <p:cNvCxnSpPr>
+            <a:stCxn id="7" idx="2"/>
+            <a:endCxn id="10" idx="0"/>
+          </p:cNvCxnSpPr>
+          <p:nvPr/>
+        </p:nvCxnSpPr>
+        <p:spPr>
+          <a:xfrm rot="16200000" flipH="1">
+            <a:off x="6970177" y="2430338"/>
+            <a:ext cx="922263" cy="2670624"/>
+          </a:xfrm>
+          <a:prstGeom prst="bentConnector3">
+            <a:avLst/>
+          </a:prstGeom>
+          <a:ln>
+            <a:tailEnd type="triangle"/>
+          </a:ln>
+        </p:spPr>
+        <p:style>
+          <a:lnRef idx="2">
+            <a:schemeClr val="dk1"/>
+          </a:lnRef>
+          <a:fillRef idx="0">
+            <a:schemeClr val="dk1"/>
+          </a:fillRef>
+          <a:effectRef idx="1">
+            <a:schemeClr val="dk1"/>
+          </a:effectRef>
+          <a:fontRef idx="minor">
+            <a:schemeClr val="tx1"/>
+          </a:fontRef>
+        </p:style>
+      </p:cxnSp>
+      <p:cxnSp>
+        <p:nvCxnSpPr>
+          <p:cNvPr id="22" name="Straight Arrow Connector 21">
+            <a:extLst>
+              <a:ext uri="{FF2B5EF4-FFF2-40B4-BE49-F238E27FC236}">
+                <a16:creationId xmlns:a16="http://schemas.microsoft.com/office/drawing/2014/main" id="{FE6D100E-8941-743C-29D6-0C71A5315607}"/>
+              </a:ext>
+            </a:extLst>
+          </p:cNvPr>
+          <p:cNvCxnSpPr>
+            <a:stCxn id="7" idx="2"/>
+            <a:endCxn id="13" idx="0"/>
+          </p:cNvCxnSpPr>
+          <p:nvPr/>
+        </p:nvCxnSpPr>
+        <p:spPr>
+          <a:xfrm flipH="1">
+            <a:off x="6095995" y="3304519"/>
+            <a:ext cx="1" cy="922264"/>
+          </a:xfrm>
+          <a:prstGeom prst="straightConnector1">
+            <a:avLst/>
+          </a:prstGeom>
+          <a:ln>
+            <a:tailEnd type="triangle"/>
+          </a:ln>
+        </p:spPr>
+        <p:style>
+          <a:lnRef idx="2">
+            <a:schemeClr val="dk1"/>
+          </a:lnRef>
+          <a:fillRef idx="0">
+            <a:schemeClr val="dk1"/>
+          </a:fillRef>
+          <a:effectRef idx="1">
+            <a:schemeClr val="dk1"/>
+          </a:effectRef>
+          <a:fontRef idx="minor">
+            <a:schemeClr val="tx1"/>
+          </a:fontRef>
+        </p:style>
+      </p:cxnSp>
+      <p:cxnSp>
+        <p:nvCxnSpPr>
+          <p:cNvPr id="24" name="Connector: Elbow 23">
+            <a:extLst>
+              <a:ext uri="{FF2B5EF4-FFF2-40B4-BE49-F238E27FC236}">
+                <a16:creationId xmlns:a16="http://schemas.microsoft.com/office/drawing/2014/main" id="{F9C580E9-8E79-1E8F-AB63-09D4FD405977}"/>
+              </a:ext>
+            </a:extLst>
+          </p:cNvPr>
+          <p:cNvCxnSpPr>
+            <a:stCxn id="14" idx="2"/>
+            <a:endCxn id="11" idx="0"/>
+          </p:cNvCxnSpPr>
+          <p:nvPr/>
+        </p:nvCxnSpPr>
+        <p:spPr>
+          <a:xfrm rot="16200000" flipH="1">
+            <a:off x="4500109" y="4070999"/>
+            <a:ext cx="521146" cy="2670629"/>
+          </a:xfrm>
+          <a:prstGeom prst="bentConnector3">
+            <a:avLst/>
+          </a:prstGeom>
+          <a:ln>
+            <a:tailEnd type="triangle"/>
+          </a:ln>
+        </p:spPr>
+        <p:style>
+          <a:lnRef idx="2">
+            <a:schemeClr val="dk1"/>
+          </a:lnRef>
+          <a:fillRef idx="0">
+            <a:schemeClr val="dk1"/>
+          </a:fillRef>
+          <a:effectRef idx="1">
+            <a:schemeClr val="dk1"/>
+          </a:effectRef>
+          <a:fontRef idx="minor">
+            <a:schemeClr val="tx1"/>
+          </a:fontRef>
+        </p:style>
+      </p:cxnSp>
+      <p:cxnSp>
+        <p:nvCxnSpPr>
+          <p:cNvPr id="26" name="Connector: Elbow 25">
+            <a:extLst>
+              <a:ext uri="{FF2B5EF4-FFF2-40B4-BE49-F238E27FC236}">
+                <a16:creationId xmlns:a16="http://schemas.microsoft.com/office/drawing/2014/main" id="{1C89D13F-0BBE-DCF1-45CA-92E7A51B7144}"/>
+              </a:ext>
+            </a:extLst>
+          </p:cNvPr>
+          <p:cNvCxnSpPr>
+            <a:stCxn id="10" idx="2"/>
+            <a:endCxn id="11" idx="0"/>
+          </p:cNvCxnSpPr>
+          <p:nvPr/>
+        </p:nvCxnSpPr>
+        <p:spPr>
+          <a:xfrm rot="5400000">
+            <a:off x="7170736" y="4071003"/>
+            <a:ext cx="521146" cy="2670623"/>
+          </a:xfrm>
+          <a:prstGeom prst="bentConnector3">
+            <a:avLst/>
+          </a:prstGeom>
+          <a:ln>
+            <a:tailEnd type="triangle"/>
+          </a:ln>
+        </p:spPr>
+        <p:style>
+          <a:lnRef idx="2">
+            <a:schemeClr val="dk1"/>
+          </a:lnRef>
+          <a:fillRef idx="0">
+            <a:schemeClr val="dk1"/>
+          </a:fillRef>
+          <a:effectRef idx="1">
+            <a:schemeClr val="dk1"/>
+          </a:effectRef>
+          <a:fontRef idx="minor">
+            <a:schemeClr val="tx1"/>
+          </a:fontRef>
+        </p:style>
+      </p:cxnSp>
+      <p:cxnSp>
+        <p:nvCxnSpPr>
+          <p:cNvPr id="28" name="Straight Arrow Connector 27">
+            <a:extLst>
+              <a:ext uri="{FF2B5EF4-FFF2-40B4-BE49-F238E27FC236}">
+                <a16:creationId xmlns:a16="http://schemas.microsoft.com/office/drawing/2014/main" id="{FB6D00F6-A407-C787-2346-1AA42382CD26}"/>
+              </a:ext>
+            </a:extLst>
+          </p:cNvPr>
+          <p:cNvCxnSpPr>
+            <a:stCxn id="13" idx="2"/>
+            <a:endCxn id="11" idx="0"/>
+          </p:cNvCxnSpPr>
+          <p:nvPr/>
+        </p:nvCxnSpPr>
+        <p:spPr>
+          <a:xfrm>
+            <a:off x="6095995" y="5145741"/>
+            <a:ext cx="2" cy="521146"/>
+          </a:xfrm>
+          <a:prstGeom prst="straightConnector1">
+            <a:avLst/>
+          </a:prstGeom>
+          <a:ln>
+            <a:tailEnd type="triangle"/>
+          </a:ln>
+        </p:spPr>
+        <p:style>
+          <a:lnRef idx="2">
+            <a:schemeClr val="dk1"/>
+          </a:lnRef>
+          <a:fillRef idx="0">
+            <a:schemeClr val="dk1"/>
+          </a:fillRef>
+          <a:effectRef idx="1">
+            <a:schemeClr val="dk1"/>
+          </a:effectRef>
+          <a:fontRef idx="minor">
+            <a:schemeClr val="tx1"/>
+          </a:fontRef>
+        </p:style>
+      </p:cxnSp>
+      <p:cxnSp>
+        <p:nvCxnSpPr>
+          <p:cNvPr id="60" name="Straight Connector 59">
+            <a:extLst>
+              <a:ext uri="{FF2B5EF4-FFF2-40B4-BE49-F238E27FC236}">
+                <a16:creationId xmlns:a16="http://schemas.microsoft.com/office/drawing/2014/main" id="{C98A81B2-15C8-2E73-697D-69BC47E647F4}"/>
+              </a:ext>
+            </a:extLst>
+          </p:cNvPr>
+          <p:cNvCxnSpPr>
+            <a:stCxn id="11" idx="3"/>
+          </p:cNvCxnSpPr>
+          <p:nvPr/>
+        </p:nvCxnSpPr>
+        <p:spPr>
+          <a:xfrm>
+            <a:off x="7794168" y="5888230"/>
+            <a:ext cx="2353132" cy="4570"/>
+          </a:xfrm>
+          <a:prstGeom prst="line">
+            <a:avLst/>
+          </a:prstGeom>
+        </p:spPr>
+        <p:style>
+          <a:lnRef idx="2">
+            <a:schemeClr val="dk1"/>
+          </a:lnRef>
+          <a:fillRef idx="0">
+            <a:schemeClr val="dk1"/>
+          </a:fillRef>
+          <a:effectRef idx="1">
+            <a:schemeClr val="dk1"/>
+          </a:effectRef>
+          <a:fontRef idx="minor">
+            <a:schemeClr val="tx1"/>
+          </a:fontRef>
+        </p:style>
+      </p:cxnSp>
+      <p:cxnSp>
+        <p:nvCxnSpPr>
+          <p:cNvPr id="62" name="Straight Connector 61">
+            <a:extLst>
+              <a:ext uri="{FF2B5EF4-FFF2-40B4-BE49-F238E27FC236}">
+                <a16:creationId xmlns:a16="http://schemas.microsoft.com/office/drawing/2014/main" id="{72E10347-06D2-B46A-6CF3-94D7E3ABF76C}"/>
+              </a:ext>
+            </a:extLst>
+          </p:cNvPr>
+          <p:cNvCxnSpPr>
+            <a:cxnSpLocks/>
+          </p:cNvCxnSpPr>
+          <p:nvPr/>
+        </p:nvCxnSpPr>
+        <p:spPr>
+          <a:xfrm flipV="1">
+            <a:off x="10160000" y="1943100"/>
+            <a:ext cx="0" cy="3949700"/>
+          </a:xfrm>
+          <a:prstGeom prst="line">
+            <a:avLst/>
+          </a:prstGeom>
+        </p:spPr>
+        <p:style>
+          <a:lnRef idx="2">
+            <a:schemeClr val="dk1"/>
+          </a:lnRef>
+          <a:fillRef idx="0">
+            <a:schemeClr val="dk1"/>
+          </a:fillRef>
+          <a:effectRef idx="1">
+            <a:schemeClr val="dk1"/>
+          </a:effectRef>
+          <a:fontRef idx="minor">
+            <a:schemeClr val="tx1"/>
+          </a:fontRef>
+        </p:style>
+      </p:cxnSp>
+      <p:cxnSp>
+        <p:nvCxnSpPr>
+          <p:cNvPr id="64" name="Straight Arrow Connector 63">
+            <a:extLst>
+              <a:ext uri="{FF2B5EF4-FFF2-40B4-BE49-F238E27FC236}">
+                <a16:creationId xmlns:a16="http://schemas.microsoft.com/office/drawing/2014/main" id="{DA842740-3219-9EF7-D5E9-592606E6A6CE}"/>
+              </a:ext>
+            </a:extLst>
+          </p:cNvPr>
+          <p:cNvCxnSpPr>
+            <a:cxnSpLocks/>
+            <a:endCxn id="5" idx="3"/>
+          </p:cNvCxnSpPr>
+          <p:nvPr/>
+        </p:nvCxnSpPr>
+        <p:spPr>
+          <a:xfrm flipH="1" flipV="1">
+            <a:off x="7794171" y="1933602"/>
+            <a:ext cx="2365829" cy="9498"/>
+          </a:xfrm>
+          <a:prstGeom prst="straightConnector1">
+            <a:avLst/>
+          </a:prstGeom>
+          <a:ln>
+            <a:tailEnd type="triangle"/>
+          </a:ln>
+        </p:spPr>
+        <p:style>
+          <a:lnRef idx="2">
+            <a:schemeClr val="dk1"/>
+          </a:lnRef>
+          <a:fillRef idx="0">
+            <a:schemeClr val="dk1"/>
+          </a:fillRef>
+          <a:effectRef idx="1">
+            <a:schemeClr val="dk1"/>
+          </a:effectRef>
+          <a:fontRef idx="minor">
+            <a:schemeClr val="tx1"/>
+          </a:fontRef>
+        </p:style>
+      </p:cxnSp>
+      <p:cxnSp>
+        <p:nvCxnSpPr>
+          <p:cNvPr id="68" name="Straight Arrow Connector 67">
+            <a:extLst>
+              <a:ext uri="{FF2B5EF4-FFF2-40B4-BE49-F238E27FC236}">
+                <a16:creationId xmlns:a16="http://schemas.microsoft.com/office/drawing/2014/main" id="{2D61EA22-C9A4-D74D-0276-BA2D71358CFF}"/>
+              </a:ext>
+            </a:extLst>
+          </p:cNvPr>
+          <p:cNvCxnSpPr>
+            <a:stCxn id="4" idx="2"/>
+            <a:endCxn id="5" idx="0"/>
+          </p:cNvCxnSpPr>
+          <p:nvPr/>
+        </p:nvCxnSpPr>
+        <p:spPr>
+          <a:xfrm>
+            <a:off x="6095998" y="1395226"/>
+            <a:ext cx="2" cy="317033"/>
+          </a:xfrm>
+          <a:prstGeom prst="straightConnector1">
+            <a:avLst/>
+          </a:prstGeom>
+          <a:ln>
+            <a:tailEnd type="triangle"/>
+          </a:ln>
+        </p:spPr>
+        <p:style>
+          <a:lnRef idx="2">
+            <a:schemeClr val="dk1"/>
+          </a:lnRef>
+          <a:fillRef idx="0">
+            <a:schemeClr val="dk1"/>
+          </a:fillRef>
+          <a:effectRef idx="1">
+            <a:schemeClr val="dk1"/>
+          </a:effectRef>
+          <a:fontRef idx="minor">
+            <a:schemeClr val="tx1"/>
+          </a:fontRef>
+        </p:style>
+      </p:cxnSp>
+      <p:cxnSp>
+        <p:nvCxnSpPr>
+          <p:cNvPr id="70" name="Straight Arrow Connector 69">
+            <a:extLst>
+              <a:ext uri="{FF2B5EF4-FFF2-40B4-BE49-F238E27FC236}">
+                <a16:creationId xmlns:a16="http://schemas.microsoft.com/office/drawing/2014/main" id="{E5B654EA-E6A5-4BF9-FE8B-3AECDD898393}"/>
+              </a:ext>
+            </a:extLst>
+          </p:cNvPr>
+          <p:cNvCxnSpPr>
+            <a:stCxn id="5" idx="2"/>
+            <a:endCxn id="7" idx="0"/>
+          </p:cNvCxnSpPr>
+          <p:nvPr/>
+        </p:nvCxnSpPr>
+        <p:spPr>
+          <a:xfrm flipH="1">
+            <a:off x="6095996" y="2154945"/>
+            <a:ext cx="4" cy="706888"/>
+          </a:xfrm>
+          <a:prstGeom prst="straightConnector1">
+            <a:avLst/>
+          </a:prstGeom>
+          <a:ln>
+            <a:tailEnd type="triangle"/>
+          </a:ln>
+        </p:spPr>
+        <p:style>
+          <a:lnRef idx="2">
+            <a:schemeClr val="dk1"/>
+          </a:lnRef>
+          <a:fillRef idx="0">
+            <a:schemeClr val="dk1"/>
+          </a:fillRef>
+          <a:effectRef idx="1">
+            <a:schemeClr val="dk1"/>
+          </a:effectRef>
+          <a:fontRef idx="minor">
+            <a:schemeClr val="tx1"/>
+          </a:fontRef>
+        </p:style>
+      </p:cxnSp>
+    </p:spTree>
+    <p:extLst>
+      <p:ext uri="{BB962C8B-B14F-4D97-AF65-F5344CB8AC3E}">
+        <p14:creationId xmlns:p14="http://schemas.microsoft.com/office/powerpoint/2010/main" val="649960317"/>
+      </p:ext>
+    </p:extLst>
+  </p:cSld>
+  <p:clrMapOvr>
+    <a:masterClrMapping/>
+  </p:clrMapOvr>
+</p:sld>
+</file>
+
+<file path=ppt/slides/slide12.xml><?xml version="1.0" encoding="utf-8"?>
+<p:sld xmlns:a="http://schemas.openxmlformats.org/drawingml/2006/main" xmlns:r="http://schemas.openxmlformats.org/officeDocument/2006/relationships" xmlns:p="http://schemas.openxmlformats.org/presentationml/2006/main">
+  <p:cSld>
+    <p:spTree>
+      <p:nvGrpSpPr>
+        <p:cNvPr id="1" name=""/>
+        <p:cNvGrpSpPr/>
+        <p:nvPr/>
+      </p:nvGrpSpPr>
+      <p:grpSpPr>
+        <a:xfrm>
+          <a:off x="0" y="0"/>
+          <a:ext cx="0" cy="0"/>
+          <a:chOff x="0" y="0"/>
+          <a:chExt cx="0" cy="0"/>
+        </a:xfrm>
+      </p:grpSpPr>
+      <p:sp>
+        <p:nvSpPr>
+          <p:cNvPr id="2" name="Oval 1">
+            <a:extLst>
+              <a:ext uri="{FF2B5EF4-FFF2-40B4-BE49-F238E27FC236}">
+                <a16:creationId xmlns:a16="http://schemas.microsoft.com/office/drawing/2014/main" id="{77CED487-EC9D-C1F7-B17E-3A44C10E3D8E}"/>
+              </a:ext>
+            </a:extLst>
+          </p:cNvPr>
+          <p:cNvSpPr/>
+          <p:nvPr/>
+        </p:nvSpPr>
+        <p:spPr>
+          <a:xfrm>
+            <a:off x="994227" y="557529"/>
+            <a:ext cx="1844040" cy="838200"/>
+          </a:xfrm>
+          <a:prstGeom prst="ellipse">
+            <a:avLst/>
+          </a:prstGeom>
+          <a:solidFill>
+            <a:schemeClr val="bg2"/>
+          </a:solidFill>
+          <a:ln>
+            <a:solidFill>
+              <a:schemeClr val="tx1"/>
+            </a:solidFill>
+          </a:ln>
+        </p:spPr>
+        <p:style>
+          <a:lnRef idx="2">
+            <a:schemeClr val="dk1"/>
+          </a:lnRef>
+          <a:fillRef idx="1">
+            <a:schemeClr val="lt1"/>
+          </a:fillRef>
+          <a:effectRef idx="0">
+            <a:schemeClr val="dk1"/>
+          </a:effectRef>
+          <a:fontRef idx="minor">
+            <a:schemeClr val="dk1"/>
+          </a:fontRef>
+        </p:style>
+        <p:txBody>
+          <a:bodyPr rtlCol="0" anchor="ctr"/>
+          <a:lstStyle/>
+          <a:p>
+            <a:pPr algn="ctr"/>
+            <a:r>
+              <a:rPr lang="en-US">
+                <a:solidFill>
+                  <a:schemeClr val="tx1"/>
+                </a:solidFill>
+                <a:latin typeface="Times New Roman" panose="02020603050405020304" pitchFamily="18" charset="0"/>
+                <a:cs typeface="Times New Roman" panose="02020603050405020304" pitchFamily="18" charset="0"/>
+              </a:rPr>
+              <a:t>Bắt đầu</a:t>
+            </a:r>
+          </a:p>
+        </p:txBody>
+      </p:sp>
+      <p:sp>
+        <p:nvSpPr>
+          <p:cNvPr id="3" name="Rectangle: Rounded Corners 2">
+            <a:extLst>
+              <a:ext uri="{FF2B5EF4-FFF2-40B4-BE49-F238E27FC236}">
+                <a16:creationId xmlns:a16="http://schemas.microsoft.com/office/drawing/2014/main" id="{1AB19B60-C3F6-5444-5F43-179014C1CCC8}"/>
+              </a:ext>
+            </a:extLst>
+          </p:cNvPr>
+          <p:cNvSpPr/>
+          <p:nvPr/>
+        </p:nvSpPr>
+        <p:spPr>
+          <a:xfrm>
+            <a:off x="4666339" y="558072"/>
+            <a:ext cx="2859315" cy="837657"/>
+          </a:xfrm>
+          <a:prstGeom prst="roundRect">
+            <a:avLst/>
+          </a:prstGeom>
+          <a:solidFill>
+            <a:schemeClr val="bg2"/>
+          </a:solidFill>
+          <a:ln>
+            <a:solidFill>
+              <a:schemeClr val="tx1"/>
+            </a:solidFill>
+          </a:ln>
+        </p:spPr>
+        <p:style>
+          <a:lnRef idx="2">
+            <a:schemeClr val="accent1">
+              <a:shade val="15000"/>
+            </a:schemeClr>
+          </a:lnRef>
+          <a:fillRef idx="1">
+            <a:schemeClr val="accent1"/>
+          </a:fillRef>
+          <a:effectRef idx="0">
+            <a:schemeClr val="accent1"/>
+          </a:effectRef>
+          <a:fontRef idx="minor">
+            <a:schemeClr val="lt1"/>
+          </a:fontRef>
+        </p:style>
+        <p:txBody>
+          <a:bodyPr rtlCol="0" anchor="ctr"/>
+          <a:lstStyle/>
+          <a:p>
+            <a:pPr algn="ctr"/>
+            <a:r>
+              <a:rPr lang="en-US">
+                <a:solidFill>
+                  <a:schemeClr val="tx1"/>
+                </a:solidFill>
+                <a:latin typeface="Times New Roman" panose="02020603050405020304" pitchFamily="18" charset="0"/>
+                <a:cs typeface="Times New Roman" panose="02020603050405020304" pitchFamily="18" charset="0"/>
+              </a:rPr>
+              <a:t>Người dùng lựa chọn các</a:t>
+            </a:r>
+          </a:p>
+          <a:p>
+            <a:pPr algn="ctr"/>
+            <a:r>
+              <a:rPr lang="en-US">
+                <a:solidFill>
+                  <a:schemeClr val="tx1"/>
+                </a:solidFill>
+                <a:latin typeface="Times New Roman" panose="02020603050405020304" pitchFamily="18" charset="0"/>
+                <a:cs typeface="Times New Roman" panose="02020603050405020304" pitchFamily="18" charset="0"/>
+              </a:rPr>
+              <a:t>cài đặt tùy chọn</a:t>
+            </a:r>
+          </a:p>
+        </p:txBody>
+      </p:sp>
+      <p:sp>
+        <p:nvSpPr>
+          <p:cNvPr id="5" name="Rectangle: Rounded Corners 4">
+            <a:extLst>
+              <a:ext uri="{FF2B5EF4-FFF2-40B4-BE49-F238E27FC236}">
+                <a16:creationId xmlns:a16="http://schemas.microsoft.com/office/drawing/2014/main" id="{66666381-152F-F2B7-0F1D-ABE9AA69BF20}"/>
+              </a:ext>
+            </a:extLst>
+          </p:cNvPr>
+          <p:cNvSpPr/>
+          <p:nvPr/>
+        </p:nvSpPr>
+        <p:spPr>
+          <a:xfrm>
+            <a:off x="4666339" y="2443279"/>
+            <a:ext cx="2859315" cy="837657"/>
+          </a:xfrm>
+          <a:prstGeom prst="roundRect">
+            <a:avLst/>
+          </a:prstGeom>
+          <a:solidFill>
+            <a:schemeClr val="bg2"/>
+          </a:solidFill>
+          <a:ln>
+            <a:solidFill>
+              <a:schemeClr val="tx1"/>
+            </a:solidFill>
+            <a:prstDash val="dash"/>
+          </a:ln>
+        </p:spPr>
+        <p:style>
+          <a:lnRef idx="2">
+            <a:schemeClr val="accent1">
+              <a:shade val="15000"/>
+            </a:schemeClr>
+          </a:lnRef>
+          <a:fillRef idx="1">
+            <a:schemeClr val="accent1"/>
+          </a:fillRef>
+          <a:effectRef idx="0">
+            <a:schemeClr val="accent1"/>
+          </a:effectRef>
+          <a:fontRef idx="minor">
+            <a:schemeClr val="lt1"/>
+          </a:fontRef>
+        </p:style>
+        <p:txBody>
+          <a:bodyPr rtlCol="0" anchor="ctr"/>
+          <a:lstStyle/>
+          <a:p>
+            <a:pPr algn="ctr"/>
+            <a:r>
+              <a:rPr lang="en-US">
+                <a:solidFill>
+                  <a:schemeClr val="tx1"/>
+                </a:solidFill>
+                <a:latin typeface="Times New Roman" panose="02020603050405020304" pitchFamily="18" charset="0"/>
+                <a:cs typeface="Times New Roman" panose="02020603050405020304" pitchFamily="18" charset="0"/>
+              </a:rPr>
+              <a:t>Chọn sử dụng streaming khi</a:t>
+            </a:r>
+          </a:p>
+          <a:p>
+            <a:pPr algn="ctr"/>
+            <a:r>
+              <a:rPr lang="en-US">
+                <a:solidFill>
+                  <a:schemeClr val="tx1"/>
+                </a:solidFill>
+                <a:latin typeface="Times New Roman" panose="02020603050405020304" pitchFamily="18" charset="0"/>
+                <a:cs typeface="Times New Roman" panose="02020603050405020304" pitchFamily="18" charset="0"/>
+              </a:rPr>
+              <a:t>sinh phản hồi hay không</a:t>
+            </a:r>
+          </a:p>
+        </p:txBody>
+      </p:sp>
+      <p:sp>
+        <p:nvSpPr>
+          <p:cNvPr id="6" name="Rectangle: Rounded Corners 5">
+            <a:extLst>
+              <a:ext uri="{FF2B5EF4-FFF2-40B4-BE49-F238E27FC236}">
+                <a16:creationId xmlns:a16="http://schemas.microsoft.com/office/drawing/2014/main" id="{B3ED9545-85A4-EC52-6D48-EA294F061EEC}"/>
+              </a:ext>
+            </a:extLst>
+          </p:cNvPr>
+          <p:cNvSpPr/>
+          <p:nvPr/>
+        </p:nvSpPr>
+        <p:spPr>
+          <a:xfrm>
+            <a:off x="994227" y="2443278"/>
+            <a:ext cx="2859315" cy="837657"/>
+          </a:xfrm>
+          <a:prstGeom prst="roundRect">
+            <a:avLst/>
+          </a:prstGeom>
+          <a:solidFill>
+            <a:schemeClr val="bg2"/>
+          </a:solidFill>
+          <a:ln>
+            <a:solidFill>
+              <a:schemeClr val="tx1"/>
+            </a:solidFill>
+            <a:prstDash val="dash"/>
+          </a:ln>
+        </p:spPr>
+        <p:style>
+          <a:lnRef idx="2">
+            <a:schemeClr val="accent1">
+              <a:shade val="15000"/>
+            </a:schemeClr>
+          </a:lnRef>
+          <a:fillRef idx="1">
+            <a:schemeClr val="accent1"/>
+          </a:fillRef>
+          <a:effectRef idx="0">
+            <a:schemeClr val="accent1"/>
+          </a:effectRef>
+          <a:fontRef idx="minor">
+            <a:schemeClr val="lt1"/>
+          </a:fontRef>
+        </p:style>
+        <p:txBody>
+          <a:bodyPr rtlCol="0" anchor="ctr"/>
+          <a:lstStyle/>
+          <a:p>
+            <a:pPr algn="ctr"/>
+            <a:r>
+              <a:rPr lang="en-US">
+                <a:solidFill>
+                  <a:schemeClr val="tx1"/>
+                </a:solidFill>
+                <a:latin typeface="Times New Roman" panose="02020603050405020304" pitchFamily="18" charset="0"/>
+                <a:cs typeface="Times New Roman" panose="02020603050405020304" pitchFamily="18" charset="0"/>
+              </a:rPr>
+              <a:t>Lựa chọn mô hình LLM</a:t>
+            </a:r>
+          </a:p>
+          <a:p>
+            <a:pPr algn="ctr"/>
+            <a:r>
+              <a:rPr lang="en-US">
+                <a:solidFill>
+                  <a:schemeClr val="tx1"/>
+                </a:solidFill>
+                <a:latin typeface="Times New Roman" panose="02020603050405020304" pitchFamily="18" charset="0"/>
+                <a:cs typeface="Times New Roman" panose="02020603050405020304" pitchFamily="18" charset="0"/>
+              </a:rPr>
+              <a:t>sẽ sinh phản hồi</a:t>
+            </a:r>
+          </a:p>
+        </p:txBody>
+      </p:sp>
+      <p:sp>
+        <p:nvSpPr>
+          <p:cNvPr id="7" name="Rectangle: Rounded Corners 6">
+            <a:extLst>
+              <a:ext uri="{FF2B5EF4-FFF2-40B4-BE49-F238E27FC236}">
+                <a16:creationId xmlns:a16="http://schemas.microsoft.com/office/drawing/2014/main" id="{BDF037F5-B213-F186-DA20-182B7F151232}"/>
+              </a:ext>
+            </a:extLst>
+          </p:cNvPr>
+          <p:cNvSpPr/>
+          <p:nvPr/>
+        </p:nvSpPr>
+        <p:spPr>
+          <a:xfrm>
+            <a:off x="8338451" y="2423613"/>
+            <a:ext cx="2859315" cy="857320"/>
+          </a:xfrm>
+          <a:prstGeom prst="roundRect">
+            <a:avLst/>
+          </a:prstGeom>
+          <a:solidFill>
+            <a:schemeClr val="bg2"/>
+          </a:solidFill>
+          <a:ln>
+            <a:solidFill>
+              <a:schemeClr val="tx1"/>
+            </a:solidFill>
+            <a:prstDash val="dash"/>
+          </a:ln>
+        </p:spPr>
+        <p:style>
+          <a:lnRef idx="2">
+            <a:schemeClr val="accent1">
+              <a:shade val="15000"/>
+            </a:schemeClr>
+          </a:lnRef>
+          <a:fillRef idx="1">
+            <a:schemeClr val="accent1"/>
+          </a:fillRef>
+          <a:effectRef idx="0">
+            <a:schemeClr val="accent1"/>
+          </a:effectRef>
+          <a:fontRef idx="minor">
+            <a:schemeClr val="lt1"/>
+          </a:fontRef>
+        </p:style>
+        <p:txBody>
+          <a:bodyPr rtlCol="0" anchor="ctr"/>
+          <a:lstStyle/>
+          <a:p>
+            <a:pPr algn="ctr"/>
+            <a:r>
+              <a:rPr lang="en-US">
+                <a:solidFill>
+                  <a:schemeClr val="tx1"/>
+                </a:solidFill>
+                <a:latin typeface="Times New Roman" panose="02020603050405020304" pitchFamily="18" charset="0"/>
+                <a:cs typeface="Times New Roman" panose="02020603050405020304" pitchFamily="18" charset="0"/>
+              </a:rPr>
+              <a:t>Lựa chọn độ “thân thiện”</a:t>
+            </a:r>
+          </a:p>
+          <a:p>
+            <a:pPr algn="ctr"/>
+            <a:r>
+              <a:rPr lang="en-US">
+                <a:solidFill>
+                  <a:schemeClr val="tx1"/>
+                </a:solidFill>
+                <a:latin typeface="Times New Roman" panose="02020603050405020304" pitchFamily="18" charset="0"/>
+                <a:cs typeface="Times New Roman" panose="02020603050405020304" pitchFamily="18" charset="0"/>
+              </a:rPr>
+              <a:t>của phản hồi</a:t>
+            </a:r>
+          </a:p>
+        </p:txBody>
+      </p:sp>
+      <p:sp>
+        <p:nvSpPr>
+          <p:cNvPr id="8" name="Rectangle: Rounded Corners 7">
+            <a:extLst>
+              <a:ext uri="{FF2B5EF4-FFF2-40B4-BE49-F238E27FC236}">
+                <a16:creationId xmlns:a16="http://schemas.microsoft.com/office/drawing/2014/main" id="{1C4C8401-2614-0C9B-8301-5C8989FEA059}"/>
+              </a:ext>
+            </a:extLst>
+          </p:cNvPr>
+          <p:cNvSpPr/>
+          <p:nvPr/>
+        </p:nvSpPr>
+        <p:spPr>
+          <a:xfrm>
+            <a:off x="4666339" y="3915940"/>
+            <a:ext cx="2859315" cy="837657"/>
+          </a:xfrm>
+          <a:prstGeom prst="roundRect">
+            <a:avLst/>
+          </a:prstGeom>
+          <a:solidFill>
+            <a:schemeClr val="bg2"/>
+          </a:solidFill>
+          <a:ln>
+            <a:solidFill>
+              <a:schemeClr val="tx1"/>
+            </a:solidFill>
+          </a:ln>
+        </p:spPr>
+        <p:style>
+          <a:lnRef idx="2">
+            <a:schemeClr val="accent1">
+              <a:shade val="15000"/>
+            </a:schemeClr>
+          </a:lnRef>
+          <a:fillRef idx="1">
+            <a:schemeClr val="accent1"/>
+          </a:fillRef>
+          <a:effectRef idx="0">
+            <a:schemeClr val="accent1"/>
+          </a:effectRef>
+          <a:fontRef idx="minor">
+            <a:schemeClr val="lt1"/>
+          </a:fontRef>
+        </p:style>
+        <p:txBody>
+          <a:bodyPr rtlCol="0" anchor="ctr"/>
+          <a:lstStyle/>
+          <a:p>
+            <a:pPr algn="ctr"/>
+            <a:r>
+              <a:rPr lang="en-US">
+                <a:solidFill>
+                  <a:schemeClr val="tx1"/>
+                </a:solidFill>
+                <a:latin typeface="Times New Roman" panose="02020603050405020304" pitchFamily="18" charset="0"/>
+                <a:cs typeface="Times New Roman" panose="02020603050405020304" pitchFamily="18" charset="0"/>
+              </a:rPr>
+              <a:t>Áp dụng cài đặt tùy chọn cho phản hồi tiếp theo</a:t>
+            </a:r>
+          </a:p>
+        </p:txBody>
+      </p:sp>
+      <p:sp>
+        <p:nvSpPr>
+          <p:cNvPr id="9" name="Oval 8">
+            <a:extLst>
+              <a:ext uri="{FF2B5EF4-FFF2-40B4-BE49-F238E27FC236}">
+                <a16:creationId xmlns:a16="http://schemas.microsoft.com/office/drawing/2014/main" id="{5DAC9F1C-A7FA-6017-347A-E665382BDD60}"/>
+              </a:ext>
+            </a:extLst>
+          </p:cNvPr>
+          <p:cNvSpPr/>
+          <p:nvPr/>
+        </p:nvSpPr>
+        <p:spPr>
+          <a:xfrm>
+            <a:off x="5173976" y="5388601"/>
+            <a:ext cx="1844040" cy="838200"/>
+          </a:xfrm>
+          <a:prstGeom prst="ellipse">
+            <a:avLst/>
+          </a:prstGeom>
+          <a:solidFill>
+            <a:schemeClr val="bg2"/>
+          </a:solidFill>
+          <a:ln>
+            <a:solidFill>
+              <a:schemeClr val="tx1"/>
+            </a:solidFill>
+          </a:ln>
+        </p:spPr>
+        <p:style>
+          <a:lnRef idx="2">
+            <a:schemeClr val="dk1"/>
+          </a:lnRef>
+          <a:fillRef idx="1">
+            <a:schemeClr val="lt1"/>
+          </a:fillRef>
+          <a:effectRef idx="0">
+            <a:schemeClr val="dk1"/>
+          </a:effectRef>
+          <a:fontRef idx="minor">
+            <a:schemeClr val="dk1"/>
+          </a:fontRef>
+        </p:style>
+        <p:txBody>
+          <a:bodyPr rtlCol="0" anchor="ctr"/>
+          <a:lstStyle/>
+          <a:p>
+            <a:pPr algn="ctr"/>
+            <a:r>
+              <a:rPr lang="en-US">
+                <a:solidFill>
+                  <a:schemeClr val="tx1"/>
+                </a:solidFill>
+                <a:latin typeface="Times New Roman" panose="02020603050405020304" pitchFamily="18" charset="0"/>
+                <a:cs typeface="Times New Roman" panose="02020603050405020304" pitchFamily="18" charset="0"/>
+              </a:rPr>
+              <a:t>Kết thúc</a:t>
+            </a:r>
+          </a:p>
+        </p:txBody>
+      </p:sp>
+      <p:cxnSp>
+        <p:nvCxnSpPr>
+          <p:cNvPr id="11" name="Straight Arrow Connector 10">
+            <a:extLst>
+              <a:ext uri="{FF2B5EF4-FFF2-40B4-BE49-F238E27FC236}">
+                <a16:creationId xmlns:a16="http://schemas.microsoft.com/office/drawing/2014/main" id="{CF3AABFA-E81C-3DA9-3929-6C4D726031DA}"/>
+              </a:ext>
+            </a:extLst>
+          </p:cNvPr>
+          <p:cNvCxnSpPr>
+            <a:stCxn id="2" idx="6"/>
+            <a:endCxn id="3" idx="1"/>
+          </p:cNvCxnSpPr>
+          <p:nvPr/>
+        </p:nvCxnSpPr>
+        <p:spPr>
+          <a:xfrm>
+            <a:off x="2838267" y="976629"/>
+            <a:ext cx="1828072" cy="272"/>
+          </a:xfrm>
+          <a:prstGeom prst="straightConnector1">
+            <a:avLst/>
+          </a:prstGeom>
+          <a:ln>
+            <a:tailEnd type="triangle"/>
+          </a:ln>
+        </p:spPr>
+        <p:style>
+          <a:lnRef idx="2">
+            <a:schemeClr val="dk1"/>
+          </a:lnRef>
+          <a:fillRef idx="0">
+            <a:schemeClr val="dk1"/>
+          </a:fillRef>
+          <a:effectRef idx="1">
+            <a:schemeClr val="dk1"/>
+          </a:effectRef>
+          <a:fontRef idx="minor">
+            <a:schemeClr val="tx1"/>
+          </a:fontRef>
+        </p:style>
+      </p:cxnSp>
+      <p:cxnSp>
+        <p:nvCxnSpPr>
+          <p:cNvPr id="13" name="Connector: Elbow 12">
+            <a:extLst>
+              <a:ext uri="{FF2B5EF4-FFF2-40B4-BE49-F238E27FC236}">
+                <a16:creationId xmlns:a16="http://schemas.microsoft.com/office/drawing/2014/main" id="{D34FF8B5-C2AD-CECE-E769-23CF3686B352}"/>
+              </a:ext>
+            </a:extLst>
+          </p:cNvPr>
+          <p:cNvCxnSpPr>
+            <a:stCxn id="3" idx="2"/>
+            <a:endCxn id="6" idx="0"/>
+          </p:cNvCxnSpPr>
+          <p:nvPr/>
+        </p:nvCxnSpPr>
+        <p:spPr>
+          <a:xfrm rot="5400000">
+            <a:off x="3736167" y="83447"/>
+            <a:ext cx="1047549" cy="3672112"/>
+          </a:xfrm>
+          <a:prstGeom prst="bentConnector3">
+            <a:avLst/>
+          </a:prstGeom>
+          <a:ln>
+            <a:tailEnd type="triangle"/>
+          </a:ln>
+        </p:spPr>
+        <p:style>
+          <a:lnRef idx="2">
+            <a:schemeClr val="dk1"/>
+          </a:lnRef>
+          <a:fillRef idx="0">
+            <a:schemeClr val="dk1"/>
+          </a:fillRef>
+          <a:effectRef idx="1">
+            <a:schemeClr val="dk1"/>
+          </a:effectRef>
+          <a:fontRef idx="minor">
+            <a:schemeClr val="tx1"/>
+          </a:fontRef>
+        </p:style>
+      </p:cxnSp>
+      <p:cxnSp>
+        <p:nvCxnSpPr>
+          <p:cNvPr id="15" name="Connector: Elbow 14">
+            <a:extLst>
+              <a:ext uri="{FF2B5EF4-FFF2-40B4-BE49-F238E27FC236}">
+                <a16:creationId xmlns:a16="http://schemas.microsoft.com/office/drawing/2014/main" id="{F1D76289-375D-3C3C-77EB-EDBE077429A1}"/>
+              </a:ext>
+            </a:extLst>
+          </p:cNvPr>
+          <p:cNvCxnSpPr>
+            <a:cxnSpLocks/>
+            <a:stCxn id="3" idx="2"/>
+            <a:endCxn id="7" idx="0"/>
+          </p:cNvCxnSpPr>
+          <p:nvPr/>
+        </p:nvCxnSpPr>
+        <p:spPr>
+          <a:xfrm rot="16200000" flipH="1">
+            <a:off x="7418111" y="73615"/>
+            <a:ext cx="1027884" cy="3672112"/>
+          </a:xfrm>
+          <a:prstGeom prst="bentConnector3">
+            <a:avLst>
+              <a:gd name="adj1" fmla="val 50927"/>
+            </a:avLst>
+          </a:prstGeom>
+          <a:ln>
+            <a:tailEnd type="triangle"/>
+          </a:ln>
+        </p:spPr>
+        <p:style>
+          <a:lnRef idx="2">
+            <a:schemeClr val="dk1"/>
+          </a:lnRef>
+          <a:fillRef idx="0">
+            <a:schemeClr val="dk1"/>
+          </a:fillRef>
+          <a:effectRef idx="1">
+            <a:schemeClr val="dk1"/>
+          </a:effectRef>
+          <a:fontRef idx="minor">
+            <a:schemeClr val="tx1"/>
+          </a:fontRef>
+        </p:style>
+      </p:cxnSp>
+      <p:cxnSp>
+        <p:nvCxnSpPr>
+          <p:cNvPr id="17" name="Straight Arrow Connector 16">
+            <a:extLst>
+              <a:ext uri="{FF2B5EF4-FFF2-40B4-BE49-F238E27FC236}">
+                <a16:creationId xmlns:a16="http://schemas.microsoft.com/office/drawing/2014/main" id="{ECD5ABF1-E50E-E16D-84CD-C5C8E41F8327}"/>
+              </a:ext>
+            </a:extLst>
+          </p:cNvPr>
+          <p:cNvCxnSpPr>
+            <a:stCxn id="3" idx="2"/>
+            <a:endCxn id="5" idx="0"/>
+          </p:cNvCxnSpPr>
+          <p:nvPr/>
+        </p:nvCxnSpPr>
+        <p:spPr>
+          <a:xfrm>
+            <a:off x="6095997" y="1395729"/>
+            <a:ext cx="0" cy="1047550"/>
+          </a:xfrm>
+          <a:prstGeom prst="straightConnector1">
+            <a:avLst/>
+          </a:prstGeom>
+          <a:ln>
+            <a:tailEnd type="triangle"/>
+          </a:ln>
+        </p:spPr>
+        <p:style>
+          <a:lnRef idx="2">
+            <a:schemeClr val="dk1"/>
+          </a:lnRef>
+          <a:fillRef idx="0">
+            <a:schemeClr val="dk1"/>
+          </a:fillRef>
+          <a:effectRef idx="1">
+            <a:schemeClr val="dk1"/>
+          </a:effectRef>
+          <a:fontRef idx="minor">
+            <a:schemeClr val="tx1"/>
+          </a:fontRef>
+        </p:style>
+      </p:cxnSp>
+      <p:cxnSp>
+        <p:nvCxnSpPr>
+          <p:cNvPr id="20" name="Connector: Elbow 19">
+            <a:extLst>
+              <a:ext uri="{FF2B5EF4-FFF2-40B4-BE49-F238E27FC236}">
+                <a16:creationId xmlns:a16="http://schemas.microsoft.com/office/drawing/2014/main" id="{CA280FE3-81C5-D2CD-D963-293BB29A7BCC}"/>
+              </a:ext>
+            </a:extLst>
+          </p:cNvPr>
+          <p:cNvCxnSpPr>
+            <a:stCxn id="6" idx="2"/>
+            <a:endCxn id="8" idx="0"/>
+          </p:cNvCxnSpPr>
+          <p:nvPr/>
+        </p:nvCxnSpPr>
+        <p:spPr>
+          <a:xfrm rot="16200000" flipH="1">
+            <a:off x="3942439" y="1762381"/>
+            <a:ext cx="635005" cy="3672112"/>
+          </a:xfrm>
+          <a:prstGeom prst="bentConnector3">
+            <a:avLst/>
+          </a:prstGeom>
+          <a:ln>
+            <a:tailEnd type="triangle"/>
+          </a:ln>
+        </p:spPr>
+        <p:style>
+          <a:lnRef idx="2">
+            <a:schemeClr val="dk1"/>
+          </a:lnRef>
+          <a:fillRef idx="0">
+            <a:schemeClr val="dk1"/>
+          </a:fillRef>
+          <a:effectRef idx="1">
+            <a:schemeClr val="dk1"/>
+          </a:effectRef>
+          <a:fontRef idx="minor">
+            <a:schemeClr val="tx1"/>
+          </a:fontRef>
+        </p:style>
+      </p:cxnSp>
+      <p:cxnSp>
+        <p:nvCxnSpPr>
+          <p:cNvPr id="22" name="Connector: Elbow 21">
+            <a:extLst>
+              <a:ext uri="{FF2B5EF4-FFF2-40B4-BE49-F238E27FC236}">
+                <a16:creationId xmlns:a16="http://schemas.microsoft.com/office/drawing/2014/main" id="{BABF387F-162D-4BDA-2E13-4D97F788CD90}"/>
+              </a:ext>
+            </a:extLst>
+          </p:cNvPr>
+          <p:cNvCxnSpPr>
+            <a:cxnSpLocks/>
+            <a:stCxn id="7" idx="2"/>
+            <a:endCxn id="8" idx="0"/>
+          </p:cNvCxnSpPr>
+          <p:nvPr/>
+        </p:nvCxnSpPr>
+        <p:spPr>
+          <a:xfrm rot="5400000">
+            <a:off x="7614550" y="1762380"/>
+            <a:ext cx="635007" cy="3672112"/>
+          </a:xfrm>
+          <a:prstGeom prst="bentConnector3">
+            <a:avLst>
+              <a:gd name="adj1" fmla="val 50000"/>
+            </a:avLst>
+          </a:prstGeom>
+          <a:ln>
+            <a:solidFill>
+              <a:schemeClr val="tx1"/>
+            </a:solidFill>
+            <a:tailEnd type="triangle"/>
+          </a:ln>
+        </p:spPr>
+        <p:style>
+          <a:lnRef idx="2">
+            <a:schemeClr val="accent1"/>
+          </a:lnRef>
+          <a:fillRef idx="0">
+            <a:schemeClr val="accent1"/>
+          </a:fillRef>
+          <a:effectRef idx="1">
+            <a:schemeClr val="accent1"/>
+          </a:effectRef>
+          <a:fontRef idx="minor">
+            <a:schemeClr val="tx1"/>
+          </a:fontRef>
+        </p:style>
+      </p:cxnSp>
+      <p:cxnSp>
+        <p:nvCxnSpPr>
+          <p:cNvPr id="24" name="Straight Arrow Connector 23">
+            <a:extLst>
+              <a:ext uri="{FF2B5EF4-FFF2-40B4-BE49-F238E27FC236}">
+                <a16:creationId xmlns:a16="http://schemas.microsoft.com/office/drawing/2014/main" id="{E057C5D9-2615-466F-FFDA-7EDB739064CD}"/>
+              </a:ext>
+            </a:extLst>
+          </p:cNvPr>
+          <p:cNvCxnSpPr>
+            <a:stCxn id="5" idx="2"/>
+            <a:endCxn id="8" idx="0"/>
+          </p:cNvCxnSpPr>
+          <p:nvPr/>
+        </p:nvCxnSpPr>
+        <p:spPr>
+          <a:xfrm>
+            <a:off x="6095997" y="3280936"/>
+            <a:ext cx="0" cy="635004"/>
+          </a:xfrm>
+          <a:prstGeom prst="straightConnector1">
+            <a:avLst/>
+          </a:prstGeom>
+          <a:ln>
+            <a:tailEnd type="triangle"/>
+          </a:ln>
+        </p:spPr>
+        <p:style>
+          <a:lnRef idx="2">
+            <a:schemeClr val="dk1"/>
+          </a:lnRef>
+          <a:fillRef idx="0">
+            <a:schemeClr val="dk1"/>
+          </a:fillRef>
+          <a:effectRef idx="1">
+            <a:schemeClr val="dk1"/>
+          </a:effectRef>
+          <a:fontRef idx="minor">
+            <a:schemeClr val="tx1"/>
+          </a:fontRef>
+        </p:style>
+      </p:cxnSp>
+      <p:cxnSp>
+        <p:nvCxnSpPr>
+          <p:cNvPr id="27" name="Straight Arrow Connector 26">
+            <a:extLst>
+              <a:ext uri="{FF2B5EF4-FFF2-40B4-BE49-F238E27FC236}">
+                <a16:creationId xmlns:a16="http://schemas.microsoft.com/office/drawing/2014/main" id="{FB67C2E8-511F-C48F-A441-8704CF1CC29D}"/>
+              </a:ext>
+            </a:extLst>
+          </p:cNvPr>
+          <p:cNvCxnSpPr>
+            <a:stCxn id="8" idx="2"/>
+            <a:endCxn id="9" idx="0"/>
+          </p:cNvCxnSpPr>
+          <p:nvPr/>
+        </p:nvCxnSpPr>
+        <p:spPr>
+          <a:xfrm flipH="1">
+            <a:off x="6095996" y="4753597"/>
+            <a:ext cx="1" cy="635004"/>
+          </a:xfrm>
+          <a:prstGeom prst="straightConnector1">
+            <a:avLst/>
+          </a:prstGeom>
+          <a:ln>
+            <a:tailEnd type="triangle"/>
+          </a:ln>
+        </p:spPr>
+        <p:style>
+          <a:lnRef idx="2">
+            <a:schemeClr val="dk1"/>
+          </a:lnRef>
+          <a:fillRef idx="0">
+            <a:schemeClr val="dk1"/>
+          </a:fillRef>
+          <a:effectRef idx="1">
+            <a:schemeClr val="dk1"/>
+          </a:effectRef>
+          <a:fontRef idx="minor">
+            <a:schemeClr val="tx1"/>
+          </a:fontRef>
+        </p:style>
+      </p:cxnSp>
+      <p:sp>
+        <p:nvSpPr>
+          <p:cNvPr id="28" name="TextBox 27">
+            <a:extLst>
+              <a:ext uri="{FF2B5EF4-FFF2-40B4-BE49-F238E27FC236}">
+                <a16:creationId xmlns:a16="http://schemas.microsoft.com/office/drawing/2014/main" id="{1FABBE4D-112E-E0DF-8FF5-CDA539404E35}"/>
+              </a:ext>
+            </a:extLst>
+          </p:cNvPr>
+          <p:cNvSpPr txBox="1"/>
+          <p:nvPr/>
+        </p:nvSpPr>
+        <p:spPr>
+          <a:xfrm>
+            <a:off x="2838267" y="638346"/>
+            <a:ext cx="425116" cy="338554"/>
+          </a:xfrm>
+          <a:prstGeom prst="rect">
+            <a:avLst/>
+          </a:prstGeom>
+          <a:noFill/>
+        </p:spPr>
+        <p:txBody>
+          <a:bodyPr wrap="none" rtlCol="0">
+            <a:spAutoFit/>
+          </a:bodyPr>
+          <a:lstStyle/>
+          <a:p>
+            <a:r>
+              <a:rPr lang="en-US" sz="1600">
+                <a:latin typeface="Times New Roman" panose="02020603050405020304" pitchFamily="18" charset="0"/>
+                <a:cs typeface="Times New Roman" panose="02020603050405020304" pitchFamily="18" charset="0"/>
+              </a:rPr>
+              <a:t>(1)</a:t>
+            </a:r>
+          </a:p>
+        </p:txBody>
+      </p:sp>
+      <p:sp>
+        <p:nvSpPr>
+          <p:cNvPr id="29" name="TextBox 28">
+            <a:extLst>
+              <a:ext uri="{FF2B5EF4-FFF2-40B4-BE49-F238E27FC236}">
+                <a16:creationId xmlns:a16="http://schemas.microsoft.com/office/drawing/2014/main" id="{79ECD4CE-CEAB-C0B3-C070-A2A55C7F7C71}"/>
+              </a:ext>
+            </a:extLst>
+          </p:cNvPr>
+          <p:cNvSpPr txBox="1"/>
+          <p:nvPr/>
+        </p:nvSpPr>
+        <p:spPr>
+          <a:xfrm>
+            <a:off x="6095996" y="1401840"/>
+            <a:ext cx="425116" cy="338554"/>
+          </a:xfrm>
+          <a:prstGeom prst="rect">
+            <a:avLst/>
+          </a:prstGeom>
+          <a:noFill/>
+        </p:spPr>
+        <p:txBody>
+          <a:bodyPr wrap="none" rtlCol="0">
+            <a:spAutoFit/>
+          </a:bodyPr>
+          <a:lstStyle/>
+          <a:p>
+            <a:r>
+              <a:rPr lang="en-US" sz="1600">
+                <a:latin typeface="Times New Roman" panose="02020603050405020304" pitchFamily="18" charset="0"/>
+                <a:cs typeface="Times New Roman" panose="02020603050405020304" pitchFamily="18" charset="0"/>
+              </a:rPr>
+              <a:t>(2)</a:t>
+            </a:r>
+          </a:p>
+        </p:txBody>
+      </p:sp>
+      <p:sp>
+        <p:nvSpPr>
+          <p:cNvPr id="30" name="TextBox 29">
+            <a:extLst>
+              <a:ext uri="{FF2B5EF4-FFF2-40B4-BE49-F238E27FC236}">
+                <a16:creationId xmlns:a16="http://schemas.microsoft.com/office/drawing/2014/main" id="{CD5A52F6-029F-BA1C-5F6F-5AB5C809D3D9}"/>
+              </a:ext>
+            </a:extLst>
+          </p:cNvPr>
+          <p:cNvSpPr txBox="1"/>
+          <p:nvPr/>
+        </p:nvSpPr>
+        <p:spPr>
+          <a:xfrm>
+            <a:off x="2423884" y="3280933"/>
+            <a:ext cx="572593" cy="338554"/>
+          </a:xfrm>
+          <a:prstGeom prst="rect">
+            <a:avLst/>
+          </a:prstGeom>
+          <a:noFill/>
+        </p:spPr>
+        <p:txBody>
+          <a:bodyPr wrap="none" rtlCol="0">
+            <a:spAutoFit/>
+          </a:bodyPr>
+          <a:lstStyle/>
+          <a:p>
+            <a:r>
+              <a:rPr lang="en-US" sz="1600">
+                <a:latin typeface="Times New Roman" panose="02020603050405020304" pitchFamily="18" charset="0"/>
+                <a:cs typeface="Times New Roman" panose="02020603050405020304" pitchFamily="18" charset="0"/>
+              </a:rPr>
+              <a:t>(2A)</a:t>
+            </a:r>
+          </a:p>
+        </p:txBody>
+      </p:sp>
+      <p:sp>
+        <p:nvSpPr>
+          <p:cNvPr id="31" name="TextBox 30">
+            <a:extLst>
+              <a:ext uri="{FF2B5EF4-FFF2-40B4-BE49-F238E27FC236}">
+                <a16:creationId xmlns:a16="http://schemas.microsoft.com/office/drawing/2014/main" id="{ACA3D5B3-750A-CA8E-24C0-FDAAC4C85725}"/>
+              </a:ext>
+            </a:extLst>
+          </p:cNvPr>
+          <p:cNvSpPr txBox="1"/>
+          <p:nvPr/>
+        </p:nvSpPr>
+        <p:spPr>
+          <a:xfrm>
+            <a:off x="6095996" y="3283106"/>
+            <a:ext cx="561372" cy="338554"/>
+          </a:xfrm>
+          <a:prstGeom prst="rect">
+            <a:avLst/>
+          </a:prstGeom>
+          <a:noFill/>
+        </p:spPr>
+        <p:txBody>
+          <a:bodyPr wrap="none" rtlCol="0">
+            <a:spAutoFit/>
+          </a:bodyPr>
+          <a:lstStyle/>
+          <a:p>
+            <a:r>
+              <a:rPr lang="en-US" sz="1600">
+                <a:latin typeface="Times New Roman" panose="02020603050405020304" pitchFamily="18" charset="0"/>
+                <a:cs typeface="Times New Roman" panose="02020603050405020304" pitchFamily="18" charset="0"/>
+              </a:rPr>
+              <a:t>(2B)</a:t>
+            </a:r>
+          </a:p>
+        </p:txBody>
+      </p:sp>
+      <p:sp>
+        <p:nvSpPr>
+          <p:cNvPr id="32" name="TextBox 31">
+            <a:extLst>
+              <a:ext uri="{FF2B5EF4-FFF2-40B4-BE49-F238E27FC236}">
+                <a16:creationId xmlns:a16="http://schemas.microsoft.com/office/drawing/2014/main" id="{CF50E784-DD4C-9D6F-2266-5CA7C6AD71CE}"/>
+              </a:ext>
+            </a:extLst>
+          </p:cNvPr>
+          <p:cNvSpPr txBox="1"/>
+          <p:nvPr/>
+        </p:nvSpPr>
+        <p:spPr>
+          <a:xfrm>
+            <a:off x="9768108" y="3294788"/>
+            <a:ext cx="561372" cy="338554"/>
+          </a:xfrm>
+          <a:prstGeom prst="rect">
+            <a:avLst/>
+          </a:prstGeom>
+          <a:noFill/>
+        </p:spPr>
+        <p:txBody>
+          <a:bodyPr wrap="none" rtlCol="0">
+            <a:spAutoFit/>
+          </a:bodyPr>
+          <a:lstStyle/>
+          <a:p>
+            <a:r>
+              <a:rPr lang="en-US" sz="1600">
+                <a:latin typeface="Times New Roman" panose="02020603050405020304" pitchFamily="18" charset="0"/>
+                <a:cs typeface="Times New Roman" panose="02020603050405020304" pitchFamily="18" charset="0"/>
+              </a:rPr>
+              <a:t>(2C)</a:t>
+            </a:r>
+          </a:p>
+        </p:txBody>
+      </p:sp>
+      <p:sp>
+        <p:nvSpPr>
+          <p:cNvPr id="35" name="TextBox 34">
+            <a:extLst>
+              <a:ext uri="{FF2B5EF4-FFF2-40B4-BE49-F238E27FC236}">
+                <a16:creationId xmlns:a16="http://schemas.microsoft.com/office/drawing/2014/main" id="{567604A8-1CCF-4A8E-C09D-5110B5DF2965}"/>
+              </a:ext>
+            </a:extLst>
+          </p:cNvPr>
+          <p:cNvSpPr txBox="1"/>
+          <p:nvPr/>
+        </p:nvSpPr>
+        <p:spPr>
+          <a:xfrm>
+            <a:off x="6095996" y="4753593"/>
+            <a:ext cx="425116" cy="338554"/>
+          </a:xfrm>
+          <a:prstGeom prst="rect">
+            <a:avLst/>
+          </a:prstGeom>
+          <a:noFill/>
+        </p:spPr>
+        <p:txBody>
+          <a:bodyPr wrap="none" rtlCol="0">
+            <a:spAutoFit/>
+          </a:bodyPr>
+          <a:lstStyle/>
+          <a:p>
+            <a:r>
+              <a:rPr lang="en-US" sz="1600">
+                <a:latin typeface="Times New Roman" panose="02020603050405020304" pitchFamily="18" charset="0"/>
+                <a:cs typeface="Times New Roman" panose="02020603050405020304" pitchFamily="18" charset="0"/>
+              </a:rPr>
+              <a:t>(3)</a:t>
+            </a:r>
+          </a:p>
+        </p:txBody>
+      </p:sp>
+    </p:spTree>
+    <p:extLst>
+      <p:ext uri="{BB962C8B-B14F-4D97-AF65-F5344CB8AC3E}">
+        <p14:creationId xmlns:p14="http://schemas.microsoft.com/office/powerpoint/2010/main" val="1653470133"/>
+      </p:ext>
+    </p:extLst>
+  </p:cSld>
+  <p:clrMapOvr>
+    <a:masterClrMapping/>
+  </p:clrMapOvr>
+</p:sld>
+</file>
+
+<file path=ppt/slides/slide13.xml><?xml version="1.0" encoding="utf-8"?>
 <p:sld xmlns:a="http://schemas.openxmlformats.org/drawingml/2006/main" xmlns:r="http://schemas.openxmlformats.org/officeDocument/2006/relationships" xmlns:p="http://schemas.openxmlformats.org/presentationml/2006/main">
   <p:cSld>
     <p:spTree>
@@ -12608,113 +16161,6 @@
       </p:grpSpPr>
       <p:sp>
         <p:nvSpPr>
-          <p:cNvPr id="2" name="TextBox 1">
-            <a:extLst>
-              <a:ext uri="{FF2B5EF4-FFF2-40B4-BE49-F238E27FC236}">
-                <a16:creationId xmlns:a16="http://schemas.microsoft.com/office/drawing/2014/main" id="{DDC3B24D-E97B-2982-21AB-8F7CB06C7A45}"/>
-              </a:ext>
-            </a:extLst>
-          </p:cNvPr>
-          <p:cNvSpPr txBox="1"/>
-          <p:nvPr/>
-        </p:nvSpPr>
-        <p:spPr>
-          <a:xfrm>
-            <a:off x="282388" y="349624"/>
-            <a:ext cx="5611088" cy="369332"/>
-          </a:xfrm>
-          <a:prstGeom prst="rect">
-            <a:avLst/>
-          </a:prstGeom>
-          <a:noFill/>
-        </p:spPr>
-        <p:txBody>
-          <a:bodyPr wrap="none" rtlCol="0">
-            <a:spAutoFit/>
-          </a:bodyPr>
-          <a:lstStyle/>
-          <a:p>
-            <a:r>
-              <a:rPr lang="en-US" dirty="0"/>
-              <a:t>Minh </a:t>
-            </a:r>
-            <a:r>
-              <a:rPr lang="en-US" dirty="0" err="1"/>
-              <a:t>họa</a:t>
-            </a:r>
-            <a:r>
-              <a:rPr lang="en-US" dirty="0"/>
-              <a:t> </a:t>
-            </a:r>
-            <a:r>
-              <a:rPr lang="en-US" dirty="0" err="1"/>
-              <a:t>tại</a:t>
-            </a:r>
-            <a:r>
-              <a:rPr lang="en-US" dirty="0"/>
-              <a:t> </a:t>
-            </a:r>
-            <a:r>
-              <a:rPr lang="en-US" dirty="0" err="1"/>
-              <a:t>sao</a:t>
-            </a:r>
-            <a:r>
-              <a:rPr lang="en-US" dirty="0"/>
-              <a:t> </a:t>
-            </a:r>
-            <a:r>
-              <a:rPr lang="en-US" dirty="0" err="1"/>
-              <a:t>phải</a:t>
-            </a:r>
-            <a:r>
-              <a:rPr lang="en-US" dirty="0"/>
-              <a:t> </a:t>
-            </a:r>
-            <a:r>
-              <a:rPr lang="en-US" dirty="0" err="1"/>
-              <a:t>đánh</a:t>
-            </a:r>
-            <a:r>
-              <a:rPr lang="en-US" dirty="0"/>
-              <a:t> </a:t>
-            </a:r>
-            <a:r>
-              <a:rPr lang="en-US" dirty="0" err="1"/>
-              <a:t>giá</a:t>
-            </a:r>
-            <a:r>
-              <a:rPr lang="en-US" dirty="0"/>
-              <a:t> </a:t>
-            </a:r>
-            <a:r>
-              <a:rPr lang="en-US" dirty="0" err="1"/>
-              <a:t>các</a:t>
-            </a:r>
-            <a:r>
-              <a:rPr lang="en-US" dirty="0"/>
-              <a:t> </a:t>
-            </a:r>
-            <a:r>
-              <a:rPr lang="en-US" dirty="0" err="1"/>
-              <a:t>mô</a:t>
-            </a:r>
-            <a:r>
-              <a:rPr lang="en-US" dirty="0"/>
-              <a:t> </a:t>
-            </a:r>
-            <a:r>
-              <a:rPr lang="en-US" dirty="0" err="1"/>
-              <a:t>hình</a:t>
-            </a:r>
-            <a:r>
-              <a:rPr lang="en-US" dirty="0"/>
-              <a:t> embedding</a:t>
-            </a:r>
-          </a:p>
-        </p:txBody>
-      </p:sp>
-      <p:sp>
-        <p:nvSpPr>
           <p:cNvPr id="4" name="Rectangle: Rounded Corners 3">
             <a:extLst>
               <a:ext uri="{FF2B5EF4-FFF2-40B4-BE49-F238E27FC236}">
@@ -13753,6 +17199,193 @@
 </file>
 
 <file path=ppt/slides/slide8.xml><?xml version="1.0" encoding="utf-8"?>
+<p:sld xmlns:a="http://schemas.openxmlformats.org/drawingml/2006/main" xmlns:r="http://schemas.openxmlformats.org/officeDocument/2006/relationships" xmlns:p="http://schemas.openxmlformats.org/presentationml/2006/main">
+  <p:cSld>
+    <p:spTree>
+      <p:nvGrpSpPr>
+        <p:cNvPr id="1" name=""/>
+        <p:cNvGrpSpPr/>
+        <p:nvPr/>
+      </p:nvGrpSpPr>
+      <p:grpSpPr>
+        <a:xfrm>
+          <a:off x="0" y="0"/>
+          <a:ext cx="0" cy="0"/>
+          <a:chOff x="0" y="0"/>
+          <a:chExt cx="0" cy="0"/>
+        </a:xfrm>
+      </p:grpSpPr>
+      <p:sp>
+        <p:nvSpPr>
+          <p:cNvPr id="2" name="TextBox 1">
+            <a:extLst>
+              <a:ext uri="{FF2B5EF4-FFF2-40B4-BE49-F238E27FC236}">
+                <a16:creationId xmlns:a16="http://schemas.microsoft.com/office/drawing/2014/main" id="{A76BB85E-EAB6-2089-5682-48447CE032A4}"/>
+              </a:ext>
+            </a:extLst>
+          </p:cNvPr>
+          <p:cNvSpPr txBox="1"/>
+          <p:nvPr/>
+        </p:nvSpPr>
+        <p:spPr>
+          <a:xfrm>
+            <a:off x="612648" y="795528"/>
+            <a:ext cx="8497839" cy="3693319"/>
+          </a:xfrm>
+          <a:prstGeom prst="rect">
+            <a:avLst/>
+          </a:prstGeom>
+          <a:noFill/>
+        </p:spPr>
+        <p:txBody>
+          <a:bodyPr wrap="none" rtlCol="0">
+            <a:spAutoFit/>
+          </a:bodyPr>
+          <a:lstStyle/>
+          <a:p>
+            <a:pPr marL="285750" indent="-285750">
+              <a:buFontTx/>
+              <a:buChar char="-"/>
+            </a:pPr>
+            <a:r>
+              <a:rPr lang="vi-VN"/>
+              <a:t>Chức năng đăng nhập/đăng xuất: biểu đồ chức năng, usecase, tuần tự</a:t>
+            </a:r>
+          </a:p>
+          <a:p>
+            <a:pPr marL="285750" indent="-285750">
+              <a:buFontTx/>
+              <a:buChar char="-"/>
+            </a:pPr>
+            <a:r>
+              <a:rPr lang="vi-VN"/>
+              <a:t>Chức năng cài đặt người dùng tùy chọn: biểu đồ  chức năng, usecase, tuần tự</a:t>
+            </a:r>
+          </a:p>
+          <a:p>
+            <a:pPr marL="285750" indent="-285750">
+              <a:buFontTx/>
+              <a:buChar char="-"/>
+            </a:pPr>
+            <a:r>
+              <a:rPr lang="vi-VN"/>
+              <a:t>Chức năng khởi tạo starter: biểu đồ tuần tự</a:t>
+            </a:r>
+          </a:p>
+          <a:p>
+            <a:pPr marL="285750" indent="-285750">
+              <a:buFontTx/>
+              <a:buChar char="-"/>
+            </a:pPr>
+            <a:r>
+              <a:rPr lang="vi-VN"/>
+              <a:t>Chức năng trò chuyện văn bản: biểu đồ chức năng, usecase, tuần tự</a:t>
+            </a:r>
+          </a:p>
+          <a:p>
+            <a:pPr marL="285750" indent="-285750">
+              <a:buFontTx/>
+              <a:buChar char="-"/>
+            </a:pPr>
+            <a:r>
+              <a:rPr lang="vi-VN"/>
+              <a:t>Chức năng trò chuyện âm thanh: chức năng, usecase, tuần tự</a:t>
+            </a:r>
+          </a:p>
+          <a:p>
+            <a:pPr marL="285750" indent="-285750">
+              <a:buFontTx/>
+              <a:buChar char="-"/>
+            </a:pPr>
+            <a:r>
+              <a:rPr lang="vi-VN"/>
+              <a:t>Chức năng tăng cường trí nhớ hội thoại: chức năng, usecase, tuần tự</a:t>
+            </a:r>
+          </a:p>
+          <a:p>
+            <a:pPr marL="285750" indent="-285750">
+              <a:buFontTx/>
+              <a:buChar char="-"/>
+            </a:pPr>
+            <a:r>
+              <a:rPr lang="vi-VN"/>
+              <a:t>Chức năng quản lý hành vi người dùng: chức năng, usecase, tuần tự</a:t>
+            </a:r>
+          </a:p>
+          <a:p>
+            <a:pPr marL="285750" indent="-285750">
+              <a:buFontTx/>
+              <a:buChar char="-"/>
+            </a:pPr>
+            <a:r>
+              <a:rPr lang="vi-VN"/>
+              <a:t>Chức năng quản lý hội thoại: chức năng, usecase, tuần tự</a:t>
+            </a:r>
+          </a:p>
+          <a:p>
+            <a:pPr marL="285750" indent="-285750">
+              <a:buFontTx/>
+              <a:buChar char="-"/>
+            </a:pPr>
+            <a:r>
+              <a:rPr lang="vi-VN"/>
+              <a:t>Chức năng xử lý trích xuất thông tin trò chuyện</a:t>
+            </a:r>
+          </a:p>
+          <a:p>
+            <a:pPr marL="285750" indent="-285750">
+              <a:buFontTx/>
+              <a:buChar char="-"/>
+            </a:pPr>
+            <a:endParaRPr lang="vi-VN"/>
+          </a:p>
+          <a:p>
+            <a:pPr marL="285750" indent="-285750">
+              <a:buFontTx/>
+              <a:buChar char="-"/>
+            </a:pPr>
+            <a:r>
+              <a:rPr lang="vi-VN"/>
+              <a:t>Thiết kế cơ sở dữ liệu embedding: có những trường nào</a:t>
+            </a:r>
+          </a:p>
+          <a:p>
+            <a:pPr marL="285750" indent="-285750">
+              <a:buFontTx/>
+              <a:buChar char="-"/>
+            </a:pPr>
+            <a:r>
+              <a:rPr lang="vi-VN"/>
+              <a:t>Cơ sở dữ liệu lưu trữ lịch sử hội thoại</a:t>
+            </a:r>
+          </a:p>
+          <a:p>
+            <a:pPr marL="285750" indent="-285750">
+              <a:buFontTx/>
+              <a:buChar char="-"/>
+            </a:pPr>
+            <a:r>
+              <a:rPr lang="vi-VN"/>
+              <a:t>Co sơ dữ liệu lưu trữ thông tin người dùng</a:t>
+            </a:r>
+            <a:endParaRPr lang="en-US"/>
+          </a:p>
+        </p:txBody>
+      </p:sp>
+    </p:spTree>
+    <p:extLst>
+      <p:ext uri="{BB962C8B-B14F-4D97-AF65-F5344CB8AC3E}">
+        <p14:creationId xmlns:p14="http://schemas.microsoft.com/office/powerpoint/2010/main" val="629964740"/>
+      </p:ext>
+    </p:extLst>
+  </p:cSld>
+  <p:clrMapOvr>
+    <a:masterClrMapping/>
+  </p:clrMapOvr>
+</p:sld>
+</file>
+
+<file path=ppt/slides/slide9.xml><?xml version="1.0" encoding="utf-8"?>
 <p:sld xmlns:a="http://schemas.openxmlformats.org/drawingml/2006/main" xmlns:r="http://schemas.openxmlformats.org/officeDocument/2006/relationships" xmlns:p="http://schemas.openxmlformats.org/presentationml/2006/main">
   <p:cSld>
     <p:spTree>
@@ -14909,40 +18542,124 @@
           </a:p>
         </p:txBody>
       </p:sp>
+      <p:sp>
+        <p:nvSpPr>
+          <p:cNvPr id="7" name="TextBox 6">
+            <a:extLst>
+              <a:ext uri="{FF2B5EF4-FFF2-40B4-BE49-F238E27FC236}">
+                <a16:creationId xmlns:a16="http://schemas.microsoft.com/office/drawing/2014/main" id="{41DDCBEC-3C22-77D3-FA32-656909EE95EC}"/>
+              </a:ext>
+            </a:extLst>
+          </p:cNvPr>
+          <p:cNvSpPr txBox="1"/>
+          <p:nvPr/>
+        </p:nvSpPr>
+        <p:spPr>
+          <a:xfrm>
+            <a:off x="6095997" y="5228556"/>
+            <a:ext cx="978153" cy="523220"/>
+          </a:xfrm>
+          <a:prstGeom prst="rect">
+            <a:avLst/>
+          </a:prstGeom>
+          <a:noFill/>
+        </p:spPr>
+        <p:txBody>
+          <a:bodyPr wrap="none" rtlCol="0">
+            <a:spAutoFit/>
+          </a:bodyPr>
+          <a:lstStyle/>
+          <a:p>
+            <a:r>
+              <a:rPr lang="vi-VN" sz="1400">
+                <a:latin typeface="+mj-lt"/>
+              </a:rPr>
+              <a:t>Đăng</a:t>
+            </a:r>
+            <a:r>
+              <a:rPr lang="en-US" sz="1400">
+                <a:latin typeface="Times New Roman" panose="02020603050405020304" pitchFamily="18" charset="0"/>
+                <a:cs typeface="Times New Roman" panose="02020603050405020304" pitchFamily="18" charset="0"/>
+              </a:rPr>
+              <a:t> nhập</a:t>
+            </a:r>
+            <a:endParaRPr lang="vi-VN" sz="1400">
+              <a:latin typeface="+mj-lt"/>
+            </a:endParaRPr>
+          </a:p>
+          <a:p>
+            <a:r>
+              <a:rPr lang="vi-VN" sz="1400">
+                <a:latin typeface="+mj-lt"/>
+              </a:rPr>
+              <a:t>thành công</a:t>
+            </a:r>
+            <a:endParaRPr lang="en-US" sz="1400">
+              <a:latin typeface="+mj-lt"/>
+            </a:endParaRPr>
+          </a:p>
+        </p:txBody>
+      </p:sp>
+      <p:sp>
+        <p:nvSpPr>
+          <p:cNvPr id="9" name="TextBox 8">
+            <a:extLst>
+              <a:ext uri="{FF2B5EF4-FFF2-40B4-BE49-F238E27FC236}">
+                <a16:creationId xmlns:a16="http://schemas.microsoft.com/office/drawing/2014/main" id="{F2AAA943-F699-9525-C9F3-9D5D1B642FF4}"/>
+              </a:ext>
+            </a:extLst>
+          </p:cNvPr>
+          <p:cNvSpPr txBox="1"/>
+          <p:nvPr/>
+        </p:nvSpPr>
+        <p:spPr>
+          <a:xfrm>
+            <a:off x="6890036" y="4298973"/>
+            <a:ext cx="978153" cy="523220"/>
+          </a:xfrm>
+          <a:prstGeom prst="rect">
+            <a:avLst/>
+          </a:prstGeom>
+          <a:noFill/>
+        </p:spPr>
+        <p:txBody>
+          <a:bodyPr wrap="none" rtlCol="0">
+            <a:spAutoFit/>
+          </a:bodyPr>
+          <a:lstStyle/>
+          <a:p>
+            <a:r>
+              <a:rPr lang="vi-VN" sz="1400">
+                <a:latin typeface="+mj-lt"/>
+              </a:rPr>
+              <a:t>Đăng</a:t>
+            </a:r>
+            <a:r>
+              <a:rPr lang="en-US" sz="1400">
+                <a:latin typeface="Times New Roman" panose="02020603050405020304" pitchFamily="18" charset="0"/>
+                <a:cs typeface="Times New Roman" panose="02020603050405020304" pitchFamily="18" charset="0"/>
+              </a:rPr>
+              <a:t> nhập</a:t>
+            </a:r>
+            <a:endParaRPr lang="vi-VN" sz="1400">
+              <a:latin typeface="+mj-lt"/>
+            </a:endParaRPr>
+          </a:p>
+          <a:p>
+            <a:r>
+              <a:rPr lang="en-US" sz="1400">
+                <a:latin typeface="Times New Roman" panose="02020603050405020304" pitchFamily="18" charset="0"/>
+                <a:cs typeface="Times New Roman" panose="02020603050405020304" pitchFamily="18" charset="0"/>
+              </a:rPr>
+              <a:t>thất bại</a:t>
+            </a:r>
+          </a:p>
+        </p:txBody>
+      </p:sp>
     </p:spTree>
     <p:extLst>
       <p:ext uri="{BB962C8B-B14F-4D97-AF65-F5344CB8AC3E}">
         <p14:creationId xmlns:p14="http://schemas.microsoft.com/office/powerpoint/2010/main" val="3049573887"/>
-      </p:ext>
-    </p:extLst>
-  </p:cSld>
-  <p:clrMapOvr>
-    <a:masterClrMapping/>
-  </p:clrMapOvr>
-</p:sld>
-</file>
-
-<file path=ppt/slides/slide9.xml><?xml version="1.0" encoding="utf-8"?>
-<p:sld xmlns:a="http://schemas.openxmlformats.org/drawingml/2006/main" xmlns:r="http://schemas.openxmlformats.org/officeDocument/2006/relationships" xmlns:p="http://schemas.openxmlformats.org/presentationml/2006/main">
-  <p:cSld>
-    <p:spTree>
-      <p:nvGrpSpPr>
-        <p:cNvPr id="1" name=""/>
-        <p:cNvGrpSpPr/>
-        <p:nvPr/>
-      </p:nvGrpSpPr>
-      <p:grpSpPr>
-        <a:xfrm>
-          <a:off x="0" y="0"/>
-          <a:ext cx="0" cy="0"/>
-          <a:chOff x="0" y="0"/>
-          <a:chExt cx="0" cy="0"/>
-        </a:xfrm>
-      </p:grpSpPr>
-    </p:spTree>
-    <p:extLst>
-      <p:ext uri="{BB962C8B-B14F-4D97-AF65-F5344CB8AC3E}">
-        <p14:creationId xmlns:p14="http://schemas.microsoft.com/office/powerpoint/2010/main" val="3397203099"/>
       </p:ext>
     </p:extLst>
   </p:cSld>

</xml_diff>

<commit_message>
Update file bao cao va hinh anh: Mot so bieu do tuan tu
</commit_message>
<xml_diff>
--- a/documents/hinh_ve_trong_cao_cao_do_an.pptx
+++ b/documents/hinh_ve_trong_cao_cao_do_an.pptx
@@ -29470,8 +29470,8 @@
         </p:nvSpPr>
         <p:spPr>
           <a:xfrm>
-            <a:off x="984353" y="488573"/>
-            <a:ext cx="1947969" cy="646331"/>
+            <a:off x="993971" y="488573"/>
+            <a:ext cx="1928734" cy="707886"/>
           </a:xfrm>
           <a:prstGeom prst="rect">
             <a:avLst/>
@@ -29486,21 +29486,21 @@
           <a:p>
             <a:pPr algn="ctr"/>
             <a:r>
-              <a:rPr lang="en-US">
+              <a:rPr lang="en-US" sz="2000">
                 <a:latin typeface="Times New Roman" panose="02020603050405020304" pitchFamily="18" charset="0"/>
                 <a:cs typeface="Times New Roman" panose="02020603050405020304" pitchFamily="18" charset="0"/>
               </a:rPr>
-              <a:t>Turing Test</a:t>
+              <a:t>Turing Test,</a:t>
             </a:r>
           </a:p>
           <a:p>
             <a:pPr algn="ctr"/>
             <a:r>
-              <a:rPr lang="en-US">
+              <a:rPr lang="en-US" sz="2000">
                 <a:latin typeface="Times New Roman" panose="02020603050405020304" pitchFamily="18" charset="0"/>
                 <a:cs typeface="Times New Roman" panose="02020603050405020304" pitchFamily="18" charset="0"/>
               </a:rPr>
-              <a:t>Syntactic Structure</a:t>
+              <a:t>Cấu trúc cú pháp</a:t>
             </a:r>
           </a:p>
         </p:txBody>
@@ -29519,8 +29519,8 @@
         </p:nvSpPr>
         <p:spPr>
           <a:xfrm>
-            <a:off x="3732892" y="485001"/>
-            <a:ext cx="2059218" cy="646331"/>
+            <a:off x="3621003" y="485001"/>
+            <a:ext cx="2282997" cy="707886"/>
           </a:xfrm>
           <a:prstGeom prst="rect">
             <a:avLst/>
@@ -29535,21 +29535,21 @@
           <a:p>
             <a:pPr algn="ctr"/>
             <a:r>
-              <a:rPr lang="en-US">
+              <a:rPr lang="en-US" sz="2000">
                 <a:latin typeface="Times New Roman" panose="02020603050405020304" pitchFamily="18" charset="0"/>
                 <a:cs typeface="Times New Roman" panose="02020603050405020304" pitchFamily="18" charset="0"/>
               </a:rPr>
-              <a:t>Conceptual</a:t>
+              <a:t>Lý thuyết</a:t>
             </a:r>
           </a:p>
           <a:p>
             <a:pPr algn="ctr"/>
             <a:r>
-              <a:rPr lang="en-US">
+              <a:rPr lang="en-US" sz="2000">
                 <a:latin typeface="Times New Roman" panose="02020603050405020304" pitchFamily="18" charset="0"/>
                 <a:cs typeface="Times New Roman" panose="02020603050405020304" pitchFamily="18" charset="0"/>
               </a:rPr>
-              <a:t>Dependency Theory</a:t>
+              <a:t>phụ thuộc khái niệm</a:t>
             </a:r>
           </a:p>
         </p:txBody>
@@ -29568,8 +29568,8 @@
         </p:nvSpPr>
         <p:spPr>
           <a:xfrm>
-            <a:off x="6301370" y="485001"/>
-            <a:ext cx="2256259" cy="646331"/>
+            <a:off x="6412237" y="485001"/>
+            <a:ext cx="2034531" cy="707886"/>
           </a:xfrm>
           <a:prstGeom prst="rect">
             <a:avLst/>
@@ -29584,21 +29584,21 @@
           <a:p>
             <a:pPr algn="ctr"/>
             <a:r>
-              <a:rPr lang="en-US">
+              <a:rPr lang="en-US" sz="2000">
                 <a:latin typeface="Times New Roman" panose="02020603050405020304" pitchFamily="18" charset="0"/>
                 <a:cs typeface="Times New Roman" panose="02020603050405020304" pitchFamily="18" charset="0"/>
               </a:rPr>
-              <a:t>Augmented Transition</a:t>
+              <a:t>Mạng chuyển tiếp</a:t>
             </a:r>
           </a:p>
           <a:p>
             <a:pPr algn="ctr"/>
             <a:r>
-              <a:rPr lang="en-US">
+              <a:rPr lang="en-US" sz="2000">
                 <a:latin typeface="Times New Roman" panose="02020603050405020304" pitchFamily="18" charset="0"/>
                 <a:cs typeface="Times New Roman" panose="02020603050405020304" pitchFamily="18" charset="0"/>
               </a:rPr>
-              <a:t>Network</a:t>
+              <a:t>tăng cường</a:t>
             </a:r>
           </a:p>
         </p:txBody>
@@ -29617,8 +29617,8 @@
         </p:nvSpPr>
         <p:spPr>
           <a:xfrm>
-            <a:off x="9096971" y="485001"/>
-            <a:ext cx="2273378" cy="646331"/>
+            <a:off x="9014416" y="485001"/>
+            <a:ext cx="2438488" cy="707886"/>
           </a:xfrm>
           <a:prstGeom prst="rect">
             <a:avLst/>
@@ -29633,7 +29633,7 @@
           <a:p>
             <a:pPr algn="ctr"/>
             <a:r>
-              <a:rPr lang="en-US">
+              <a:rPr lang="en-US" sz="2000">
                 <a:latin typeface="Times New Roman" panose="02020603050405020304" pitchFamily="18" charset="0"/>
                 <a:cs typeface="Times New Roman" panose="02020603050405020304" pitchFamily="18" charset="0"/>
               </a:rPr>
@@ -29643,11 +29643,11 @@
           <a:p>
             <a:pPr algn="ctr"/>
             <a:r>
-              <a:rPr lang="en-US">
+              <a:rPr lang="en-US" sz="2000">
                 <a:latin typeface="Times New Roman" panose="02020603050405020304" pitchFamily="18" charset="0"/>
                 <a:cs typeface="Times New Roman" panose="02020603050405020304" pitchFamily="18" charset="0"/>
               </a:rPr>
-              <a:t>Symbolic NLP</a:t>
+              <a:t>NLP bằng quy tắc</a:t>
             </a:r>
           </a:p>
         </p:txBody>
@@ -29666,8 +29666,8 @@
         </p:nvSpPr>
         <p:spPr>
           <a:xfrm>
-            <a:off x="1227751" y="5330428"/>
-            <a:ext cx="1461169" cy="646331"/>
+            <a:off x="800808" y="5330428"/>
+            <a:ext cx="2315056" cy="1015663"/>
           </a:xfrm>
           <a:prstGeom prst="rect">
             <a:avLst/>
@@ -29682,21 +29682,31 @@
           <a:p>
             <a:pPr algn="ctr"/>
             <a:r>
-              <a:rPr lang="en-US">
+              <a:rPr lang="en-US" sz="2000">
                 <a:latin typeface="Times New Roman" panose="02020603050405020304" pitchFamily="18" charset="0"/>
                 <a:cs typeface="Times New Roman" panose="02020603050405020304" pitchFamily="18" charset="0"/>
               </a:rPr>
-              <a:t>ML ra đời</a:t>
+              <a:t>ML ra đời,</a:t>
             </a:r>
           </a:p>
           <a:p>
             <a:pPr algn="ctr"/>
             <a:r>
-              <a:rPr lang="en-US">
+              <a:rPr lang="en-US" sz="2000">
                 <a:latin typeface="Times New Roman" panose="02020603050405020304" pitchFamily="18" charset="0"/>
                 <a:cs typeface="Times New Roman" panose="02020603050405020304" pitchFamily="18" charset="0"/>
               </a:rPr>
-              <a:t>Statistic NLP</a:t>
+              <a:t>Bắt đầu thời kỳ NLP</a:t>
+            </a:r>
+          </a:p>
+          <a:p>
+            <a:pPr algn="ctr"/>
+            <a:r>
+              <a:rPr lang="en-US" sz="2000">
+                <a:latin typeface="Times New Roman" panose="02020603050405020304" pitchFamily="18" charset="0"/>
+                <a:cs typeface="Times New Roman" panose="02020603050405020304" pitchFamily="18" charset="0"/>
+              </a:rPr>
+              <a:t>bằng thống kê</a:t>
             </a:r>
           </a:p>
         </p:txBody>
@@ -29778,8 +29788,8 @@
         </p:nvSpPr>
         <p:spPr>
           <a:xfrm>
-            <a:off x="3583364" y="5468927"/>
-            <a:ext cx="2358274" cy="369332"/>
+            <a:off x="3511201" y="5468927"/>
+            <a:ext cx="2502608" cy="707886"/>
           </a:xfrm>
           <a:prstGeom prst="rect">
             <a:avLst/>
@@ -29794,11 +29804,21 @@
           <a:p>
             <a:pPr algn="ctr"/>
             <a:r>
-              <a:rPr lang="en-US">
+              <a:rPr lang="en-US" sz="2000">
                 <a:latin typeface="Times New Roman" panose="02020603050405020304" pitchFamily="18" charset="0"/>
                 <a:cs typeface="Times New Roman" panose="02020603050405020304" pitchFamily="18" charset="0"/>
               </a:rPr>
-              <a:t>Mô hình hóa ngôn ngữ</a:t>
+              <a:t>Các nghiên cứu về</a:t>
+            </a:r>
+          </a:p>
+          <a:p>
+            <a:pPr algn="ctr"/>
+            <a:r>
+              <a:rPr lang="en-US" sz="2000">
+                <a:latin typeface="Times New Roman" panose="02020603050405020304" pitchFamily="18" charset="0"/>
+                <a:cs typeface="Times New Roman" panose="02020603050405020304" pitchFamily="18" charset="0"/>
+              </a:rPr>
+              <a:t>mô hình hóa ngôn ngữ</a:t>
             </a:r>
           </a:p>
         </p:txBody>
@@ -29880,8 +29900,8 @@
         </p:nvSpPr>
         <p:spPr>
           <a:xfrm>
-            <a:off x="6285673" y="5334000"/>
-            <a:ext cx="2283254" cy="923330"/>
+            <a:off x="5917051" y="5334000"/>
+            <a:ext cx="3020507" cy="1015663"/>
           </a:xfrm>
           <a:prstGeom prst="rect">
             <a:avLst/>
@@ -29896,31 +29916,31 @@
           <a:p>
             <a:pPr algn="ctr"/>
             <a:r>
-              <a:rPr lang="en-US">
+              <a:rPr lang="en-US" sz="2000">
                 <a:latin typeface="Times New Roman" panose="02020603050405020304" pitchFamily="18" charset="0"/>
                 <a:cs typeface="Times New Roman" panose="02020603050405020304" pitchFamily="18" charset="0"/>
               </a:rPr>
-              <a:t>NLP với NN</a:t>
+              <a:t>Thời kỳ của NLP bằng NN,</a:t>
             </a:r>
           </a:p>
           <a:p>
             <a:pPr algn="ctr"/>
             <a:r>
-              <a:rPr lang="en-US">
+              <a:rPr lang="en-US" sz="2000">
                 <a:latin typeface="Times New Roman" panose="02020603050405020304" pitchFamily="18" charset="0"/>
                 <a:cs typeface="Times New Roman" panose="02020603050405020304" pitchFamily="18" charset="0"/>
               </a:rPr>
-              <a:t>Mô hình Transformer</a:t>
+              <a:t>với sự xuất hiện của </a:t>
             </a:r>
           </a:p>
           <a:p>
             <a:pPr algn="ctr"/>
             <a:r>
-              <a:rPr lang="en-US">
+              <a:rPr lang="en-US" sz="2000">
                 <a:latin typeface="Times New Roman" panose="02020603050405020304" pitchFamily="18" charset="0"/>
                 <a:cs typeface="Times New Roman" panose="02020603050405020304" pitchFamily="18" charset="0"/>
               </a:rPr>
-              <a:t>Sự xuất hiện của LLM</a:t>
+              <a:t>Transformer và LLM</a:t>
             </a:r>
           </a:p>
         </p:txBody>
@@ -30500,8 +30520,8 @@
         </p:nvCxnSpPr>
         <p:spPr>
           <a:xfrm flipH="1" flipV="1">
-            <a:off x="1958338" y="1134904"/>
-            <a:ext cx="2" cy="389096"/>
+            <a:off x="1958338" y="1196459"/>
+            <a:ext cx="2" cy="327541"/>
           </a:xfrm>
           <a:prstGeom prst="line">
             <a:avLst/>
@@ -33374,8 +33394,8 @@
         </p:nvSpPr>
         <p:spPr>
           <a:xfrm>
-            <a:off x="853440" y="2045970"/>
-            <a:ext cx="2438400" cy="838200"/>
+            <a:off x="655320" y="2045970"/>
+            <a:ext cx="2758440" cy="838200"/>
           </a:xfrm>
           <a:prstGeom prst="roundRect">
             <a:avLst/>
@@ -33406,7 +33426,7 @@
           <a:p>
             <a:pPr algn="ctr"/>
             <a:r>
-              <a:rPr lang="en-US">
+              <a:rPr lang="en-US" sz="2400">
                 <a:solidFill>
                   <a:schemeClr val="tx1"/>
                 </a:solidFill>
@@ -33432,8 +33452,8 @@
         </p:nvSpPr>
         <p:spPr>
           <a:xfrm>
-            <a:off x="2499360" y="754380"/>
-            <a:ext cx="2438400" cy="838200"/>
+            <a:off x="2301240" y="754380"/>
+            <a:ext cx="2758440" cy="838200"/>
           </a:xfrm>
           <a:prstGeom prst="roundRect">
             <a:avLst/>
@@ -33464,7 +33484,7 @@
           <a:p>
             <a:pPr algn="ctr"/>
             <a:r>
-              <a:rPr lang="en-US">
+              <a:rPr lang="en-US" sz="2400">
                 <a:solidFill>
                   <a:schemeClr val="tx1"/>
                 </a:solidFill>
@@ -33490,8 +33510,8 @@
         </p:nvSpPr>
         <p:spPr>
           <a:xfrm>
-            <a:off x="853440" y="3756660"/>
-            <a:ext cx="2438400" cy="838200"/>
+            <a:off x="655320" y="3756660"/>
+            <a:ext cx="2758440" cy="838200"/>
           </a:xfrm>
           <a:prstGeom prst="roundRect">
             <a:avLst/>
@@ -33522,7 +33542,7 @@
           <a:p>
             <a:pPr algn="ctr"/>
             <a:r>
-              <a:rPr lang="en-US">
+              <a:rPr lang="en-US" sz="2400">
                 <a:solidFill>
                   <a:schemeClr val="tx1"/>
                 </a:solidFill>
@@ -33548,8 +33568,8 @@
         </p:nvSpPr>
         <p:spPr>
           <a:xfrm>
-            <a:off x="2499360" y="5227320"/>
-            <a:ext cx="2438400" cy="838200"/>
+            <a:off x="2301240" y="5227320"/>
+            <a:ext cx="2758440" cy="838200"/>
           </a:xfrm>
           <a:prstGeom prst="roundRect">
             <a:avLst/>
@@ -33580,7 +33600,7 @@
           <a:p>
             <a:pPr algn="ctr"/>
             <a:r>
-              <a:rPr lang="en-US">
+              <a:rPr lang="en-US" sz="2400">
                 <a:solidFill>
                   <a:schemeClr val="tx1"/>
                 </a:solidFill>
@@ -33606,8 +33626,8 @@
         </p:nvSpPr>
         <p:spPr>
           <a:xfrm>
-            <a:off x="7254240" y="765810"/>
-            <a:ext cx="2438400" cy="838200"/>
+            <a:off x="7056120" y="765810"/>
+            <a:ext cx="2758440" cy="838200"/>
           </a:xfrm>
           <a:prstGeom prst="roundRect">
             <a:avLst/>
@@ -33638,7 +33658,7 @@
           <a:p>
             <a:pPr algn="ctr"/>
             <a:r>
-              <a:rPr lang="en-US">
+              <a:rPr lang="en-US" sz="2400">
                 <a:solidFill>
                   <a:schemeClr val="tx1"/>
                 </a:solidFill>
@@ -33651,7 +33671,7 @@
           <a:p>
             <a:pPr algn="ctr"/>
             <a:r>
-              <a:rPr lang="en-US">
+              <a:rPr lang="en-US" sz="2400">
                 <a:solidFill>
                   <a:schemeClr val="tx1"/>
                 </a:solidFill>
@@ -33677,8 +33697,8 @@
         </p:nvSpPr>
         <p:spPr>
           <a:xfrm>
-            <a:off x="8900160" y="2045970"/>
-            <a:ext cx="2438400" cy="838200"/>
+            <a:off x="8702040" y="2045970"/>
+            <a:ext cx="2758440" cy="838200"/>
           </a:xfrm>
           <a:prstGeom prst="roundRect">
             <a:avLst/>
@@ -33709,7 +33729,7 @@
           <a:p>
             <a:pPr algn="ctr"/>
             <a:r>
-              <a:rPr lang="en-US">
+              <a:rPr lang="en-US" sz="2400">
                 <a:solidFill>
                   <a:schemeClr val="tx1"/>
                 </a:solidFill>
@@ -33735,8 +33755,8 @@
         </p:nvSpPr>
         <p:spPr>
           <a:xfrm>
-            <a:off x="8900160" y="3756660"/>
-            <a:ext cx="2438400" cy="838200"/>
+            <a:off x="8702040" y="3756660"/>
+            <a:ext cx="2758440" cy="838200"/>
           </a:xfrm>
           <a:prstGeom prst="roundRect">
             <a:avLst/>
@@ -33767,7 +33787,7 @@
           <a:p>
             <a:pPr algn="ctr"/>
             <a:r>
-              <a:rPr lang="en-US">
+              <a:rPr lang="en-US" sz="2400">
                 <a:solidFill>
                   <a:schemeClr val="tx1"/>
                 </a:solidFill>
@@ -33793,8 +33813,8 @@
         </p:nvSpPr>
         <p:spPr>
           <a:xfrm>
-            <a:off x="7254240" y="5227320"/>
-            <a:ext cx="2438400" cy="838200"/>
+            <a:off x="7056120" y="5227320"/>
+            <a:ext cx="2758440" cy="838200"/>
           </a:xfrm>
           <a:prstGeom prst="roundRect">
             <a:avLst/>
@@ -33825,7 +33845,7 @@
           <a:p>
             <a:pPr algn="ctr"/>
             <a:r>
-              <a:rPr lang="en-US">
+              <a:rPr lang="en-US" sz="2400">
                 <a:solidFill>
                   <a:schemeClr val="tx1"/>
                 </a:solidFill>
@@ -34206,8 +34226,8 @@
         </p:nvSpPr>
         <p:spPr>
           <a:xfrm>
-            <a:off x="8534400" y="1228634"/>
-            <a:ext cx="2772229" cy="919480"/>
+            <a:off x="8061960" y="1094014"/>
+            <a:ext cx="3244669" cy="1188720"/>
           </a:xfrm>
           <a:prstGeom prst="roundRect">
             <a:avLst/>
@@ -34243,7 +34263,7 @@
           <a:p>
             <a:pPr algn="ctr"/>
             <a:r>
-              <a:rPr lang="en-US" sz="2000">
+              <a:rPr lang="en-US" sz="2400">
                 <a:solidFill>
                   <a:schemeClr val="tx1"/>
                 </a:solidFill>
@@ -34269,8 +34289,8 @@
         </p:nvSpPr>
         <p:spPr>
           <a:xfrm>
-            <a:off x="8708572" y="2969260"/>
-            <a:ext cx="2772229" cy="919480"/>
+            <a:off x="8236132" y="2834640"/>
+            <a:ext cx="3244669" cy="1188720"/>
           </a:xfrm>
           <a:prstGeom prst="roundRect">
             <a:avLst/>
@@ -34306,7 +34326,7 @@
           <a:p>
             <a:pPr algn="ctr"/>
             <a:r>
-              <a:rPr lang="en-US" sz="2000">
+              <a:rPr lang="en-US" sz="2400">
                 <a:solidFill>
                   <a:schemeClr val="tx1"/>
                 </a:solidFill>
@@ -34319,7 +34339,7 @@
           <a:p>
             <a:pPr algn="ctr"/>
             <a:r>
-              <a:rPr lang="en-US" sz="2000">
+              <a:rPr lang="en-US" sz="2400">
                 <a:solidFill>
                   <a:schemeClr val="tx1"/>
                 </a:solidFill>
@@ -34345,8 +34365,8 @@
         </p:nvSpPr>
         <p:spPr>
           <a:xfrm>
-            <a:off x="8534400" y="4709886"/>
-            <a:ext cx="2772229" cy="919480"/>
+            <a:off x="8061960" y="4575266"/>
+            <a:ext cx="3244669" cy="1188720"/>
           </a:xfrm>
           <a:prstGeom prst="roundRect">
             <a:avLst/>
@@ -34382,7 +34402,7 @@
           <a:p>
             <a:pPr algn="ctr"/>
             <a:r>
-              <a:rPr lang="en-US" sz="2000">
+              <a:rPr lang="en-US" sz="2400">
                 <a:solidFill>
                   <a:schemeClr val="tx1"/>
                 </a:solidFill>
@@ -34395,7 +34415,7 @@
           <a:p>
             <a:pPr algn="ctr"/>
             <a:r>
-              <a:rPr lang="en-US" sz="2000">
+              <a:rPr lang="en-US" sz="2400">
                 <a:solidFill>
                   <a:schemeClr val="tx1"/>
                 </a:solidFill>
@@ -34545,6 +34565,7 @@
             </a:extLst>
           </p:cNvPr>
           <p:cNvCxnSpPr>
+            <a:cxnSpLocks/>
             <a:stCxn id="3" idx="7"/>
             <a:endCxn id="6" idx="1"/>
           </p:cNvCxnSpPr>
@@ -34553,7 +34574,7 @@
         <p:spPr>
           <a:xfrm flipV="1">
             <a:off x="6742578" y="1688374"/>
-            <a:ext cx="1791822" cy="1094048"/>
+            <a:ext cx="1319382" cy="1094048"/>
           </a:xfrm>
           <a:prstGeom prst="line">
             <a:avLst/>
@@ -34593,7 +34614,7 @@
         <p:spPr>
           <a:xfrm>
             <a:off x="6742578" y="4075578"/>
-            <a:ext cx="1791822" cy="1094048"/>
+            <a:ext cx="1319382" cy="1094048"/>
           </a:xfrm>
           <a:prstGeom prst="line">
             <a:avLst/>
@@ -34633,7 +34654,7 @@
         <p:spPr>
           <a:xfrm>
             <a:off x="7010400" y="3429000"/>
-            <a:ext cx="1698172" cy="0"/>
+            <a:ext cx="1225732" cy="0"/>
           </a:xfrm>
           <a:prstGeom prst="line">
             <a:avLst/>
@@ -35369,14 +35390,14 @@
           <a:p>
             <a:pPr algn="ctr"/>
             <a:r>
-              <a:rPr lang="en-US" sz="2000">
+              <a:rPr lang="en-US" sz="2800">
                 <a:solidFill>
                   <a:schemeClr val="tx1"/>
                 </a:solidFill>
                 <a:latin typeface="Times New Roman" panose="02020603050405020304" pitchFamily="18" charset="0"/>
                 <a:cs typeface="Times New Roman" panose="02020603050405020304" pitchFamily="18" charset="0"/>
               </a:rPr>
-              <a:t>Các kiến trúc mạng neural, như ANN, CNN, RNN,…</a:t>
+              <a:t>Các kiến trúc mạng neural như ANN, CNN, RNN,…</a:t>
             </a:r>
           </a:p>
         </p:txBody>
@@ -35503,7 +35524,7 @@
         </p:nvSpPr>
         <p:spPr>
           <a:xfrm>
-            <a:off x="2804160" y="1854200"/>
+            <a:off x="2804160" y="2341880"/>
             <a:ext cx="1828800" cy="1828800"/>
           </a:xfrm>
           <a:prstGeom prst="ellipse">
@@ -35540,7 +35561,7 @@
           <a:p>
             <a:pPr algn="ctr"/>
             <a:r>
-              <a:rPr lang="en-US" sz="2000" b="1">
+              <a:rPr lang="en-US" sz="2800" b="1">
                 <a:solidFill>
                   <a:schemeClr val="tx1"/>
                 </a:solidFill>
@@ -35566,7 +35587,7 @@
         </p:nvSpPr>
         <p:spPr>
           <a:xfrm>
-            <a:off x="6096000" y="4155440"/>
+            <a:off x="6096000" y="4643120"/>
             <a:ext cx="2956560" cy="990600"/>
           </a:xfrm>
           <a:prstGeom prst="roundRect">
@@ -35603,7 +35624,7 @@
           <a:p>
             <a:pPr algn="ctr"/>
             <a:r>
-              <a:rPr lang="en-US" sz="2000">
+              <a:rPr lang="en-US" sz="2800">
                 <a:solidFill>
                   <a:schemeClr val="tx1"/>
                 </a:solidFill>
@@ -35629,7 +35650,7 @@
         </p:nvSpPr>
         <p:spPr>
           <a:xfrm>
-            <a:off x="6096000" y="1678940"/>
+            <a:off x="6096000" y="2166620"/>
             <a:ext cx="2956560" cy="990600"/>
           </a:xfrm>
           <a:prstGeom prst="roundRect">
@@ -35666,7 +35687,7 @@
           <a:p>
             <a:pPr algn="ctr"/>
             <a:r>
-              <a:rPr lang="en-US" sz="2000">
+              <a:rPr lang="en-US" sz="2800">
                 <a:solidFill>
                   <a:schemeClr val="tx1"/>
                 </a:solidFill>
@@ -35692,7 +35713,7 @@
         </p:nvSpPr>
         <p:spPr>
           <a:xfrm>
-            <a:off x="6096000" y="2917190"/>
+            <a:off x="6096000" y="3404870"/>
             <a:ext cx="2956560" cy="990600"/>
           </a:xfrm>
           <a:prstGeom prst="roundRect">
@@ -35729,7 +35750,7 @@
           <a:p>
             <a:pPr algn="ctr"/>
             <a:r>
-              <a:rPr lang="en-US" sz="2000">
+              <a:rPr lang="en-US" sz="2800">
                 <a:solidFill>
                   <a:schemeClr val="tx1"/>
                 </a:solidFill>
@@ -35755,7 +35776,7 @@
         </p:nvSpPr>
         <p:spPr>
           <a:xfrm>
-            <a:off x="6096000" y="440690"/>
+            <a:off x="6096000" y="928370"/>
             <a:ext cx="2956560" cy="990600"/>
           </a:xfrm>
           <a:prstGeom prst="roundRect">
@@ -35792,7 +35813,7 @@
           <a:p>
             <a:pPr algn="ctr"/>
             <a:r>
-              <a:rPr lang="en-US" sz="2000">
+              <a:rPr lang="en-US" sz="2800">
                 <a:solidFill>
                   <a:schemeClr val="tx1"/>
                 </a:solidFill>
@@ -35821,7 +35842,7 @@
         </p:nvCxnSpPr>
         <p:spPr>
           <a:xfrm flipV="1">
-            <a:off x="4632960" y="935990"/>
+            <a:off x="4632960" y="1423670"/>
             <a:ext cx="1463040" cy="1832610"/>
           </a:xfrm>
           <a:prstGeom prst="bentConnector3">
@@ -35863,7 +35884,7 @@
         </p:nvCxnSpPr>
         <p:spPr>
           <a:xfrm flipV="1">
-            <a:off x="4632960" y="2174240"/>
+            <a:off x="4632960" y="2661920"/>
             <a:ext cx="1463040" cy="594360"/>
           </a:xfrm>
           <a:prstGeom prst="bentConnector3">
@@ -35905,7 +35926,7 @@
         </p:nvCxnSpPr>
         <p:spPr>
           <a:xfrm>
-            <a:off x="4632960" y="2768600"/>
+            <a:off x="4632960" y="3256280"/>
             <a:ext cx="1463040" cy="643890"/>
           </a:xfrm>
           <a:prstGeom prst="bentConnector3">
@@ -35947,7 +35968,7 @@
         </p:nvCxnSpPr>
         <p:spPr>
           <a:xfrm>
-            <a:off x="4632960" y="2768600"/>
+            <a:off x="4632960" y="3256280"/>
             <a:ext cx="1463040" cy="1882140"/>
           </a:xfrm>
           <a:prstGeom prst="bentConnector3">

</xml_diff>

<commit_message>
Update file bao cao va hinh anh: them anh cau truc prompt
</commit_message>
<xml_diff>
--- a/documents/hinh_ve_trong_cao_cao_do_an.pptx
+++ b/documents/hinh_ve_trong_cao_cao_do_an.pptx
@@ -5,7 +5,7 @@
     <p:sldMasterId id="2147483648" r:id="rId1"/>
   </p:sldMasterIdLst>
   <p:notesMasterIdLst>
-    <p:notesMasterId r:id="rId34"/>
+    <p:notesMasterId r:id="rId38"/>
   </p:notesMasterIdLst>
   <p:sldIdLst>
     <p:sldId id="263" r:id="rId2"/>
@@ -39,7 +39,11 @@
     <p:sldId id="277" r:id="rId30"/>
     <p:sldId id="280" r:id="rId31"/>
     <p:sldId id="279" r:id="rId32"/>
-    <p:sldId id="270" r:id="rId33"/>
+    <p:sldId id="294" r:id="rId33"/>
+    <p:sldId id="295" r:id="rId34"/>
+    <p:sldId id="292" r:id="rId35"/>
+    <p:sldId id="293" r:id="rId36"/>
+    <p:sldId id="270" r:id="rId37"/>
   </p:sldIdLst>
   <p:sldSz cx="12192000" cy="6858000"/>
   <p:notesSz cx="6858000" cy="9144000"/>
@@ -228,7 +232,7 @@
           <a:p>
             <a:fld id="{1699B688-3183-4F5A-8B47-70F70E2DF15B}" type="datetimeFigureOut">
               <a:rPr lang="en-US" smtClean="0"/>
-              <a:t>5/29/2025</a:t>
+              <a:t>5/30/2025</a:t>
             </a:fld>
             <a:endParaRPr lang="en-US"/>
           </a:p>
@@ -2564,10 +2568,9 @@
           <a:lstStyle/>
           <a:p>
             <a:r>
-              <a:rPr lang="vi-VN"/>
-              <a:t>Style</a:t>
-            </a:r>
-            <a:endParaRPr lang="en-US"/>
+              <a:rPr lang="en-US"/>
+              <a:t>Bieu do chuc nang quan ly hanh vi nguoi dung</a:t>
+            </a:r>
           </a:p>
         </p:txBody>
       </p:sp>
@@ -2589,6 +2592,355 @@
             <a:fld id="{959F4E64-33AD-4E03-A94E-822473CE3B48}" type="slidenum">
               <a:rPr lang="en-US" smtClean="0"/>
               <a:t>32</a:t>
+            </a:fld>
+            <a:endParaRPr lang="en-US"/>
+          </a:p>
+        </p:txBody>
+      </p:sp>
+    </p:spTree>
+    <p:extLst>
+      <p:ext uri="{BB962C8B-B14F-4D97-AF65-F5344CB8AC3E}">
+        <p14:creationId xmlns:p14="http://schemas.microsoft.com/office/powerpoint/2010/main" val="2235046049"/>
+      </p:ext>
+    </p:extLst>
+  </p:cSld>
+  <p:clrMapOvr>
+    <a:masterClrMapping/>
+  </p:clrMapOvr>
+</p:notes>
+</file>
+
+<file path=ppt/notesSlides/notesSlide31.xml><?xml version="1.0" encoding="utf-8"?>
+<p:notes xmlns:a="http://schemas.openxmlformats.org/drawingml/2006/main" xmlns:r="http://schemas.openxmlformats.org/officeDocument/2006/relationships" xmlns:p="http://schemas.openxmlformats.org/presentationml/2006/main">
+  <p:cSld>
+    <p:spTree>
+      <p:nvGrpSpPr>
+        <p:cNvPr id="1" name=""/>
+        <p:cNvGrpSpPr/>
+        <p:nvPr/>
+      </p:nvGrpSpPr>
+      <p:grpSpPr>
+        <a:xfrm>
+          <a:off x="0" y="0"/>
+          <a:ext cx="0" cy="0"/>
+          <a:chOff x="0" y="0"/>
+          <a:chExt cx="0" cy="0"/>
+        </a:xfrm>
+      </p:grpSpPr>
+      <p:sp>
+        <p:nvSpPr>
+          <p:cNvPr id="2" name="Slide Image Placeholder 1"/>
+          <p:cNvSpPr>
+            <a:spLocks noGrp="1" noRot="1" noChangeAspect="1"/>
+          </p:cNvSpPr>
+          <p:nvPr>
+            <p:ph type="sldImg"/>
+          </p:nvPr>
+        </p:nvSpPr>
+        <p:spPr/>
+      </p:sp>
+      <p:sp>
+        <p:nvSpPr>
+          <p:cNvPr id="3" name="Notes Placeholder 2"/>
+          <p:cNvSpPr>
+            <a:spLocks noGrp="1"/>
+          </p:cNvSpPr>
+          <p:nvPr>
+            <p:ph type="body" idx="1"/>
+          </p:nvPr>
+        </p:nvSpPr>
+        <p:spPr/>
+        <p:txBody>
+          <a:bodyPr/>
+          <a:lstStyle/>
+          <a:p>
+            <a:r>
+              <a:rPr lang="en-US"/>
+              <a:t>Cau truc prompt khoi tao starter</a:t>
+            </a:r>
+          </a:p>
+        </p:txBody>
+      </p:sp>
+      <p:sp>
+        <p:nvSpPr>
+          <p:cNvPr id="4" name="Slide Number Placeholder 3"/>
+          <p:cNvSpPr>
+            <a:spLocks noGrp="1"/>
+          </p:cNvSpPr>
+          <p:nvPr>
+            <p:ph type="sldNum" sz="quarter" idx="5"/>
+          </p:nvPr>
+        </p:nvSpPr>
+        <p:spPr/>
+        <p:txBody>
+          <a:bodyPr/>
+          <a:lstStyle/>
+          <a:p>
+            <a:fld id="{959F4E64-33AD-4E03-A94E-822473CE3B48}" type="slidenum">
+              <a:rPr lang="en-US" smtClean="0"/>
+              <a:t>33</a:t>
+            </a:fld>
+            <a:endParaRPr lang="en-US"/>
+          </a:p>
+        </p:txBody>
+      </p:sp>
+    </p:spTree>
+    <p:extLst>
+      <p:ext uri="{BB962C8B-B14F-4D97-AF65-F5344CB8AC3E}">
+        <p14:creationId xmlns:p14="http://schemas.microsoft.com/office/powerpoint/2010/main" val="2281483521"/>
+      </p:ext>
+    </p:extLst>
+  </p:cSld>
+  <p:clrMapOvr>
+    <a:masterClrMapping/>
+  </p:clrMapOvr>
+</p:notes>
+</file>
+
+<file path=ppt/notesSlides/notesSlide32.xml><?xml version="1.0" encoding="utf-8"?>
+<p:notes xmlns:a="http://schemas.openxmlformats.org/drawingml/2006/main" xmlns:r="http://schemas.openxmlformats.org/officeDocument/2006/relationships" xmlns:p="http://schemas.openxmlformats.org/presentationml/2006/main">
+  <p:cSld>
+    <p:spTree>
+      <p:nvGrpSpPr>
+        <p:cNvPr id="1" name=""/>
+        <p:cNvGrpSpPr/>
+        <p:nvPr/>
+      </p:nvGrpSpPr>
+      <p:grpSpPr>
+        <a:xfrm>
+          <a:off x="0" y="0"/>
+          <a:ext cx="0" cy="0"/>
+          <a:chOff x="0" y="0"/>
+          <a:chExt cx="0" cy="0"/>
+        </a:xfrm>
+      </p:grpSpPr>
+      <p:sp>
+        <p:nvSpPr>
+          <p:cNvPr id="2" name="Slide Image Placeholder 1"/>
+          <p:cNvSpPr>
+            <a:spLocks noGrp="1" noRot="1" noChangeAspect="1"/>
+          </p:cNvSpPr>
+          <p:nvPr>
+            <p:ph type="sldImg"/>
+          </p:nvPr>
+        </p:nvSpPr>
+        <p:spPr/>
+      </p:sp>
+      <p:sp>
+        <p:nvSpPr>
+          <p:cNvPr id="3" name="Notes Placeholder 2"/>
+          <p:cNvSpPr>
+            <a:spLocks noGrp="1"/>
+          </p:cNvSpPr>
+          <p:nvPr>
+            <p:ph type="body" idx="1"/>
+          </p:nvPr>
+        </p:nvSpPr>
+        <p:spPr/>
+        <p:txBody>
+          <a:bodyPr/>
+          <a:lstStyle/>
+          <a:p>
+            <a:r>
+              <a:rPr lang="en-US"/>
+              <a:t>Cau truc prompt tro chuyen voi nguoi dung</a:t>
+            </a:r>
+          </a:p>
+        </p:txBody>
+      </p:sp>
+      <p:sp>
+        <p:nvSpPr>
+          <p:cNvPr id="4" name="Slide Number Placeholder 3"/>
+          <p:cNvSpPr>
+            <a:spLocks noGrp="1"/>
+          </p:cNvSpPr>
+          <p:nvPr>
+            <p:ph type="sldNum" sz="quarter" idx="5"/>
+          </p:nvPr>
+        </p:nvSpPr>
+        <p:spPr/>
+        <p:txBody>
+          <a:bodyPr/>
+          <a:lstStyle/>
+          <a:p>
+            <a:fld id="{959F4E64-33AD-4E03-A94E-822473CE3B48}" type="slidenum">
+              <a:rPr lang="en-US" smtClean="0"/>
+              <a:t>34</a:t>
+            </a:fld>
+            <a:endParaRPr lang="en-US"/>
+          </a:p>
+        </p:txBody>
+      </p:sp>
+    </p:spTree>
+    <p:extLst>
+      <p:ext uri="{BB962C8B-B14F-4D97-AF65-F5344CB8AC3E}">
+        <p14:creationId xmlns:p14="http://schemas.microsoft.com/office/powerpoint/2010/main" val="2988671580"/>
+      </p:ext>
+    </p:extLst>
+  </p:cSld>
+  <p:clrMapOvr>
+    <a:masterClrMapping/>
+  </p:clrMapOvr>
+</p:notes>
+</file>
+
+<file path=ppt/notesSlides/notesSlide33.xml><?xml version="1.0" encoding="utf-8"?>
+<p:notes xmlns:a="http://schemas.openxmlformats.org/drawingml/2006/main" xmlns:r="http://schemas.openxmlformats.org/officeDocument/2006/relationships" xmlns:p="http://schemas.openxmlformats.org/presentationml/2006/main">
+  <p:cSld>
+    <p:spTree>
+      <p:nvGrpSpPr>
+        <p:cNvPr id="1" name=""/>
+        <p:cNvGrpSpPr/>
+        <p:nvPr/>
+      </p:nvGrpSpPr>
+      <p:grpSpPr>
+        <a:xfrm>
+          <a:off x="0" y="0"/>
+          <a:ext cx="0" cy="0"/>
+          <a:chOff x="0" y="0"/>
+          <a:chExt cx="0" cy="0"/>
+        </a:xfrm>
+      </p:grpSpPr>
+      <p:sp>
+        <p:nvSpPr>
+          <p:cNvPr id="2" name="Slide Image Placeholder 1"/>
+          <p:cNvSpPr>
+            <a:spLocks noGrp="1" noRot="1" noChangeAspect="1"/>
+          </p:cNvSpPr>
+          <p:nvPr>
+            <p:ph type="sldImg"/>
+          </p:nvPr>
+        </p:nvSpPr>
+        <p:spPr/>
+      </p:sp>
+      <p:sp>
+        <p:nvSpPr>
+          <p:cNvPr id="3" name="Notes Placeholder 2"/>
+          <p:cNvSpPr>
+            <a:spLocks noGrp="1"/>
+          </p:cNvSpPr>
+          <p:nvPr>
+            <p:ph type="body" idx="1"/>
+          </p:nvPr>
+        </p:nvSpPr>
+        <p:spPr/>
+        <p:txBody>
+          <a:bodyPr/>
+          <a:lstStyle/>
+          <a:p>
+            <a:r>
+              <a:rPr lang="en-US"/>
+              <a:t>Cau truc prompt trich xuat thong tin</a:t>
+            </a:r>
+          </a:p>
+        </p:txBody>
+      </p:sp>
+      <p:sp>
+        <p:nvSpPr>
+          <p:cNvPr id="4" name="Slide Number Placeholder 3"/>
+          <p:cNvSpPr>
+            <a:spLocks noGrp="1"/>
+          </p:cNvSpPr>
+          <p:nvPr>
+            <p:ph type="sldNum" sz="quarter" idx="5"/>
+          </p:nvPr>
+        </p:nvSpPr>
+        <p:spPr/>
+        <p:txBody>
+          <a:bodyPr/>
+          <a:lstStyle/>
+          <a:p>
+            <a:fld id="{959F4E64-33AD-4E03-A94E-822473CE3B48}" type="slidenum">
+              <a:rPr lang="en-US" smtClean="0"/>
+              <a:t>35</a:t>
+            </a:fld>
+            <a:endParaRPr lang="en-US"/>
+          </a:p>
+        </p:txBody>
+      </p:sp>
+    </p:spTree>
+    <p:extLst>
+      <p:ext uri="{BB962C8B-B14F-4D97-AF65-F5344CB8AC3E}">
+        <p14:creationId xmlns:p14="http://schemas.microsoft.com/office/powerpoint/2010/main" val="819052166"/>
+      </p:ext>
+    </p:extLst>
+  </p:cSld>
+  <p:clrMapOvr>
+    <a:masterClrMapping/>
+  </p:clrMapOvr>
+</p:notes>
+</file>
+
+<file path=ppt/notesSlides/notesSlide34.xml><?xml version="1.0" encoding="utf-8"?>
+<p:notes xmlns:a="http://schemas.openxmlformats.org/drawingml/2006/main" xmlns:r="http://schemas.openxmlformats.org/officeDocument/2006/relationships" xmlns:p="http://schemas.openxmlformats.org/presentationml/2006/main">
+  <p:cSld>
+    <p:spTree>
+      <p:nvGrpSpPr>
+        <p:cNvPr id="1" name=""/>
+        <p:cNvGrpSpPr/>
+        <p:nvPr/>
+      </p:nvGrpSpPr>
+      <p:grpSpPr>
+        <a:xfrm>
+          <a:off x="0" y="0"/>
+          <a:ext cx="0" cy="0"/>
+          <a:chOff x="0" y="0"/>
+          <a:chExt cx="0" cy="0"/>
+        </a:xfrm>
+      </p:grpSpPr>
+      <p:sp>
+        <p:nvSpPr>
+          <p:cNvPr id="2" name="Slide Image Placeholder 1"/>
+          <p:cNvSpPr>
+            <a:spLocks noGrp="1" noRot="1" noChangeAspect="1"/>
+          </p:cNvSpPr>
+          <p:nvPr>
+            <p:ph type="sldImg"/>
+          </p:nvPr>
+        </p:nvSpPr>
+        <p:spPr/>
+      </p:sp>
+      <p:sp>
+        <p:nvSpPr>
+          <p:cNvPr id="3" name="Notes Placeholder 2"/>
+          <p:cNvSpPr>
+            <a:spLocks noGrp="1"/>
+          </p:cNvSpPr>
+          <p:nvPr>
+            <p:ph type="body" idx="1"/>
+          </p:nvPr>
+        </p:nvSpPr>
+        <p:spPr/>
+        <p:txBody>
+          <a:bodyPr/>
+          <a:lstStyle/>
+          <a:p>
+            <a:r>
+              <a:rPr lang="vi-VN"/>
+              <a:t>Style</a:t>
+            </a:r>
+            <a:endParaRPr lang="en-US"/>
+          </a:p>
+        </p:txBody>
+      </p:sp>
+      <p:sp>
+        <p:nvSpPr>
+          <p:cNvPr id="4" name="Slide Number Placeholder 3"/>
+          <p:cNvSpPr>
+            <a:spLocks noGrp="1"/>
+          </p:cNvSpPr>
+          <p:nvPr>
+            <p:ph type="sldNum" sz="quarter" idx="5"/>
+          </p:nvPr>
+        </p:nvSpPr>
+        <p:spPr/>
+        <p:txBody>
+          <a:bodyPr/>
+          <a:lstStyle/>
+          <a:p>
+            <a:fld id="{959F4E64-33AD-4E03-A94E-822473CE3B48}" type="slidenum">
+              <a:rPr lang="en-US" smtClean="0"/>
+              <a:t>36</a:t>
             </a:fld>
             <a:endParaRPr lang="en-US"/>
           </a:p>
@@ -3276,7 +3628,7 @@
           <a:p>
             <a:fld id="{1274BF1E-CB95-4284-9B4D-720351FD5384}" type="datetimeFigureOut">
               <a:rPr lang="en-US" smtClean="0"/>
-              <a:t>5/29/2025</a:t>
+              <a:t>5/30/2025</a:t>
             </a:fld>
             <a:endParaRPr lang="en-US"/>
           </a:p>
@@ -3474,7 +3826,7 @@
           <a:p>
             <a:fld id="{1274BF1E-CB95-4284-9B4D-720351FD5384}" type="datetimeFigureOut">
               <a:rPr lang="en-US" smtClean="0"/>
-              <a:t>5/29/2025</a:t>
+              <a:t>5/30/2025</a:t>
             </a:fld>
             <a:endParaRPr lang="en-US"/>
           </a:p>
@@ -3682,7 +4034,7 @@
           <a:p>
             <a:fld id="{1274BF1E-CB95-4284-9B4D-720351FD5384}" type="datetimeFigureOut">
               <a:rPr lang="en-US" smtClean="0"/>
-              <a:t>5/29/2025</a:t>
+              <a:t>5/30/2025</a:t>
             </a:fld>
             <a:endParaRPr lang="en-US"/>
           </a:p>
@@ -3880,7 +4232,7 @@
           <a:p>
             <a:fld id="{1274BF1E-CB95-4284-9B4D-720351FD5384}" type="datetimeFigureOut">
               <a:rPr lang="en-US" smtClean="0"/>
-              <a:t>5/29/2025</a:t>
+              <a:t>5/30/2025</a:t>
             </a:fld>
             <a:endParaRPr lang="en-US"/>
           </a:p>
@@ -4155,7 +4507,7 @@
           <a:p>
             <a:fld id="{1274BF1E-CB95-4284-9B4D-720351FD5384}" type="datetimeFigureOut">
               <a:rPr lang="en-US" smtClean="0"/>
-              <a:t>5/29/2025</a:t>
+              <a:t>5/30/2025</a:t>
             </a:fld>
             <a:endParaRPr lang="en-US"/>
           </a:p>
@@ -4420,7 +4772,7 @@
           <a:p>
             <a:fld id="{1274BF1E-CB95-4284-9B4D-720351FD5384}" type="datetimeFigureOut">
               <a:rPr lang="en-US" smtClean="0"/>
-              <a:t>5/29/2025</a:t>
+              <a:t>5/30/2025</a:t>
             </a:fld>
             <a:endParaRPr lang="en-US"/>
           </a:p>
@@ -4832,7 +5184,7 @@
           <a:p>
             <a:fld id="{1274BF1E-CB95-4284-9B4D-720351FD5384}" type="datetimeFigureOut">
               <a:rPr lang="en-US" smtClean="0"/>
-              <a:t>5/29/2025</a:t>
+              <a:t>5/30/2025</a:t>
             </a:fld>
             <a:endParaRPr lang="en-US"/>
           </a:p>
@@ -4973,7 +5325,7 @@
           <a:p>
             <a:fld id="{1274BF1E-CB95-4284-9B4D-720351FD5384}" type="datetimeFigureOut">
               <a:rPr lang="en-US" smtClean="0"/>
-              <a:t>5/29/2025</a:t>
+              <a:t>5/30/2025</a:t>
             </a:fld>
             <a:endParaRPr lang="en-US"/>
           </a:p>
@@ -5086,7 +5438,7 @@
           <a:p>
             <a:fld id="{1274BF1E-CB95-4284-9B4D-720351FD5384}" type="datetimeFigureOut">
               <a:rPr lang="en-US" smtClean="0"/>
-              <a:t>5/29/2025</a:t>
+              <a:t>5/30/2025</a:t>
             </a:fld>
             <a:endParaRPr lang="en-US"/>
           </a:p>
@@ -5397,7 +5749,7 @@
           <a:p>
             <a:fld id="{1274BF1E-CB95-4284-9B4D-720351FD5384}" type="datetimeFigureOut">
               <a:rPr lang="en-US" smtClean="0"/>
-              <a:t>5/29/2025</a:t>
+              <a:t>5/30/2025</a:t>
             </a:fld>
             <a:endParaRPr lang="en-US"/>
           </a:p>
@@ -5685,7 +6037,7 @@
           <a:p>
             <a:fld id="{1274BF1E-CB95-4284-9B4D-720351FD5384}" type="datetimeFigureOut">
               <a:rPr lang="en-US" smtClean="0"/>
-              <a:t>5/29/2025</a:t>
+              <a:t>5/30/2025</a:t>
             </a:fld>
             <a:endParaRPr lang="en-US"/>
           </a:p>
@@ -5926,7 +6278,7 @@
           <a:p>
             <a:fld id="{1274BF1E-CB95-4284-9B4D-720351FD5384}" type="datetimeFigureOut">
               <a:rPr lang="en-US" smtClean="0"/>
-              <a:t>5/29/2025</a:t>
+              <a:t>5/30/2025</a:t>
             </a:fld>
             <a:endParaRPr lang="en-US"/>
           </a:p>
@@ -33320,6 +33672,2518 @@
           <a:chExt cx="0" cy="0"/>
         </a:xfrm>
       </p:grpSpPr>
+      <p:sp>
+        <p:nvSpPr>
+          <p:cNvPr id="2" name="Oval 1">
+            <a:extLst>
+              <a:ext uri="{FF2B5EF4-FFF2-40B4-BE49-F238E27FC236}">
+                <a16:creationId xmlns:a16="http://schemas.microsoft.com/office/drawing/2014/main" id="{71B2C4F9-1C0F-1CF9-481D-E75171FFEB29}"/>
+              </a:ext>
+            </a:extLst>
+          </p:cNvPr>
+          <p:cNvSpPr/>
+          <p:nvPr/>
+        </p:nvSpPr>
+        <p:spPr>
+          <a:xfrm>
+            <a:off x="1327694" y="1014002"/>
+            <a:ext cx="1844040" cy="777240"/>
+          </a:xfrm>
+          <a:prstGeom prst="ellipse">
+            <a:avLst/>
+          </a:prstGeom>
+          <a:solidFill>
+            <a:schemeClr val="bg2"/>
+          </a:solidFill>
+          <a:ln>
+            <a:solidFill>
+              <a:schemeClr val="tx1"/>
+            </a:solidFill>
+          </a:ln>
+        </p:spPr>
+        <p:style>
+          <a:lnRef idx="2">
+            <a:schemeClr val="dk1"/>
+          </a:lnRef>
+          <a:fillRef idx="1">
+            <a:schemeClr val="lt1"/>
+          </a:fillRef>
+          <a:effectRef idx="0">
+            <a:schemeClr val="dk1"/>
+          </a:effectRef>
+          <a:fontRef idx="minor">
+            <a:schemeClr val="dk1"/>
+          </a:fontRef>
+        </p:style>
+        <p:txBody>
+          <a:bodyPr rtlCol="0" anchor="ctr"/>
+          <a:lstStyle/>
+          <a:p>
+            <a:pPr algn="ctr"/>
+            <a:r>
+              <a:rPr lang="en-US" sz="2400">
+                <a:solidFill>
+                  <a:schemeClr val="tx1"/>
+                </a:solidFill>
+                <a:latin typeface="Times New Roman" panose="02020603050405020304" pitchFamily="18" charset="0"/>
+                <a:cs typeface="Times New Roman" panose="02020603050405020304" pitchFamily="18" charset="0"/>
+              </a:rPr>
+              <a:t>Bắt đầu</a:t>
+            </a:r>
+          </a:p>
+        </p:txBody>
+      </p:sp>
+      <p:sp>
+        <p:nvSpPr>
+          <p:cNvPr id="3" name="Rectangle: Rounded Corners 2">
+            <a:extLst>
+              <a:ext uri="{FF2B5EF4-FFF2-40B4-BE49-F238E27FC236}">
+                <a16:creationId xmlns:a16="http://schemas.microsoft.com/office/drawing/2014/main" id="{E9423A58-5224-8B0E-F5F4-8BEB42C3EAEF}"/>
+              </a:ext>
+            </a:extLst>
+          </p:cNvPr>
+          <p:cNvSpPr/>
+          <p:nvPr/>
+        </p:nvSpPr>
+        <p:spPr>
+          <a:xfrm>
+            <a:off x="2794000" y="2450434"/>
+            <a:ext cx="3302000" cy="924618"/>
+          </a:xfrm>
+          <a:prstGeom prst="roundRect">
+            <a:avLst/>
+          </a:prstGeom>
+          <a:solidFill>
+            <a:schemeClr val="bg2"/>
+          </a:solidFill>
+          <a:ln>
+            <a:solidFill>
+              <a:schemeClr val="tx1"/>
+            </a:solidFill>
+          </a:ln>
+        </p:spPr>
+        <p:style>
+          <a:lnRef idx="2">
+            <a:schemeClr val="accent1">
+              <a:shade val="15000"/>
+            </a:schemeClr>
+          </a:lnRef>
+          <a:fillRef idx="1">
+            <a:schemeClr val="accent1"/>
+          </a:fillRef>
+          <a:effectRef idx="0">
+            <a:schemeClr val="accent1"/>
+          </a:effectRef>
+          <a:fontRef idx="minor">
+            <a:schemeClr val="lt1"/>
+          </a:fontRef>
+        </p:style>
+        <p:txBody>
+          <a:bodyPr rtlCol="0" anchor="ctr"/>
+          <a:lstStyle/>
+          <a:p>
+            <a:pPr algn="ctr"/>
+            <a:r>
+              <a:rPr lang="en-US" sz="2000">
+                <a:solidFill>
+                  <a:schemeClr val="tx1"/>
+                </a:solidFill>
+                <a:latin typeface="Times New Roman" panose="02020603050405020304" pitchFamily="18" charset="0"/>
+                <a:cs typeface="Times New Roman" panose="02020603050405020304" pitchFamily="18" charset="0"/>
+              </a:rPr>
+              <a:t>Người dùng thực hiện</a:t>
+            </a:r>
+          </a:p>
+          <a:p>
+            <a:pPr algn="ctr"/>
+            <a:r>
+              <a:rPr lang="en-US" sz="2000">
+                <a:solidFill>
+                  <a:schemeClr val="tx1"/>
+                </a:solidFill>
+                <a:latin typeface="Times New Roman" panose="02020603050405020304" pitchFamily="18" charset="0"/>
+                <a:cs typeface="Times New Roman" panose="02020603050405020304" pitchFamily="18" charset="0"/>
+              </a:rPr>
+              <a:t>một hành vi đánh giá</a:t>
+            </a:r>
+          </a:p>
+        </p:txBody>
+      </p:sp>
+      <p:sp>
+        <p:nvSpPr>
+          <p:cNvPr id="4" name="Rectangle: Rounded Corners 3">
+            <a:extLst>
+              <a:ext uri="{FF2B5EF4-FFF2-40B4-BE49-F238E27FC236}">
+                <a16:creationId xmlns:a16="http://schemas.microsoft.com/office/drawing/2014/main" id="{62133B71-7D08-E4AD-3AB4-C3CF9EF83B1A}"/>
+              </a:ext>
+            </a:extLst>
+          </p:cNvPr>
+          <p:cNvSpPr/>
+          <p:nvPr/>
+        </p:nvSpPr>
+        <p:spPr>
+          <a:xfrm>
+            <a:off x="6096000" y="3710882"/>
+            <a:ext cx="3302000" cy="924618"/>
+          </a:xfrm>
+          <a:prstGeom prst="roundRect">
+            <a:avLst/>
+          </a:prstGeom>
+          <a:solidFill>
+            <a:schemeClr val="bg2"/>
+          </a:solidFill>
+          <a:ln>
+            <a:solidFill>
+              <a:schemeClr val="tx1"/>
+            </a:solidFill>
+          </a:ln>
+        </p:spPr>
+        <p:style>
+          <a:lnRef idx="2">
+            <a:schemeClr val="accent1">
+              <a:shade val="15000"/>
+            </a:schemeClr>
+          </a:lnRef>
+          <a:fillRef idx="1">
+            <a:schemeClr val="accent1"/>
+          </a:fillRef>
+          <a:effectRef idx="0">
+            <a:schemeClr val="accent1"/>
+          </a:effectRef>
+          <a:fontRef idx="minor">
+            <a:schemeClr val="lt1"/>
+          </a:fontRef>
+        </p:style>
+        <p:txBody>
+          <a:bodyPr rtlCol="0" anchor="ctr"/>
+          <a:lstStyle/>
+          <a:p>
+            <a:pPr algn="ctr"/>
+            <a:r>
+              <a:rPr lang="en-US" sz="2000">
+                <a:solidFill>
+                  <a:schemeClr val="tx1"/>
+                </a:solidFill>
+                <a:latin typeface="Times New Roman" panose="02020603050405020304" pitchFamily="18" charset="0"/>
+                <a:cs typeface="Times New Roman" panose="02020603050405020304" pitchFamily="18" charset="0"/>
+              </a:rPr>
+              <a:t>Hệ thống cập nhật hành vi</a:t>
+            </a:r>
+          </a:p>
+          <a:p>
+            <a:pPr algn="ctr"/>
+            <a:r>
+              <a:rPr lang="en-US" sz="2000">
+                <a:solidFill>
+                  <a:schemeClr val="tx1"/>
+                </a:solidFill>
+                <a:latin typeface="Times New Roman" panose="02020603050405020304" pitchFamily="18" charset="0"/>
+                <a:cs typeface="Times New Roman" panose="02020603050405020304" pitchFamily="18" charset="0"/>
+              </a:rPr>
+              <a:t>của người dùng vào CSDL</a:t>
+            </a:r>
+          </a:p>
+        </p:txBody>
+      </p:sp>
+      <p:sp>
+        <p:nvSpPr>
+          <p:cNvPr id="6" name="Oval 5">
+            <a:extLst>
+              <a:ext uri="{FF2B5EF4-FFF2-40B4-BE49-F238E27FC236}">
+                <a16:creationId xmlns:a16="http://schemas.microsoft.com/office/drawing/2014/main" id="{41E78B99-0B43-8090-58DE-2DC7F0DAF15C}"/>
+              </a:ext>
+            </a:extLst>
+          </p:cNvPr>
+          <p:cNvSpPr/>
+          <p:nvPr/>
+        </p:nvSpPr>
+        <p:spPr>
+          <a:xfrm>
+            <a:off x="9042400" y="4969096"/>
+            <a:ext cx="1844040" cy="777240"/>
+          </a:xfrm>
+          <a:prstGeom prst="ellipse">
+            <a:avLst/>
+          </a:prstGeom>
+          <a:solidFill>
+            <a:schemeClr val="bg2"/>
+          </a:solidFill>
+          <a:ln>
+            <a:solidFill>
+              <a:schemeClr val="tx1"/>
+            </a:solidFill>
+          </a:ln>
+        </p:spPr>
+        <p:style>
+          <a:lnRef idx="2">
+            <a:schemeClr val="dk1"/>
+          </a:lnRef>
+          <a:fillRef idx="1">
+            <a:schemeClr val="lt1"/>
+          </a:fillRef>
+          <a:effectRef idx="0">
+            <a:schemeClr val="dk1"/>
+          </a:effectRef>
+          <a:fontRef idx="minor">
+            <a:schemeClr val="dk1"/>
+          </a:fontRef>
+        </p:style>
+        <p:txBody>
+          <a:bodyPr rtlCol="0" anchor="ctr"/>
+          <a:lstStyle/>
+          <a:p>
+            <a:pPr algn="ctr"/>
+            <a:r>
+              <a:rPr lang="en-US" sz="2400">
+                <a:solidFill>
+                  <a:schemeClr val="tx1"/>
+                </a:solidFill>
+                <a:latin typeface="Times New Roman" panose="02020603050405020304" pitchFamily="18" charset="0"/>
+                <a:cs typeface="Times New Roman" panose="02020603050405020304" pitchFamily="18" charset="0"/>
+              </a:rPr>
+              <a:t>Kết thúc</a:t>
+            </a:r>
+          </a:p>
+        </p:txBody>
+      </p:sp>
+      <p:sp>
+        <p:nvSpPr>
+          <p:cNvPr id="18" name="TextBox 17">
+            <a:extLst>
+              <a:ext uri="{FF2B5EF4-FFF2-40B4-BE49-F238E27FC236}">
+                <a16:creationId xmlns:a16="http://schemas.microsoft.com/office/drawing/2014/main" id="{350D8F2E-A5EA-2C12-2109-C38A249237E7}"/>
+              </a:ext>
+            </a:extLst>
+          </p:cNvPr>
+          <p:cNvSpPr txBox="1"/>
+          <p:nvPr/>
+        </p:nvSpPr>
+        <p:spPr>
+          <a:xfrm>
+            <a:off x="3171734" y="1002512"/>
+            <a:ext cx="482824" cy="400110"/>
+          </a:xfrm>
+          <a:prstGeom prst="rect">
+            <a:avLst/>
+          </a:prstGeom>
+          <a:noFill/>
+        </p:spPr>
+        <p:txBody>
+          <a:bodyPr wrap="none" rtlCol="0">
+            <a:spAutoFit/>
+          </a:bodyPr>
+          <a:lstStyle/>
+          <a:p>
+            <a:r>
+              <a:rPr lang="en-US" sz="2000">
+                <a:latin typeface="Times New Roman" panose="02020603050405020304" pitchFamily="18" charset="0"/>
+                <a:cs typeface="Times New Roman" panose="02020603050405020304" pitchFamily="18" charset="0"/>
+              </a:rPr>
+              <a:t>(1)</a:t>
+            </a:r>
+          </a:p>
+        </p:txBody>
+      </p:sp>
+      <p:sp>
+        <p:nvSpPr>
+          <p:cNvPr id="19" name="TextBox 18">
+            <a:extLst>
+              <a:ext uri="{FF2B5EF4-FFF2-40B4-BE49-F238E27FC236}">
+                <a16:creationId xmlns:a16="http://schemas.microsoft.com/office/drawing/2014/main" id="{A541460D-3078-ACE9-FC0C-77F71E274E2D}"/>
+              </a:ext>
+            </a:extLst>
+          </p:cNvPr>
+          <p:cNvSpPr txBox="1"/>
+          <p:nvPr/>
+        </p:nvSpPr>
+        <p:spPr>
+          <a:xfrm>
+            <a:off x="6096000" y="2512633"/>
+            <a:ext cx="482824" cy="400110"/>
+          </a:xfrm>
+          <a:prstGeom prst="rect">
+            <a:avLst/>
+          </a:prstGeom>
+          <a:noFill/>
+        </p:spPr>
+        <p:txBody>
+          <a:bodyPr wrap="none" rtlCol="0">
+            <a:spAutoFit/>
+          </a:bodyPr>
+          <a:lstStyle/>
+          <a:p>
+            <a:r>
+              <a:rPr lang="en-US" sz="2000">
+                <a:latin typeface="Times New Roman" panose="02020603050405020304" pitchFamily="18" charset="0"/>
+                <a:cs typeface="Times New Roman" panose="02020603050405020304" pitchFamily="18" charset="0"/>
+              </a:rPr>
+              <a:t>(2)</a:t>
+            </a:r>
+          </a:p>
+        </p:txBody>
+      </p:sp>
+      <p:sp>
+        <p:nvSpPr>
+          <p:cNvPr id="20" name="TextBox 19">
+            <a:extLst>
+              <a:ext uri="{FF2B5EF4-FFF2-40B4-BE49-F238E27FC236}">
+                <a16:creationId xmlns:a16="http://schemas.microsoft.com/office/drawing/2014/main" id="{1EF642F4-A632-F076-ECA9-894516DA9C81}"/>
+              </a:ext>
+            </a:extLst>
+          </p:cNvPr>
+          <p:cNvSpPr txBox="1"/>
+          <p:nvPr/>
+        </p:nvSpPr>
+        <p:spPr>
+          <a:xfrm>
+            <a:off x="9398000" y="3773081"/>
+            <a:ext cx="482824" cy="400110"/>
+          </a:xfrm>
+          <a:prstGeom prst="rect">
+            <a:avLst/>
+          </a:prstGeom>
+          <a:noFill/>
+        </p:spPr>
+        <p:txBody>
+          <a:bodyPr wrap="none" rtlCol="0">
+            <a:spAutoFit/>
+          </a:bodyPr>
+          <a:lstStyle/>
+          <a:p>
+            <a:r>
+              <a:rPr lang="en-US" sz="2000">
+                <a:latin typeface="Times New Roman" panose="02020603050405020304" pitchFamily="18" charset="0"/>
+                <a:cs typeface="Times New Roman" panose="02020603050405020304" pitchFamily="18" charset="0"/>
+              </a:rPr>
+              <a:t>(3)</a:t>
+            </a:r>
+          </a:p>
+        </p:txBody>
+      </p:sp>
+      <p:cxnSp>
+        <p:nvCxnSpPr>
+          <p:cNvPr id="29" name="Connector: Elbow 28">
+            <a:extLst>
+              <a:ext uri="{FF2B5EF4-FFF2-40B4-BE49-F238E27FC236}">
+                <a16:creationId xmlns:a16="http://schemas.microsoft.com/office/drawing/2014/main" id="{F4D02D3B-11BE-D88E-3232-2AF9C20A721B}"/>
+              </a:ext>
+            </a:extLst>
+          </p:cNvPr>
+          <p:cNvCxnSpPr>
+            <a:cxnSpLocks/>
+            <a:stCxn id="2" idx="6"/>
+            <a:endCxn id="3" idx="0"/>
+          </p:cNvCxnSpPr>
+          <p:nvPr/>
+        </p:nvCxnSpPr>
+        <p:spPr>
+          <a:xfrm>
+            <a:off x="3171734" y="1402622"/>
+            <a:ext cx="1273266" cy="1047812"/>
+          </a:xfrm>
+          <a:prstGeom prst="bentConnector2">
+            <a:avLst/>
+          </a:prstGeom>
+          <a:ln>
+            <a:tailEnd type="triangle"/>
+          </a:ln>
+        </p:spPr>
+        <p:style>
+          <a:lnRef idx="2">
+            <a:schemeClr val="dk1"/>
+          </a:lnRef>
+          <a:fillRef idx="0">
+            <a:schemeClr val="dk1"/>
+          </a:fillRef>
+          <a:effectRef idx="1">
+            <a:schemeClr val="dk1"/>
+          </a:effectRef>
+          <a:fontRef idx="minor">
+            <a:schemeClr val="tx1"/>
+          </a:fontRef>
+        </p:style>
+      </p:cxnSp>
+      <p:cxnSp>
+        <p:nvCxnSpPr>
+          <p:cNvPr id="31" name="Connector: Elbow 30">
+            <a:extLst>
+              <a:ext uri="{FF2B5EF4-FFF2-40B4-BE49-F238E27FC236}">
+                <a16:creationId xmlns:a16="http://schemas.microsoft.com/office/drawing/2014/main" id="{DBC04417-11EE-9F9F-5B12-FA8212176C2A}"/>
+              </a:ext>
+            </a:extLst>
+          </p:cNvPr>
+          <p:cNvCxnSpPr>
+            <a:cxnSpLocks/>
+            <a:stCxn id="3" idx="3"/>
+            <a:endCxn id="4" idx="0"/>
+          </p:cNvCxnSpPr>
+          <p:nvPr/>
+        </p:nvCxnSpPr>
+        <p:spPr>
+          <a:xfrm>
+            <a:off x="6096000" y="2912743"/>
+            <a:ext cx="1651000" cy="798139"/>
+          </a:xfrm>
+          <a:prstGeom prst="bentConnector2">
+            <a:avLst/>
+          </a:prstGeom>
+          <a:ln>
+            <a:tailEnd type="triangle"/>
+          </a:ln>
+        </p:spPr>
+        <p:style>
+          <a:lnRef idx="2">
+            <a:schemeClr val="dk1"/>
+          </a:lnRef>
+          <a:fillRef idx="0">
+            <a:schemeClr val="dk1"/>
+          </a:fillRef>
+          <a:effectRef idx="1">
+            <a:schemeClr val="dk1"/>
+          </a:effectRef>
+          <a:fontRef idx="minor">
+            <a:schemeClr val="tx1"/>
+          </a:fontRef>
+        </p:style>
+      </p:cxnSp>
+      <p:cxnSp>
+        <p:nvCxnSpPr>
+          <p:cNvPr id="33" name="Connector: Elbow 32">
+            <a:extLst>
+              <a:ext uri="{FF2B5EF4-FFF2-40B4-BE49-F238E27FC236}">
+                <a16:creationId xmlns:a16="http://schemas.microsoft.com/office/drawing/2014/main" id="{EDF04D07-B273-B93A-F8F4-5475F0D810F2}"/>
+              </a:ext>
+            </a:extLst>
+          </p:cNvPr>
+          <p:cNvCxnSpPr>
+            <a:cxnSpLocks/>
+            <a:stCxn id="4" idx="3"/>
+            <a:endCxn id="6" idx="0"/>
+          </p:cNvCxnSpPr>
+          <p:nvPr/>
+        </p:nvCxnSpPr>
+        <p:spPr>
+          <a:xfrm>
+            <a:off x="9398000" y="4173191"/>
+            <a:ext cx="566420" cy="795905"/>
+          </a:xfrm>
+          <a:prstGeom prst="bentConnector2">
+            <a:avLst/>
+          </a:prstGeom>
+          <a:ln>
+            <a:tailEnd type="triangle"/>
+          </a:ln>
+        </p:spPr>
+        <p:style>
+          <a:lnRef idx="2">
+            <a:schemeClr val="dk1"/>
+          </a:lnRef>
+          <a:fillRef idx="0">
+            <a:schemeClr val="dk1"/>
+          </a:fillRef>
+          <a:effectRef idx="1">
+            <a:schemeClr val="dk1"/>
+          </a:effectRef>
+          <a:fontRef idx="minor">
+            <a:schemeClr val="tx1"/>
+          </a:fontRef>
+        </p:style>
+      </p:cxnSp>
+    </p:spTree>
+    <p:extLst>
+      <p:ext uri="{BB962C8B-B14F-4D97-AF65-F5344CB8AC3E}">
+        <p14:creationId xmlns:p14="http://schemas.microsoft.com/office/powerpoint/2010/main" val="285086992"/>
+      </p:ext>
+    </p:extLst>
+  </p:cSld>
+  <p:clrMapOvr>
+    <a:masterClrMapping/>
+  </p:clrMapOvr>
+</p:sld>
+</file>
+
+<file path=ppt/slides/slide33.xml><?xml version="1.0" encoding="utf-8"?>
+<p:sld xmlns:a="http://schemas.openxmlformats.org/drawingml/2006/main" xmlns:r="http://schemas.openxmlformats.org/officeDocument/2006/relationships" xmlns:p="http://schemas.openxmlformats.org/presentationml/2006/main">
+  <p:cSld>
+    <p:spTree>
+      <p:nvGrpSpPr>
+        <p:cNvPr id="1" name=""/>
+        <p:cNvGrpSpPr/>
+        <p:nvPr/>
+      </p:nvGrpSpPr>
+      <p:grpSpPr>
+        <a:xfrm>
+          <a:off x="0" y="0"/>
+          <a:ext cx="0" cy="0"/>
+          <a:chOff x="0" y="0"/>
+          <a:chExt cx="0" cy="0"/>
+        </a:xfrm>
+      </p:grpSpPr>
+      <p:sp>
+        <p:nvSpPr>
+          <p:cNvPr id="2" name="Rectangle: Rounded Corners 1">
+            <a:extLst>
+              <a:ext uri="{FF2B5EF4-FFF2-40B4-BE49-F238E27FC236}">
+                <a16:creationId xmlns:a16="http://schemas.microsoft.com/office/drawing/2014/main" id="{E4ADF9A4-DE0B-8F8B-4DF4-46018C8FE330}"/>
+              </a:ext>
+            </a:extLst>
+          </p:cNvPr>
+          <p:cNvSpPr/>
+          <p:nvPr/>
+        </p:nvSpPr>
+        <p:spPr>
+          <a:xfrm>
+            <a:off x="4957151" y="1317577"/>
+            <a:ext cx="2277687" cy="465513"/>
+          </a:xfrm>
+          <a:prstGeom prst="roundRect">
+            <a:avLst/>
+          </a:prstGeom>
+          <a:solidFill>
+            <a:schemeClr val="bg2"/>
+          </a:solidFill>
+          <a:ln>
+            <a:solidFill>
+              <a:schemeClr val="tx1"/>
+            </a:solidFill>
+          </a:ln>
+        </p:spPr>
+        <p:style>
+          <a:lnRef idx="2">
+            <a:schemeClr val="accent1">
+              <a:shade val="15000"/>
+            </a:schemeClr>
+          </a:lnRef>
+          <a:fillRef idx="1">
+            <a:schemeClr val="accent1"/>
+          </a:fillRef>
+          <a:effectRef idx="0">
+            <a:schemeClr val="accent1"/>
+          </a:effectRef>
+          <a:fontRef idx="minor">
+            <a:schemeClr val="lt1"/>
+          </a:fontRef>
+        </p:style>
+        <p:txBody>
+          <a:bodyPr rtlCol="0" anchor="ctr"/>
+          <a:lstStyle/>
+          <a:p>
+            <a:pPr algn="ctr"/>
+            <a:r>
+              <a:rPr lang="en-US" sz="2000">
+                <a:solidFill>
+                  <a:schemeClr val="tx1"/>
+                </a:solidFill>
+                <a:latin typeface="Times New Roman" panose="02020603050405020304" pitchFamily="18" charset="0"/>
+                <a:cs typeface="Times New Roman" panose="02020603050405020304" pitchFamily="18" charset="0"/>
+              </a:rPr>
+              <a:t>Vai trò</a:t>
+            </a:r>
+          </a:p>
+        </p:txBody>
+      </p:sp>
+      <p:sp>
+        <p:nvSpPr>
+          <p:cNvPr id="3" name="Rectangle: Rounded Corners 2">
+            <a:extLst>
+              <a:ext uri="{FF2B5EF4-FFF2-40B4-BE49-F238E27FC236}">
+                <a16:creationId xmlns:a16="http://schemas.microsoft.com/office/drawing/2014/main" id="{8CC44113-62FE-B628-2505-D75FDEFC7AE5}"/>
+              </a:ext>
+            </a:extLst>
+          </p:cNvPr>
+          <p:cNvSpPr/>
+          <p:nvPr/>
+        </p:nvSpPr>
+        <p:spPr>
+          <a:xfrm>
+            <a:off x="4957151" y="1941045"/>
+            <a:ext cx="2277687" cy="465513"/>
+          </a:xfrm>
+          <a:prstGeom prst="roundRect">
+            <a:avLst/>
+          </a:prstGeom>
+          <a:solidFill>
+            <a:schemeClr val="bg2"/>
+          </a:solidFill>
+          <a:ln>
+            <a:solidFill>
+              <a:schemeClr val="tx1"/>
+            </a:solidFill>
+          </a:ln>
+        </p:spPr>
+        <p:style>
+          <a:lnRef idx="2">
+            <a:schemeClr val="accent1">
+              <a:shade val="15000"/>
+            </a:schemeClr>
+          </a:lnRef>
+          <a:fillRef idx="1">
+            <a:schemeClr val="accent1"/>
+          </a:fillRef>
+          <a:effectRef idx="0">
+            <a:schemeClr val="accent1"/>
+          </a:effectRef>
+          <a:fontRef idx="minor">
+            <a:schemeClr val="lt1"/>
+          </a:fontRef>
+        </p:style>
+        <p:txBody>
+          <a:bodyPr rtlCol="0" anchor="ctr"/>
+          <a:lstStyle/>
+          <a:p>
+            <a:pPr algn="ctr"/>
+            <a:r>
+              <a:rPr lang="en-US" sz="2000">
+                <a:solidFill>
+                  <a:schemeClr val="tx1"/>
+                </a:solidFill>
+                <a:latin typeface="Times New Roman" panose="02020603050405020304" pitchFamily="18" charset="0"/>
+                <a:cs typeface="Times New Roman" panose="02020603050405020304" pitchFamily="18" charset="0"/>
+              </a:rPr>
+              <a:t>Bối cảnh</a:t>
+            </a:r>
+          </a:p>
+        </p:txBody>
+      </p:sp>
+      <p:sp>
+        <p:nvSpPr>
+          <p:cNvPr id="4" name="Rectangle: Rounded Corners 3">
+            <a:extLst>
+              <a:ext uri="{FF2B5EF4-FFF2-40B4-BE49-F238E27FC236}">
+                <a16:creationId xmlns:a16="http://schemas.microsoft.com/office/drawing/2014/main" id="{9AF6F156-0943-2C06-9194-54696915F448}"/>
+              </a:ext>
+            </a:extLst>
+          </p:cNvPr>
+          <p:cNvSpPr/>
+          <p:nvPr/>
+        </p:nvSpPr>
+        <p:spPr>
+          <a:xfrm>
+            <a:off x="4957151" y="2564513"/>
+            <a:ext cx="2277687" cy="465513"/>
+          </a:xfrm>
+          <a:prstGeom prst="roundRect">
+            <a:avLst/>
+          </a:prstGeom>
+          <a:solidFill>
+            <a:schemeClr val="bg2"/>
+          </a:solidFill>
+          <a:ln>
+            <a:solidFill>
+              <a:schemeClr val="tx1"/>
+            </a:solidFill>
+          </a:ln>
+        </p:spPr>
+        <p:style>
+          <a:lnRef idx="2">
+            <a:schemeClr val="accent1">
+              <a:shade val="15000"/>
+            </a:schemeClr>
+          </a:lnRef>
+          <a:fillRef idx="1">
+            <a:schemeClr val="accent1"/>
+          </a:fillRef>
+          <a:effectRef idx="0">
+            <a:schemeClr val="accent1"/>
+          </a:effectRef>
+          <a:fontRef idx="minor">
+            <a:schemeClr val="lt1"/>
+          </a:fontRef>
+        </p:style>
+        <p:txBody>
+          <a:bodyPr rtlCol="0" anchor="ctr"/>
+          <a:lstStyle/>
+          <a:p>
+            <a:pPr algn="ctr"/>
+            <a:r>
+              <a:rPr lang="en-US" sz="2000">
+                <a:solidFill>
+                  <a:schemeClr val="tx1"/>
+                </a:solidFill>
+                <a:latin typeface="Times New Roman" panose="02020603050405020304" pitchFamily="18" charset="0"/>
+                <a:cs typeface="Times New Roman" panose="02020603050405020304" pitchFamily="18" charset="0"/>
+              </a:rPr>
+              <a:t>Nhiệm vụ</a:t>
+            </a:r>
+          </a:p>
+        </p:txBody>
+      </p:sp>
+      <p:sp>
+        <p:nvSpPr>
+          <p:cNvPr id="5" name="Rectangle: Rounded Corners 4">
+            <a:extLst>
+              <a:ext uri="{FF2B5EF4-FFF2-40B4-BE49-F238E27FC236}">
+                <a16:creationId xmlns:a16="http://schemas.microsoft.com/office/drawing/2014/main" id="{6AE5A87F-B9A7-AA4E-457F-FA124B5068AB}"/>
+              </a:ext>
+            </a:extLst>
+          </p:cNvPr>
+          <p:cNvSpPr/>
+          <p:nvPr/>
+        </p:nvSpPr>
+        <p:spPr>
+          <a:xfrm>
+            <a:off x="4957151" y="3811341"/>
+            <a:ext cx="2277687" cy="465513"/>
+          </a:xfrm>
+          <a:prstGeom prst="roundRect">
+            <a:avLst/>
+          </a:prstGeom>
+          <a:solidFill>
+            <a:schemeClr val="bg2"/>
+          </a:solidFill>
+          <a:ln>
+            <a:solidFill>
+              <a:schemeClr val="tx1"/>
+            </a:solidFill>
+          </a:ln>
+        </p:spPr>
+        <p:style>
+          <a:lnRef idx="2">
+            <a:schemeClr val="accent1">
+              <a:shade val="15000"/>
+            </a:schemeClr>
+          </a:lnRef>
+          <a:fillRef idx="1">
+            <a:schemeClr val="accent1"/>
+          </a:fillRef>
+          <a:effectRef idx="0">
+            <a:schemeClr val="accent1"/>
+          </a:effectRef>
+          <a:fontRef idx="minor">
+            <a:schemeClr val="lt1"/>
+          </a:fontRef>
+        </p:style>
+        <p:txBody>
+          <a:bodyPr rtlCol="0" anchor="ctr"/>
+          <a:lstStyle/>
+          <a:p>
+            <a:pPr algn="ctr"/>
+            <a:r>
+              <a:rPr lang="en-US" sz="2000">
+                <a:solidFill>
+                  <a:schemeClr val="tx1"/>
+                </a:solidFill>
+                <a:latin typeface="Times New Roman" panose="02020603050405020304" pitchFamily="18" charset="0"/>
+                <a:cs typeface="Times New Roman" panose="02020603050405020304" pitchFamily="18" charset="0"/>
+              </a:rPr>
+              <a:t>Ví dụ 1</a:t>
+            </a:r>
+          </a:p>
+        </p:txBody>
+      </p:sp>
+      <p:sp>
+        <p:nvSpPr>
+          <p:cNvPr id="6" name="Rectangle: Rounded Corners 5">
+            <a:extLst>
+              <a:ext uri="{FF2B5EF4-FFF2-40B4-BE49-F238E27FC236}">
+                <a16:creationId xmlns:a16="http://schemas.microsoft.com/office/drawing/2014/main" id="{F7CCF113-E741-D820-34D8-31288E48EA5F}"/>
+              </a:ext>
+            </a:extLst>
+          </p:cNvPr>
+          <p:cNvSpPr/>
+          <p:nvPr/>
+        </p:nvSpPr>
+        <p:spPr>
+          <a:xfrm>
+            <a:off x="4957151" y="4434809"/>
+            <a:ext cx="2277687" cy="465513"/>
+          </a:xfrm>
+          <a:prstGeom prst="roundRect">
+            <a:avLst/>
+          </a:prstGeom>
+          <a:solidFill>
+            <a:schemeClr val="bg2"/>
+          </a:solidFill>
+          <a:ln>
+            <a:solidFill>
+              <a:schemeClr val="tx1"/>
+            </a:solidFill>
+          </a:ln>
+        </p:spPr>
+        <p:style>
+          <a:lnRef idx="2">
+            <a:schemeClr val="accent1">
+              <a:shade val="15000"/>
+            </a:schemeClr>
+          </a:lnRef>
+          <a:fillRef idx="1">
+            <a:schemeClr val="accent1"/>
+          </a:fillRef>
+          <a:effectRef idx="0">
+            <a:schemeClr val="accent1"/>
+          </a:effectRef>
+          <a:fontRef idx="minor">
+            <a:schemeClr val="lt1"/>
+          </a:fontRef>
+        </p:style>
+        <p:txBody>
+          <a:bodyPr rtlCol="0" anchor="ctr"/>
+          <a:lstStyle/>
+          <a:p>
+            <a:pPr algn="ctr"/>
+            <a:r>
+              <a:rPr lang="en-US" sz="2000">
+                <a:solidFill>
+                  <a:schemeClr val="tx1"/>
+                </a:solidFill>
+                <a:latin typeface="Times New Roman" panose="02020603050405020304" pitchFamily="18" charset="0"/>
+                <a:cs typeface="Times New Roman" panose="02020603050405020304" pitchFamily="18" charset="0"/>
+              </a:rPr>
+              <a:t>Ví dụ …</a:t>
+            </a:r>
+          </a:p>
+        </p:txBody>
+      </p:sp>
+      <p:sp>
+        <p:nvSpPr>
+          <p:cNvPr id="7" name="Rectangle: Rounded Corners 6">
+            <a:extLst>
+              <a:ext uri="{FF2B5EF4-FFF2-40B4-BE49-F238E27FC236}">
+                <a16:creationId xmlns:a16="http://schemas.microsoft.com/office/drawing/2014/main" id="{4BFFF11C-3CBC-D614-936E-224461FB2ACF}"/>
+              </a:ext>
+            </a:extLst>
+          </p:cNvPr>
+          <p:cNvSpPr/>
+          <p:nvPr/>
+        </p:nvSpPr>
+        <p:spPr>
+          <a:xfrm>
+            <a:off x="4957151" y="5058277"/>
+            <a:ext cx="2277687" cy="465513"/>
+          </a:xfrm>
+          <a:prstGeom prst="roundRect">
+            <a:avLst/>
+          </a:prstGeom>
+          <a:solidFill>
+            <a:schemeClr val="bg2"/>
+          </a:solidFill>
+          <a:ln>
+            <a:solidFill>
+              <a:schemeClr val="tx1"/>
+            </a:solidFill>
+          </a:ln>
+        </p:spPr>
+        <p:style>
+          <a:lnRef idx="2">
+            <a:schemeClr val="accent1">
+              <a:shade val="15000"/>
+            </a:schemeClr>
+          </a:lnRef>
+          <a:fillRef idx="1">
+            <a:schemeClr val="accent1"/>
+          </a:fillRef>
+          <a:effectRef idx="0">
+            <a:schemeClr val="accent1"/>
+          </a:effectRef>
+          <a:fontRef idx="minor">
+            <a:schemeClr val="lt1"/>
+          </a:fontRef>
+        </p:style>
+        <p:txBody>
+          <a:bodyPr rtlCol="0" anchor="ctr"/>
+          <a:lstStyle/>
+          <a:p>
+            <a:pPr algn="ctr"/>
+            <a:r>
+              <a:rPr lang="en-US" sz="2000">
+                <a:solidFill>
+                  <a:schemeClr val="tx1"/>
+                </a:solidFill>
+                <a:latin typeface="Times New Roman" panose="02020603050405020304" pitchFamily="18" charset="0"/>
+                <a:cs typeface="Times New Roman" panose="02020603050405020304" pitchFamily="18" charset="0"/>
+              </a:rPr>
+              <a:t>Hướng dẫn</a:t>
+            </a:r>
+          </a:p>
+        </p:txBody>
+      </p:sp>
+      <p:sp>
+        <p:nvSpPr>
+          <p:cNvPr id="8" name="Rectangle: Rounded Corners 7">
+            <a:extLst>
+              <a:ext uri="{FF2B5EF4-FFF2-40B4-BE49-F238E27FC236}">
+                <a16:creationId xmlns:a16="http://schemas.microsoft.com/office/drawing/2014/main" id="{87AE8872-DB4B-0CAC-7DB2-0F81067540C1}"/>
+              </a:ext>
+            </a:extLst>
+          </p:cNvPr>
+          <p:cNvSpPr/>
+          <p:nvPr/>
+        </p:nvSpPr>
+        <p:spPr>
+          <a:xfrm>
+            <a:off x="4957151" y="5681745"/>
+            <a:ext cx="2277687" cy="465513"/>
+          </a:xfrm>
+          <a:prstGeom prst="roundRect">
+            <a:avLst/>
+          </a:prstGeom>
+          <a:solidFill>
+            <a:schemeClr val="bg2"/>
+          </a:solidFill>
+          <a:ln>
+            <a:solidFill>
+              <a:schemeClr val="tx1"/>
+            </a:solidFill>
+          </a:ln>
+        </p:spPr>
+        <p:style>
+          <a:lnRef idx="2">
+            <a:schemeClr val="accent1">
+              <a:shade val="15000"/>
+            </a:schemeClr>
+          </a:lnRef>
+          <a:fillRef idx="1">
+            <a:schemeClr val="accent1"/>
+          </a:fillRef>
+          <a:effectRef idx="0">
+            <a:schemeClr val="accent1"/>
+          </a:effectRef>
+          <a:fontRef idx="minor">
+            <a:schemeClr val="lt1"/>
+          </a:fontRef>
+        </p:style>
+        <p:txBody>
+          <a:bodyPr rtlCol="0" anchor="ctr"/>
+          <a:lstStyle/>
+          <a:p>
+            <a:pPr algn="ctr"/>
+            <a:r>
+              <a:rPr lang="en-US" sz="2000">
+                <a:solidFill>
+                  <a:schemeClr val="tx1"/>
+                </a:solidFill>
+                <a:latin typeface="Times New Roman" panose="02020603050405020304" pitchFamily="18" charset="0"/>
+                <a:cs typeface="Times New Roman" panose="02020603050405020304" pitchFamily="18" charset="0"/>
+              </a:rPr>
+              <a:t>Lưu ý</a:t>
+            </a:r>
+          </a:p>
+        </p:txBody>
+      </p:sp>
+      <p:sp>
+        <p:nvSpPr>
+          <p:cNvPr id="9" name="Rectangle: Rounded Corners 8">
+            <a:extLst>
+              <a:ext uri="{FF2B5EF4-FFF2-40B4-BE49-F238E27FC236}">
+                <a16:creationId xmlns:a16="http://schemas.microsoft.com/office/drawing/2014/main" id="{C97A42C2-BBE0-F9E1-48F5-620BDEE672F5}"/>
+              </a:ext>
+            </a:extLst>
+          </p:cNvPr>
+          <p:cNvSpPr/>
+          <p:nvPr/>
+        </p:nvSpPr>
+        <p:spPr>
+          <a:xfrm>
+            <a:off x="3535675" y="536181"/>
+            <a:ext cx="5120640" cy="6001790"/>
+          </a:xfrm>
+          <a:prstGeom prst="roundRect">
+            <a:avLst/>
+          </a:prstGeom>
+          <a:noFill/>
+          <a:ln>
+            <a:solidFill>
+              <a:srgbClr val="FF0000"/>
+            </a:solidFill>
+            <a:prstDash val="dash"/>
+          </a:ln>
+        </p:spPr>
+        <p:style>
+          <a:lnRef idx="2">
+            <a:schemeClr val="accent1">
+              <a:shade val="15000"/>
+            </a:schemeClr>
+          </a:lnRef>
+          <a:fillRef idx="1">
+            <a:schemeClr val="accent1"/>
+          </a:fillRef>
+          <a:effectRef idx="0">
+            <a:schemeClr val="accent1"/>
+          </a:effectRef>
+          <a:fontRef idx="minor">
+            <a:schemeClr val="lt1"/>
+          </a:fontRef>
+        </p:style>
+        <p:txBody>
+          <a:bodyPr rtlCol="0" anchor="ctr"/>
+          <a:lstStyle/>
+          <a:p>
+            <a:pPr algn="ctr"/>
+            <a:endParaRPr lang="en-US" sz="2000">
+              <a:latin typeface="Times New Roman" panose="02020603050405020304" pitchFamily="18" charset="0"/>
+              <a:cs typeface="Times New Roman" panose="02020603050405020304" pitchFamily="18" charset="0"/>
+            </a:endParaRPr>
+          </a:p>
+        </p:txBody>
+      </p:sp>
+      <p:sp>
+        <p:nvSpPr>
+          <p:cNvPr id="10" name="Rectangle: Rounded Corners 9">
+            <a:extLst>
+              <a:ext uri="{FF2B5EF4-FFF2-40B4-BE49-F238E27FC236}">
+                <a16:creationId xmlns:a16="http://schemas.microsoft.com/office/drawing/2014/main" id="{E2031F3D-9150-2123-189F-AF63D3578697}"/>
+              </a:ext>
+            </a:extLst>
+          </p:cNvPr>
+          <p:cNvSpPr/>
+          <p:nvPr/>
+        </p:nvSpPr>
+        <p:spPr>
+          <a:xfrm>
+            <a:off x="4574766" y="145469"/>
+            <a:ext cx="3042458" cy="781396"/>
+          </a:xfrm>
+          <a:prstGeom prst="roundRect">
+            <a:avLst/>
+          </a:prstGeom>
+          <a:solidFill>
+            <a:srgbClr val="FFFFFF"/>
+          </a:solidFill>
+          <a:ln>
+            <a:solidFill>
+              <a:srgbClr val="FF0000"/>
+            </a:solidFill>
+          </a:ln>
+        </p:spPr>
+        <p:style>
+          <a:lnRef idx="2">
+            <a:schemeClr val="accent1">
+              <a:shade val="15000"/>
+            </a:schemeClr>
+          </a:lnRef>
+          <a:fillRef idx="1">
+            <a:schemeClr val="accent1"/>
+          </a:fillRef>
+          <a:effectRef idx="0">
+            <a:schemeClr val="accent1"/>
+          </a:effectRef>
+          <a:fontRef idx="minor">
+            <a:schemeClr val="lt1"/>
+          </a:fontRef>
+        </p:style>
+        <p:txBody>
+          <a:bodyPr rtlCol="0" anchor="ctr"/>
+          <a:lstStyle/>
+          <a:p>
+            <a:pPr algn="ctr"/>
+            <a:r>
+              <a:rPr lang="en-US" sz="2000">
+                <a:ln w="0">
+                  <a:solidFill>
+                    <a:schemeClr val="tx1"/>
+                  </a:solidFill>
+                </a:ln>
+                <a:solidFill>
+                  <a:schemeClr val="tx1"/>
+                </a:solidFill>
+                <a:latin typeface="Times New Roman" panose="02020603050405020304" pitchFamily="18" charset="0"/>
+                <a:cs typeface="Times New Roman" panose="02020603050405020304" pitchFamily="18" charset="0"/>
+              </a:rPr>
+              <a:t>Prompt cho tác vụ</a:t>
+            </a:r>
+          </a:p>
+          <a:p>
+            <a:pPr algn="ctr"/>
+            <a:r>
+              <a:rPr lang="en-US" sz="2000">
+                <a:ln w="0">
+                  <a:solidFill>
+                    <a:schemeClr val="tx1"/>
+                  </a:solidFill>
+                </a:ln>
+                <a:solidFill>
+                  <a:schemeClr val="tx1"/>
+                </a:solidFill>
+                <a:latin typeface="Times New Roman" panose="02020603050405020304" pitchFamily="18" charset="0"/>
+                <a:cs typeface="Times New Roman" panose="02020603050405020304" pitchFamily="18" charset="0"/>
+              </a:rPr>
+              <a:t>trích xuất thông tin</a:t>
+            </a:r>
+          </a:p>
+        </p:txBody>
+      </p:sp>
+      <p:sp>
+        <p:nvSpPr>
+          <p:cNvPr id="11" name="Rectangle: Rounded Corners 10">
+            <a:extLst>
+              <a:ext uri="{FF2B5EF4-FFF2-40B4-BE49-F238E27FC236}">
+                <a16:creationId xmlns:a16="http://schemas.microsoft.com/office/drawing/2014/main" id="{1CB039DE-91EA-0092-CC10-04B3DF401AD0}"/>
+              </a:ext>
+            </a:extLst>
+          </p:cNvPr>
+          <p:cNvSpPr/>
+          <p:nvPr/>
+        </p:nvSpPr>
+        <p:spPr>
+          <a:xfrm>
+            <a:off x="4957151" y="3187927"/>
+            <a:ext cx="2277687" cy="465513"/>
+          </a:xfrm>
+          <a:prstGeom prst="roundRect">
+            <a:avLst/>
+          </a:prstGeom>
+          <a:solidFill>
+            <a:schemeClr val="bg2"/>
+          </a:solidFill>
+          <a:ln>
+            <a:solidFill>
+              <a:schemeClr val="tx1"/>
+            </a:solidFill>
+          </a:ln>
+        </p:spPr>
+        <p:style>
+          <a:lnRef idx="2">
+            <a:schemeClr val="accent1">
+              <a:shade val="15000"/>
+            </a:schemeClr>
+          </a:lnRef>
+          <a:fillRef idx="1">
+            <a:schemeClr val="accent1"/>
+          </a:fillRef>
+          <a:effectRef idx="0">
+            <a:schemeClr val="accent1"/>
+          </a:effectRef>
+          <a:fontRef idx="minor">
+            <a:schemeClr val="lt1"/>
+          </a:fontRef>
+        </p:style>
+        <p:txBody>
+          <a:bodyPr rtlCol="0" anchor="ctr"/>
+          <a:lstStyle/>
+          <a:p>
+            <a:pPr algn="ctr"/>
+            <a:r>
+              <a:rPr lang="en-US" sz="2000">
+                <a:solidFill>
+                  <a:schemeClr val="tx1"/>
+                </a:solidFill>
+                <a:latin typeface="Times New Roman" panose="02020603050405020304" pitchFamily="18" charset="0"/>
+                <a:cs typeface="Times New Roman" panose="02020603050405020304" pitchFamily="18" charset="0"/>
+              </a:rPr>
+              <a:t>Đầu ra có cấu trúc</a:t>
+            </a:r>
+          </a:p>
+        </p:txBody>
+      </p:sp>
+    </p:spTree>
+    <p:extLst>
+      <p:ext uri="{BB962C8B-B14F-4D97-AF65-F5344CB8AC3E}">
+        <p14:creationId xmlns:p14="http://schemas.microsoft.com/office/powerpoint/2010/main" val="2705721519"/>
+      </p:ext>
+    </p:extLst>
+  </p:cSld>
+  <p:clrMapOvr>
+    <a:masterClrMapping/>
+  </p:clrMapOvr>
+</p:sld>
+</file>
+
+<file path=ppt/slides/slide34.xml><?xml version="1.0" encoding="utf-8"?>
+<p:sld xmlns:a="http://schemas.openxmlformats.org/drawingml/2006/main" xmlns:r="http://schemas.openxmlformats.org/officeDocument/2006/relationships" xmlns:p="http://schemas.openxmlformats.org/presentationml/2006/main">
+  <p:cSld>
+    <p:spTree>
+      <p:nvGrpSpPr>
+        <p:cNvPr id="1" name=""/>
+        <p:cNvGrpSpPr/>
+        <p:nvPr/>
+      </p:nvGrpSpPr>
+      <p:grpSpPr>
+        <a:xfrm>
+          <a:off x="0" y="0"/>
+          <a:ext cx="0" cy="0"/>
+          <a:chOff x="0" y="0"/>
+          <a:chExt cx="0" cy="0"/>
+        </a:xfrm>
+      </p:grpSpPr>
+      <p:sp>
+        <p:nvSpPr>
+          <p:cNvPr id="3" name="Rectangle: Rounded Corners 2">
+            <a:extLst>
+              <a:ext uri="{FF2B5EF4-FFF2-40B4-BE49-F238E27FC236}">
+                <a16:creationId xmlns:a16="http://schemas.microsoft.com/office/drawing/2014/main" id="{048EB605-C214-F543-6B11-029AC50FDEBD}"/>
+              </a:ext>
+            </a:extLst>
+          </p:cNvPr>
+          <p:cNvSpPr/>
+          <p:nvPr/>
+        </p:nvSpPr>
+        <p:spPr>
+          <a:xfrm>
+            <a:off x="4957153" y="1404850"/>
+            <a:ext cx="2277687" cy="465513"/>
+          </a:xfrm>
+          <a:prstGeom prst="roundRect">
+            <a:avLst/>
+          </a:prstGeom>
+          <a:solidFill>
+            <a:schemeClr val="bg2"/>
+          </a:solidFill>
+          <a:ln>
+            <a:solidFill>
+              <a:schemeClr val="tx1"/>
+            </a:solidFill>
+          </a:ln>
+        </p:spPr>
+        <p:style>
+          <a:lnRef idx="2">
+            <a:schemeClr val="accent1">
+              <a:shade val="15000"/>
+            </a:schemeClr>
+          </a:lnRef>
+          <a:fillRef idx="1">
+            <a:schemeClr val="accent1"/>
+          </a:fillRef>
+          <a:effectRef idx="0">
+            <a:schemeClr val="accent1"/>
+          </a:effectRef>
+          <a:fontRef idx="minor">
+            <a:schemeClr val="lt1"/>
+          </a:fontRef>
+        </p:style>
+        <p:txBody>
+          <a:bodyPr rtlCol="0" anchor="ctr"/>
+          <a:lstStyle/>
+          <a:p>
+            <a:pPr algn="ctr"/>
+            <a:r>
+              <a:rPr lang="en-US" sz="2000">
+                <a:solidFill>
+                  <a:schemeClr val="tx1"/>
+                </a:solidFill>
+                <a:latin typeface="Times New Roman" panose="02020603050405020304" pitchFamily="18" charset="0"/>
+                <a:cs typeface="Times New Roman" panose="02020603050405020304" pitchFamily="18" charset="0"/>
+              </a:rPr>
+              <a:t>Vai trò</a:t>
+            </a:r>
+          </a:p>
+        </p:txBody>
+      </p:sp>
+      <p:sp>
+        <p:nvSpPr>
+          <p:cNvPr id="4" name="Rectangle: Rounded Corners 3">
+            <a:extLst>
+              <a:ext uri="{FF2B5EF4-FFF2-40B4-BE49-F238E27FC236}">
+                <a16:creationId xmlns:a16="http://schemas.microsoft.com/office/drawing/2014/main" id="{54BC9C70-A4ED-0B89-64FD-D4C0E2B71AA4}"/>
+              </a:ext>
+            </a:extLst>
+          </p:cNvPr>
+          <p:cNvSpPr/>
+          <p:nvPr/>
+        </p:nvSpPr>
+        <p:spPr>
+          <a:xfrm>
+            <a:off x="4957153" y="2115592"/>
+            <a:ext cx="2277687" cy="465513"/>
+          </a:xfrm>
+          <a:prstGeom prst="roundRect">
+            <a:avLst/>
+          </a:prstGeom>
+          <a:solidFill>
+            <a:schemeClr val="bg2"/>
+          </a:solidFill>
+          <a:ln>
+            <a:solidFill>
+              <a:schemeClr val="tx1"/>
+            </a:solidFill>
+          </a:ln>
+        </p:spPr>
+        <p:style>
+          <a:lnRef idx="2">
+            <a:schemeClr val="accent1">
+              <a:shade val="15000"/>
+            </a:schemeClr>
+          </a:lnRef>
+          <a:fillRef idx="1">
+            <a:schemeClr val="accent1"/>
+          </a:fillRef>
+          <a:effectRef idx="0">
+            <a:schemeClr val="accent1"/>
+          </a:effectRef>
+          <a:fontRef idx="minor">
+            <a:schemeClr val="lt1"/>
+          </a:fontRef>
+        </p:style>
+        <p:txBody>
+          <a:bodyPr rtlCol="0" anchor="ctr"/>
+          <a:lstStyle/>
+          <a:p>
+            <a:pPr algn="ctr"/>
+            <a:r>
+              <a:rPr lang="en-US" sz="2000">
+                <a:solidFill>
+                  <a:schemeClr val="tx1"/>
+                </a:solidFill>
+                <a:latin typeface="Times New Roman" panose="02020603050405020304" pitchFamily="18" charset="0"/>
+                <a:cs typeface="Times New Roman" panose="02020603050405020304" pitchFamily="18" charset="0"/>
+              </a:rPr>
+              <a:t>Bối cảnh</a:t>
+            </a:r>
+          </a:p>
+        </p:txBody>
+      </p:sp>
+      <p:sp>
+        <p:nvSpPr>
+          <p:cNvPr id="5" name="Rectangle: Rounded Corners 4">
+            <a:extLst>
+              <a:ext uri="{FF2B5EF4-FFF2-40B4-BE49-F238E27FC236}">
+                <a16:creationId xmlns:a16="http://schemas.microsoft.com/office/drawing/2014/main" id="{ABB99AF4-2C14-05D1-265A-F78135C3126E}"/>
+              </a:ext>
+            </a:extLst>
+          </p:cNvPr>
+          <p:cNvSpPr/>
+          <p:nvPr/>
+        </p:nvSpPr>
+        <p:spPr>
+          <a:xfrm>
+            <a:off x="4957153" y="2826334"/>
+            <a:ext cx="2277687" cy="465513"/>
+          </a:xfrm>
+          <a:prstGeom prst="roundRect">
+            <a:avLst/>
+          </a:prstGeom>
+          <a:solidFill>
+            <a:schemeClr val="bg2"/>
+          </a:solidFill>
+          <a:ln>
+            <a:solidFill>
+              <a:schemeClr val="tx1"/>
+            </a:solidFill>
+          </a:ln>
+        </p:spPr>
+        <p:style>
+          <a:lnRef idx="2">
+            <a:schemeClr val="accent1">
+              <a:shade val="15000"/>
+            </a:schemeClr>
+          </a:lnRef>
+          <a:fillRef idx="1">
+            <a:schemeClr val="accent1"/>
+          </a:fillRef>
+          <a:effectRef idx="0">
+            <a:schemeClr val="accent1"/>
+          </a:effectRef>
+          <a:fontRef idx="minor">
+            <a:schemeClr val="lt1"/>
+          </a:fontRef>
+        </p:style>
+        <p:txBody>
+          <a:bodyPr rtlCol="0" anchor="ctr"/>
+          <a:lstStyle/>
+          <a:p>
+            <a:pPr algn="ctr"/>
+            <a:r>
+              <a:rPr lang="en-US" sz="2000">
+                <a:solidFill>
+                  <a:schemeClr val="tx1"/>
+                </a:solidFill>
+                <a:latin typeface="Times New Roman" panose="02020603050405020304" pitchFamily="18" charset="0"/>
+                <a:cs typeface="Times New Roman" panose="02020603050405020304" pitchFamily="18" charset="0"/>
+              </a:rPr>
+              <a:t>Câu hỏi</a:t>
+            </a:r>
+          </a:p>
+        </p:txBody>
+      </p:sp>
+      <p:sp>
+        <p:nvSpPr>
+          <p:cNvPr id="6" name="Rectangle: Rounded Corners 5">
+            <a:extLst>
+              <a:ext uri="{FF2B5EF4-FFF2-40B4-BE49-F238E27FC236}">
+                <a16:creationId xmlns:a16="http://schemas.microsoft.com/office/drawing/2014/main" id="{15D95F07-863A-45BC-041C-86202B8CE299}"/>
+              </a:ext>
+            </a:extLst>
+          </p:cNvPr>
+          <p:cNvSpPr/>
+          <p:nvPr/>
+        </p:nvSpPr>
+        <p:spPr>
+          <a:xfrm>
+            <a:off x="4957152" y="3537076"/>
+            <a:ext cx="2277687" cy="465513"/>
+          </a:xfrm>
+          <a:prstGeom prst="roundRect">
+            <a:avLst/>
+          </a:prstGeom>
+          <a:solidFill>
+            <a:schemeClr val="bg2"/>
+          </a:solidFill>
+          <a:ln>
+            <a:solidFill>
+              <a:schemeClr val="tx1"/>
+            </a:solidFill>
+          </a:ln>
+        </p:spPr>
+        <p:style>
+          <a:lnRef idx="2">
+            <a:schemeClr val="accent1">
+              <a:shade val="15000"/>
+            </a:schemeClr>
+          </a:lnRef>
+          <a:fillRef idx="1">
+            <a:schemeClr val="accent1"/>
+          </a:fillRef>
+          <a:effectRef idx="0">
+            <a:schemeClr val="accent1"/>
+          </a:effectRef>
+          <a:fontRef idx="minor">
+            <a:schemeClr val="lt1"/>
+          </a:fontRef>
+        </p:style>
+        <p:txBody>
+          <a:bodyPr rtlCol="0" anchor="ctr"/>
+          <a:lstStyle/>
+          <a:p>
+            <a:pPr algn="ctr"/>
+            <a:r>
+              <a:rPr lang="en-US" sz="2000">
+                <a:solidFill>
+                  <a:schemeClr val="tx1"/>
+                </a:solidFill>
+                <a:latin typeface="Times New Roman" panose="02020603050405020304" pitchFamily="18" charset="0"/>
+                <a:cs typeface="Times New Roman" panose="02020603050405020304" pitchFamily="18" charset="0"/>
+              </a:rPr>
+              <a:t>Ví dụ 1</a:t>
+            </a:r>
+          </a:p>
+        </p:txBody>
+      </p:sp>
+      <p:sp>
+        <p:nvSpPr>
+          <p:cNvPr id="7" name="Rectangle: Rounded Corners 6">
+            <a:extLst>
+              <a:ext uri="{FF2B5EF4-FFF2-40B4-BE49-F238E27FC236}">
+                <a16:creationId xmlns:a16="http://schemas.microsoft.com/office/drawing/2014/main" id="{A7B5ECB3-AC0A-79C1-04C3-54D8536F115C}"/>
+              </a:ext>
+            </a:extLst>
+          </p:cNvPr>
+          <p:cNvSpPr/>
+          <p:nvPr/>
+        </p:nvSpPr>
+        <p:spPr>
+          <a:xfrm>
+            <a:off x="4957152" y="4247818"/>
+            <a:ext cx="2277687" cy="465513"/>
+          </a:xfrm>
+          <a:prstGeom prst="roundRect">
+            <a:avLst/>
+          </a:prstGeom>
+          <a:solidFill>
+            <a:schemeClr val="bg2"/>
+          </a:solidFill>
+          <a:ln>
+            <a:solidFill>
+              <a:schemeClr val="tx1"/>
+            </a:solidFill>
+          </a:ln>
+        </p:spPr>
+        <p:style>
+          <a:lnRef idx="2">
+            <a:schemeClr val="accent1">
+              <a:shade val="15000"/>
+            </a:schemeClr>
+          </a:lnRef>
+          <a:fillRef idx="1">
+            <a:schemeClr val="accent1"/>
+          </a:fillRef>
+          <a:effectRef idx="0">
+            <a:schemeClr val="accent1"/>
+          </a:effectRef>
+          <a:fontRef idx="minor">
+            <a:schemeClr val="lt1"/>
+          </a:fontRef>
+        </p:style>
+        <p:txBody>
+          <a:bodyPr rtlCol="0" anchor="ctr"/>
+          <a:lstStyle/>
+          <a:p>
+            <a:pPr algn="ctr"/>
+            <a:r>
+              <a:rPr lang="en-US" sz="2000">
+                <a:solidFill>
+                  <a:schemeClr val="tx1"/>
+                </a:solidFill>
+                <a:latin typeface="Times New Roman" panose="02020603050405020304" pitchFamily="18" charset="0"/>
+                <a:cs typeface="Times New Roman" panose="02020603050405020304" pitchFamily="18" charset="0"/>
+              </a:rPr>
+              <a:t>Ví dụ …</a:t>
+            </a:r>
+          </a:p>
+        </p:txBody>
+      </p:sp>
+      <p:sp>
+        <p:nvSpPr>
+          <p:cNvPr id="8" name="Rectangle: Rounded Corners 7">
+            <a:extLst>
+              <a:ext uri="{FF2B5EF4-FFF2-40B4-BE49-F238E27FC236}">
+                <a16:creationId xmlns:a16="http://schemas.microsoft.com/office/drawing/2014/main" id="{EA8C18FB-766B-5769-7A4B-4DE68340C0A0}"/>
+              </a:ext>
+            </a:extLst>
+          </p:cNvPr>
+          <p:cNvSpPr/>
+          <p:nvPr/>
+        </p:nvSpPr>
+        <p:spPr>
+          <a:xfrm>
+            <a:off x="4957152" y="4958560"/>
+            <a:ext cx="2277687" cy="465513"/>
+          </a:xfrm>
+          <a:prstGeom prst="roundRect">
+            <a:avLst/>
+          </a:prstGeom>
+          <a:solidFill>
+            <a:schemeClr val="bg2"/>
+          </a:solidFill>
+          <a:ln>
+            <a:solidFill>
+              <a:schemeClr val="tx1"/>
+            </a:solidFill>
+          </a:ln>
+        </p:spPr>
+        <p:style>
+          <a:lnRef idx="2">
+            <a:schemeClr val="accent1">
+              <a:shade val="15000"/>
+            </a:schemeClr>
+          </a:lnRef>
+          <a:fillRef idx="1">
+            <a:schemeClr val="accent1"/>
+          </a:fillRef>
+          <a:effectRef idx="0">
+            <a:schemeClr val="accent1"/>
+          </a:effectRef>
+          <a:fontRef idx="minor">
+            <a:schemeClr val="lt1"/>
+          </a:fontRef>
+        </p:style>
+        <p:txBody>
+          <a:bodyPr rtlCol="0" anchor="ctr"/>
+          <a:lstStyle/>
+          <a:p>
+            <a:pPr algn="ctr"/>
+            <a:r>
+              <a:rPr lang="en-US" sz="2000">
+                <a:solidFill>
+                  <a:schemeClr val="tx1"/>
+                </a:solidFill>
+                <a:latin typeface="Times New Roman" panose="02020603050405020304" pitchFamily="18" charset="0"/>
+                <a:cs typeface="Times New Roman" panose="02020603050405020304" pitchFamily="18" charset="0"/>
+              </a:rPr>
+              <a:t>Hướng dẫn</a:t>
+            </a:r>
+          </a:p>
+        </p:txBody>
+      </p:sp>
+      <p:sp>
+        <p:nvSpPr>
+          <p:cNvPr id="9" name="Rectangle: Rounded Corners 8">
+            <a:extLst>
+              <a:ext uri="{FF2B5EF4-FFF2-40B4-BE49-F238E27FC236}">
+                <a16:creationId xmlns:a16="http://schemas.microsoft.com/office/drawing/2014/main" id="{E2667497-E73D-C9B7-735A-15EA3A038FC9}"/>
+              </a:ext>
+            </a:extLst>
+          </p:cNvPr>
+          <p:cNvSpPr/>
+          <p:nvPr/>
+        </p:nvSpPr>
+        <p:spPr>
+          <a:xfrm>
+            <a:off x="4957152" y="5669302"/>
+            <a:ext cx="2277687" cy="465513"/>
+          </a:xfrm>
+          <a:prstGeom prst="roundRect">
+            <a:avLst/>
+          </a:prstGeom>
+          <a:solidFill>
+            <a:schemeClr val="bg2"/>
+          </a:solidFill>
+          <a:ln>
+            <a:solidFill>
+              <a:schemeClr val="tx1"/>
+            </a:solidFill>
+          </a:ln>
+        </p:spPr>
+        <p:style>
+          <a:lnRef idx="2">
+            <a:schemeClr val="accent1">
+              <a:shade val="15000"/>
+            </a:schemeClr>
+          </a:lnRef>
+          <a:fillRef idx="1">
+            <a:schemeClr val="accent1"/>
+          </a:fillRef>
+          <a:effectRef idx="0">
+            <a:schemeClr val="accent1"/>
+          </a:effectRef>
+          <a:fontRef idx="minor">
+            <a:schemeClr val="lt1"/>
+          </a:fontRef>
+        </p:style>
+        <p:txBody>
+          <a:bodyPr rtlCol="0" anchor="ctr"/>
+          <a:lstStyle/>
+          <a:p>
+            <a:pPr algn="ctr"/>
+            <a:r>
+              <a:rPr lang="en-US" sz="2000">
+                <a:solidFill>
+                  <a:schemeClr val="tx1"/>
+                </a:solidFill>
+                <a:latin typeface="Times New Roman" panose="02020603050405020304" pitchFamily="18" charset="0"/>
+                <a:cs typeface="Times New Roman" panose="02020603050405020304" pitchFamily="18" charset="0"/>
+              </a:rPr>
+              <a:t>Lưu ý</a:t>
+            </a:r>
+          </a:p>
+        </p:txBody>
+      </p:sp>
+      <p:sp>
+        <p:nvSpPr>
+          <p:cNvPr id="12" name="Rectangle: Rounded Corners 11">
+            <a:extLst>
+              <a:ext uri="{FF2B5EF4-FFF2-40B4-BE49-F238E27FC236}">
+                <a16:creationId xmlns:a16="http://schemas.microsoft.com/office/drawing/2014/main" id="{31359D66-3D89-0106-62D7-169807288848}"/>
+              </a:ext>
+            </a:extLst>
+          </p:cNvPr>
+          <p:cNvSpPr/>
+          <p:nvPr/>
+        </p:nvSpPr>
+        <p:spPr>
+          <a:xfrm>
+            <a:off x="3535675" y="536181"/>
+            <a:ext cx="5120640" cy="6001790"/>
+          </a:xfrm>
+          <a:prstGeom prst="roundRect">
+            <a:avLst/>
+          </a:prstGeom>
+          <a:noFill/>
+          <a:ln>
+            <a:solidFill>
+              <a:srgbClr val="FF0000"/>
+            </a:solidFill>
+            <a:prstDash val="dash"/>
+          </a:ln>
+        </p:spPr>
+        <p:style>
+          <a:lnRef idx="2">
+            <a:schemeClr val="accent1">
+              <a:shade val="15000"/>
+            </a:schemeClr>
+          </a:lnRef>
+          <a:fillRef idx="1">
+            <a:schemeClr val="accent1"/>
+          </a:fillRef>
+          <a:effectRef idx="0">
+            <a:schemeClr val="accent1"/>
+          </a:effectRef>
+          <a:fontRef idx="minor">
+            <a:schemeClr val="lt1"/>
+          </a:fontRef>
+        </p:style>
+        <p:txBody>
+          <a:bodyPr rtlCol="0" anchor="ctr"/>
+          <a:lstStyle/>
+          <a:p>
+            <a:pPr algn="ctr"/>
+            <a:endParaRPr lang="en-US" sz="2000">
+              <a:latin typeface="Times New Roman" panose="02020603050405020304" pitchFamily="18" charset="0"/>
+              <a:cs typeface="Times New Roman" panose="02020603050405020304" pitchFamily="18" charset="0"/>
+            </a:endParaRPr>
+          </a:p>
+        </p:txBody>
+      </p:sp>
+      <p:sp>
+        <p:nvSpPr>
+          <p:cNvPr id="2" name="Rectangle: Rounded Corners 1">
+            <a:extLst>
+              <a:ext uri="{FF2B5EF4-FFF2-40B4-BE49-F238E27FC236}">
+                <a16:creationId xmlns:a16="http://schemas.microsoft.com/office/drawing/2014/main" id="{68358D49-BEFB-0F3C-74B3-68D07EFC7EF5}"/>
+              </a:ext>
+            </a:extLst>
+          </p:cNvPr>
+          <p:cNvSpPr/>
+          <p:nvPr/>
+        </p:nvSpPr>
+        <p:spPr>
+          <a:xfrm>
+            <a:off x="4574766" y="145469"/>
+            <a:ext cx="3042458" cy="781396"/>
+          </a:xfrm>
+          <a:prstGeom prst="roundRect">
+            <a:avLst/>
+          </a:prstGeom>
+          <a:solidFill>
+            <a:srgbClr val="FFFFFF"/>
+          </a:solidFill>
+          <a:ln>
+            <a:solidFill>
+              <a:srgbClr val="FF0000"/>
+            </a:solidFill>
+          </a:ln>
+        </p:spPr>
+        <p:style>
+          <a:lnRef idx="2">
+            <a:schemeClr val="accent1">
+              <a:shade val="15000"/>
+            </a:schemeClr>
+          </a:lnRef>
+          <a:fillRef idx="1">
+            <a:schemeClr val="accent1"/>
+          </a:fillRef>
+          <a:effectRef idx="0">
+            <a:schemeClr val="accent1"/>
+          </a:effectRef>
+          <a:fontRef idx="minor">
+            <a:schemeClr val="lt1"/>
+          </a:fontRef>
+        </p:style>
+        <p:txBody>
+          <a:bodyPr rtlCol="0" anchor="ctr"/>
+          <a:lstStyle/>
+          <a:p>
+            <a:pPr algn="ctr"/>
+            <a:r>
+              <a:rPr lang="en-US" sz="2000">
+                <a:ln w="0">
+                  <a:solidFill>
+                    <a:schemeClr val="tx1"/>
+                  </a:solidFill>
+                </a:ln>
+                <a:solidFill>
+                  <a:schemeClr val="tx1"/>
+                </a:solidFill>
+                <a:latin typeface="Times New Roman" panose="02020603050405020304" pitchFamily="18" charset="0"/>
+                <a:cs typeface="Times New Roman" panose="02020603050405020304" pitchFamily="18" charset="0"/>
+              </a:rPr>
+              <a:t>Prompt cho chức năng</a:t>
+            </a:r>
+          </a:p>
+          <a:p>
+            <a:pPr algn="ctr"/>
+            <a:r>
+              <a:rPr lang="en-US" sz="2000">
+                <a:ln w="0">
+                  <a:solidFill>
+                    <a:schemeClr val="tx1"/>
+                  </a:solidFill>
+                </a:ln>
+                <a:solidFill>
+                  <a:schemeClr val="tx1"/>
+                </a:solidFill>
+                <a:latin typeface="Times New Roman" panose="02020603050405020304" pitchFamily="18" charset="0"/>
+                <a:cs typeface="Times New Roman" panose="02020603050405020304" pitchFamily="18" charset="0"/>
+              </a:rPr>
+              <a:t>trò chuyện với người dùng</a:t>
+            </a:r>
+          </a:p>
+        </p:txBody>
+      </p:sp>
+    </p:spTree>
+    <p:extLst>
+      <p:ext uri="{BB962C8B-B14F-4D97-AF65-F5344CB8AC3E}">
+        <p14:creationId xmlns:p14="http://schemas.microsoft.com/office/powerpoint/2010/main" val="2964644478"/>
+      </p:ext>
+    </p:extLst>
+  </p:cSld>
+  <p:clrMapOvr>
+    <a:masterClrMapping/>
+  </p:clrMapOvr>
+</p:sld>
+</file>
+
+<file path=ppt/slides/slide35.xml><?xml version="1.0" encoding="utf-8"?>
+<p:sld xmlns:a="http://schemas.openxmlformats.org/drawingml/2006/main" xmlns:r="http://schemas.openxmlformats.org/officeDocument/2006/relationships" xmlns:p="http://schemas.openxmlformats.org/presentationml/2006/main">
+  <p:cSld>
+    <p:spTree>
+      <p:nvGrpSpPr>
+        <p:cNvPr id="1" name=""/>
+        <p:cNvGrpSpPr/>
+        <p:nvPr/>
+      </p:nvGrpSpPr>
+      <p:grpSpPr>
+        <a:xfrm>
+          <a:off x="0" y="0"/>
+          <a:ext cx="0" cy="0"/>
+          <a:chOff x="0" y="0"/>
+          <a:chExt cx="0" cy="0"/>
+        </a:xfrm>
+      </p:grpSpPr>
+      <p:sp>
+        <p:nvSpPr>
+          <p:cNvPr id="2" name="Rectangle: Rounded Corners 1">
+            <a:extLst>
+              <a:ext uri="{FF2B5EF4-FFF2-40B4-BE49-F238E27FC236}">
+                <a16:creationId xmlns:a16="http://schemas.microsoft.com/office/drawing/2014/main" id="{AB2F63C9-07C9-28F7-CACF-8CC92E29BBF1}"/>
+              </a:ext>
+            </a:extLst>
+          </p:cNvPr>
+          <p:cNvSpPr/>
+          <p:nvPr/>
+        </p:nvSpPr>
+        <p:spPr>
+          <a:xfrm>
+            <a:off x="4957151" y="1317577"/>
+            <a:ext cx="2277687" cy="465513"/>
+          </a:xfrm>
+          <a:prstGeom prst="roundRect">
+            <a:avLst/>
+          </a:prstGeom>
+          <a:solidFill>
+            <a:schemeClr val="bg2"/>
+          </a:solidFill>
+          <a:ln>
+            <a:solidFill>
+              <a:schemeClr val="tx1"/>
+            </a:solidFill>
+          </a:ln>
+        </p:spPr>
+        <p:style>
+          <a:lnRef idx="2">
+            <a:schemeClr val="accent1">
+              <a:shade val="15000"/>
+            </a:schemeClr>
+          </a:lnRef>
+          <a:fillRef idx="1">
+            <a:schemeClr val="accent1"/>
+          </a:fillRef>
+          <a:effectRef idx="0">
+            <a:schemeClr val="accent1"/>
+          </a:effectRef>
+          <a:fontRef idx="minor">
+            <a:schemeClr val="lt1"/>
+          </a:fontRef>
+        </p:style>
+        <p:txBody>
+          <a:bodyPr rtlCol="0" anchor="ctr"/>
+          <a:lstStyle/>
+          <a:p>
+            <a:pPr algn="ctr"/>
+            <a:r>
+              <a:rPr lang="en-US" sz="2000">
+                <a:solidFill>
+                  <a:schemeClr val="tx1"/>
+                </a:solidFill>
+                <a:latin typeface="Times New Roman" panose="02020603050405020304" pitchFamily="18" charset="0"/>
+                <a:cs typeface="Times New Roman" panose="02020603050405020304" pitchFamily="18" charset="0"/>
+              </a:rPr>
+              <a:t>Vai trò</a:t>
+            </a:r>
+          </a:p>
+        </p:txBody>
+      </p:sp>
+      <p:sp>
+        <p:nvSpPr>
+          <p:cNvPr id="3" name="Rectangle: Rounded Corners 2">
+            <a:extLst>
+              <a:ext uri="{FF2B5EF4-FFF2-40B4-BE49-F238E27FC236}">
+                <a16:creationId xmlns:a16="http://schemas.microsoft.com/office/drawing/2014/main" id="{A9748CE9-C615-3005-D1A7-04AD7FAC795C}"/>
+              </a:ext>
+            </a:extLst>
+          </p:cNvPr>
+          <p:cNvSpPr/>
+          <p:nvPr/>
+        </p:nvSpPr>
+        <p:spPr>
+          <a:xfrm>
+            <a:off x="4957151" y="1941045"/>
+            <a:ext cx="2277687" cy="465513"/>
+          </a:xfrm>
+          <a:prstGeom prst="roundRect">
+            <a:avLst/>
+          </a:prstGeom>
+          <a:solidFill>
+            <a:schemeClr val="bg2"/>
+          </a:solidFill>
+          <a:ln>
+            <a:solidFill>
+              <a:schemeClr val="tx1"/>
+            </a:solidFill>
+          </a:ln>
+        </p:spPr>
+        <p:style>
+          <a:lnRef idx="2">
+            <a:schemeClr val="accent1">
+              <a:shade val="15000"/>
+            </a:schemeClr>
+          </a:lnRef>
+          <a:fillRef idx="1">
+            <a:schemeClr val="accent1"/>
+          </a:fillRef>
+          <a:effectRef idx="0">
+            <a:schemeClr val="accent1"/>
+          </a:effectRef>
+          <a:fontRef idx="minor">
+            <a:schemeClr val="lt1"/>
+          </a:fontRef>
+        </p:style>
+        <p:txBody>
+          <a:bodyPr rtlCol="0" anchor="ctr"/>
+          <a:lstStyle/>
+          <a:p>
+            <a:pPr algn="ctr"/>
+            <a:r>
+              <a:rPr lang="en-US" sz="2000">
+                <a:solidFill>
+                  <a:schemeClr val="tx1"/>
+                </a:solidFill>
+                <a:latin typeface="Times New Roman" panose="02020603050405020304" pitchFamily="18" charset="0"/>
+                <a:cs typeface="Times New Roman" panose="02020603050405020304" pitchFamily="18" charset="0"/>
+              </a:rPr>
+              <a:t>Bối cảnh</a:t>
+            </a:r>
+          </a:p>
+        </p:txBody>
+      </p:sp>
+      <p:sp>
+        <p:nvSpPr>
+          <p:cNvPr id="4" name="Rectangle: Rounded Corners 3">
+            <a:extLst>
+              <a:ext uri="{FF2B5EF4-FFF2-40B4-BE49-F238E27FC236}">
+                <a16:creationId xmlns:a16="http://schemas.microsoft.com/office/drawing/2014/main" id="{523FB17A-2C6D-D419-B862-CAC1F16E1338}"/>
+              </a:ext>
+            </a:extLst>
+          </p:cNvPr>
+          <p:cNvSpPr/>
+          <p:nvPr/>
+        </p:nvSpPr>
+        <p:spPr>
+          <a:xfrm>
+            <a:off x="4957151" y="2564513"/>
+            <a:ext cx="2277687" cy="465513"/>
+          </a:xfrm>
+          <a:prstGeom prst="roundRect">
+            <a:avLst/>
+          </a:prstGeom>
+          <a:solidFill>
+            <a:schemeClr val="bg2"/>
+          </a:solidFill>
+          <a:ln>
+            <a:solidFill>
+              <a:schemeClr val="tx1"/>
+            </a:solidFill>
+          </a:ln>
+        </p:spPr>
+        <p:style>
+          <a:lnRef idx="2">
+            <a:schemeClr val="accent1">
+              <a:shade val="15000"/>
+            </a:schemeClr>
+          </a:lnRef>
+          <a:fillRef idx="1">
+            <a:schemeClr val="accent1"/>
+          </a:fillRef>
+          <a:effectRef idx="0">
+            <a:schemeClr val="accent1"/>
+          </a:effectRef>
+          <a:fontRef idx="minor">
+            <a:schemeClr val="lt1"/>
+          </a:fontRef>
+        </p:style>
+        <p:txBody>
+          <a:bodyPr rtlCol="0" anchor="ctr"/>
+          <a:lstStyle/>
+          <a:p>
+            <a:pPr algn="ctr"/>
+            <a:r>
+              <a:rPr lang="en-US" sz="2000">
+                <a:solidFill>
+                  <a:schemeClr val="tx1"/>
+                </a:solidFill>
+                <a:latin typeface="Times New Roman" panose="02020603050405020304" pitchFamily="18" charset="0"/>
+                <a:cs typeface="Times New Roman" panose="02020603050405020304" pitchFamily="18" charset="0"/>
+              </a:rPr>
+              <a:t>Câu hỏi</a:t>
+            </a:r>
+          </a:p>
+        </p:txBody>
+      </p:sp>
+      <p:sp>
+        <p:nvSpPr>
+          <p:cNvPr id="5" name="Rectangle: Rounded Corners 4">
+            <a:extLst>
+              <a:ext uri="{FF2B5EF4-FFF2-40B4-BE49-F238E27FC236}">
+                <a16:creationId xmlns:a16="http://schemas.microsoft.com/office/drawing/2014/main" id="{52A1AEB5-777B-E184-7C3D-ED57EC360533}"/>
+              </a:ext>
+            </a:extLst>
+          </p:cNvPr>
+          <p:cNvSpPr/>
+          <p:nvPr/>
+        </p:nvSpPr>
+        <p:spPr>
+          <a:xfrm>
+            <a:off x="4957151" y="3811341"/>
+            <a:ext cx="2277687" cy="465513"/>
+          </a:xfrm>
+          <a:prstGeom prst="roundRect">
+            <a:avLst/>
+          </a:prstGeom>
+          <a:solidFill>
+            <a:schemeClr val="bg2"/>
+          </a:solidFill>
+          <a:ln>
+            <a:solidFill>
+              <a:schemeClr val="tx1"/>
+            </a:solidFill>
+          </a:ln>
+        </p:spPr>
+        <p:style>
+          <a:lnRef idx="2">
+            <a:schemeClr val="accent1">
+              <a:shade val="15000"/>
+            </a:schemeClr>
+          </a:lnRef>
+          <a:fillRef idx="1">
+            <a:schemeClr val="accent1"/>
+          </a:fillRef>
+          <a:effectRef idx="0">
+            <a:schemeClr val="accent1"/>
+          </a:effectRef>
+          <a:fontRef idx="minor">
+            <a:schemeClr val="lt1"/>
+          </a:fontRef>
+        </p:style>
+        <p:txBody>
+          <a:bodyPr rtlCol="0" anchor="ctr"/>
+          <a:lstStyle/>
+          <a:p>
+            <a:pPr algn="ctr"/>
+            <a:r>
+              <a:rPr lang="en-US" sz="2000">
+                <a:solidFill>
+                  <a:schemeClr val="tx1"/>
+                </a:solidFill>
+                <a:latin typeface="Times New Roman" panose="02020603050405020304" pitchFamily="18" charset="0"/>
+                <a:cs typeface="Times New Roman" panose="02020603050405020304" pitchFamily="18" charset="0"/>
+              </a:rPr>
+              <a:t>Ví dụ 1</a:t>
+            </a:r>
+          </a:p>
+        </p:txBody>
+      </p:sp>
+      <p:sp>
+        <p:nvSpPr>
+          <p:cNvPr id="6" name="Rectangle: Rounded Corners 5">
+            <a:extLst>
+              <a:ext uri="{FF2B5EF4-FFF2-40B4-BE49-F238E27FC236}">
+                <a16:creationId xmlns:a16="http://schemas.microsoft.com/office/drawing/2014/main" id="{4C0C7C49-EAAD-F3F6-4482-427D3CDA991E}"/>
+              </a:ext>
+            </a:extLst>
+          </p:cNvPr>
+          <p:cNvSpPr/>
+          <p:nvPr/>
+        </p:nvSpPr>
+        <p:spPr>
+          <a:xfrm>
+            <a:off x="4957151" y="4434809"/>
+            <a:ext cx="2277687" cy="465513"/>
+          </a:xfrm>
+          <a:prstGeom prst="roundRect">
+            <a:avLst/>
+          </a:prstGeom>
+          <a:solidFill>
+            <a:schemeClr val="bg2"/>
+          </a:solidFill>
+          <a:ln>
+            <a:solidFill>
+              <a:schemeClr val="tx1"/>
+            </a:solidFill>
+          </a:ln>
+        </p:spPr>
+        <p:style>
+          <a:lnRef idx="2">
+            <a:schemeClr val="accent1">
+              <a:shade val="15000"/>
+            </a:schemeClr>
+          </a:lnRef>
+          <a:fillRef idx="1">
+            <a:schemeClr val="accent1"/>
+          </a:fillRef>
+          <a:effectRef idx="0">
+            <a:schemeClr val="accent1"/>
+          </a:effectRef>
+          <a:fontRef idx="minor">
+            <a:schemeClr val="lt1"/>
+          </a:fontRef>
+        </p:style>
+        <p:txBody>
+          <a:bodyPr rtlCol="0" anchor="ctr"/>
+          <a:lstStyle/>
+          <a:p>
+            <a:pPr algn="ctr"/>
+            <a:r>
+              <a:rPr lang="en-US" sz="2000">
+                <a:solidFill>
+                  <a:schemeClr val="tx1"/>
+                </a:solidFill>
+                <a:latin typeface="Times New Roman" panose="02020603050405020304" pitchFamily="18" charset="0"/>
+                <a:cs typeface="Times New Roman" panose="02020603050405020304" pitchFamily="18" charset="0"/>
+              </a:rPr>
+              <a:t>Ví dụ …</a:t>
+            </a:r>
+          </a:p>
+        </p:txBody>
+      </p:sp>
+      <p:sp>
+        <p:nvSpPr>
+          <p:cNvPr id="7" name="Rectangle: Rounded Corners 6">
+            <a:extLst>
+              <a:ext uri="{FF2B5EF4-FFF2-40B4-BE49-F238E27FC236}">
+                <a16:creationId xmlns:a16="http://schemas.microsoft.com/office/drawing/2014/main" id="{71D9D5E7-CE64-04CF-C0A7-0AB82FF47521}"/>
+              </a:ext>
+            </a:extLst>
+          </p:cNvPr>
+          <p:cNvSpPr/>
+          <p:nvPr/>
+        </p:nvSpPr>
+        <p:spPr>
+          <a:xfrm>
+            <a:off x="4957151" y="5058277"/>
+            <a:ext cx="2277687" cy="465513"/>
+          </a:xfrm>
+          <a:prstGeom prst="roundRect">
+            <a:avLst/>
+          </a:prstGeom>
+          <a:solidFill>
+            <a:schemeClr val="bg2"/>
+          </a:solidFill>
+          <a:ln>
+            <a:solidFill>
+              <a:schemeClr val="tx1"/>
+            </a:solidFill>
+          </a:ln>
+        </p:spPr>
+        <p:style>
+          <a:lnRef idx="2">
+            <a:schemeClr val="accent1">
+              <a:shade val="15000"/>
+            </a:schemeClr>
+          </a:lnRef>
+          <a:fillRef idx="1">
+            <a:schemeClr val="accent1"/>
+          </a:fillRef>
+          <a:effectRef idx="0">
+            <a:schemeClr val="accent1"/>
+          </a:effectRef>
+          <a:fontRef idx="minor">
+            <a:schemeClr val="lt1"/>
+          </a:fontRef>
+        </p:style>
+        <p:txBody>
+          <a:bodyPr rtlCol="0" anchor="ctr"/>
+          <a:lstStyle/>
+          <a:p>
+            <a:pPr algn="ctr"/>
+            <a:r>
+              <a:rPr lang="en-US" sz="2000">
+                <a:solidFill>
+                  <a:schemeClr val="tx1"/>
+                </a:solidFill>
+                <a:latin typeface="Times New Roman" panose="02020603050405020304" pitchFamily="18" charset="0"/>
+                <a:cs typeface="Times New Roman" panose="02020603050405020304" pitchFamily="18" charset="0"/>
+              </a:rPr>
+              <a:t>Hướng dẫn</a:t>
+            </a:r>
+          </a:p>
+        </p:txBody>
+      </p:sp>
+      <p:sp>
+        <p:nvSpPr>
+          <p:cNvPr id="8" name="Rectangle: Rounded Corners 7">
+            <a:extLst>
+              <a:ext uri="{FF2B5EF4-FFF2-40B4-BE49-F238E27FC236}">
+                <a16:creationId xmlns:a16="http://schemas.microsoft.com/office/drawing/2014/main" id="{0AB434B3-C344-31F7-495F-0AA705CD2676}"/>
+              </a:ext>
+            </a:extLst>
+          </p:cNvPr>
+          <p:cNvSpPr/>
+          <p:nvPr/>
+        </p:nvSpPr>
+        <p:spPr>
+          <a:xfrm>
+            <a:off x="4957151" y="5681745"/>
+            <a:ext cx="2277687" cy="465513"/>
+          </a:xfrm>
+          <a:prstGeom prst="roundRect">
+            <a:avLst/>
+          </a:prstGeom>
+          <a:solidFill>
+            <a:schemeClr val="bg2"/>
+          </a:solidFill>
+          <a:ln>
+            <a:solidFill>
+              <a:schemeClr val="tx1"/>
+            </a:solidFill>
+          </a:ln>
+        </p:spPr>
+        <p:style>
+          <a:lnRef idx="2">
+            <a:schemeClr val="accent1">
+              <a:shade val="15000"/>
+            </a:schemeClr>
+          </a:lnRef>
+          <a:fillRef idx="1">
+            <a:schemeClr val="accent1"/>
+          </a:fillRef>
+          <a:effectRef idx="0">
+            <a:schemeClr val="accent1"/>
+          </a:effectRef>
+          <a:fontRef idx="minor">
+            <a:schemeClr val="lt1"/>
+          </a:fontRef>
+        </p:style>
+        <p:txBody>
+          <a:bodyPr rtlCol="0" anchor="ctr"/>
+          <a:lstStyle/>
+          <a:p>
+            <a:pPr algn="ctr"/>
+            <a:r>
+              <a:rPr lang="en-US" sz="2000">
+                <a:solidFill>
+                  <a:schemeClr val="tx1"/>
+                </a:solidFill>
+                <a:latin typeface="Times New Roman" panose="02020603050405020304" pitchFamily="18" charset="0"/>
+                <a:cs typeface="Times New Roman" panose="02020603050405020304" pitchFamily="18" charset="0"/>
+              </a:rPr>
+              <a:t>Lưu ý</a:t>
+            </a:r>
+          </a:p>
+        </p:txBody>
+      </p:sp>
+      <p:sp>
+        <p:nvSpPr>
+          <p:cNvPr id="9" name="Rectangle: Rounded Corners 8">
+            <a:extLst>
+              <a:ext uri="{FF2B5EF4-FFF2-40B4-BE49-F238E27FC236}">
+                <a16:creationId xmlns:a16="http://schemas.microsoft.com/office/drawing/2014/main" id="{D800047B-C85B-E86D-B48E-E40693192A88}"/>
+              </a:ext>
+            </a:extLst>
+          </p:cNvPr>
+          <p:cNvSpPr/>
+          <p:nvPr/>
+        </p:nvSpPr>
+        <p:spPr>
+          <a:xfrm>
+            <a:off x="3535675" y="536181"/>
+            <a:ext cx="5120640" cy="6001790"/>
+          </a:xfrm>
+          <a:prstGeom prst="roundRect">
+            <a:avLst/>
+          </a:prstGeom>
+          <a:noFill/>
+          <a:ln>
+            <a:solidFill>
+              <a:srgbClr val="FF0000"/>
+            </a:solidFill>
+            <a:prstDash val="dash"/>
+          </a:ln>
+        </p:spPr>
+        <p:style>
+          <a:lnRef idx="2">
+            <a:schemeClr val="accent1">
+              <a:shade val="15000"/>
+            </a:schemeClr>
+          </a:lnRef>
+          <a:fillRef idx="1">
+            <a:schemeClr val="accent1"/>
+          </a:fillRef>
+          <a:effectRef idx="0">
+            <a:schemeClr val="accent1"/>
+          </a:effectRef>
+          <a:fontRef idx="minor">
+            <a:schemeClr val="lt1"/>
+          </a:fontRef>
+        </p:style>
+        <p:txBody>
+          <a:bodyPr rtlCol="0" anchor="ctr"/>
+          <a:lstStyle/>
+          <a:p>
+            <a:pPr algn="ctr"/>
+            <a:endParaRPr lang="en-US" sz="2000">
+              <a:latin typeface="Times New Roman" panose="02020603050405020304" pitchFamily="18" charset="0"/>
+              <a:cs typeface="Times New Roman" panose="02020603050405020304" pitchFamily="18" charset="0"/>
+            </a:endParaRPr>
+          </a:p>
+        </p:txBody>
+      </p:sp>
+      <p:sp>
+        <p:nvSpPr>
+          <p:cNvPr id="10" name="Rectangle: Rounded Corners 9">
+            <a:extLst>
+              <a:ext uri="{FF2B5EF4-FFF2-40B4-BE49-F238E27FC236}">
+                <a16:creationId xmlns:a16="http://schemas.microsoft.com/office/drawing/2014/main" id="{2260C8B5-26F6-45A9-6F8F-27DB4488B198}"/>
+              </a:ext>
+            </a:extLst>
+          </p:cNvPr>
+          <p:cNvSpPr/>
+          <p:nvPr/>
+        </p:nvSpPr>
+        <p:spPr>
+          <a:xfrm>
+            <a:off x="4574766" y="145469"/>
+            <a:ext cx="3042458" cy="781396"/>
+          </a:xfrm>
+          <a:prstGeom prst="roundRect">
+            <a:avLst/>
+          </a:prstGeom>
+          <a:solidFill>
+            <a:srgbClr val="FFFFFF"/>
+          </a:solidFill>
+          <a:ln>
+            <a:solidFill>
+              <a:srgbClr val="FF0000"/>
+            </a:solidFill>
+          </a:ln>
+        </p:spPr>
+        <p:style>
+          <a:lnRef idx="2">
+            <a:schemeClr val="accent1">
+              <a:shade val="15000"/>
+            </a:schemeClr>
+          </a:lnRef>
+          <a:fillRef idx="1">
+            <a:schemeClr val="accent1"/>
+          </a:fillRef>
+          <a:effectRef idx="0">
+            <a:schemeClr val="accent1"/>
+          </a:effectRef>
+          <a:fontRef idx="minor">
+            <a:schemeClr val="lt1"/>
+          </a:fontRef>
+        </p:style>
+        <p:txBody>
+          <a:bodyPr rtlCol="0" anchor="ctr"/>
+          <a:lstStyle/>
+          <a:p>
+            <a:pPr algn="ctr"/>
+            <a:r>
+              <a:rPr lang="en-US" sz="2000">
+                <a:ln w="0">
+                  <a:solidFill>
+                    <a:schemeClr val="tx1"/>
+                  </a:solidFill>
+                </a:ln>
+                <a:solidFill>
+                  <a:schemeClr val="tx1"/>
+                </a:solidFill>
+                <a:latin typeface="Times New Roman" panose="02020603050405020304" pitchFamily="18" charset="0"/>
+                <a:cs typeface="Times New Roman" panose="02020603050405020304" pitchFamily="18" charset="0"/>
+              </a:rPr>
+              <a:t>Prompt cho tác vụ</a:t>
+            </a:r>
+          </a:p>
+          <a:p>
+            <a:pPr algn="ctr"/>
+            <a:r>
+              <a:rPr lang="en-US" sz="2000">
+                <a:ln w="0">
+                  <a:solidFill>
+                    <a:schemeClr val="tx1"/>
+                  </a:solidFill>
+                </a:ln>
+                <a:solidFill>
+                  <a:schemeClr val="tx1"/>
+                </a:solidFill>
+                <a:latin typeface="Times New Roman" panose="02020603050405020304" pitchFamily="18" charset="0"/>
+                <a:cs typeface="Times New Roman" panose="02020603050405020304" pitchFamily="18" charset="0"/>
+              </a:rPr>
+              <a:t>trích xuất thông tin</a:t>
+            </a:r>
+          </a:p>
+        </p:txBody>
+      </p:sp>
+      <p:sp>
+        <p:nvSpPr>
+          <p:cNvPr id="11" name="Rectangle: Rounded Corners 10">
+            <a:extLst>
+              <a:ext uri="{FF2B5EF4-FFF2-40B4-BE49-F238E27FC236}">
+                <a16:creationId xmlns:a16="http://schemas.microsoft.com/office/drawing/2014/main" id="{F4D89389-FC1C-90EA-1BC5-0AE4888836C0}"/>
+              </a:ext>
+            </a:extLst>
+          </p:cNvPr>
+          <p:cNvSpPr/>
+          <p:nvPr/>
+        </p:nvSpPr>
+        <p:spPr>
+          <a:xfrm>
+            <a:off x="4957151" y="3187927"/>
+            <a:ext cx="2277687" cy="465513"/>
+          </a:xfrm>
+          <a:prstGeom prst="roundRect">
+            <a:avLst/>
+          </a:prstGeom>
+          <a:solidFill>
+            <a:schemeClr val="bg2"/>
+          </a:solidFill>
+          <a:ln>
+            <a:solidFill>
+              <a:schemeClr val="tx1"/>
+            </a:solidFill>
+          </a:ln>
+        </p:spPr>
+        <p:style>
+          <a:lnRef idx="2">
+            <a:schemeClr val="accent1">
+              <a:shade val="15000"/>
+            </a:schemeClr>
+          </a:lnRef>
+          <a:fillRef idx="1">
+            <a:schemeClr val="accent1"/>
+          </a:fillRef>
+          <a:effectRef idx="0">
+            <a:schemeClr val="accent1"/>
+          </a:effectRef>
+          <a:fontRef idx="minor">
+            <a:schemeClr val="lt1"/>
+          </a:fontRef>
+        </p:style>
+        <p:txBody>
+          <a:bodyPr rtlCol="0" anchor="ctr"/>
+          <a:lstStyle/>
+          <a:p>
+            <a:pPr algn="ctr"/>
+            <a:r>
+              <a:rPr lang="en-US" sz="2000">
+                <a:solidFill>
+                  <a:schemeClr val="tx1"/>
+                </a:solidFill>
+                <a:latin typeface="Times New Roman" panose="02020603050405020304" pitchFamily="18" charset="0"/>
+                <a:cs typeface="Times New Roman" panose="02020603050405020304" pitchFamily="18" charset="0"/>
+              </a:rPr>
+              <a:t>Đầu ra có cấu trúc</a:t>
+            </a:r>
+          </a:p>
+        </p:txBody>
+      </p:sp>
+    </p:spTree>
+    <p:extLst>
+      <p:ext uri="{BB962C8B-B14F-4D97-AF65-F5344CB8AC3E}">
+        <p14:creationId xmlns:p14="http://schemas.microsoft.com/office/powerpoint/2010/main" val="3447625200"/>
+      </p:ext>
+    </p:extLst>
+  </p:cSld>
+  <p:clrMapOvr>
+    <a:masterClrMapping/>
+  </p:clrMapOvr>
+</p:sld>
+</file>
+
+<file path=ppt/slides/slide36.xml><?xml version="1.0" encoding="utf-8"?>
+<p:sld xmlns:a="http://schemas.openxmlformats.org/drawingml/2006/main" xmlns:r="http://schemas.openxmlformats.org/officeDocument/2006/relationships" xmlns:p="http://schemas.openxmlformats.org/presentationml/2006/main">
+  <p:cSld>
+    <p:spTree>
+      <p:nvGrpSpPr>
+        <p:cNvPr id="1" name=""/>
+        <p:cNvGrpSpPr/>
+        <p:nvPr/>
+      </p:nvGrpSpPr>
+      <p:grpSpPr>
+        <a:xfrm>
+          <a:off x="0" y="0"/>
+          <a:ext cx="0" cy="0"/>
+          <a:chOff x="0" y="0"/>
+          <a:chExt cx="0" cy="0"/>
+        </a:xfrm>
+      </p:grpSpPr>
       <p:pic>
         <p:nvPicPr>
           <p:cNvPr id="3" name="Picture 2">

</xml_diff>